<commit_message>
Wire SME upload to in-app model training output and bootstrap subadmins.
CSV upload now returns train/test model metrics, frontend auto-starts backend when launching dev UI, and fixed initial subadmin IDs are seeded with PIN 1234; defence PPT updated accordingly.

Co-authored-by: Cursor <cursoragent@cursor.com>
</commit_message>
<xml_diff>
--- a/Presentation/Ushirika_Group15_Defence_Presentation.pptx
+++ b/Presentation/Ushirika_Group15_Defence_Presentation.pptx
@@ -5,20 +5,20 @@
     <p:sldMasterId id="2147483648" r:id="rId1"/>
   </p:sldMasterIdLst>
   <p:sldIdLst>
-    <p:sldId id="256" r:id="rId2"/>
-    <p:sldId id="257" r:id="rId3"/>
-    <p:sldId id="258" r:id="rId4"/>
-    <p:sldId id="259" r:id="rId5"/>
-    <p:sldId id="260" r:id="rId6"/>
-    <p:sldId id="261" r:id="rId7"/>
-    <p:sldId id="262" r:id="rId8"/>
-    <p:sldId id="263" r:id="rId9"/>
-    <p:sldId id="264" r:id="rId10"/>
-    <p:sldId id="265" r:id="rId11"/>
-    <p:sldId id="266" r:id="rId12"/>
-    <p:sldId id="267" r:id="rId13"/>
+    <p:sldId id="256" r:id="rId7"/>
+    <p:sldId id="257" r:id="rId8"/>
+    <p:sldId id="258" r:id="rId9"/>
+    <p:sldId id="259" r:id="rId10"/>
+    <p:sldId id="260" r:id="rId11"/>
+    <p:sldId id="261" r:id="rId12"/>
+    <p:sldId id="262" r:id="rId13"/>
+    <p:sldId id="263" r:id="rId14"/>
+    <p:sldId id="264" r:id="rId15"/>
+    <p:sldId id="265" r:id="rId16"/>
+    <p:sldId id="266" r:id="rId17"/>
+    <p:sldId id="267" r:id="rId18"/>
   </p:sldIdLst>
-  <p:sldSz cx="12192000" cy="6858000"/>
+  <p:sldSz cx="12191695" cy="6858000" type="screen4x3"/>
   <p:notesSz cx="6858000" cy="9144000"/>
   <p:defaultTextStyle>
     <a:defPPr>
@@ -115,22 +115,6 @@
       </a:defRPr>
     </a:lvl9pPr>
   </p:defaultTextStyle>
-  <p:extLst>
-    <p:ext uri="{EFAFB233-063F-42B5-8137-9DF3F51BA10A}">
-      <p15:sldGuideLst xmlns:p15="http://schemas.microsoft.com/office/powerpoint/2012/main">
-        <p15:guide id="1" orient="horz" pos="2160">
-          <p15:clr>
-            <a:srgbClr val="A4A3A4"/>
-          </p15:clr>
-        </p15:guide>
-        <p15:guide id="2" pos="2880">
-          <p15:clr>
-            <a:srgbClr val="A4A3A4"/>
-          </p15:clr>
-        </p15:guide>
-      </p15:sldGuideLst>
-    </p:ext>
-  </p:extLst>
 </p:presentation>
 </file>
 
@@ -172,9 +156,10 @@
           <a:lstStyle/>
           <a:p>
             <a:r>
-              <a:rPr lang="en-US"/>
+              <a:rPr lang="en-US" smtClean="0"/>
               <a:t>Click to edit Master title style</a:t>
             </a:r>
+            <a:endParaRPr lang="en-US"/>
           </a:p>
         </p:txBody>
       </p:sp>
@@ -290,9 +275,10 @@
           </a:lstStyle>
           <a:p>
             <a:r>
-              <a:rPr lang="en-US"/>
+              <a:rPr lang="en-US" smtClean="0"/>
               <a:t>Click to edit Master subtitle style</a:t>
             </a:r>
+            <a:endParaRPr lang="en-US"/>
           </a:p>
         </p:txBody>
       </p:sp>
@@ -313,7 +299,7 @@
           <a:p>
             <a:fld id="{5BCAD085-E8A6-8845-BD4E-CB4CCA059FC4}" type="datetimeFigureOut">
               <a:rPr lang="en-US" smtClean="0"/>
-              <a:t>7/19/2026</a:t>
+              <a:t>1/27/13</a:t>
             </a:fld>
             <a:endParaRPr lang="en-US"/>
           </a:p>
@@ -407,9 +393,10 @@
           <a:lstStyle/>
           <a:p>
             <a:r>
-              <a:rPr lang="en-US"/>
+              <a:rPr lang="en-US" smtClean="0"/>
               <a:t>Click to edit Master title style</a:t>
             </a:r>
+            <a:endParaRPr lang="en-US"/>
           </a:p>
         </p:txBody>
       </p:sp>
@@ -430,37 +417,38 @@
           <a:p>
             <a:pPr lvl="0"/>
             <a:r>
-              <a:rPr lang="en-US"/>
+              <a:rPr lang="en-US" smtClean="0"/>
               <a:t>Click to edit Master text styles</a:t>
             </a:r>
           </a:p>
           <a:p>
             <a:pPr lvl="1"/>
             <a:r>
-              <a:rPr lang="en-US"/>
+              <a:rPr lang="en-US" smtClean="0"/>
               <a:t>Second level</a:t>
             </a:r>
           </a:p>
           <a:p>
             <a:pPr lvl="2"/>
             <a:r>
-              <a:rPr lang="en-US"/>
+              <a:rPr lang="en-US" smtClean="0"/>
               <a:t>Third level</a:t>
             </a:r>
           </a:p>
           <a:p>
             <a:pPr lvl="3"/>
             <a:r>
-              <a:rPr lang="en-US"/>
+              <a:rPr lang="en-US" smtClean="0"/>
               <a:t>Fourth level</a:t>
             </a:r>
           </a:p>
           <a:p>
             <a:pPr lvl="4"/>
             <a:r>
-              <a:rPr lang="en-US"/>
+              <a:rPr lang="en-US" smtClean="0"/>
               <a:t>Fifth level</a:t>
             </a:r>
+            <a:endParaRPr lang="en-US"/>
           </a:p>
         </p:txBody>
       </p:sp>
@@ -481,7 +469,7 @@
           <a:p>
             <a:fld id="{5BCAD085-E8A6-8845-BD4E-CB4CCA059FC4}" type="datetimeFigureOut">
               <a:rPr lang="en-US" smtClean="0"/>
-              <a:t>7/19/2026</a:t>
+              <a:t>1/27/13</a:t>
             </a:fld>
             <a:endParaRPr lang="en-US"/>
           </a:p>
@@ -580,9 +568,10 @@
           <a:lstStyle/>
           <a:p>
             <a:r>
-              <a:rPr lang="en-US"/>
+              <a:rPr lang="en-US" smtClean="0"/>
               <a:t>Click to edit Master title style</a:t>
             </a:r>
+            <a:endParaRPr lang="en-US"/>
           </a:p>
         </p:txBody>
       </p:sp>
@@ -608,37 +597,38 @@
           <a:p>
             <a:pPr lvl="0"/>
             <a:r>
-              <a:rPr lang="en-US"/>
+              <a:rPr lang="en-US" smtClean="0"/>
               <a:t>Click to edit Master text styles</a:t>
             </a:r>
           </a:p>
           <a:p>
             <a:pPr lvl="1"/>
             <a:r>
-              <a:rPr lang="en-US"/>
+              <a:rPr lang="en-US" smtClean="0"/>
               <a:t>Second level</a:t>
             </a:r>
           </a:p>
           <a:p>
             <a:pPr lvl="2"/>
             <a:r>
-              <a:rPr lang="en-US"/>
+              <a:rPr lang="en-US" smtClean="0"/>
               <a:t>Third level</a:t>
             </a:r>
           </a:p>
           <a:p>
             <a:pPr lvl="3"/>
             <a:r>
-              <a:rPr lang="en-US"/>
+              <a:rPr lang="en-US" smtClean="0"/>
               <a:t>Fourth level</a:t>
             </a:r>
           </a:p>
           <a:p>
             <a:pPr lvl="4"/>
             <a:r>
-              <a:rPr lang="en-US"/>
+              <a:rPr lang="en-US" smtClean="0"/>
               <a:t>Fifth level</a:t>
             </a:r>
+            <a:endParaRPr lang="en-US"/>
           </a:p>
         </p:txBody>
       </p:sp>
@@ -659,7 +649,7 @@
           <a:p>
             <a:fld id="{5BCAD085-E8A6-8845-BD4E-CB4CCA059FC4}" type="datetimeFigureOut">
               <a:rPr lang="en-US" smtClean="0"/>
-              <a:t>7/19/2026</a:t>
+              <a:t>1/27/13</a:t>
             </a:fld>
             <a:endParaRPr lang="en-US"/>
           </a:p>
@@ -753,9 +743,10 @@
           <a:lstStyle/>
           <a:p>
             <a:r>
-              <a:rPr lang="en-US"/>
+              <a:rPr lang="en-US" smtClean="0"/>
               <a:t>Click to edit Master title style</a:t>
             </a:r>
+            <a:endParaRPr lang="en-US"/>
           </a:p>
         </p:txBody>
       </p:sp>
@@ -776,37 +767,38 @@
           <a:p>
             <a:pPr lvl="0"/>
             <a:r>
-              <a:rPr lang="en-US"/>
+              <a:rPr lang="en-US" smtClean="0"/>
               <a:t>Click to edit Master text styles</a:t>
             </a:r>
           </a:p>
           <a:p>
             <a:pPr lvl="1"/>
             <a:r>
-              <a:rPr lang="en-US"/>
+              <a:rPr lang="en-US" smtClean="0"/>
               <a:t>Second level</a:t>
             </a:r>
           </a:p>
           <a:p>
             <a:pPr lvl="2"/>
             <a:r>
-              <a:rPr lang="en-US"/>
+              <a:rPr lang="en-US" smtClean="0"/>
               <a:t>Third level</a:t>
             </a:r>
           </a:p>
           <a:p>
             <a:pPr lvl="3"/>
             <a:r>
-              <a:rPr lang="en-US"/>
+              <a:rPr lang="en-US" smtClean="0"/>
               <a:t>Fourth level</a:t>
             </a:r>
           </a:p>
           <a:p>
             <a:pPr lvl="4"/>
             <a:r>
-              <a:rPr lang="en-US"/>
+              <a:rPr lang="en-US" smtClean="0"/>
               <a:t>Fifth level</a:t>
             </a:r>
+            <a:endParaRPr lang="en-US"/>
           </a:p>
         </p:txBody>
       </p:sp>
@@ -827,7 +819,7 @@
           <a:p>
             <a:fld id="{5BCAD085-E8A6-8845-BD4E-CB4CCA059FC4}" type="datetimeFigureOut">
               <a:rPr lang="en-US" smtClean="0"/>
-              <a:t>7/19/2026</a:t>
+              <a:t>1/27/13</a:t>
             </a:fld>
             <a:endParaRPr lang="en-US"/>
           </a:p>
@@ -930,9 +922,10 @@
           </a:lstStyle>
           <a:p>
             <a:r>
-              <a:rPr lang="en-US"/>
+              <a:rPr lang="en-US" smtClean="0"/>
               <a:t>Click to edit Master title style</a:t>
             </a:r>
+            <a:endParaRPr lang="en-US"/>
           </a:p>
         </p:txBody>
       </p:sp>
@@ -1049,7 +1042,7 @@
           <a:p>
             <a:pPr lvl="0"/>
             <a:r>
-              <a:rPr lang="en-US"/>
+              <a:rPr lang="en-US" smtClean="0"/>
               <a:t>Click to edit Master text styles</a:t>
             </a:r>
           </a:p>
@@ -1072,7 +1065,7 @@
           <a:p>
             <a:fld id="{5BCAD085-E8A6-8845-BD4E-CB4CCA059FC4}" type="datetimeFigureOut">
               <a:rPr lang="en-US" smtClean="0"/>
-              <a:t>7/19/2026</a:t>
+              <a:t>1/27/13</a:t>
             </a:fld>
             <a:endParaRPr lang="en-US"/>
           </a:p>
@@ -1166,9 +1159,10 @@
           <a:lstStyle/>
           <a:p>
             <a:r>
-              <a:rPr lang="en-US"/>
+              <a:rPr lang="en-US" smtClean="0"/>
               <a:t>Click to edit Master title style</a:t>
             </a:r>
+            <a:endParaRPr lang="en-US"/>
           </a:p>
         </p:txBody>
       </p:sp>
@@ -1222,37 +1216,38 @@
           <a:p>
             <a:pPr lvl="0"/>
             <a:r>
-              <a:rPr lang="en-US"/>
+              <a:rPr lang="en-US" smtClean="0"/>
               <a:t>Click to edit Master text styles</a:t>
             </a:r>
           </a:p>
           <a:p>
             <a:pPr lvl="1"/>
             <a:r>
-              <a:rPr lang="en-US"/>
+              <a:rPr lang="en-US" smtClean="0"/>
               <a:t>Second level</a:t>
             </a:r>
           </a:p>
           <a:p>
             <a:pPr lvl="2"/>
             <a:r>
-              <a:rPr lang="en-US"/>
+              <a:rPr lang="en-US" smtClean="0"/>
               <a:t>Third level</a:t>
             </a:r>
           </a:p>
           <a:p>
             <a:pPr lvl="3"/>
             <a:r>
-              <a:rPr lang="en-US"/>
+              <a:rPr lang="en-US" smtClean="0"/>
               <a:t>Fourth level</a:t>
             </a:r>
           </a:p>
           <a:p>
             <a:pPr lvl="4"/>
             <a:r>
-              <a:rPr lang="en-US"/>
+              <a:rPr lang="en-US" smtClean="0"/>
               <a:t>Fifth level</a:t>
             </a:r>
+            <a:endParaRPr lang="en-US"/>
           </a:p>
         </p:txBody>
       </p:sp>
@@ -1306,37 +1301,38 @@
           <a:p>
             <a:pPr lvl="0"/>
             <a:r>
-              <a:rPr lang="en-US"/>
+              <a:rPr lang="en-US" smtClean="0"/>
               <a:t>Click to edit Master text styles</a:t>
             </a:r>
           </a:p>
           <a:p>
             <a:pPr lvl="1"/>
             <a:r>
-              <a:rPr lang="en-US"/>
+              <a:rPr lang="en-US" smtClean="0"/>
               <a:t>Second level</a:t>
             </a:r>
           </a:p>
           <a:p>
             <a:pPr lvl="2"/>
             <a:r>
-              <a:rPr lang="en-US"/>
+              <a:rPr lang="en-US" smtClean="0"/>
               <a:t>Third level</a:t>
             </a:r>
           </a:p>
           <a:p>
             <a:pPr lvl="3"/>
             <a:r>
-              <a:rPr lang="en-US"/>
+              <a:rPr lang="en-US" smtClean="0"/>
               <a:t>Fourth level</a:t>
             </a:r>
           </a:p>
           <a:p>
             <a:pPr lvl="4"/>
             <a:r>
-              <a:rPr lang="en-US"/>
+              <a:rPr lang="en-US" smtClean="0"/>
               <a:t>Fifth level</a:t>
             </a:r>
+            <a:endParaRPr lang="en-US"/>
           </a:p>
         </p:txBody>
       </p:sp>
@@ -1357,7 +1353,7 @@
           <a:p>
             <a:fld id="{5BCAD085-E8A6-8845-BD4E-CB4CCA059FC4}" type="datetimeFigureOut">
               <a:rPr lang="en-US" smtClean="0"/>
-              <a:t>7/19/2026</a:t>
+              <a:t>1/27/13</a:t>
             </a:fld>
             <a:endParaRPr lang="en-US"/>
           </a:p>
@@ -1455,9 +1451,10 @@
           </a:lstStyle>
           <a:p>
             <a:r>
-              <a:rPr lang="en-US"/>
+              <a:rPr lang="en-US" smtClean="0"/>
               <a:t>Click to edit Master title style</a:t>
             </a:r>
+            <a:endParaRPr lang="en-US"/>
           </a:p>
         </p:txBody>
       </p:sp>
@@ -1520,7 +1517,7 @@
           <a:p>
             <a:pPr lvl="0"/>
             <a:r>
-              <a:rPr lang="en-US"/>
+              <a:rPr lang="en-US" smtClean="0"/>
               <a:t>Click to edit Master text styles</a:t>
             </a:r>
           </a:p>
@@ -1576,37 +1573,38 @@
           <a:p>
             <a:pPr lvl="0"/>
             <a:r>
-              <a:rPr lang="en-US"/>
+              <a:rPr lang="en-US" smtClean="0"/>
               <a:t>Click to edit Master text styles</a:t>
             </a:r>
           </a:p>
           <a:p>
             <a:pPr lvl="1"/>
             <a:r>
-              <a:rPr lang="en-US"/>
+              <a:rPr lang="en-US" smtClean="0"/>
               <a:t>Second level</a:t>
             </a:r>
           </a:p>
           <a:p>
             <a:pPr lvl="2"/>
             <a:r>
-              <a:rPr lang="en-US"/>
+              <a:rPr lang="en-US" smtClean="0"/>
               <a:t>Third level</a:t>
             </a:r>
           </a:p>
           <a:p>
             <a:pPr lvl="3"/>
             <a:r>
-              <a:rPr lang="en-US"/>
+              <a:rPr lang="en-US" smtClean="0"/>
               <a:t>Fourth level</a:t>
             </a:r>
           </a:p>
           <a:p>
             <a:pPr lvl="4"/>
             <a:r>
-              <a:rPr lang="en-US"/>
+              <a:rPr lang="en-US" smtClean="0"/>
               <a:t>Fifth level</a:t>
             </a:r>
+            <a:endParaRPr lang="en-US"/>
           </a:p>
         </p:txBody>
       </p:sp>
@@ -1669,7 +1667,7 @@
           <a:p>
             <a:pPr lvl="0"/>
             <a:r>
-              <a:rPr lang="en-US"/>
+              <a:rPr lang="en-US" smtClean="0"/>
               <a:t>Click to edit Master text styles</a:t>
             </a:r>
           </a:p>
@@ -1725,37 +1723,38 @@
           <a:p>
             <a:pPr lvl="0"/>
             <a:r>
-              <a:rPr lang="en-US"/>
+              <a:rPr lang="en-US" smtClean="0"/>
               <a:t>Click to edit Master text styles</a:t>
             </a:r>
           </a:p>
           <a:p>
             <a:pPr lvl="1"/>
             <a:r>
-              <a:rPr lang="en-US"/>
+              <a:rPr lang="en-US" smtClean="0"/>
               <a:t>Second level</a:t>
             </a:r>
           </a:p>
           <a:p>
             <a:pPr lvl="2"/>
             <a:r>
-              <a:rPr lang="en-US"/>
+              <a:rPr lang="en-US" smtClean="0"/>
               <a:t>Third level</a:t>
             </a:r>
           </a:p>
           <a:p>
             <a:pPr lvl="3"/>
             <a:r>
-              <a:rPr lang="en-US"/>
+              <a:rPr lang="en-US" smtClean="0"/>
               <a:t>Fourth level</a:t>
             </a:r>
           </a:p>
           <a:p>
             <a:pPr lvl="4"/>
             <a:r>
-              <a:rPr lang="en-US"/>
+              <a:rPr lang="en-US" smtClean="0"/>
               <a:t>Fifth level</a:t>
             </a:r>
+            <a:endParaRPr lang="en-US"/>
           </a:p>
         </p:txBody>
       </p:sp>
@@ -1776,7 +1775,7 @@
           <a:p>
             <a:fld id="{5BCAD085-E8A6-8845-BD4E-CB4CCA059FC4}" type="datetimeFigureOut">
               <a:rPr lang="en-US" smtClean="0"/>
-              <a:t>7/19/2026</a:t>
+              <a:t>1/27/13</a:t>
             </a:fld>
             <a:endParaRPr lang="en-US"/>
           </a:p>
@@ -1870,9 +1869,10 @@
           <a:lstStyle/>
           <a:p>
             <a:r>
-              <a:rPr lang="en-US"/>
+              <a:rPr lang="en-US" smtClean="0"/>
               <a:t>Click to edit Master title style</a:t>
             </a:r>
+            <a:endParaRPr lang="en-US"/>
           </a:p>
         </p:txBody>
       </p:sp>
@@ -1893,7 +1893,7 @@
           <a:p>
             <a:fld id="{5BCAD085-E8A6-8845-BD4E-CB4CCA059FC4}" type="datetimeFigureOut">
               <a:rPr lang="en-US" smtClean="0"/>
-              <a:t>7/19/2026</a:t>
+              <a:t>1/27/13</a:t>
             </a:fld>
             <a:endParaRPr lang="en-US"/>
           </a:p>
@@ -1988,7 +1988,7 @@
           <a:p>
             <a:fld id="{5BCAD085-E8A6-8845-BD4E-CB4CCA059FC4}" type="datetimeFigureOut">
               <a:rPr lang="en-US" smtClean="0"/>
-              <a:t>7/19/2026</a:t>
+              <a:t>1/27/13</a:t>
             </a:fld>
             <a:endParaRPr lang="en-US"/>
           </a:p>
@@ -2091,9 +2091,10 @@
           </a:lstStyle>
           <a:p>
             <a:r>
-              <a:rPr lang="en-US"/>
+              <a:rPr lang="en-US" smtClean="0"/>
               <a:t>Click to edit Master title style</a:t>
             </a:r>
+            <a:endParaRPr lang="en-US"/>
           </a:p>
         </p:txBody>
       </p:sp>
@@ -2147,37 +2148,38 @@
           <a:p>
             <a:pPr lvl="0"/>
             <a:r>
-              <a:rPr lang="en-US"/>
+              <a:rPr lang="en-US" smtClean="0"/>
               <a:t>Click to edit Master text styles</a:t>
             </a:r>
           </a:p>
           <a:p>
             <a:pPr lvl="1"/>
             <a:r>
-              <a:rPr lang="en-US"/>
+              <a:rPr lang="en-US" smtClean="0"/>
               <a:t>Second level</a:t>
             </a:r>
           </a:p>
           <a:p>
             <a:pPr lvl="2"/>
             <a:r>
-              <a:rPr lang="en-US"/>
+              <a:rPr lang="en-US" smtClean="0"/>
               <a:t>Third level</a:t>
             </a:r>
           </a:p>
           <a:p>
             <a:pPr lvl="3"/>
             <a:r>
-              <a:rPr lang="en-US"/>
+              <a:rPr lang="en-US" smtClean="0"/>
               <a:t>Fourth level</a:t>
             </a:r>
           </a:p>
           <a:p>
             <a:pPr lvl="4"/>
             <a:r>
-              <a:rPr lang="en-US"/>
+              <a:rPr lang="en-US" smtClean="0"/>
               <a:t>Fifth level</a:t>
             </a:r>
+            <a:endParaRPr lang="en-US"/>
           </a:p>
         </p:txBody>
       </p:sp>
@@ -2240,7 +2242,7 @@
           <a:p>
             <a:pPr lvl="0"/>
             <a:r>
-              <a:rPr lang="en-US"/>
+              <a:rPr lang="en-US" smtClean="0"/>
               <a:t>Click to edit Master text styles</a:t>
             </a:r>
           </a:p>
@@ -2263,7 +2265,7 @@
           <a:p>
             <a:fld id="{5BCAD085-E8A6-8845-BD4E-CB4CCA059FC4}" type="datetimeFigureOut">
               <a:rPr lang="en-US" smtClean="0"/>
-              <a:t>7/19/2026</a:t>
+              <a:t>1/27/13</a:t>
             </a:fld>
             <a:endParaRPr lang="en-US"/>
           </a:p>
@@ -2366,9 +2368,10 @@
           </a:lstStyle>
           <a:p>
             <a:r>
-              <a:rPr lang="en-US"/>
+              <a:rPr lang="en-US" smtClean="0"/>
               <a:t>Click to edit Master title style</a:t>
             </a:r>
+            <a:endParaRPr lang="en-US"/>
           </a:p>
         </p:txBody>
       </p:sp>
@@ -2492,7 +2495,7 @@
           <a:p>
             <a:pPr lvl="0"/>
             <a:r>
-              <a:rPr lang="en-US"/>
+              <a:rPr lang="en-US" smtClean="0"/>
               <a:t>Click to edit Master text styles</a:t>
             </a:r>
           </a:p>
@@ -2515,7 +2518,7 @@
           <a:p>
             <a:fld id="{5BCAD085-E8A6-8845-BD4E-CB4CCA059FC4}" type="datetimeFigureOut">
               <a:rPr lang="en-US" smtClean="0"/>
-              <a:t>7/19/2026</a:t>
+              <a:t>1/27/13</a:t>
             </a:fld>
             <a:endParaRPr lang="en-US"/>
           </a:p>
@@ -2624,9 +2627,10 @@
           <a:lstStyle/>
           <a:p>
             <a:r>
-              <a:rPr lang="en-US"/>
+              <a:rPr lang="en-US" smtClean="0"/>
               <a:t>Click to edit Master title style</a:t>
             </a:r>
+            <a:endParaRPr lang="en-US"/>
           </a:p>
         </p:txBody>
       </p:sp>
@@ -2657,37 +2661,38 @@
           <a:p>
             <a:pPr lvl="0"/>
             <a:r>
-              <a:rPr lang="en-US"/>
+              <a:rPr lang="en-US" smtClean="0"/>
               <a:t>Click to edit Master text styles</a:t>
             </a:r>
           </a:p>
           <a:p>
             <a:pPr lvl="1"/>
             <a:r>
-              <a:rPr lang="en-US"/>
+              <a:rPr lang="en-US" smtClean="0"/>
               <a:t>Second level</a:t>
             </a:r>
           </a:p>
           <a:p>
             <a:pPr lvl="2"/>
             <a:r>
-              <a:rPr lang="en-US"/>
+              <a:rPr lang="en-US" smtClean="0"/>
               <a:t>Third level</a:t>
             </a:r>
           </a:p>
           <a:p>
             <a:pPr lvl="3"/>
             <a:r>
-              <a:rPr lang="en-US"/>
+              <a:rPr lang="en-US" smtClean="0"/>
               <a:t>Fourth level</a:t>
             </a:r>
           </a:p>
           <a:p>
             <a:pPr lvl="4"/>
             <a:r>
-              <a:rPr lang="en-US"/>
+              <a:rPr lang="en-US" smtClean="0"/>
               <a:t>Fifth level</a:t>
             </a:r>
+            <a:endParaRPr lang="en-US"/>
           </a:p>
         </p:txBody>
       </p:sp>
@@ -2726,7 +2731,7 @@
           <a:p>
             <a:fld id="{5BCAD085-E8A6-8845-BD4E-CB4CCA059FC4}" type="datetimeFigureOut">
               <a:rPr lang="en-US" smtClean="0"/>
-              <a:t>7/19/2026</a:t>
+              <a:t>1/27/13</a:t>
             </a:fld>
             <a:endParaRPr lang="en-US"/>
           </a:p>
@@ -3085,7 +3090,7 @@
 </file>
 
 <file path=ppt/slides/slide1.xml><?xml version="1.0" encoding="utf-8"?>
-<p:sld xmlns:a="http://schemas.openxmlformats.org/drawingml/2006/main" xmlns:r="http://schemas.openxmlformats.org/officeDocument/2006/relationships" xmlns:p="http://schemas.openxmlformats.org/presentationml/2006/main">
+<p:sld xmlns:a="http://schemas.openxmlformats.org/drawingml/2006/main" xmlns:p="http://schemas.openxmlformats.org/presentationml/2006/main" xmlns:r="http://schemas.openxmlformats.org/officeDocument/2006/relationships">
   <p:cSld>
     <p:spTree>
       <p:nvGrpSpPr>
@@ -3093,14 +3098,7 @@
         <p:cNvGrpSpPr/>
         <p:nvPr/>
       </p:nvGrpSpPr>
-      <p:grpSpPr>
-        <a:xfrm>
-          <a:off x="0" y="0"/>
-          <a:ext cx="0" cy="0"/>
-          <a:chOff x="0" y="0"/>
-          <a:chExt cx="0" cy="0"/>
-        </a:xfrm>
-      </p:grpSpPr>
+      <p:grpSpPr/>
       <p:sp>
         <p:nvSpPr>
           <p:cNvPr id="2" name="Rectangle 1"/>
@@ -3141,7 +3139,6 @@
           <a:lstStyle/>
           <a:p>
             <a:pPr algn="ctr"/>
-            <a:endParaRPr/>
           </a:p>
         </p:txBody>
       </p:sp>
@@ -3185,7 +3182,6 @@
           <a:lstStyle/>
           <a:p>
             <a:pPr algn="ctr"/>
-            <a:endParaRPr/>
           </a:p>
         </p:txBody>
       </p:sp>
@@ -3197,8 +3193,8 @@
         </p:nvSpPr>
         <p:spPr>
           <a:xfrm>
-            <a:off x="731520" y="308349"/>
-            <a:ext cx="10515600" cy="1092607"/>
+            <a:off x="731520" y="640080"/>
+            <a:ext cx="10515600" cy="320040"/>
           </a:xfrm>
           <a:prstGeom prst="rect">
             <a:avLst/>
@@ -3211,88 +3207,20 @@
           </a:bodyPr>
           <a:lstStyle/>
           <a:p>
-            <a:pPr algn="ctr">
-              <a:spcAft>
-                <a:spcPts val="300"/>
-              </a:spcAft>
-            </a:pPr>
-            <a:r>
-              <a:rPr sz="1400" b="1" dirty="0">
+            <a:pPr algn="l">
+              <a:spcAft>
+                <a:spcPts val="300"/>
+              </a:spcAft>
+            </a:pPr>
+            <a:r>
+              <a:rPr sz="1200" b="1">
                 <a:solidFill>
                   <a:srgbClr val="239688"/>
                 </a:solidFill>
-                <a:latin typeface="Times New Roman" panose="02020603050405020304" pitchFamily="18" charset="0"/>
-                <a:cs typeface="Times New Roman" panose="02020603050405020304" pitchFamily="18" charset="0"/>
-              </a:rPr>
-              <a:t>EASTERN AFRICA STATISTICAL TRAINING CENTRE  ·  </a:t>
-            </a:r>
-            <a:r>
-              <a:rPr sz="1600" b="1" dirty="0">
-                <a:solidFill>
-                  <a:srgbClr val="239688"/>
-                </a:solidFill>
-                <a:latin typeface="Times New Roman" panose="02020603050405020304" pitchFamily="18" charset="0"/>
-                <a:cs typeface="Times New Roman" panose="02020603050405020304" pitchFamily="18" charset="0"/>
-              </a:rPr>
-              <a:t>CAPSTONE</a:t>
-            </a:r>
-            <a:r>
-              <a:rPr sz="1400" b="1" dirty="0">
-                <a:solidFill>
-                  <a:srgbClr val="239688"/>
-                </a:solidFill>
-                <a:latin typeface="Times New Roman" panose="02020603050405020304" pitchFamily="18" charset="0"/>
-                <a:cs typeface="Times New Roman" panose="02020603050405020304" pitchFamily="18" charset="0"/>
-              </a:rPr>
-              <a:t> PROJECT DEFENCE</a:t>
-            </a:r>
-            <a:endParaRPr lang="en-US" sz="1400" b="1" dirty="0">
-              <a:solidFill>
-                <a:srgbClr val="239688"/>
-              </a:solidFill>
-              <a:latin typeface="Times New Roman" panose="02020603050405020304" pitchFamily="18" charset="0"/>
-              <a:cs typeface="Times New Roman" panose="02020603050405020304" pitchFamily="18" charset="0"/>
-            </a:endParaRPr>
-          </a:p>
-          <a:p>
-            <a:pPr algn="ctr">
-              <a:spcAft>
-                <a:spcPts val="300"/>
-              </a:spcAft>
-            </a:pPr>
-            <a:br>
-              <a:rPr lang="en-US" sz="1400" b="1" dirty="0">
-                <a:solidFill>
-                  <a:srgbClr val="239688"/>
-                </a:solidFill>
-                <a:latin typeface="Times New Roman" panose="02020603050405020304" pitchFamily="18" charset="0"/>
-                <a:cs typeface="Times New Roman" panose="02020603050405020304" pitchFamily="18" charset="0"/>
-              </a:rPr>
-            </a:br>
-            <a:r>
-              <a:rPr lang="en-US" sz="1600" b="0" dirty="0">
-                <a:solidFill>
-                  <a:srgbClr val="B8D0C8"/>
-                </a:solidFill>
-                <a:latin typeface="Times New Roman" panose="02020603050405020304" pitchFamily="18" charset="0"/>
-                <a:cs typeface="Times New Roman" panose="02020603050405020304" pitchFamily="18" charset="0"/>
-              </a:rPr>
-              <a:t>Bachelor of Data Science (Year III)  ·  Academic Year 2025/2026</a:t>
-            </a:r>
-          </a:p>
-          <a:p>
-            <a:pPr algn="ctr">
-              <a:spcAft>
-                <a:spcPts val="300"/>
-              </a:spcAft>
-            </a:pPr>
-            <a:endParaRPr sz="1400" b="1" dirty="0">
-              <a:solidFill>
-                <a:srgbClr val="239688"/>
-              </a:solidFill>
-              <a:latin typeface="Times New Roman" panose="02020603050405020304" pitchFamily="18" charset="0"/>
-              <a:cs typeface="Times New Roman" panose="02020603050405020304" pitchFamily="18" charset="0"/>
-            </a:endParaRPr>
+                <a:latin typeface="Calibri"/>
+              </a:rPr>
+              <a:t>EASTERN AFRICA STATISTICAL TRAINING CENTRE  ·  CAPSTONE PROJECT DEFENCE</a:t>
+            </a:r>
           </a:p>
         </p:txBody>
       </p:sp>
@@ -3304,7 +3232,7 @@
         </p:nvSpPr>
         <p:spPr>
           <a:xfrm>
-            <a:off x="998067" y="1624858"/>
+            <a:off x="731520" y="1143000"/>
             <a:ext cx="10515600" cy="1188720"/>
           </a:xfrm>
           <a:prstGeom prst="rect">
@@ -3324,7 +3252,7 @@
               </a:spcAft>
             </a:pPr>
             <a:r>
-              <a:rPr sz="2800" b="1" dirty="0">
+              <a:rPr sz="2800" b="1">
                 <a:solidFill>
                   <a:srgbClr val="FFFFFF"/>
                 </a:solidFill>
@@ -3340,7 +3268,7 @@
               </a:spcAft>
             </a:pPr>
             <a:r>
-              <a:rPr sz="2800" b="1" dirty="0">
+              <a:rPr sz="2800" b="1">
                 <a:solidFill>
                   <a:srgbClr val="FFFFFF"/>
                 </a:solidFill>
@@ -3356,7 +3284,7 @@
               </a:spcAft>
             </a:pPr>
             <a:r>
-              <a:rPr sz="2800" b="1" dirty="0">
+              <a:rPr sz="2800" b="1">
                 <a:solidFill>
                   <a:srgbClr val="FFFFFF"/>
                 </a:solidFill>
@@ -3375,7 +3303,7 @@
         </p:nvSpPr>
         <p:spPr>
           <a:xfrm>
-            <a:off x="998067" y="3037115"/>
+            <a:off x="731520" y="2514600"/>
             <a:ext cx="10515600" cy="365760"/>
           </a:xfrm>
           <a:prstGeom prst="rect">
@@ -3395,7 +3323,7 @@
               </a:spcAft>
             </a:pPr>
             <a:r>
-              <a:rPr sz="1600" b="0" dirty="0">
+              <a:rPr sz="1600" b="0">
                 <a:solidFill>
                   <a:srgbClr val="E6EEF0"/>
                 </a:solidFill>
@@ -3414,8 +3342,8 @@
         </p:nvSpPr>
         <p:spPr>
           <a:xfrm>
-            <a:off x="838047" y="3917892"/>
-            <a:ext cx="10515600" cy="2062103"/>
+            <a:off x="731520" y="3108960"/>
+            <a:ext cx="10515600" cy="1463040"/>
           </a:xfrm>
           <a:prstGeom prst="rect">
             <a:avLst/>
@@ -3434,136 +3362,93 @@
               </a:spcAft>
             </a:pPr>
             <a:r>
-              <a:rPr sz="1500" b="0" dirty="0">
+              <a:rPr sz="1300" b="0">
                 <a:solidFill>
                   <a:srgbClr val="B8D0C8"/>
                 </a:solidFill>
-                <a:latin typeface="Times New Roman" panose="02020603050405020304" pitchFamily="18" charset="0"/>
-                <a:cs typeface="Times New Roman" panose="02020603050405020304" pitchFamily="18" charset="0"/>
+                <a:latin typeface="Calibri"/>
               </a:rPr>
               <a:t>PRESENTED BY — GROUP 15</a:t>
             </a:r>
           </a:p>
           <a:p>
-            <a:pPr>
-              <a:spcAft>
-                <a:spcPts val="300"/>
-              </a:spcAft>
-            </a:pPr>
-            <a:r>
-              <a:rPr lang="en-US" sz="1500" b="0" dirty="0">
+            <a:pPr algn="l">
+              <a:spcAft>
+                <a:spcPts val="300"/>
+              </a:spcAft>
+            </a:pPr>
+            <a:r>
+              <a:rPr sz="1300" b="0">
                 <a:solidFill>
                   <a:srgbClr val="B8D0C8"/>
                 </a:solidFill>
-                <a:latin typeface="Times New Roman" panose="02020603050405020304" pitchFamily="18" charset="0"/>
-                <a:cs typeface="Times New Roman" panose="02020603050405020304" pitchFamily="18" charset="0"/>
-              </a:rPr>
-              <a:t>Priscila Nestor Mpembela</a:t>
-            </a:r>
-          </a:p>
-          <a:p>
-            <a:pPr algn="l">
-              <a:spcAft>
-                <a:spcPts val="300"/>
-              </a:spcAft>
-            </a:pPr>
-            <a:r>
-              <a:rPr sz="1500" b="0" dirty="0">
+                <a:latin typeface="Calibri"/>
+              </a:rPr>
+              <a:t>Herman Edward Mkumbwa  ·  Raymond Elphance Tungaraza  ·  Edwin Celestin Silayo</a:t>
+            </a:r>
+          </a:p>
+          <a:p>
+            <a:pPr algn="l">
+              <a:spcAft>
+                <a:spcPts val="300"/>
+              </a:spcAft>
+            </a:pPr>
+            <a:r>
+              <a:rPr sz="1300" b="0">
                 <a:solidFill>
                   <a:srgbClr val="B8D0C8"/>
                 </a:solidFill>
-                <a:latin typeface="Times New Roman" panose="02020603050405020304" pitchFamily="18" charset="0"/>
-                <a:cs typeface="Times New Roman" panose="02020603050405020304" pitchFamily="18" charset="0"/>
-              </a:rPr>
-              <a:t>Herman Edward Mkumbwa  </a:t>
-            </a:r>
-            <a:br>
-              <a:rPr lang="en-US" sz="1500" b="0" dirty="0">
+                <a:latin typeface="Calibri"/>
+              </a:rPr>
+              <a:t>Grace Joachim Mohammed  ·  Priscila Nestor Mpembela</a:t>
+            </a:r>
+          </a:p>
+          <a:p>
+            <a:pPr algn="l">
+              <a:spcAft>
+                <a:spcPts val="300"/>
+              </a:spcAft>
+            </a:pPr>
+            <a:r>
+              <a:rPr sz="1300" b="0">
                 <a:solidFill>
                   <a:srgbClr val="B8D0C8"/>
                 </a:solidFill>
-                <a:latin typeface="Times New Roman" panose="02020603050405020304" pitchFamily="18" charset="0"/>
-                <a:cs typeface="Times New Roman" panose="02020603050405020304" pitchFamily="18" charset="0"/>
-              </a:rPr>
-            </a:br>
-            <a:r>
-              <a:rPr sz="1500" b="0" dirty="0">
+                <a:latin typeface="Calibri"/>
+              </a:rPr>
+              <a:t/>
+            </a:r>
+          </a:p>
+          <a:p>
+            <a:pPr algn="l">
+              <a:spcAft>
+                <a:spcPts val="300"/>
+              </a:spcAft>
+            </a:pPr>
+            <a:r>
+              <a:rPr sz="1300" b="0">
                 <a:solidFill>
                   <a:srgbClr val="B8D0C8"/>
                 </a:solidFill>
-                <a:latin typeface="Times New Roman" panose="02020603050405020304" pitchFamily="18" charset="0"/>
-                <a:cs typeface="Times New Roman" panose="02020603050405020304" pitchFamily="18" charset="0"/>
-              </a:rPr>
-              <a:t>Raymond Elphance Tungaraza  </a:t>
-            </a:r>
-            <a:br>
-              <a:rPr lang="en-US" sz="1500" dirty="0">
+                <a:latin typeface="Calibri"/>
+              </a:rPr>
+              <a:t>SUPERVISOR: Mr. Rajabu Msangi</a:t>
+            </a:r>
+          </a:p>
+          <a:p>
+            <a:pPr algn="l">
+              <a:spcAft>
+                <a:spcPts val="300"/>
+              </a:spcAft>
+            </a:pPr>
+            <a:r>
+              <a:rPr sz="1300" b="0">
                 <a:solidFill>
                   <a:srgbClr val="B8D0C8"/>
                 </a:solidFill>
-                <a:latin typeface="Times New Roman" panose="02020603050405020304" pitchFamily="18" charset="0"/>
-                <a:cs typeface="Times New Roman" panose="02020603050405020304" pitchFamily="18" charset="0"/>
-              </a:rPr>
-            </a:br>
-            <a:r>
-              <a:rPr sz="1500" b="0" dirty="0">
-                <a:solidFill>
-                  <a:srgbClr val="B8D0C8"/>
-                </a:solidFill>
-                <a:latin typeface="Times New Roman" panose="02020603050405020304" pitchFamily="18" charset="0"/>
-                <a:cs typeface="Times New Roman" panose="02020603050405020304" pitchFamily="18" charset="0"/>
-              </a:rPr>
-              <a:t>Edwin Celestin Silayo</a:t>
-            </a:r>
-          </a:p>
-          <a:p>
-            <a:pPr algn="l">
-              <a:spcAft>
-                <a:spcPts val="300"/>
-              </a:spcAft>
-            </a:pPr>
-            <a:r>
-              <a:rPr sz="1500" b="0" dirty="0">
-                <a:solidFill>
-                  <a:srgbClr val="B8D0C8"/>
-                </a:solidFill>
-                <a:latin typeface="Times New Roman" panose="02020603050405020304" pitchFamily="18" charset="0"/>
-                <a:cs typeface="Times New Roman" panose="02020603050405020304" pitchFamily="18" charset="0"/>
-              </a:rPr>
-              <a:t>Grace Joachim Mohammed  </a:t>
-            </a:r>
-            <a:br>
-              <a:rPr lang="en-US" sz="1400" dirty="0">
-                <a:solidFill>
-                  <a:srgbClr val="B8D0C8"/>
-                </a:solidFill>
-                <a:latin typeface="Times New Roman" panose="02020603050405020304" pitchFamily="18" charset="0"/>
-                <a:cs typeface="Times New Roman" panose="02020603050405020304" pitchFamily="18" charset="0"/>
-              </a:rPr>
-            </a:br>
-            <a:endParaRPr sz="1400" b="0" dirty="0">
-              <a:solidFill>
-                <a:srgbClr val="B8D0C8"/>
-              </a:solidFill>
-              <a:latin typeface="Times New Roman" panose="02020603050405020304" pitchFamily="18" charset="0"/>
-              <a:cs typeface="Times New Roman" panose="02020603050405020304" pitchFamily="18" charset="0"/>
-            </a:endParaRPr>
-          </a:p>
-          <a:p>
-            <a:pPr algn="ctr">
-              <a:spcAft>
-                <a:spcPts val="300"/>
-              </a:spcAft>
-            </a:pPr>
-            <a:r>
-              <a:rPr sz="1400" b="0" dirty="0">
-                <a:solidFill>
-                  <a:srgbClr val="B8D0C8"/>
-                </a:solidFill>
-                <a:latin typeface="Times New Roman" panose="02020603050405020304" pitchFamily="18" charset="0"/>
-                <a:cs typeface="Times New Roman" panose="02020603050405020304" pitchFamily="18" charset="0"/>
-              </a:rPr>
-              <a:t>SUPERVISOR: Mr. Rajabu Msangi</a:t>
+                <a:latin typeface="Calibri"/>
+              </a:rPr>
+              <a:t>Bachelor of Data Science (Year III)  ·  Academic Year 2025/2026</a:t>
             </a:r>
           </a:p>
         </p:txBody>
@@ -3576,8 +3461,8 @@
         </p:nvSpPr>
         <p:spPr>
           <a:xfrm>
-            <a:off x="424543" y="6439989"/>
-            <a:ext cx="9144000" cy="338554"/>
+            <a:off x="731520" y="6126480"/>
+            <a:ext cx="9144000" cy="274320"/>
           </a:xfrm>
           <a:prstGeom prst="rect">
             <a:avLst/>
@@ -3596,12 +3481,11 @@
               </a:spcAft>
             </a:pPr>
             <a:r>
-              <a:rPr sz="1600" b="0" dirty="0">
+              <a:rPr sz="1100" b="0">
                 <a:solidFill>
                   <a:srgbClr val="9BC4BA"/>
                 </a:solidFill>
-                <a:latin typeface="Times New Roman" panose="02020603050405020304" pitchFamily="18" charset="0"/>
-                <a:cs typeface="Times New Roman" panose="02020603050405020304" pitchFamily="18" charset="0"/>
+                <a:latin typeface="Calibri"/>
               </a:rPr>
               <a:t>Live portal: ushirika-sme-portal.vercel.app   ·   API: ushirika-api.onrender.com</a:t>
             </a:r>
@@ -3656,7 +3540,7 @@
 </file>
 
 <file path=ppt/slides/slide10.xml><?xml version="1.0" encoding="utf-8"?>
-<p:sld xmlns:a="http://schemas.openxmlformats.org/drawingml/2006/main" xmlns:r="http://schemas.openxmlformats.org/officeDocument/2006/relationships" xmlns:p="http://schemas.openxmlformats.org/presentationml/2006/main">
+<p:sld xmlns:a="http://schemas.openxmlformats.org/drawingml/2006/main" xmlns:p="http://schemas.openxmlformats.org/presentationml/2006/main" xmlns:r="http://schemas.openxmlformats.org/officeDocument/2006/relationships">
   <p:cSld>
     <p:spTree>
       <p:nvGrpSpPr>
@@ -3664,14 +3548,7 @@
         <p:cNvGrpSpPr/>
         <p:nvPr/>
       </p:nvGrpSpPr>
-      <p:grpSpPr>
-        <a:xfrm>
-          <a:off x="0" y="0"/>
-          <a:ext cx="0" cy="0"/>
-          <a:chOff x="0" y="0"/>
-          <a:chExt cx="0" cy="0"/>
-        </a:xfrm>
-      </p:grpSpPr>
+      <p:grpSpPr/>
       <p:sp>
         <p:nvSpPr>
           <p:cNvPr id="2" name="Rectangle 1"/>
@@ -3712,7 +3589,6 @@
           <a:lstStyle/>
           <a:p>
             <a:pPr algn="ctr"/>
-            <a:endParaRPr/>
           </a:p>
         </p:txBody>
       </p:sp>
@@ -3795,7 +3671,6 @@
           <a:lstStyle/>
           <a:p>
             <a:pPr algn="ctr"/>
-            <a:endParaRPr/>
           </a:p>
         </p:txBody>
       </p:sp>
@@ -3880,7 +3755,6 @@
           <a:lstStyle/>
           <a:p>
             <a:pPr algn="ctr"/>
-            <a:endParaRPr/>
           </a:p>
         </p:txBody>
       </p:sp>
@@ -3924,7 +3798,6 @@
           <a:lstStyle/>
           <a:p>
             <a:pPr algn="ctr"/>
-            <a:endParaRPr/>
           </a:p>
         </p:txBody>
       </p:sp>
@@ -4087,7 +3960,6 @@
           <a:lstStyle/>
           <a:p>
             <a:pPr algn="ctr"/>
-            <a:endParaRPr/>
           </a:p>
         </p:txBody>
       </p:sp>
@@ -4172,7 +4044,6 @@
           <a:lstStyle/>
           <a:p>
             <a:pPr algn="ctr"/>
-            <a:endParaRPr/>
           </a:p>
         </p:txBody>
       </p:sp>
@@ -4216,7 +4087,6 @@
           <a:lstStyle/>
           <a:p>
             <a:pPr algn="ctr"/>
-            <a:endParaRPr/>
           </a:p>
         </p:txBody>
       </p:sp>
@@ -4379,7 +4249,6 @@
           <a:lstStyle/>
           <a:p>
             <a:pPr algn="ctr"/>
-            <a:endParaRPr/>
           </a:p>
         </p:txBody>
       </p:sp>
@@ -4464,7 +4333,6 @@
           <a:lstStyle/>
           <a:p>
             <a:pPr algn="ctr"/>
-            <a:endParaRPr/>
           </a:p>
         </p:txBody>
       </p:sp>
@@ -4508,7 +4376,6 @@
           <a:lstStyle/>
           <a:p>
             <a:pPr algn="ctr"/>
-            <a:endParaRPr/>
           </a:p>
         </p:txBody>
       </p:sp>
@@ -4671,7 +4538,6 @@
           <a:lstStyle/>
           <a:p>
             <a:pPr algn="ctr"/>
-            <a:endParaRPr/>
           </a:p>
         </p:txBody>
       </p:sp>
@@ -4754,7 +4620,6 @@
           <a:lstStyle/>
           <a:p>
             <a:pPr algn="ctr"/>
-            <a:endParaRPr/>
           </a:p>
         </p:txBody>
       </p:sp>
@@ -4786,7 +4651,7 @@
               </a:spcAft>
             </a:pPr>
             <a:r>
-              <a:rPr sz="1000" b="0" dirty="0">
+              <a:rPr sz="1000" b="0">
                 <a:solidFill>
                   <a:srgbClr val="B8D0C8"/>
                 </a:solidFill>
@@ -4845,7 +4710,7 @@
 </file>
 
 <file path=ppt/slides/slide11.xml><?xml version="1.0" encoding="utf-8"?>
-<p:sld xmlns:a="http://schemas.openxmlformats.org/drawingml/2006/main" xmlns:r="http://schemas.openxmlformats.org/officeDocument/2006/relationships" xmlns:p="http://schemas.openxmlformats.org/presentationml/2006/main">
+<p:sld xmlns:a="http://schemas.openxmlformats.org/drawingml/2006/main" xmlns:p="http://schemas.openxmlformats.org/presentationml/2006/main" xmlns:r="http://schemas.openxmlformats.org/officeDocument/2006/relationships">
   <p:cSld>
     <p:spTree>
       <p:nvGrpSpPr>
@@ -4853,14 +4718,7 @@
         <p:cNvGrpSpPr/>
         <p:nvPr/>
       </p:nvGrpSpPr>
-      <p:grpSpPr>
-        <a:xfrm>
-          <a:off x="0" y="0"/>
-          <a:ext cx="0" cy="0"/>
-          <a:chOff x="0" y="0"/>
-          <a:chExt cx="0" cy="0"/>
-        </a:xfrm>
-      </p:grpSpPr>
+      <p:grpSpPr/>
       <p:sp>
         <p:nvSpPr>
           <p:cNvPr id="2" name="Rectangle 1"/>
@@ -4901,7 +4759,6 @@
           <a:lstStyle/>
           <a:p>
             <a:pPr algn="ctr"/>
-            <a:endParaRPr/>
           </a:p>
         </p:txBody>
       </p:sp>
@@ -4984,7 +4841,6 @@
           <a:lstStyle/>
           <a:p>
             <a:pPr algn="ctr"/>
-            <a:endParaRPr/>
           </a:p>
         </p:txBody>
       </p:sp>
@@ -5069,7 +4925,6 @@
           <a:lstStyle/>
           <a:p>
             <a:pPr algn="ctr"/>
-            <a:endParaRPr/>
           </a:p>
         </p:txBody>
       </p:sp>
@@ -5143,7 +4998,7 @@
               </a:spcAft>
             </a:pPr>
             <a:r>
-              <a:rPr sz="1300" b="0" dirty="0">
+              <a:rPr sz="1300" b="0">
                 <a:solidFill>
                   <a:srgbClr val="0F2830"/>
                 </a:solidFill>
@@ -5162,7 +5017,7 @@
               </a:spcAft>
             </a:pPr>
             <a:r>
-              <a:rPr sz="1300" b="0" dirty="0">
+              <a:rPr sz="1300" b="0">
                 <a:solidFill>
                   <a:srgbClr val="0F2830"/>
                 </a:solidFill>
@@ -5181,7 +5036,7 @@
               </a:spcAft>
             </a:pPr>
             <a:r>
-              <a:rPr sz="1300" b="0" dirty="0">
+              <a:rPr sz="1300" b="0">
                 <a:solidFill>
                   <a:srgbClr val="0F2830"/>
                 </a:solidFill>
@@ -5200,31 +5055,13 @@
               </a:spcAft>
             </a:pPr>
             <a:r>
-              <a:rPr sz="1300" b="0" dirty="0">
+              <a:rPr sz="1300" b="0">
                 <a:solidFill>
                   <a:srgbClr val="0F2830"/>
                 </a:solidFill>
                 <a:latin typeface="Calibri"/>
               </a:rPr>
-              <a:t>•  Altman tradition extended: from static ratios to dynamic </a:t>
-            </a:r>
-            <a:r>
-              <a:rPr sz="1300" b="0" dirty="0" err="1">
-                <a:solidFill>
-                  <a:srgbClr val="0F2830"/>
-                </a:solidFill>
-                <a:latin typeface="Calibri"/>
-              </a:rPr>
-              <a:t>behavioural</a:t>
-            </a:r>
-            <a:r>
-              <a:rPr sz="1300" b="0" dirty="0">
-                <a:solidFill>
-                  <a:srgbClr val="0F2830"/>
-                </a:solidFill>
-                <a:latin typeface="Calibri"/>
-              </a:rPr>
-              <a:t> classification.</a:t>
+              <a:t>•  Altman tradition extended: from static ratios to dynamic behavioural classification.</a:t>
             </a:r>
           </a:p>
         </p:txBody>
@@ -5271,7 +5108,6 @@
           <a:lstStyle/>
           <a:p>
             <a:pPr algn="ctr"/>
-            <a:endParaRPr/>
           </a:p>
         </p:txBody>
       </p:sp>
@@ -5472,7 +5308,6 @@
           <a:lstStyle/>
           <a:p>
             <a:pPr algn="ctr"/>
-            <a:endParaRPr/>
           </a:p>
         </p:txBody>
       </p:sp>
@@ -5504,7 +5339,7 @@
               </a:spcAft>
             </a:pPr>
             <a:r>
-              <a:rPr sz="1000" b="0" dirty="0">
+              <a:rPr sz="1000" b="0">
                 <a:solidFill>
                   <a:srgbClr val="B8D0C8"/>
                 </a:solidFill>
@@ -5563,7 +5398,7 @@
 </file>
 
 <file path=ppt/slides/slide12.xml><?xml version="1.0" encoding="utf-8"?>
-<p:sld xmlns:a="http://schemas.openxmlformats.org/drawingml/2006/main" xmlns:r="http://schemas.openxmlformats.org/officeDocument/2006/relationships" xmlns:p="http://schemas.openxmlformats.org/presentationml/2006/main">
+<p:sld xmlns:a="http://schemas.openxmlformats.org/drawingml/2006/main" xmlns:p="http://schemas.openxmlformats.org/presentationml/2006/main" xmlns:r="http://schemas.openxmlformats.org/officeDocument/2006/relationships">
   <p:cSld>
     <p:spTree>
       <p:nvGrpSpPr>
@@ -5571,14 +5406,7 @@
         <p:cNvGrpSpPr/>
         <p:nvPr/>
       </p:nvGrpSpPr>
-      <p:grpSpPr>
-        <a:xfrm>
-          <a:off x="0" y="0"/>
-          <a:ext cx="0" cy="0"/>
-          <a:chOff x="0" y="0"/>
-          <a:chExt cx="0" cy="0"/>
-        </a:xfrm>
-      </p:grpSpPr>
+      <p:grpSpPr/>
       <p:sp>
         <p:nvSpPr>
           <p:cNvPr id="2" name="Rectangle 1"/>
@@ -5619,7 +5447,6 @@
           <a:lstStyle/>
           <a:p>
             <a:pPr algn="ctr"/>
-            <a:endParaRPr/>
           </a:p>
         </p:txBody>
       </p:sp>
@@ -5663,7 +5490,6 @@
           <a:lstStyle/>
           <a:p>
             <a:pPr algn="ctr"/>
-            <a:endParaRPr/>
           </a:p>
         </p:txBody>
       </p:sp>
@@ -5773,67 +5599,13 @@
               </a:spcAft>
             </a:pPr>
             <a:r>
-              <a:rPr sz="1500" b="0" dirty="0">
+              <a:rPr sz="1500" b="0">
                 <a:solidFill>
                   <a:srgbClr val="E6EEF0"/>
                 </a:solidFill>
                 <a:latin typeface="Calibri"/>
               </a:rPr>
-              <a:t>Ushirika is a working prototype that turns supply-chain transactions into objective credit scores — with real train/test ML, RF vs LR evidence, and a live portal for </a:t>
-            </a:r>
-            <a:r>
-              <a:rPr sz="1500" b="0" dirty="0" err="1">
-                <a:solidFill>
-                  <a:srgbClr val="E6EEF0"/>
-                </a:solidFill>
-                <a:latin typeface="Calibri"/>
-              </a:rPr>
-              <a:t>Mfanyabiashara</a:t>
-            </a:r>
-            <a:r>
-              <a:rPr sz="1500" b="0" dirty="0">
-                <a:solidFill>
-                  <a:srgbClr val="E6EEF0"/>
-                </a:solidFill>
-                <a:latin typeface="Calibri"/>
-              </a:rPr>
-              <a:t>, </a:t>
-            </a:r>
-            <a:r>
-              <a:rPr sz="1500" b="0" dirty="0" err="1">
-                <a:solidFill>
-                  <a:srgbClr val="E6EEF0"/>
-                </a:solidFill>
-                <a:latin typeface="Calibri"/>
-              </a:rPr>
-              <a:t>Afisa</a:t>
-            </a:r>
-            <a:r>
-              <a:rPr sz="1500" b="0" dirty="0">
-                <a:solidFill>
-                  <a:srgbClr val="E6EEF0"/>
-                </a:solidFill>
-                <a:latin typeface="Calibri"/>
-              </a:rPr>
-              <a:t> </a:t>
-            </a:r>
-            <a:r>
-              <a:rPr sz="1500" b="0" dirty="0" err="1">
-                <a:solidFill>
-                  <a:srgbClr val="E6EEF0"/>
-                </a:solidFill>
-                <a:latin typeface="Calibri"/>
-              </a:rPr>
-              <a:t>mikopo</a:t>
-            </a:r>
-            <a:r>
-              <a:rPr sz="1500" b="0" dirty="0">
-                <a:solidFill>
-                  <a:srgbClr val="E6EEF0"/>
-                </a:solidFill>
-                <a:latin typeface="Calibri"/>
-              </a:rPr>
-              <a:t>, and Admin.</a:t>
+              <a:t>Ushirika is a working prototype that turns supply-chain transactions into objective credit scores — with real train/test ML, RF vs LR evidence, and a live portal for Mfanyabiashara, Afisa mikopo, and Admin.</a:t>
             </a:r>
           </a:p>
         </p:txBody>
@@ -6159,7 +5931,7 @@
 </file>
 
 <file path=ppt/slides/slide2.xml><?xml version="1.0" encoding="utf-8"?>
-<p:sld xmlns:a="http://schemas.openxmlformats.org/drawingml/2006/main" xmlns:r="http://schemas.openxmlformats.org/officeDocument/2006/relationships" xmlns:p="http://schemas.openxmlformats.org/presentationml/2006/main">
+<p:sld xmlns:a="http://schemas.openxmlformats.org/drawingml/2006/main" xmlns:p="http://schemas.openxmlformats.org/presentationml/2006/main" xmlns:r="http://schemas.openxmlformats.org/officeDocument/2006/relationships">
   <p:cSld>
     <p:spTree>
       <p:nvGrpSpPr>
@@ -6167,14 +5939,7 @@
         <p:cNvGrpSpPr/>
         <p:nvPr/>
       </p:nvGrpSpPr>
-      <p:grpSpPr>
-        <a:xfrm>
-          <a:off x="0" y="0"/>
-          <a:ext cx="0" cy="0"/>
-          <a:chOff x="0" y="0"/>
-          <a:chExt cx="0" cy="0"/>
-        </a:xfrm>
-      </p:grpSpPr>
+      <p:grpSpPr/>
       <p:sp>
         <p:nvSpPr>
           <p:cNvPr id="2" name="Rectangle 1"/>
@@ -6215,7 +5980,6 @@
           <a:lstStyle/>
           <a:p>
             <a:pPr algn="ctr"/>
-            <a:endParaRPr/>
           </a:p>
         </p:txBody>
       </p:sp>
@@ -6228,7 +5992,7 @@
         <p:spPr>
           <a:xfrm>
             <a:off x="502920" y="256032"/>
-            <a:ext cx="10972800" cy="307777"/>
+            <a:ext cx="10972800" cy="256032"/>
           </a:xfrm>
           <a:prstGeom prst="rect">
             <a:avLst/>
@@ -6247,12 +6011,11 @@
               </a:spcAft>
             </a:pPr>
             <a:r>
-              <a:rPr sz="1400" b="1">
+              <a:rPr sz="1200" b="1">
                 <a:solidFill>
                   <a:srgbClr val="1A7A6D"/>
                 </a:solidFill>
-                <a:latin typeface="Times New Roman" panose="02020603050405020304" pitchFamily="18" charset="0"/>
-                <a:cs typeface="Times New Roman" panose="02020603050405020304" pitchFamily="18" charset="0"/>
+                <a:latin typeface="Calibri"/>
               </a:rPr>
               <a:t>BACKGROUND</a:t>
             </a:r>
@@ -6299,7 +6062,6 @@
           <a:lstStyle/>
           <a:p>
             <a:pPr algn="ctr"/>
-            <a:endParaRPr/>
           </a:p>
         </p:txBody>
       </p:sp>
@@ -6331,13 +6093,52 @@
               </a:spcAft>
             </a:pPr>
             <a:r>
-              <a:rPr sz="2600" b="1" dirty="0">
+              <a:rPr sz="2600" b="1">
                 <a:solidFill>
                   <a:srgbClr val="0B3D2E"/>
                 </a:solidFill>
                 <a:latin typeface="Georgia"/>
               </a:rPr>
-              <a:t>The problem this project set out to solve</a:t>
+              <a:t>Why Tanzanian SMEs still struggle to get fair credit</a:t>
+            </a:r>
+          </a:p>
+        </p:txBody>
+      </p:sp>
+      <p:sp>
+        <p:nvSpPr>
+          <p:cNvPr id="6" name="TextBox 5"/>
+          <p:cNvSpPr txBox="1"/>
+          <p:nvPr/>
+        </p:nvSpPr>
+        <p:spPr>
+          <a:xfrm>
+            <a:off x="502920" y="1051560"/>
+            <a:ext cx="11155680" cy="320040"/>
+          </a:xfrm>
+          <a:prstGeom prst="rect">
+            <a:avLst/>
+          </a:prstGeom>
+          <a:noFill/>
+        </p:spPr>
+        <p:txBody>
+          <a:bodyPr wrap="square">
+            <a:spAutoFit/>
+          </a:bodyPr>
+          <a:lstStyle/>
+          <a:p>
+            <a:pPr algn="l">
+              <a:spcAft>
+                <a:spcPts val="300"/>
+              </a:spcAft>
+            </a:pPr>
+            <a:r>
+              <a:rPr sz="1300" b="0">
+                <a:solidFill>
+                  <a:srgbClr val="4A5E66"/>
+                </a:solidFill>
+                <a:latin typeface="Calibri"/>
+              </a:rPr>
+              <a:t>Grounded in the Group 15 problem statement (Section 1.2)</a:t>
             </a:r>
           </a:p>
         </p:txBody>
@@ -6350,7 +6151,7 @@
         </p:nvSpPr>
         <p:spPr>
           <a:xfrm>
-            <a:off x="457200" y="1534886"/>
+            <a:off x="457200" y="1554480"/>
             <a:ext cx="5532120" cy="1965960"/>
           </a:xfrm>
           <a:prstGeom prst="roundRect">
@@ -6384,7 +6185,6 @@
           <a:lstStyle/>
           <a:p>
             <a:pPr algn="ctr"/>
-            <a:endParaRPr sz="3600" dirty="0"/>
           </a:p>
         </p:txBody>
       </p:sp>
@@ -6428,7 +6228,6 @@
           <a:lstStyle/>
           <a:p>
             <a:pPr algn="ctr"/>
-            <a:endParaRPr/>
           </a:p>
         </p:txBody>
       </p:sp>
@@ -6460,7 +6259,7 @@
               </a:spcAft>
             </a:pPr>
             <a:r>
-              <a:rPr sz="1800" b="1" dirty="0">
+              <a:rPr sz="1800" b="1">
                 <a:solidFill>
                   <a:srgbClr val="1A7A6D"/>
                 </a:solidFill>
@@ -6480,7 +6279,7 @@
         <p:spPr>
           <a:xfrm>
             <a:off x="1554480" y="1828800"/>
-            <a:ext cx="4114800" cy="338554"/>
+            <a:ext cx="4114800" cy="320040"/>
           </a:xfrm>
           <a:prstGeom prst="rect">
             <a:avLst/>
@@ -6499,7 +6298,7 @@
               </a:spcAft>
             </a:pPr>
             <a:r>
-              <a:rPr sz="1600" b="1" dirty="0">
+              <a:rPr sz="1600" b="1">
                 <a:solidFill>
                   <a:srgbClr val="0B3D2E"/>
                 </a:solidFill>
@@ -6518,8 +6317,8 @@
         </p:nvSpPr>
         <p:spPr>
           <a:xfrm>
-            <a:off x="731520" y="2285999"/>
-            <a:ext cx="4846320" cy="584775"/>
+            <a:off x="822960" y="2331720"/>
+            <a:ext cx="4846320" cy="914400"/>
           </a:xfrm>
           <a:prstGeom prst="rect">
             <a:avLst/>
@@ -6538,7 +6337,7 @@
               </a:spcAft>
             </a:pPr>
             <a:r>
-              <a:rPr sz="1600" b="0" dirty="0">
+              <a:rPr sz="1300" b="0">
                 <a:solidFill>
                   <a:srgbClr val="4A5E66"/>
                 </a:solidFill>
@@ -6591,7 +6390,6 @@
           <a:lstStyle/>
           <a:p>
             <a:pPr algn="ctr"/>
-            <a:endParaRPr/>
           </a:p>
         </p:txBody>
       </p:sp>
@@ -6635,7 +6433,6 @@
           <a:lstStyle/>
           <a:p>
             <a:pPr algn="ctr"/>
-            <a:endParaRPr/>
           </a:p>
         </p:txBody>
       </p:sp>
@@ -6706,7 +6503,7 @@
               </a:spcAft>
             </a:pPr>
             <a:r>
-              <a:rPr sz="1600" b="1" dirty="0">
+              <a:rPr sz="1600" b="1">
                 <a:solidFill>
                   <a:srgbClr val="0B3D2E"/>
                 </a:solidFill>
@@ -6726,7 +6523,7 @@
         <p:spPr>
           <a:xfrm>
             <a:off x="6629400" y="2331720"/>
-            <a:ext cx="4846320" cy="584775"/>
+            <a:ext cx="4846320" cy="914400"/>
           </a:xfrm>
           <a:prstGeom prst="rect">
             <a:avLst/>
@@ -6745,7 +6542,7 @@
               </a:spcAft>
             </a:pPr>
             <a:r>
-              <a:rPr sz="1600" b="0" dirty="0">
+              <a:rPr sz="1300" b="0">
                 <a:solidFill>
                   <a:srgbClr val="4A5E66"/>
                 </a:solidFill>
@@ -6798,7 +6595,6 @@
           <a:lstStyle/>
           <a:p>
             <a:pPr algn="ctr"/>
-            <a:endParaRPr/>
           </a:p>
         </p:txBody>
       </p:sp>
@@ -6842,7 +6638,6 @@
           <a:lstStyle/>
           <a:p>
             <a:pPr algn="ctr"/>
-            <a:endParaRPr/>
           </a:p>
         </p:txBody>
       </p:sp>
@@ -6913,7 +6708,7 @@
               </a:spcAft>
             </a:pPr>
             <a:r>
-              <a:rPr sz="1600" b="1" dirty="0">
+              <a:rPr sz="1600" b="1">
                 <a:solidFill>
                   <a:srgbClr val="0B3D2E"/>
                 </a:solidFill>
@@ -6933,7 +6728,7 @@
         <p:spPr>
           <a:xfrm>
             <a:off x="822960" y="4526279"/>
-            <a:ext cx="4846320" cy="584775"/>
+            <a:ext cx="4846320" cy="914400"/>
           </a:xfrm>
           <a:prstGeom prst="rect">
             <a:avLst/>
@@ -6952,7 +6747,7 @@
               </a:spcAft>
             </a:pPr>
             <a:r>
-              <a:rPr sz="1600" b="0" dirty="0">
+              <a:rPr sz="1300" b="0">
                 <a:solidFill>
                   <a:srgbClr val="4A5E66"/>
                 </a:solidFill>
@@ -7005,7 +6800,6 @@
           <a:lstStyle/>
           <a:p>
             <a:pPr algn="ctr"/>
-            <a:endParaRPr/>
           </a:p>
         </p:txBody>
       </p:sp>
@@ -7049,7 +6843,6 @@
           <a:lstStyle/>
           <a:p>
             <a:pPr algn="ctr"/>
-            <a:endParaRPr/>
           </a:p>
         </p:txBody>
       </p:sp>
@@ -7120,7 +6913,7 @@
               </a:spcAft>
             </a:pPr>
             <a:r>
-              <a:rPr sz="1600" b="1" dirty="0">
+              <a:rPr sz="1600" b="1">
                 <a:solidFill>
                   <a:srgbClr val="0B3D2E"/>
                 </a:solidFill>
@@ -7140,7 +6933,7 @@
         <p:spPr>
           <a:xfrm>
             <a:off x="6629400" y="4526279"/>
-            <a:ext cx="4846320" cy="584775"/>
+            <a:ext cx="4846320" cy="914400"/>
           </a:xfrm>
           <a:prstGeom prst="rect">
             <a:avLst/>
@@ -7159,7 +6952,7 @@
               </a:spcAft>
             </a:pPr>
             <a:r>
-              <a:rPr sz="1600" b="0" dirty="0">
+              <a:rPr sz="1300" b="0">
                 <a:solidFill>
                   <a:srgbClr val="4A5E66"/>
                 </a:solidFill>
@@ -7210,7 +7003,6 @@
           <a:lstStyle/>
           <a:p>
             <a:pPr algn="ctr"/>
-            <a:endParaRPr/>
           </a:p>
         </p:txBody>
       </p:sp>
@@ -7242,7 +7034,7 @@
               </a:spcAft>
             </a:pPr>
             <a:r>
-              <a:rPr sz="1000" b="0" dirty="0">
+              <a:rPr sz="1000" b="0">
                 <a:solidFill>
                   <a:srgbClr val="B8D0C8"/>
                 </a:solidFill>
@@ -7301,7 +7093,7 @@
 </file>
 
 <file path=ppt/slides/slide3.xml><?xml version="1.0" encoding="utf-8"?>
-<p:sld xmlns:a="http://schemas.openxmlformats.org/drawingml/2006/main" xmlns:r="http://schemas.openxmlformats.org/officeDocument/2006/relationships" xmlns:p="http://schemas.openxmlformats.org/presentationml/2006/main">
+<p:sld xmlns:a="http://schemas.openxmlformats.org/drawingml/2006/main" xmlns:p="http://schemas.openxmlformats.org/presentationml/2006/main" xmlns:r="http://schemas.openxmlformats.org/officeDocument/2006/relationships">
   <p:cSld>
     <p:spTree>
       <p:nvGrpSpPr>
@@ -7309,14 +7101,7 @@
         <p:cNvGrpSpPr/>
         <p:nvPr/>
       </p:nvGrpSpPr>
-      <p:grpSpPr>
-        <a:xfrm>
-          <a:off x="0" y="0"/>
-          <a:ext cx="0" cy="0"/>
-          <a:chOff x="0" y="0"/>
-          <a:chExt cx="0" cy="0"/>
-        </a:xfrm>
-      </p:grpSpPr>
+      <p:grpSpPr/>
       <p:sp>
         <p:nvSpPr>
           <p:cNvPr id="2" name="Rectangle 1"/>
@@ -7357,7 +7142,6 @@
           <a:lstStyle/>
           <a:p>
             <a:pPr algn="ctr"/>
-            <a:endParaRPr/>
           </a:p>
         </p:txBody>
       </p:sp>
@@ -7370,7 +7154,7 @@
         <p:spPr>
           <a:xfrm>
             <a:off x="502920" y="256032"/>
-            <a:ext cx="10972800" cy="276999"/>
+            <a:ext cx="10972800" cy="256032"/>
           </a:xfrm>
           <a:prstGeom prst="rect">
             <a:avLst/>
@@ -7389,7 +7173,7 @@
               </a:spcAft>
             </a:pPr>
             <a:r>
-              <a:rPr sz="1200" b="1" dirty="0">
+              <a:rPr sz="1200" b="1">
                 <a:solidFill>
                   <a:srgbClr val="1A7A6D"/>
                 </a:solidFill>
@@ -7440,7 +7224,6 @@
           <a:lstStyle/>
           <a:p>
             <a:pPr algn="ctr"/>
-            <a:endParaRPr/>
           </a:p>
         </p:txBody>
       </p:sp>
@@ -7472,13 +7255,13 @@
               </a:spcAft>
             </a:pPr>
             <a:r>
-              <a:rPr sz="2600" b="1" dirty="0">
+              <a:rPr sz="2600" b="1">
                 <a:solidFill>
                   <a:srgbClr val="0B3D2E"/>
                 </a:solidFill>
                 <a:latin typeface="Georgia"/>
               </a:rPr>
-              <a:t>General objective and three specific objectives</a:t>
+              <a:t>What we set out to build — in clear terms</a:t>
             </a:r>
           </a:p>
         </p:txBody>
@@ -7525,7 +7308,6 @@
           <a:lstStyle/>
           <a:p>
             <a:pPr algn="ctr"/>
-            <a:endParaRPr/>
           </a:p>
         </p:txBody>
       </p:sp>
@@ -7538,7 +7320,7 @@
         <p:spPr>
           <a:xfrm>
             <a:off x="685800" y="1645920"/>
-            <a:ext cx="10789920" cy="292388"/>
+            <a:ext cx="10789920" cy="274320"/>
           </a:xfrm>
           <a:prstGeom prst="rect">
             <a:avLst/>
@@ -7557,7 +7339,7 @@
               </a:spcAft>
             </a:pPr>
             <a:r>
-              <a:rPr sz="1300" b="1" dirty="0">
+              <a:rPr sz="1100" b="1">
                 <a:solidFill>
                   <a:srgbClr val="1A7A6D"/>
                 </a:solidFill>
@@ -7577,7 +7359,7 @@
         <p:spPr>
           <a:xfrm>
             <a:off x="685800" y="1965960"/>
-            <a:ext cx="10789920" cy="584775"/>
+            <a:ext cx="10789920" cy="640080"/>
           </a:xfrm>
           <a:prstGeom prst="rect">
             <a:avLst/>
@@ -7596,7 +7378,7 @@
               </a:spcAft>
             </a:pPr>
             <a:r>
-              <a:rPr sz="1600" b="0" dirty="0">
+              <a:rPr sz="1400" b="0">
                 <a:solidFill>
                   <a:srgbClr val="0F2830"/>
                 </a:solidFill>
@@ -7649,7 +7431,6 @@
           <a:lstStyle/>
           <a:p>
             <a:pPr algn="ctr"/>
-            <a:endParaRPr/>
           </a:p>
         </p:txBody>
       </p:sp>
@@ -7693,7 +7474,6 @@
           <a:lstStyle/>
           <a:p>
             <a:pPr algn="ctr"/>
-            <a:endParaRPr/>
           </a:p>
         </p:txBody>
       </p:sp>
@@ -7725,7 +7505,7 @@
               </a:spcAft>
             </a:pPr>
             <a:r>
-              <a:rPr b="1" dirty="0">
+              <a:rPr sz="1400" b="1">
                 <a:solidFill>
                   <a:srgbClr val="FFFFFF"/>
                 </a:solidFill>
@@ -7745,7 +7525,7 @@
         <p:spPr>
           <a:xfrm>
             <a:off x="731520" y="3840480"/>
-            <a:ext cx="3108960" cy="830997"/>
+            <a:ext cx="3108960" cy="1645920"/>
           </a:xfrm>
           <a:prstGeom prst="rect">
             <a:avLst/>
@@ -7764,7 +7544,7 @@
               </a:spcAft>
             </a:pPr>
             <a:r>
-              <a:rPr sz="1600" b="0" dirty="0">
+              <a:rPr sz="1300" b="0">
                 <a:solidFill>
                   <a:srgbClr val="0F2830"/>
                 </a:solidFill>
@@ -7817,7 +7597,6 @@
           <a:lstStyle/>
           <a:p>
             <a:pPr algn="ctr"/>
-            <a:endParaRPr/>
           </a:p>
         </p:txBody>
       </p:sp>
@@ -7861,7 +7640,6 @@
           <a:lstStyle/>
           <a:p>
             <a:pPr algn="ctr"/>
-            <a:endParaRPr/>
           </a:p>
         </p:txBody>
       </p:sp>
@@ -7893,31 +7671,13 @@
               </a:spcAft>
             </a:pPr>
             <a:r>
-              <a:rPr sz="1400" b="1" dirty="0">
+              <a:rPr sz="1400" b="1">
                 <a:solidFill>
                   <a:srgbClr val="FFFFFF"/>
                 </a:solidFill>
                 <a:latin typeface="Calibri"/>
               </a:rPr>
-              <a:t>02  </a:t>
-            </a:r>
-            <a:r>
-              <a:rPr b="1" dirty="0">
-                <a:solidFill>
-                  <a:srgbClr val="FFFFFF"/>
-                </a:solidFill>
-                <a:latin typeface="Calibri"/>
-              </a:rPr>
-              <a:t>Compare</a:t>
-            </a:r>
-            <a:r>
-              <a:rPr sz="1400" b="1" dirty="0">
-                <a:solidFill>
-                  <a:srgbClr val="FFFFFF"/>
-                </a:solidFill>
-                <a:latin typeface="Calibri"/>
-              </a:rPr>
-              <a:t> ML vs classical</a:t>
+              <a:t>02  Compare ML vs classical</a:t>
             </a:r>
           </a:p>
         </p:txBody>
@@ -7931,7 +7691,7 @@
         <p:spPr>
           <a:xfrm>
             <a:off x="4572000" y="3840480"/>
-            <a:ext cx="3108960" cy="830997"/>
+            <a:ext cx="3108960" cy="1645920"/>
           </a:xfrm>
           <a:prstGeom prst="rect">
             <a:avLst/>
@@ -7950,7 +7710,7 @@
               </a:spcAft>
             </a:pPr>
             <a:r>
-              <a:rPr sz="1600" b="0">
+              <a:rPr sz="1300" b="0">
                 <a:solidFill>
                   <a:srgbClr val="0F2830"/>
                 </a:solidFill>
@@ -8003,7 +7763,6 @@
           <a:lstStyle/>
           <a:p>
             <a:pPr algn="ctr"/>
-            <a:endParaRPr/>
           </a:p>
         </p:txBody>
       </p:sp>
@@ -8047,7 +7806,6 @@
           <a:lstStyle/>
           <a:p>
             <a:pPr algn="ctr"/>
-            <a:endParaRPr/>
           </a:p>
         </p:txBody>
       </p:sp>
@@ -8079,31 +7837,13 @@
               </a:spcAft>
             </a:pPr>
             <a:r>
-              <a:rPr sz="1400" b="1" dirty="0">
+              <a:rPr sz="1400" b="1">
                 <a:solidFill>
                   <a:srgbClr val="FFFFFF"/>
                 </a:solidFill>
                 <a:latin typeface="Calibri"/>
               </a:rPr>
-              <a:t>03  </a:t>
-            </a:r>
-            <a:r>
-              <a:rPr b="1" dirty="0">
-                <a:solidFill>
-                  <a:srgbClr val="FFFFFF"/>
-                </a:solidFill>
-                <a:latin typeface="Calibri"/>
-              </a:rPr>
-              <a:t>Validate</a:t>
-            </a:r>
-            <a:r>
-              <a:rPr sz="1400" b="1" dirty="0">
-                <a:solidFill>
-                  <a:srgbClr val="FFFFFF"/>
-                </a:solidFill>
-                <a:latin typeface="Calibri"/>
-              </a:rPr>
-              <a:t> with metrics</a:t>
+              <a:t>03  Validate with metrics</a:t>
             </a:r>
           </a:p>
         </p:txBody>
@@ -8117,7 +7857,7 @@
         <p:spPr>
           <a:xfrm>
             <a:off x="8412480" y="3840480"/>
-            <a:ext cx="3108960" cy="584775"/>
+            <a:ext cx="3108960" cy="1645920"/>
           </a:xfrm>
           <a:prstGeom prst="rect">
             <a:avLst/>
@@ -8136,7 +7876,7 @@
               </a:spcAft>
             </a:pPr>
             <a:r>
-              <a:rPr sz="1600" b="0" dirty="0">
+              <a:rPr sz="1300" b="0">
                 <a:solidFill>
                   <a:srgbClr val="0F2830"/>
                 </a:solidFill>
@@ -8187,7 +7927,6 @@
           <a:lstStyle/>
           <a:p>
             <a:pPr algn="ctr"/>
-            <a:endParaRPr/>
           </a:p>
         </p:txBody>
       </p:sp>
@@ -8200,7 +7939,7 @@
         <p:spPr>
           <a:xfrm>
             <a:off x="411480" y="6565392"/>
-            <a:ext cx="9144000" cy="261610"/>
+            <a:ext cx="9144000" cy="256032"/>
           </a:xfrm>
           <a:prstGeom prst="rect">
             <a:avLst/>
@@ -8219,31 +7958,13 @@
               </a:spcAft>
             </a:pPr>
             <a:r>
-              <a:rPr sz="1000" b="0" dirty="0">
+              <a:rPr sz="1000" b="0">
                 <a:solidFill>
                   <a:srgbClr val="B8D0C8"/>
                 </a:solidFill>
                 <a:latin typeface="Calibri"/>
               </a:rPr>
-              <a:t>USHIRIKA — SME VALUE </a:t>
-            </a:r>
-            <a:r>
-              <a:rPr sz="1100" b="0" dirty="0">
-                <a:solidFill>
-                  <a:srgbClr val="B8D0C8"/>
-                </a:solidFill>
-                <a:latin typeface="Calibri"/>
-              </a:rPr>
-              <a:t>CHAIN</a:t>
-            </a:r>
-            <a:r>
-              <a:rPr sz="1000" b="0" dirty="0">
-                <a:solidFill>
-                  <a:srgbClr val="B8D0C8"/>
-                </a:solidFill>
-                <a:latin typeface="Calibri"/>
-              </a:rPr>
-              <a:t> CREDIT RISK</a:t>
+              <a:t>USHIRIKA — SME VALUE CHAIN CREDIT RISK</a:t>
             </a:r>
           </a:p>
         </p:txBody>
@@ -8296,7 +8017,7 @@
 </file>
 
 <file path=ppt/slides/slide4.xml><?xml version="1.0" encoding="utf-8"?>
-<p:sld xmlns:a="http://schemas.openxmlformats.org/drawingml/2006/main" xmlns:r="http://schemas.openxmlformats.org/officeDocument/2006/relationships" xmlns:p="http://schemas.openxmlformats.org/presentationml/2006/main">
+<p:sld xmlns:a="http://schemas.openxmlformats.org/drawingml/2006/main" xmlns:p="http://schemas.openxmlformats.org/presentationml/2006/main" xmlns:r="http://schemas.openxmlformats.org/officeDocument/2006/relationships">
   <p:cSld>
     <p:spTree>
       <p:nvGrpSpPr>
@@ -8304,14 +8025,7 @@
         <p:cNvGrpSpPr/>
         <p:nvPr/>
       </p:nvGrpSpPr>
-      <p:grpSpPr>
-        <a:xfrm>
-          <a:off x="0" y="0"/>
-          <a:ext cx="0" cy="0"/>
-          <a:chOff x="0" y="0"/>
-          <a:chExt cx="0" cy="0"/>
-        </a:xfrm>
-      </p:grpSpPr>
+      <p:grpSpPr/>
       <p:sp>
         <p:nvSpPr>
           <p:cNvPr id="2" name="Rectangle 1"/>
@@ -8352,7 +8066,6 @@
           <a:lstStyle/>
           <a:p>
             <a:pPr algn="ctr"/>
-            <a:endParaRPr/>
           </a:p>
         </p:txBody>
       </p:sp>
@@ -8365,7 +8078,7 @@
         <p:spPr>
           <a:xfrm>
             <a:off x="502920" y="256032"/>
-            <a:ext cx="10972800" cy="307777"/>
+            <a:ext cx="10972800" cy="256032"/>
           </a:xfrm>
           <a:prstGeom prst="rect">
             <a:avLst/>
@@ -8384,31 +8097,13 @@
               </a:spcAft>
             </a:pPr>
             <a:r>
-              <a:rPr sz="1200" b="1" dirty="0">
+              <a:rPr sz="1200" b="1">
                 <a:solidFill>
                   <a:srgbClr val="1A7A6D"/>
                 </a:solidFill>
                 <a:latin typeface="Calibri"/>
               </a:rPr>
-              <a:t>WHAT </a:t>
-            </a:r>
-            <a:r>
-              <a:rPr sz="1400" b="1" dirty="0">
-                <a:solidFill>
-                  <a:srgbClr val="1A7A6D"/>
-                </a:solidFill>
-                <a:latin typeface="Calibri"/>
-              </a:rPr>
-              <a:t>WAS</a:t>
-            </a:r>
-            <a:r>
-              <a:rPr sz="1200" b="1" dirty="0">
-                <a:solidFill>
-                  <a:srgbClr val="1A7A6D"/>
-                </a:solidFill>
-                <a:latin typeface="Calibri"/>
-              </a:rPr>
-              <a:t> BUILT</a:t>
+              <a:t>WHAT WAS BUILT</a:t>
             </a:r>
           </a:p>
         </p:txBody>
@@ -8453,7 +8148,6 @@
           <a:lstStyle/>
           <a:p>
             <a:pPr algn="ctr"/>
-            <a:endParaRPr/>
           </a:p>
         </p:txBody>
       </p:sp>
@@ -8485,13 +8179,52 @@
               </a:spcAft>
             </a:pPr>
             <a:r>
-              <a:rPr sz="2600" b="1" dirty="0">
+              <a:rPr sz="2600" b="1">
                 <a:solidFill>
                   <a:srgbClr val="0B3D2E"/>
                 </a:solidFill>
                 <a:latin typeface="Georgia"/>
               </a:rPr>
-              <a:t>Ushirika — end-to-end SME value-chain credit platform</a:t>
+              <a:t>Ushirika — a working credit platform for SMEs and lenders</a:t>
+            </a:r>
+          </a:p>
+        </p:txBody>
+      </p:sp>
+      <p:sp>
+        <p:nvSpPr>
+          <p:cNvPr id="6" name="TextBox 5"/>
+          <p:cNvSpPr txBox="1"/>
+          <p:nvPr/>
+        </p:nvSpPr>
+        <p:spPr>
+          <a:xfrm>
+            <a:off x="502920" y="1051560"/>
+            <a:ext cx="11155680" cy="320040"/>
+          </a:xfrm>
+          <a:prstGeom prst="rect">
+            <a:avLst/>
+          </a:prstGeom>
+          <a:noFill/>
+        </p:spPr>
+        <p:txBody>
+          <a:bodyPr wrap="square">
+            <a:spAutoFit/>
+          </a:bodyPr>
+          <a:lstStyle/>
+          <a:p>
+            <a:pPr algn="l">
+              <a:spcAft>
+                <a:spcPts val="300"/>
+              </a:spcAft>
+            </a:pPr>
+            <a:r>
+              <a:rPr sz="1300" b="0">
+                <a:solidFill>
+                  <a:srgbClr val="4A5E66"/>
+                </a:solidFill>
+                <a:latin typeface="Calibri"/>
+              </a:rPr>
+              <a:t>Deliverables match proposal Section 3.10</a:t>
             </a:r>
           </a:p>
         </p:txBody>
@@ -8538,7 +8271,6 @@
           <a:lstStyle/>
           <a:p>
             <a:pPr algn="ctr"/>
-            <a:endParaRPr/>
           </a:p>
         </p:txBody>
       </p:sp>
@@ -8582,7 +8314,6 @@
           <a:lstStyle/>
           <a:p>
             <a:pPr algn="ctr"/>
-            <a:endParaRPr/>
           </a:p>
         </p:txBody>
       </p:sp>
@@ -8595,7 +8326,7 @@
         <p:spPr>
           <a:xfrm>
             <a:off x="548640" y="1719072"/>
-            <a:ext cx="2468880" cy="338554"/>
+            <a:ext cx="2468880" cy="320040"/>
           </a:xfrm>
           <a:prstGeom prst="rect">
             <a:avLst/>
@@ -8614,7 +8345,7 @@
               </a:spcAft>
             </a:pPr>
             <a:r>
-              <a:rPr sz="1600" b="1" dirty="0">
+              <a:rPr sz="1500" b="1">
                 <a:solidFill>
                   <a:srgbClr val="FFFFFF"/>
                 </a:solidFill>
@@ -8634,7 +8365,7 @@
         <p:spPr>
           <a:xfrm>
             <a:off x="640080" y="2377440"/>
-            <a:ext cx="2286000" cy="1154162"/>
+            <a:ext cx="2286000" cy="2011680"/>
           </a:xfrm>
           <a:prstGeom prst="rect">
             <a:avLst/>
@@ -8653,7 +8384,7 @@
               </a:spcAft>
             </a:pPr>
             <a:r>
-              <a:rPr sz="1600" b="0" dirty="0">
+              <a:rPr sz="1300" b="0">
                 <a:solidFill>
                   <a:srgbClr val="0F2830"/>
                 </a:solidFill>
@@ -8669,64 +8400,45 @@
               </a:spcAft>
             </a:pPr>
             <a:r>
-              <a:rPr sz="1600" b="0" dirty="0">
+              <a:rPr sz="1300" b="0">
                 <a:solidFill>
                   <a:srgbClr val="0F2830"/>
                 </a:solidFill>
                 <a:latin typeface="Calibri"/>
               </a:rPr>
-              <a:t>SME · </a:t>
-            </a:r>
-            <a:r>
-              <a:rPr lang="en-US" sz="1600" dirty="0">
+              <a:t>SME · Lender · Admin</a:t>
+            </a:r>
+          </a:p>
+          <a:p>
+            <a:pPr algn="ctr">
+              <a:spcAft>
+                <a:spcPts val="300"/>
+              </a:spcAft>
+            </a:pPr>
+            <a:r>
+              <a:rPr sz="1300" b="0">
                 <a:solidFill>
                   <a:srgbClr val="0F2830"/>
                 </a:solidFill>
                 <a:latin typeface="Calibri"/>
               </a:rPr>
-              <a:t>Lender</a:t>
-            </a:r>
-            <a:r>
-              <a:rPr sz="1600" b="0" dirty="0">
+              <a:t>Auto-start backend from UI script</a:t>
+            </a:r>
+          </a:p>
+          <a:p>
+            <a:pPr algn="ctr">
+              <a:spcAft>
+                <a:spcPts val="300"/>
+              </a:spcAft>
+            </a:pPr>
+            <a:r>
+              <a:rPr sz="1300" b="0">
                 <a:solidFill>
                   <a:srgbClr val="0F2830"/>
                 </a:solidFill>
                 <a:latin typeface="Calibri"/>
               </a:rPr>
-              <a:t> · Admin</a:t>
-            </a:r>
-          </a:p>
-          <a:p>
-            <a:pPr algn="ctr">
-              <a:spcAft>
-                <a:spcPts val="300"/>
-              </a:spcAft>
-            </a:pPr>
-            <a:r>
-              <a:rPr sz="1600" b="0" dirty="0">
-                <a:solidFill>
-                  <a:srgbClr val="0F2830"/>
-                </a:solidFill>
-                <a:latin typeface="Calibri"/>
-              </a:rPr>
-              <a:t>EN/SW </a:t>
-            </a:r>
-            <a:br>
-              <a:rPr lang="en-US" sz="1600" b="0" dirty="0">
-                <a:solidFill>
-                  <a:srgbClr val="0F2830"/>
-                </a:solidFill>
-                <a:latin typeface="Calibri"/>
-              </a:rPr>
-            </a:br>
-            <a:r>
-              <a:rPr sz="1600" b="0" dirty="0">
-                <a:solidFill>
-                  <a:srgbClr val="0F2830"/>
-                </a:solidFill>
-                <a:latin typeface="Calibri"/>
-              </a:rPr>
-              <a:t>· live dashboards</a:t>
+              <a:t>EN / Kiswahili UI</a:t>
             </a:r>
           </a:p>
         </p:txBody>
@@ -8812,7 +8524,6 @@
           <a:lstStyle/>
           <a:p>
             <a:pPr algn="ctr"/>
-            <a:endParaRPr/>
           </a:p>
         </p:txBody>
       </p:sp>
@@ -8856,7 +8567,6 @@
           <a:lstStyle/>
           <a:p>
             <a:pPr algn="ctr"/>
-            <a:endParaRPr/>
           </a:p>
         </p:txBody>
       </p:sp>
@@ -8869,7 +8579,7 @@
         <p:spPr>
           <a:xfrm>
             <a:off x="3474720" y="1719072"/>
-            <a:ext cx="2468880" cy="338554"/>
+            <a:ext cx="2468880" cy="320040"/>
           </a:xfrm>
           <a:prstGeom prst="rect">
             <a:avLst/>
@@ -8888,7 +8598,7 @@
               </a:spcAft>
             </a:pPr>
             <a:r>
-              <a:rPr sz="1600" b="1" dirty="0">
+              <a:rPr sz="1500" b="1">
                 <a:solidFill>
                   <a:srgbClr val="FFFFFF"/>
                 </a:solidFill>
@@ -8908,7 +8618,7 @@
         <p:spPr>
           <a:xfrm>
             <a:off x="3566160" y="2377440"/>
-            <a:ext cx="2286000" cy="907941"/>
+            <a:ext cx="2286000" cy="2011680"/>
           </a:xfrm>
           <a:prstGeom prst="rect">
             <a:avLst/>
@@ -8927,7 +8637,7 @@
               </a:spcAft>
             </a:pPr>
             <a:r>
-              <a:rPr sz="1600" b="0" dirty="0">
+              <a:rPr sz="1300" b="0">
                 <a:solidFill>
                   <a:srgbClr val="0F2830"/>
                 </a:solidFill>
@@ -8943,7 +8653,7 @@
               </a:spcAft>
             </a:pPr>
             <a:r>
-              <a:rPr sz="1600" b="0" dirty="0">
+              <a:rPr sz="1300" b="0">
                 <a:solidFill>
                   <a:srgbClr val="0F2830"/>
                 </a:solidFill>
@@ -8959,7 +8669,7 @@
               </a:spcAft>
             </a:pPr>
             <a:r>
-              <a:rPr sz="1600" b="0" dirty="0">
+              <a:rPr sz="1300" b="0">
                 <a:solidFill>
                   <a:srgbClr val="0F2830"/>
                 </a:solidFill>
@@ -9051,7 +8761,6 @@
           <a:lstStyle/>
           <a:p>
             <a:pPr algn="ctr"/>
-            <a:endParaRPr/>
           </a:p>
         </p:txBody>
       </p:sp>
@@ -9095,7 +8804,6 @@
           <a:lstStyle/>
           <a:p>
             <a:pPr algn="ctr"/>
-            <a:endParaRPr/>
           </a:p>
         </p:txBody>
       </p:sp>
@@ -9108,7 +8816,7 @@
         <p:spPr>
           <a:xfrm>
             <a:off x="6400800" y="1719072"/>
-            <a:ext cx="2468880" cy="338554"/>
+            <a:ext cx="2468880" cy="320040"/>
           </a:xfrm>
           <a:prstGeom prst="rect">
             <a:avLst/>
@@ -9127,22 +8835,13 @@
               </a:spcAft>
             </a:pPr>
             <a:r>
-              <a:rPr sz="1600" b="1" dirty="0">
+              <a:rPr sz="1500" b="1">
                 <a:solidFill>
                   <a:srgbClr val="FFFFFF"/>
                 </a:solidFill>
                 <a:latin typeface="Calibri"/>
               </a:rPr>
-              <a:t>ML</a:t>
-            </a:r>
-            <a:r>
-              <a:rPr sz="1500" b="1" dirty="0">
-                <a:solidFill>
-                  <a:srgbClr val="FFFFFF"/>
-                </a:solidFill>
-                <a:latin typeface="Calibri"/>
-              </a:rPr>
-              <a:t> Core</a:t>
+              <a:t>ML Core</a:t>
             </a:r>
           </a:p>
         </p:txBody>
@@ -9156,7 +8855,7 @@
         <p:spPr>
           <a:xfrm>
             <a:off x="6492240" y="2377440"/>
-            <a:ext cx="2286000" cy="907941"/>
+            <a:ext cx="2286000" cy="2011680"/>
           </a:xfrm>
           <a:prstGeom prst="rect">
             <a:avLst/>
@@ -9175,7 +8874,7 @@
               </a:spcAft>
             </a:pPr>
             <a:r>
-              <a:rPr sz="1600" b="0" dirty="0">
+              <a:rPr sz="1300" b="0">
                 <a:solidFill>
                   <a:srgbClr val="0F2830"/>
                 </a:solidFill>
@@ -9191,7 +8890,7 @@
               </a:spcAft>
             </a:pPr>
             <a:r>
-              <a:rPr sz="1600" b="0" dirty="0">
+              <a:rPr sz="1300" b="0">
                 <a:solidFill>
                   <a:srgbClr val="0F2830"/>
                 </a:solidFill>
@@ -9207,13 +8906,13 @@
               </a:spcAft>
             </a:pPr>
             <a:r>
-              <a:rPr sz="1600" b="0" dirty="0">
+              <a:rPr sz="1300" b="0">
                 <a:solidFill>
                   <a:srgbClr val="0F2830"/>
                 </a:solidFill>
                 <a:latin typeface="Calibri"/>
               </a:rPr>
-              <a:t>80/20 train–test + CV</a:t>
+              <a:t>Upload triggers train+test output</a:t>
             </a:r>
           </a:p>
         </p:txBody>
@@ -9299,7 +8998,6 @@
           <a:lstStyle/>
           <a:p>
             <a:pPr algn="ctr"/>
-            <a:endParaRPr/>
           </a:p>
         </p:txBody>
       </p:sp>
@@ -9343,7 +9041,6 @@
           <a:lstStyle/>
           <a:p>
             <a:pPr algn="ctr"/>
-            <a:endParaRPr/>
           </a:p>
         </p:txBody>
       </p:sp>
@@ -9375,7 +9072,7 @@
               </a:spcAft>
             </a:pPr>
             <a:r>
-              <a:rPr sz="1500" b="1" dirty="0">
+              <a:rPr sz="1500" b="1">
                 <a:solidFill>
                   <a:srgbClr val="FFFFFF"/>
                 </a:solidFill>
@@ -9395,7 +9092,7 @@
         <p:spPr>
           <a:xfrm>
             <a:off x="9418320" y="2377440"/>
-            <a:ext cx="2286000" cy="907941"/>
+            <a:ext cx="2286000" cy="2011680"/>
           </a:xfrm>
           <a:prstGeom prst="rect">
             <a:avLst/>
@@ -9414,7 +9111,7 @@
               </a:spcAft>
             </a:pPr>
             <a:r>
-              <a:rPr sz="1600" b="0" dirty="0">
+              <a:rPr sz="1300" b="0">
                 <a:solidFill>
                   <a:srgbClr val="0F2830"/>
                 </a:solidFill>
@@ -9430,7 +9127,7 @@
               </a:spcAft>
             </a:pPr>
             <a:r>
-              <a:rPr sz="1600" b="0" dirty="0">
+              <a:rPr sz="1300" b="0">
                 <a:solidFill>
                   <a:srgbClr val="0F2830"/>
                 </a:solidFill>
@@ -9446,13 +9143,29 @@
               </a:spcAft>
             </a:pPr>
             <a:r>
-              <a:rPr sz="1600" b="0" dirty="0">
+              <a:rPr sz="1300" b="0">
                 <a:solidFill>
                   <a:srgbClr val="0F2830"/>
                 </a:solidFill>
                 <a:latin typeface="Calibri"/>
               </a:rPr>
-              <a:t>Outlier-aware financing</a:t>
+              <a:t>25% outlier rule</a:t>
+            </a:r>
+          </a:p>
+          <a:p>
+            <a:pPr algn="ctr">
+              <a:spcAft>
+                <a:spcPts val="300"/>
+              </a:spcAft>
+            </a:pPr>
+            <a:r>
+              <a:rPr sz="1300" b="0">
+                <a:solidFill>
+                  <a:srgbClr val="0F2830"/>
+                </a:solidFill>
+                <a:latin typeface="Calibri"/>
+              </a:rPr>
+              <a:t>Conservative loans</a:t>
             </a:r>
           </a:p>
         </p:txBody>
@@ -9466,7 +9179,7 @@
         <p:spPr>
           <a:xfrm>
             <a:off x="502920" y="4983480"/>
-            <a:ext cx="11155680" cy="869469"/>
+            <a:ext cx="11155680" cy="1097280"/>
           </a:xfrm>
           <a:prstGeom prst="rect">
             <a:avLst/>
@@ -9485,7 +9198,7 @@
               </a:spcAft>
             </a:pPr>
             <a:r>
-              <a:rPr sz="1600" b="0" dirty="0">
+              <a:rPr sz="1300" b="0">
                 <a:solidFill>
                   <a:srgbClr val="4A5E66"/>
                 </a:solidFill>
@@ -9501,13 +9214,29 @@
               </a:spcAft>
             </a:pPr>
             <a:r>
-              <a:rPr sz="1600" b="0" dirty="0">
+              <a:rPr sz="1300" b="0">
                 <a:solidFill>
                   <a:srgbClr val="4A5E66"/>
                 </a:solidFill>
                 <a:latin typeface="Calibri"/>
               </a:rPr>
-              <a:t>Also delivered beyond proposal baseline: NIDA/PIN auth, forgot-PIN via birthdate, CSV import/export, live retrain on SME data, outlier caps, and bilingual UI.</a:t>
+              <a:t>Lender workflow: progressive NIDA search → SME profile (incl. TIN) → tabs for ML metrics, signals, txs, history.</a:t>
+            </a:r>
+          </a:p>
+          <a:p>
+            <a:pPr algn="l">
+              <a:spcAft>
+                <a:spcPts val="300"/>
+              </a:spcAft>
+            </a:pPr>
+            <a:r>
+              <a:rPr sz="1300" b="0">
+                <a:solidFill>
+                  <a:srgbClr val="4A5E66"/>
+                </a:solidFill>
+                <a:latin typeface="Calibri"/>
+              </a:rPr>
+              <a:t>Initial governance now includes fixed admin + four fixed sub-admin IDs (self-PIN change enabled).</a:t>
             </a:r>
           </a:p>
         </p:txBody>
@@ -9552,7 +9281,6 @@
           <a:lstStyle/>
           <a:p>
             <a:pPr algn="ctr"/>
-            <a:endParaRPr/>
           </a:p>
         </p:txBody>
       </p:sp>
@@ -9584,7 +9312,7 @@
               </a:spcAft>
             </a:pPr>
             <a:r>
-              <a:rPr sz="1000" b="0" dirty="0">
+              <a:rPr sz="1000" b="0">
                 <a:solidFill>
                   <a:srgbClr val="B8D0C8"/>
                 </a:solidFill>
@@ -9631,48 +9359,6 @@
               </a:rPr>
               <a:t>4  /  12</a:t>
             </a:r>
-          </a:p>
-        </p:txBody>
-      </p:sp>
-      <p:sp>
-        <p:nvSpPr>
-          <p:cNvPr id="30" name="TextBox 29">
-            <a:extLst>
-              <a:ext uri="{FF2B5EF4-FFF2-40B4-BE49-F238E27FC236}">
-                <a16:creationId xmlns:a16="http://schemas.microsoft.com/office/drawing/2014/main" id="{051D3AF6-4C9F-4CF8-97FF-0C5A69BC0768}"/>
-              </a:ext>
-            </a:extLst>
-          </p:cNvPr>
-          <p:cNvSpPr txBox="1"/>
-          <p:nvPr/>
-        </p:nvSpPr>
-        <p:spPr>
-          <a:xfrm>
-            <a:off x="655320" y="1261872"/>
-            <a:ext cx="9429206" cy="234476"/>
-          </a:xfrm>
-          <a:prstGeom prst="rect">
-            <a:avLst/>
-          </a:prstGeom>
-          <a:noFill/>
-        </p:spPr>
-        <p:txBody>
-          <a:bodyPr wrap="square">
-            <a:spAutoFit/>
-          </a:bodyPr>
-          <a:lstStyle/>
-          <a:p>
-            <a:pPr algn="l">
-              <a:spcAft>
-                <a:spcPts val="300"/>
-              </a:spcAft>
-            </a:pPr>
-            <a:endParaRPr sz="1300" b="0">
-              <a:solidFill>
-                <a:srgbClr val="4A5E66"/>
-              </a:solidFill>
-              <a:latin typeface="Calibri"/>
-            </a:endParaRPr>
           </a:p>
         </p:txBody>
       </p:sp>
@@ -9685,7 +9371,7 @@
 </file>
 
 <file path=ppt/slides/slide5.xml><?xml version="1.0" encoding="utf-8"?>
-<p:sld xmlns:a="http://schemas.openxmlformats.org/drawingml/2006/main" xmlns:r="http://schemas.openxmlformats.org/officeDocument/2006/relationships" xmlns:p="http://schemas.openxmlformats.org/presentationml/2006/main">
+<p:sld xmlns:a="http://schemas.openxmlformats.org/drawingml/2006/main" xmlns:p="http://schemas.openxmlformats.org/presentationml/2006/main" xmlns:r="http://schemas.openxmlformats.org/officeDocument/2006/relationships">
   <p:cSld>
     <p:spTree>
       <p:nvGrpSpPr>
@@ -9693,14 +9379,7 @@
         <p:cNvGrpSpPr/>
         <p:nvPr/>
       </p:nvGrpSpPr>
-      <p:grpSpPr>
-        <a:xfrm>
-          <a:off x="0" y="0"/>
-          <a:ext cx="0" cy="0"/>
-          <a:chOff x="0" y="0"/>
-          <a:chExt cx="0" cy="0"/>
-        </a:xfrm>
-      </p:grpSpPr>
+      <p:grpSpPr/>
       <p:sp>
         <p:nvSpPr>
           <p:cNvPr id="2" name="Rectangle 1"/>
@@ -9741,7 +9420,6 @@
           <a:lstStyle/>
           <a:p>
             <a:pPr algn="ctr"/>
-            <a:endParaRPr/>
           </a:p>
         </p:txBody>
       </p:sp>
@@ -9824,7 +9502,6 @@
           <a:lstStyle/>
           <a:p>
             <a:pPr algn="ctr"/>
-            <a:endParaRPr/>
           </a:p>
         </p:txBody>
       </p:sp>
@@ -9909,7 +9586,6 @@
           <a:lstStyle/>
           <a:p>
             <a:pPr algn="ctr"/>
-            <a:endParaRPr/>
           </a:p>
         </p:txBody>
       </p:sp>
@@ -10033,7 +9709,6 @@
           <a:lstStyle/>
           <a:p>
             <a:pPr algn="ctr"/>
-            <a:endParaRPr/>
           </a:p>
         </p:txBody>
       </p:sp>
@@ -10157,7 +9832,6 @@
           <a:lstStyle/>
           <a:p>
             <a:pPr algn="ctr"/>
-            <a:endParaRPr/>
           </a:p>
         </p:txBody>
       </p:sp>
@@ -10281,7 +9955,6 @@
           <a:lstStyle/>
           <a:p>
             <a:pPr algn="ctr"/>
-            <a:endParaRPr/>
           </a:p>
         </p:txBody>
       </p:sp>
@@ -10405,7 +10078,6 @@
           <a:lstStyle/>
           <a:p>
             <a:pPr algn="ctr"/>
-            <a:endParaRPr/>
           </a:p>
         </p:txBody>
       </p:sp>
@@ -10479,7 +10151,7 @@
               </a:spcAft>
             </a:pPr>
             <a:r>
-              <a:rPr sz="1300" b="0" dirty="0">
+              <a:rPr sz="1300" b="0">
                 <a:solidFill>
                   <a:srgbClr val="FFFFFF"/>
                 </a:solidFill>
@@ -10498,7 +10170,7 @@
               </a:spcAft>
             </a:pPr>
             <a:r>
-              <a:rPr sz="1300" b="0" dirty="0">
+              <a:rPr sz="1300" b="0">
                 <a:solidFill>
                   <a:srgbClr val="FFFFFF"/>
                 </a:solidFill>
@@ -10517,7 +10189,7 @@
               </a:spcAft>
             </a:pPr>
             <a:r>
-              <a:rPr sz="1300" b="0" dirty="0">
+              <a:rPr sz="1300" b="0">
                 <a:solidFill>
                   <a:srgbClr val="FFFFFF"/>
                 </a:solidFill>
@@ -10536,31 +10208,13 @@
               </a:spcAft>
             </a:pPr>
             <a:r>
-              <a:rPr sz="1300" b="0" dirty="0">
+              <a:rPr sz="1300" b="0">
                 <a:solidFill>
                   <a:srgbClr val="FFFFFF"/>
                 </a:solidFill>
                 <a:latin typeface="Calibri"/>
               </a:rPr>
-              <a:t>•  Ushirika </a:t>
-            </a:r>
-            <a:r>
-              <a:rPr sz="1300" b="0" dirty="0" err="1">
-                <a:solidFill>
-                  <a:srgbClr val="FFFFFF"/>
-                </a:solidFill>
-                <a:latin typeface="Calibri"/>
-              </a:rPr>
-              <a:t>operationalises</a:t>
-            </a:r>
-            <a:r>
-              <a:rPr sz="1300" b="0" dirty="0">
-                <a:solidFill>
-                  <a:srgbClr val="FFFFFF"/>
-                </a:solidFill>
-                <a:latin typeface="Calibri"/>
-              </a:rPr>
-              <a:t> that gap as a working prototype.</a:t>
+              <a:t>•  Ushirika operationalises that gap as a working prototype.</a:t>
             </a:r>
           </a:p>
         </p:txBody>
@@ -10605,7 +10259,6 @@
           <a:lstStyle/>
           <a:p>
             <a:pPr algn="ctr"/>
-            <a:endParaRPr/>
           </a:p>
         </p:txBody>
       </p:sp>
@@ -10637,7 +10290,7 @@
               </a:spcAft>
             </a:pPr>
             <a:r>
-              <a:rPr sz="1000" b="0" dirty="0">
+              <a:rPr sz="1000" b="0">
                 <a:solidFill>
                   <a:srgbClr val="B8D0C8"/>
                 </a:solidFill>
@@ -10696,7 +10349,7 @@
 </file>
 
 <file path=ppt/slides/slide6.xml><?xml version="1.0" encoding="utf-8"?>
-<p:sld xmlns:a="http://schemas.openxmlformats.org/drawingml/2006/main" xmlns:r="http://schemas.openxmlformats.org/officeDocument/2006/relationships" xmlns:p="http://schemas.openxmlformats.org/presentationml/2006/main">
+<p:sld xmlns:a="http://schemas.openxmlformats.org/drawingml/2006/main" xmlns:p="http://schemas.openxmlformats.org/presentationml/2006/main" xmlns:r="http://schemas.openxmlformats.org/officeDocument/2006/relationships">
   <p:cSld>
     <p:spTree>
       <p:nvGrpSpPr>
@@ -10704,14 +10357,7 @@
         <p:cNvGrpSpPr/>
         <p:nvPr/>
       </p:nvGrpSpPr>
-      <p:grpSpPr>
-        <a:xfrm>
-          <a:off x="0" y="0"/>
-          <a:ext cx="0" cy="0"/>
-          <a:chOff x="0" y="0"/>
-          <a:chExt cx="0" cy="0"/>
-        </a:xfrm>
-      </p:grpSpPr>
+      <p:grpSpPr/>
       <p:sp>
         <p:nvSpPr>
           <p:cNvPr id="2" name="Rectangle 1"/>
@@ -10752,7 +10398,6 @@
           <a:lstStyle/>
           <a:p>
             <a:pPr algn="ctr"/>
-            <a:endParaRPr/>
           </a:p>
         </p:txBody>
       </p:sp>
@@ -10835,7 +10480,6 @@
           <a:lstStyle/>
           <a:p>
             <a:pPr algn="ctr"/>
-            <a:endParaRPr/>
           </a:p>
         </p:txBody>
       </p:sp>
@@ -10873,7 +10517,7 @@
                 </a:solidFill>
                 <a:latin typeface="Georgia"/>
               </a:rPr>
-              <a:t>A controlled train–test design — not a hard-coded score table</a:t>
+              <a:t>How we trained and tested the models fairly</a:t>
             </a:r>
           </a:p>
         </p:txBody>
@@ -10920,7 +10564,6 @@
           <a:lstStyle/>
           <a:p>
             <a:pPr algn="ctr"/>
-            <a:endParaRPr/>
           </a:p>
         </p:txBody>
       </p:sp>
@@ -10994,7 +10637,7 @@
               </a:spcAft>
             </a:pPr>
             <a:r>
-              <a:rPr sz="1300" b="0" dirty="0">
+              <a:rPr sz="1300" b="0">
                 <a:solidFill>
                   <a:srgbClr val="0F2830"/>
                 </a:solidFill>
@@ -11013,49 +10656,13 @@
               </a:spcAft>
             </a:pPr>
             <a:r>
-              <a:rPr sz="1300" b="0" dirty="0">
+              <a:rPr sz="1300" b="0">
                 <a:solidFill>
                   <a:srgbClr val="0F2830"/>
                 </a:solidFill>
                 <a:latin typeface="Calibri"/>
               </a:rPr>
-              <a:t>•  80/20 stratified </a:t>
-            </a:r>
-            <a:r>
-              <a:rPr sz="1300" b="0" dirty="0" err="1">
-                <a:solidFill>
-                  <a:srgbClr val="0F2830"/>
-                </a:solidFill>
-                <a:latin typeface="Calibri"/>
-              </a:rPr>
-              <a:t>train_test_split</a:t>
-            </a:r>
-            <a:r>
-              <a:rPr sz="1300" b="0" dirty="0">
-                <a:solidFill>
-                  <a:srgbClr val="0F2830"/>
-                </a:solidFill>
-                <a:latin typeface="Calibri"/>
-              </a:rPr>
-              <a:t> (</a:t>
-            </a:r>
-            <a:r>
-              <a:rPr sz="1300" b="0" dirty="0" err="1">
-                <a:solidFill>
-                  <a:srgbClr val="0F2830"/>
-                </a:solidFill>
-                <a:latin typeface="Calibri"/>
-              </a:rPr>
-              <a:t>random_state</a:t>
-            </a:r>
-            <a:r>
-              <a:rPr sz="1300" b="0" dirty="0">
-                <a:solidFill>
-                  <a:srgbClr val="0F2830"/>
-                </a:solidFill>
-                <a:latin typeface="Calibri"/>
-              </a:rPr>
-              <a:t>=42).</a:t>
+              <a:t>•  80/20 stratified train_test_split (random_state=42).</a:t>
             </a:r>
           </a:p>
           <a:p>
@@ -11068,7 +10675,7 @@
               </a:spcAft>
             </a:pPr>
             <a:r>
-              <a:rPr sz="1300" b="0" dirty="0">
+              <a:rPr sz="1300" b="0">
                 <a:solidFill>
                   <a:srgbClr val="0F2830"/>
                 </a:solidFill>
@@ -11087,7 +10694,7 @@
               </a:spcAft>
             </a:pPr>
             <a:r>
-              <a:rPr sz="1300" b="0" dirty="0">
+              <a:rPr sz="1300" b="0">
                 <a:solidFill>
                   <a:srgbClr val="0F2830"/>
                 </a:solidFill>
@@ -11106,7 +10713,7 @@
               </a:spcAft>
             </a:pPr>
             <a:r>
-              <a:rPr sz="1300" b="0" dirty="0">
+              <a:rPr sz="1300" b="0">
                 <a:solidFill>
                   <a:srgbClr val="0F2830"/>
                 </a:solidFill>
@@ -11125,13 +10732,13 @@
               </a:spcAft>
             </a:pPr>
             <a:r>
-              <a:rPr sz="1300" b="0" dirty="0">
+              <a:rPr sz="1300" b="0">
                 <a:solidFill>
                   <a:srgbClr val="0F2830"/>
                 </a:solidFill>
                 <a:latin typeface="Calibri"/>
               </a:rPr>
-              <a:t>•  Outliers are flagged; financing caps use typical volume, not one-off spikes.</a:t>
+              <a:t>•  Outlier rule: rare large deals (&lt;25% of txs) are excluded from loan sizing; frequent large deals count as pattern.</a:t>
             </a:r>
           </a:p>
         </p:txBody>
@@ -11178,7 +10785,6 @@
           <a:lstStyle/>
           <a:p>
             <a:pPr algn="ctr"/>
-            <a:endParaRPr/>
           </a:p>
         </p:txBody>
       </p:sp>
@@ -11398,7 +11004,6 @@
           <a:lstStyle/>
           <a:p>
             <a:pPr algn="ctr"/>
-            <a:endParaRPr/>
           </a:p>
         </p:txBody>
       </p:sp>
@@ -11430,7 +11035,7 @@
               </a:spcAft>
             </a:pPr>
             <a:r>
-              <a:rPr sz="1000" b="0" dirty="0">
+              <a:rPr sz="1000" b="0">
                 <a:solidFill>
                   <a:srgbClr val="B8D0C8"/>
                 </a:solidFill>
@@ -11489,7 +11094,7 @@
 </file>
 
 <file path=ppt/slides/slide7.xml><?xml version="1.0" encoding="utf-8"?>
-<p:sld xmlns:a="http://schemas.openxmlformats.org/drawingml/2006/main" xmlns:r="http://schemas.openxmlformats.org/officeDocument/2006/relationships" xmlns:p="http://schemas.openxmlformats.org/presentationml/2006/main">
+<p:sld xmlns:a="http://schemas.openxmlformats.org/drawingml/2006/main" xmlns:p="http://schemas.openxmlformats.org/presentationml/2006/main" xmlns:r="http://schemas.openxmlformats.org/officeDocument/2006/relationships">
   <p:cSld>
     <p:spTree>
       <p:nvGrpSpPr>
@@ -11497,14 +11102,7 @@
         <p:cNvGrpSpPr/>
         <p:nvPr/>
       </p:nvGrpSpPr>
-      <p:grpSpPr>
-        <a:xfrm>
-          <a:off x="0" y="0"/>
-          <a:ext cx="0" cy="0"/>
-          <a:chOff x="0" y="0"/>
-          <a:chExt cx="0" cy="0"/>
-        </a:xfrm>
-      </p:grpSpPr>
+      <p:grpSpPr/>
       <p:sp>
         <p:nvSpPr>
           <p:cNvPr id="2" name="Rectangle 1"/>
@@ -11545,7 +11143,6 @@
           <a:lstStyle/>
           <a:p>
             <a:pPr algn="ctr"/>
-            <a:endParaRPr/>
           </a:p>
         </p:txBody>
       </p:sp>
@@ -11628,7 +11225,6 @@
           <a:lstStyle/>
           <a:p>
             <a:pPr algn="ctr"/>
-            <a:endParaRPr/>
           </a:p>
         </p:txBody>
       </p:sp>
@@ -11713,7 +11309,6 @@
           <a:lstStyle/>
           <a:p>
             <a:pPr algn="ctr"/>
-            <a:endParaRPr/>
           </a:p>
         </p:txBody>
       </p:sp>
@@ -11757,7 +11352,6 @@
           <a:lstStyle/>
           <a:p>
             <a:pPr algn="ctr"/>
-            <a:endParaRPr/>
           </a:p>
         </p:txBody>
       </p:sp>
@@ -11881,7 +11475,6 @@
           <a:lstStyle/>
           <a:p>
             <a:pPr algn="ctr"/>
-            <a:endParaRPr/>
           </a:p>
         </p:txBody>
       </p:sp>
@@ -11925,7 +11518,6 @@
           <a:lstStyle/>
           <a:p>
             <a:pPr algn="ctr"/>
-            <a:endParaRPr/>
           </a:p>
         </p:txBody>
       </p:sp>
@@ -12049,7 +11641,6 @@
           <a:lstStyle/>
           <a:p>
             <a:pPr algn="ctr"/>
-            <a:endParaRPr/>
           </a:p>
         </p:txBody>
       </p:sp>
@@ -12093,7 +11684,6 @@
           <a:lstStyle/>
           <a:p>
             <a:pPr algn="ctr"/>
-            <a:endParaRPr/>
           </a:p>
         </p:txBody>
       </p:sp>
@@ -12217,7 +11807,6 @@
           <a:lstStyle/>
           <a:p>
             <a:pPr algn="ctr"/>
-            <a:endParaRPr/>
           </a:p>
         </p:txBody>
       </p:sp>
@@ -12261,7 +11850,6 @@
           <a:lstStyle/>
           <a:p>
             <a:pPr algn="ctr"/>
-            <a:endParaRPr/>
           </a:p>
         </p:txBody>
       </p:sp>
@@ -12385,7 +11973,6 @@
           <a:lstStyle/>
           <a:p>
             <a:pPr algn="ctr"/>
-            <a:endParaRPr/>
           </a:p>
         </p:txBody>
       </p:sp>
@@ -12429,7 +12016,6 @@
           <a:lstStyle/>
           <a:p>
             <a:pPr algn="ctr"/>
-            <a:endParaRPr/>
           </a:p>
         </p:txBody>
       </p:sp>
@@ -12553,7 +12139,6 @@
           <a:lstStyle/>
           <a:p>
             <a:pPr algn="ctr"/>
-            <a:endParaRPr/>
           </a:p>
         </p:txBody>
       </p:sp>
@@ -12597,7 +12182,6 @@
           <a:lstStyle/>
           <a:p>
             <a:pPr algn="ctr"/>
-            <a:endParaRPr/>
           </a:p>
         </p:txBody>
       </p:sp>
@@ -12674,7 +12258,7 @@
                 </a:solidFill>
                 <a:latin typeface="Calibri"/>
               </a:rPr>
-              <a:t>IQR flags unusual large deals for lending caps</a:t>
+              <a:t>25% frequency guard: rare spikes excluded from loan; pattern large deals kept</a:t>
             </a:r>
           </a:p>
         </p:txBody>
@@ -12719,7 +12303,6 @@
           <a:lstStyle/>
           <a:p>
             <a:pPr algn="ctr"/>
-            <a:endParaRPr/>
           </a:p>
         </p:txBody>
       </p:sp>
@@ -12751,7 +12334,7 @@
               </a:spcAft>
             </a:pPr>
             <a:r>
-              <a:rPr sz="1000" b="0" dirty="0">
+              <a:rPr sz="1000" b="0">
                 <a:solidFill>
                   <a:srgbClr val="B8D0C8"/>
                 </a:solidFill>
@@ -12810,7 +12393,7 @@
 </file>
 
 <file path=ppt/slides/slide8.xml><?xml version="1.0" encoding="utf-8"?>
-<p:sld xmlns:a="http://schemas.openxmlformats.org/drawingml/2006/main" xmlns:r="http://schemas.openxmlformats.org/officeDocument/2006/relationships" xmlns:p="http://schemas.openxmlformats.org/presentationml/2006/main">
+<p:sld xmlns:a="http://schemas.openxmlformats.org/drawingml/2006/main" xmlns:p="http://schemas.openxmlformats.org/presentationml/2006/main" xmlns:r="http://schemas.openxmlformats.org/officeDocument/2006/relationships">
   <p:cSld>
     <p:spTree>
       <p:nvGrpSpPr>
@@ -12818,14 +12401,7 @@
         <p:cNvGrpSpPr/>
         <p:nvPr/>
       </p:nvGrpSpPr>
-      <p:grpSpPr>
-        <a:xfrm>
-          <a:off x="0" y="0"/>
-          <a:ext cx="0" cy="0"/>
-          <a:chOff x="0" y="0"/>
-          <a:chExt cx="0" cy="0"/>
-        </a:xfrm>
-      </p:grpSpPr>
+      <p:grpSpPr/>
       <p:sp>
         <p:nvSpPr>
           <p:cNvPr id="2" name="Rectangle 1"/>
@@ -12866,7 +12442,6 @@
           <a:lstStyle/>
           <a:p>
             <a:pPr algn="ctr"/>
-            <a:endParaRPr/>
           </a:p>
         </p:txBody>
       </p:sp>
@@ -12949,7 +12524,6 @@
           <a:lstStyle/>
           <a:p>
             <a:pPr algn="ctr"/>
-            <a:endParaRPr/>
           </a:p>
         </p:txBody>
       </p:sp>
@@ -13034,7 +12608,6 @@
           <a:lstStyle/>
           <a:p>
             <a:pPr algn="ctr"/>
-            <a:endParaRPr/>
           </a:p>
         </p:txBody>
       </p:sp>
@@ -13078,7 +12651,6 @@
           <a:lstStyle/>
           <a:p>
             <a:pPr algn="ctr"/>
-            <a:endParaRPr/>
           </a:p>
         </p:txBody>
       </p:sp>
@@ -13202,7 +12774,6 @@
           <a:lstStyle/>
           <a:p>
             <a:pPr algn="ctr"/>
-            <a:endParaRPr/>
           </a:p>
         </p:txBody>
       </p:sp>
@@ -13246,7 +12817,6 @@
           <a:lstStyle/>
           <a:p>
             <a:pPr algn="ctr"/>
-            <a:endParaRPr/>
           </a:p>
         </p:txBody>
       </p:sp>
@@ -13370,7 +12940,6 @@
           <a:lstStyle/>
           <a:p>
             <a:pPr algn="ctr"/>
-            <a:endParaRPr/>
           </a:p>
         </p:txBody>
       </p:sp>
@@ -13414,7 +12983,6 @@
           <a:lstStyle/>
           <a:p>
             <a:pPr algn="ctr"/>
-            <a:endParaRPr/>
           </a:p>
         </p:txBody>
       </p:sp>
@@ -13538,7 +13106,6 @@
           <a:lstStyle/>
           <a:p>
             <a:pPr algn="ctr"/>
-            <a:endParaRPr/>
           </a:p>
         </p:txBody>
       </p:sp>
@@ -13582,7 +13149,6 @@
           <a:lstStyle/>
           <a:p>
             <a:pPr algn="ctr"/>
-            <a:endParaRPr/>
           </a:p>
         </p:txBody>
       </p:sp>
@@ -13706,7 +13272,6 @@
           <a:lstStyle/>
           <a:p>
             <a:pPr algn="ctr"/>
-            <a:endParaRPr/>
           </a:p>
         </p:txBody>
       </p:sp>
@@ -13888,7 +13453,6 @@
           <a:lstStyle/>
           <a:p>
             <a:pPr algn="ctr"/>
-            <a:endParaRPr/>
           </a:p>
         </p:txBody>
       </p:sp>
@@ -13920,7 +13484,7 @@
               </a:spcAft>
             </a:pPr>
             <a:r>
-              <a:rPr sz="1000" b="0" dirty="0">
+              <a:rPr sz="1000" b="0">
                 <a:solidFill>
                   <a:srgbClr val="B8D0C8"/>
                 </a:solidFill>
@@ -13979,7 +13543,7 @@
 </file>
 
 <file path=ppt/slides/slide9.xml><?xml version="1.0" encoding="utf-8"?>
-<p:sld xmlns:a="http://schemas.openxmlformats.org/drawingml/2006/main" xmlns:r="http://schemas.openxmlformats.org/officeDocument/2006/relationships" xmlns:p="http://schemas.openxmlformats.org/presentationml/2006/main">
+<p:sld xmlns:a="http://schemas.openxmlformats.org/drawingml/2006/main" xmlns:p="http://schemas.openxmlformats.org/presentationml/2006/main" xmlns:r="http://schemas.openxmlformats.org/officeDocument/2006/relationships">
   <p:cSld>
     <p:spTree>
       <p:nvGrpSpPr>
@@ -13987,14 +13551,7 @@
         <p:cNvGrpSpPr/>
         <p:nvPr/>
       </p:nvGrpSpPr>
-      <p:grpSpPr>
-        <a:xfrm>
-          <a:off x="0" y="0"/>
-          <a:ext cx="0" cy="0"/>
-          <a:chOff x="0" y="0"/>
-          <a:chExt cx="0" cy="0"/>
-        </a:xfrm>
-      </p:grpSpPr>
+      <p:grpSpPr/>
       <p:sp>
         <p:nvSpPr>
           <p:cNvPr id="2" name="Rectangle 1"/>
@@ -14035,7 +13592,6 @@
           <a:lstStyle/>
           <a:p>
             <a:pPr algn="ctr"/>
-            <a:endParaRPr/>
           </a:p>
         </p:txBody>
       </p:sp>
@@ -14118,7 +13674,6 @@
           <a:lstStyle/>
           <a:p>
             <a:pPr algn="ctr"/>
-            <a:endParaRPr/>
           </a:p>
         </p:txBody>
       </p:sp>
@@ -14203,7 +13758,6 @@
           <a:lstStyle/>
           <a:p>
             <a:pPr algn="ctr"/>
-            <a:endParaRPr/>
           </a:p>
         </p:txBody>
       </p:sp>
@@ -14359,7 +13913,7 @@
                 </a:solidFill>
                 <a:latin typeface="Calibri"/>
               </a:rPr>
-              <a:t>•  Financing never exceeds typical (non-outlier) capacity — realistic lending.</a:t>
+              <a:t>•  Financing capped at ~50% of typical (non-outlier) volume — reduces unpaid-loan risk.</a:t>
             </a:r>
           </a:p>
           <a:p>
@@ -14425,7 +13979,6 @@
           <a:lstStyle/>
           <a:p>
             <a:pPr algn="ctr"/>
-            <a:endParaRPr/>
           </a:p>
         </p:txBody>
       </p:sp>
@@ -14524,7 +14077,7 @@
                 </a:solidFill>
                 <a:latin typeface="Calibri"/>
               </a:rPr>
-              <a:t>•  Eligible financing (TZS) with outlier-aware caps.</a:t>
+              <a:t>•  Eligible financing (TZS) with 25% outlier-aware caps.</a:t>
             </a:r>
           </a:p>
           <a:p>
@@ -14543,7 +14096,7 @@
                 </a:solidFill>
                 <a:latin typeface="Calibri"/>
               </a:rPr>
-              <a:t>•  Human-readable score components for explainability.</a:t>
+              <a:t>•  Crucial score signals only (not every engineered feature).</a:t>
             </a:r>
           </a:p>
           <a:p>
@@ -14562,7 +14115,7 @@
                 </a:solidFill>
                 <a:latin typeface="Calibri"/>
               </a:rPr>
-              <a:t>•  Lender portfolio view by NIDA / membership ID.</a:t>
+              <a:t>•  Lender: progressive NIDA search + tabbed SME analytics.</a:t>
             </a:r>
           </a:p>
           <a:p>
@@ -14581,7 +14134,7 @@
                 </a:solidFill>
                 <a:latin typeface="Calibri"/>
               </a:rPr>
-              <a:t>•  Admin governance for accounts and PIN reset.</a:t>
+              <a:t>•  TIN shown on SME profile (SME + Lender views).</a:t>
             </a:r>
           </a:p>
           <a:p>
@@ -14600,7 +14153,7 @@
                 </a:solidFill>
                 <a:latin typeface="Calibri"/>
               </a:rPr>
-              <a:t>•  Bilingual portal (English / Kiswahili).</a:t>
+              <a:t>•  Bilingual portal (English / Kiswahili) end-to-end.</a:t>
             </a:r>
           </a:p>
         </p:txBody>
@@ -14645,7 +14198,6 @@
           <a:lstStyle/>
           <a:p>
             <a:pPr algn="ctr"/>
-            <a:endParaRPr/>
           </a:p>
         </p:txBody>
       </p:sp>
@@ -14677,7 +14229,7 @@
               </a:spcAft>
             </a:pPr>
             <a:r>
-              <a:rPr sz="1000" b="0" dirty="0">
+              <a:rPr sz="1000" b="0">
                 <a:solidFill>
                   <a:srgbClr val="B8D0C8"/>
                 </a:solidFill>

</xml_diff>

<commit_message>
Improve Tanzanian onboarding and transaction safeguards
Make forms easier to understand while enforcing consistent phone, email, age, gender, nationality, and transaction-date rules across the UI and API.

Co-authored-by: Cursor <cursoragent@cursor.com>
</commit_message>
<xml_diff>
--- a/Presentation/Ushirika_Group15_Defence_Presentation.pptx
+++ b/Presentation/Ushirika_Group15_Defence_Presentation.pptx
@@ -8422,7 +8422,7 @@
                 </a:solidFill>
                 <a:latin typeface="Calibri"/>
               </a:rPr>
-              <a:t>Auto-start backend from UI script</a:t>
+              <a:t>Cloud API wake-up</a:t>
             </a:r>
           </a:p>
           <a:p>
@@ -8438,7 +8438,7 @@
                 </a:solidFill>
                 <a:latin typeface="Calibri"/>
               </a:rPr>
-              <a:t>EN / Kiswahili UI</a:t>
+              <a:t>Simple EN / Kiswahili UI</a:t>
             </a:r>
           </a:p>
         </p:txBody>
@@ -8659,7 +8659,7 @@
                 </a:solidFill>
                 <a:latin typeface="Calibri"/>
               </a:rPr>
-              <a:t>Transactions + TIN</a:t>
+              <a:t>Strict age, phone, email</a:t>
             </a:r>
           </a:p>
           <a:p>
@@ -8675,7 +8675,7 @@
                 </a:solidFill>
                 <a:latin typeface="Calibri"/>
               </a:rPr>
-              <a:t>Role-based access</a:t>
+              <a:t>No future transactions</a:t>
             </a:r>
           </a:p>
         </p:txBody>
@@ -8912,7 +8912,7 @@
                 </a:solidFill>
                 <a:latin typeface="Calibri"/>
               </a:rPr>
-              <a:t>Upload triggers train+test output</a:t>
+              <a:t>Upload scores immediately</a:t>
             </a:r>
           </a:p>
         </p:txBody>
@@ -9236,7 +9236,7 @@
                 </a:solidFill>
                 <a:latin typeface="Calibri"/>
               </a:rPr>
-              <a:t>Initial governance now includes fixed admin + four fixed sub-admin IDs (self-PIN change enabled).</a:t>
+              <a:t>Inclusive controls: +255 phone entry, age 18+ eligibility, Male/Female choices, live email checks, and clear bilingual labels.</a:t>
             </a:r>
           </a:p>
         </p:txBody>

</xml_diff>

<commit_message>
Show TIN on SME profile and fix premature session expiry
- Return tin in /sme/profile response so the profile modal displays it
- Extend access token lifetime from 30 min to 4 hours
- Relax inactivity auto-logout from 90 seconds to 15 minutes
- Redirect cleanly to login on expired-token 401s instead of surfacing raw errors
- Bump backend to v1.3.6 and refresh defence deck

Co-authored-by: Cursor <cursoragent@cursor.com>
</commit_message>
<xml_diff>
--- a/Presentation/Ushirika_Group15_Defence_Presentation.pptx
+++ b/Presentation/Ushirika_Group15_Defence_Presentation.pptx
@@ -3913,7 +3913,7 @@
                 </a:solidFill>
                 <a:latin typeface="Calibri"/>
               </a:rPr>
-              <a:t>Transaction pipelines produce 13 engineered predictors + outlier flags used for scoring and financing.</a:t>
+              <a:t>Transaction pipelines produce 17 engineered predictors + outlier flags used for scoring and financing.</a:t>
             </a:r>
           </a:p>
         </p:txBody>
@@ -4202,7 +4202,7 @@
                 </a:solidFill>
                 <a:latin typeface="Calibri"/>
               </a:rPr>
-              <a:t>RF and LR trained on identical split; RF wins on ROC-AUC (88.5% vs 75.4%).</a:t>
+              <a:t>RF and LR trained on identical split; RF wins on ROC-AUC (95.8% vs 87.5%).</a:t>
             </a:r>
           </a:p>
         </p:txBody>
@@ -12688,7 +12688,7 @@
                 </a:solidFill>
                 <a:latin typeface="Calibri"/>
               </a:rPr>
-              <a:t>88.5%</a:t>
+              <a:t>95.8%</a:t>
             </a:r>
           </a:p>
         </p:txBody>
@@ -12854,7 +12854,7 @@
                 </a:solidFill>
                 <a:latin typeface="Calibri"/>
               </a:rPr>
-              <a:t>84.2%</a:t>
+              <a:t>88.6%</a:t>
             </a:r>
           </a:p>
         </p:txBody>
@@ -13020,7 +13020,7 @@
                 </a:solidFill>
                 <a:latin typeface="Calibri"/>
               </a:rPr>
-              <a:t>75.4%</a:t>
+              <a:t>87.5%</a:t>
             </a:r>
           </a:p>
         </p:txBody>
@@ -13351,7 +13351,7 @@
                 </a:solidFill>
                 <a:latin typeface="Calibri"/>
               </a:rPr>
-              <a:t>•  Random Forest: Accuracy 84.2% · Precision 85.7% · Recall 52.9% · F1 65.5% · ROC-AUC 88.5%.</a:t>
+              <a:t>•  Random Forest: Accuracy 88.6% · Precision 93.0% · Recall 85.7% · F1 89.2% · ROC-AUC 95.8%.</a:t>
             </a:r>
           </a:p>
           <a:p>
@@ -13370,7 +13370,7 @@
                 </a:solidFill>
                 <a:latin typeface="Calibri"/>
               </a:rPr>
-              <a:t>•  Logistic Regression: Accuracy 74.6% · Precision 64.0% · Recall 23.5% · F1 34.4% · ROC-AUC 75.4%.</a:t>
+              <a:t>•  Logistic Regression: Accuracy 77.9% · Precision 75.8% · Recall 87.7% · F1 81.3% · ROC-AUC 87.5%.</a:t>
             </a:r>
           </a:p>
           <a:p>
@@ -13932,6 +13932,44 @@
                 </a:solidFill>
                 <a:latin typeface="Calibri"/>
               </a:rPr>
+              <a:t>•  Input validation: +255 phone (9 digits), live email checks, age 18+, Male/Female only, no future payment dates.</a:t>
+            </a:r>
+          </a:p>
+          <a:p>
+            <a:pPr algn="l">
+              <a:spcBef>
+                <a:spcPts val="400"/>
+              </a:spcBef>
+              <a:spcAft>
+                <a:spcPts val="400"/>
+              </a:spcAft>
+            </a:pPr>
+            <a:r>
+              <a:rPr sz="1300" b="0">
+                <a:solidFill>
+                  <a:srgbClr val="0F2830"/>
+                </a:solidFill>
+                <a:latin typeface="Calibri"/>
+              </a:rPr>
+              <a:t>•  Stable sessions: 4-hour tokens, auto sign-out after 15 min idle, clean redirect on expiry.</a:t>
+            </a:r>
+          </a:p>
+          <a:p>
+            <a:pPr algn="l">
+              <a:spcBef>
+                <a:spcPts val="400"/>
+              </a:spcBef>
+              <a:spcAft>
+                <a:spcPts val="400"/>
+              </a:spcAft>
+            </a:pPr>
+            <a:r>
+              <a:rPr sz="1300" b="0">
+                <a:solidFill>
+                  <a:srgbClr val="0F2830"/>
+                </a:solidFill>
+                <a:latin typeface="Calibri"/>
+              </a:rPr>
               <a:t>•  Technical Performance Report documents honesty of evaluation.</a:t>
             </a:r>
           </a:p>
@@ -14153,7 +14191,7 @@
                 </a:solidFill>
                 <a:latin typeface="Calibri"/>
               </a:rPr>
-              <a:t>•  Bilingual portal (English / Kiswahili) end-to-end.</a:t>
+              <a:t>•  Plain-language bilingual forms (e.g. Receipt No / Namba ya risiti ya malipo).</a:t>
             </a:r>
           </a:p>
         </p:txBody>

</xml_diff>

<commit_message>
Align bilingual forms and CSV templates
Use consistent receipt, gender, business-type, and login wording across English and Swahili while generating importable CSV templates in the selected language and removing redundant age messaging.

Co-authored-by: Cursor <cursoragent@cursor.com>
</commit_message>
<xml_diff>
--- a/Presentation/Ushirika_Group15_Defence_Presentation.pptx
+++ b/Presentation/Ushirika_Group15_Defence_Presentation.pptx
@@ -8659,7 +8659,7 @@
                 </a:solidFill>
                 <a:latin typeface="Calibri"/>
               </a:rPr>
-              <a:t>Strict age, phone, email</a:t>
+              <a:t>NIDA-DOB, phone, email</a:t>
             </a:r>
           </a:p>
           <a:p>
@@ -9236,7 +9236,7 @@
                 </a:solidFill>
                 <a:latin typeface="Calibri"/>
               </a:rPr>
-              <a:t>Inclusive controls: +255 phone entry, age 18+ eligibility, Male/Female choices, live email checks, and clear bilingual labels.</a:t>
+              <a:t>Inclusive controls: NIDA-DOB matching, +255 phone entry, bilingual gender/business labels, live email checks, and clear forms.</a:t>
             </a:r>
           </a:p>
         </p:txBody>
@@ -13932,7 +13932,7 @@
                 </a:solidFill>
                 <a:latin typeface="Calibri"/>
               </a:rPr>
-              <a:t>•  Input validation: 20-digit NIDA with DOB match (DD-MM-YYYY), +255 phone, live email checks, age 18+, and no future dates.</a:t>
+              <a:t>•  Input validation: 20-digit NIDA with DOB match (DD-MM-YYYY), +255 phone, live email checks, and no future dates.</a:t>
             </a:r>
           </a:p>
           <a:p>
@@ -14191,7 +14191,7 @@
                 </a:solidFill>
                 <a:latin typeface="Calibri"/>
               </a:rPr>
-              <a:t>•  Plain-language bilingual forms (e.g. Receipt No / Namba ya risiti ya malipo).</a:t>
+              <a:t>•  Language-matched CSV templates and forms (Receipt No. / Namba ya Stakabadhi).</a:t>
             </a:r>
           </a:p>
         </p:txBody>

</xml_diff>

<commit_message>
Fix sleep-safe logout and complete dashboard translations
Enforce the 90-second idle deadline across browser sleep and wake events, and remove remaining hardcoded account UI so headers, forms, dialogs, statuses, and metrics follow the selected language.

Co-authored-by: Cursor <cursoragent@cursor.com>
</commit_message>
<xml_diff>
--- a/Presentation/Ushirika_Group15_Defence_Presentation.pptx
+++ b/Presentation/Ushirika_Group15_Defence_Presentation.pptx
@@ -13951,7 +13951,7 @@
                 </a:solidFill>
                 <a:latin typeface="Calibri"/>
               </a:rPr>
-              <a:t>•  Stable sessions: 4-hour tokens, auto sign-out after 15 min idle, clean redirect on expiry.</a:t>
+              <a:t>•  Stable sessions: 4-hour tokens, reliable 90-second idle sign-out across device sleep/wake, and clean expiry redirects.</a:t>
             </a:r>
           </a:p>
           <a:p>
@@ -14191,7 +14191,7 @@
                 </a:solidFill>
                 <a:latin typeface="Calibri"/>
               </a:rPr>
-              <a:t>•  Language-matched CSV templates and forms (Receipt No. / Namba ya Stakabadhi).</a:t>
+              <a:t>•  Fully bilingual account dashboards, headers, forms, and language-matched CSV templates.</a:t>
             </a:r>
           </a:p>
         </p:txBody>

</xml_diff>

<commit_message>
Verify phone in PIN recovery and add instant per-field form errors
Co-authored-by: Cursor <cursoragent@cursor.com>
</commit_message>
<xml_diff>
--- a/Presentation/Ushirika_Group15_Defence_Presentation.pptx
+++ b/Presentation/Ushirika_Group15_Defence_Presentation.pptx
@@ -13933,6 +13933,44 @@
                 <a:latin typeface="Calibri"/>
               </a:rPr>
               <a:t>•  Input validation: 20-digit NIDA with DOB match (DD-MM-YYYY), +255 phone, live email checks, and no future dates.</a:t>
+            </a:r>
+          </a:p>
+          <a:p>
+            <a:pPr algn="l">
+              <a:spcBef>
+                <a:spcPts val="400"/>
+              </a:spcBef>
+              <a:spcAft>
+                <a:spcPts val="400"/>
+              </a:spcAft>
+            </a:pPr>
+            <a:r>
+              <a:rPr sz="1300" b="0">
+                <a:solidFill>
+                  <a:srgbClr val="0F2830"/>
+                </a:solidFill>
+                <a:latin typeface="Calibri"/>
+              </a:rPr>
+              <a:t>•  Instant per-field errors: every form flags mistakes on the field itself before the user moves on.</a:t>
+            </a:r>
+          </a:p>
+          <a:p>
+            <a:pPr algn="l">
+              <a:spcBef>
+                <a:spcPts val="400"/>
+              </a:spcBef>
+              <a:spcAft>
+                <a:spcPts val="400"/>
+              </a:spcAft>
+            </a:pPr>
+            <a:r>
+              <a:rPr sz="1300" b="0">
+                <a:solidFill>
+                  <a:srgbClr val="0F2830"/>
+                </a:solidFill>
+                <a:latin typeface="Calibri"/>
+              </a:rPr>
+              <a:t>•  PIN recovery verifies both birth date and registered phone number before a reset.</a:t>
             </a:r>
           </a:p>
           <a:p>

</xml_diff>

<commit_message>
Improve form error targeting, optional counterparty TIN, and lender list labels
Co-authored-by: Cursor <cursoragent@cursor.com>
</commit_message>
<xml_diff>
--- a/Presentation/Ushirika_Group15_Defence_Presentation.pptx
+++ b/Presentation/Ushirika_Group15_Defence_Presentation.pptx
@@ -13951,7 +13951,26 @@
                 </a:solidFill>
                 <a:latin typeface="Calibri"/>
               </a:rPr>
-              <a:t>•  Instant per-field errors: every form flags mistakes on the field itself before the user moves on.</a:t>
+              <a:t>•  Instant per-field errors: forms flag mistakes on the field itself and PIN recovery enforces step-by-step completion.</a:t>
+            </a:r>
+          </a:p>
+          <a:p>
+            <a:pPr algn="l">
+              <a:spcBef>
+                <a:spcPts val="400"/>
+              </a:spcBef>
+              <a:spcAft>
+                <a:spcPts val="400"/>
+              </a:spcAft>
+            </a:pPr>
+            <a:r>
+              <a:rPr sz="1300" b="0">
+                <a:solidFill>
+                  <a:srgbClr val="0F2830"/>
+                </a:solidFill>
+                <a:latin typeface="Calibri"/>
+              </a:rPr>
+              <a:t>•  Counterparty TIN optional on transactions — informal buyers/sellers without TIN are supported.</a:t>
             </a:r>
           </a:p>
           <a:p>

</xml_diff>

<commit_message>
Update findings chapters and panel defence deck
Align Chapters 4–5 with measured model results and current prototype capabilities, while keeping the defence presentation concise and evidence-led for panel review.

Co-authored-by: Cursor <cursoragent@cursor.com>
</commit_message>
<xml_diff>
--- a/Presentation/Ushirika_Group15_Defence_Presentation.pptx
+++ b/Presentation/Ushirika_Group15_Defence_Presentation.pptx
@@ -5187,7 +5187,7 @@
                 </a:solidFill>
                 <a:latin typeface="Calibri"/>
               </a:rPr>
-              <a:t>•  Prototype scope — not yet a full bank production system.</a:t>
+              <a:t>•  Online prototype is operational, but not yet a bank-production system.</a:t>
             </a:r>
           </a:p>
           <a:p>
@@ -5206,7 +5206,7 @@
                 </a:solidFill>
                 <a:latin typeface="Calibri"/>
               </a:rPr>
-              <a:t>•  Training still relies partly on synthetic bootstrap when live SMEs are few.</a:t>
+              <a:t>•  Training still partly uses synthetic bootstrap and engineered labels.</a:t>
             </a:r>
           </a:p>
           <a:p>
@@ -5225,7 +5225,7 @@
                 </a:solidFill>
                 <a:latin typeface="Calibri"/>
               </a:rPr>
-              <a:t>•  Need larger, multi-sector Tanzanian transaction panels.</a:t>
+              <a:t>•  Need longitudinal repayment outcomes from multiple Tanzanian sectors.</a:t>
             </a:r>
           </a:p>
           <a:p>
@@ -5244,7 +5244,7 @@
                 </a:solidFill>
                 <a:latin typeface="Calibri"/>
               </a:rPr>
-              <a:t>•  Future: XGBoost/GBM, live ERP connectors, stronger model monitoring.</a:t>
+              <a:t>•  Pilot priorities: fairness, calibration, drift, security and human review.</a:t>
             </a:r>
           </a:p>
           <a:p>
@@ -5263,7 +5263,7 @@
                 </a:solidFill>
                 <a:latin typeface="Calibri"/>
               </a:rPr>
-              <a:t>•  Future: formal NIDA verification and managed Postgres.</a:t>
+              <a:t>•  Production: verified NIDA, managed Postgres, ERP/payment integrations.</a:t>
             </a:r>
           </a:p>
         </p:txBody>
@@ -12561,7 +12561,7 @@
                 </a:solidFill>
                 <a:latin typeface="Georgia"/>
               </a:rPr>
-              <a:t>Ensemble Random Forest outperforms classical Logistic Regression</a:t>
+              <a:t>Random Forest outperformed Logistic Regression on unseen test data</a:t>
             </a:r>
           </a:p>
         </p:txBody>
@@ -13309,7 +13309,7 @@
                 </a:solidFill>
                 <a:latin typeface="Calibri"/>
               </a:rPr>
-              <a:t>Hold-out comparison (seed=42) — metrics from model_meta.json</a:t>
+              <a:t>Hold-out comparison: 280 unseen records · stratified split · seed=42</a:t>
             </a:r>
           </a:p>
         </p:txBody>
@@ -13408,7 +13408,7 @@
                 </a:solidFill>
                 <a:latin typeface="Calibri"/>
               </a:rPr>
-              <a:t>•  Evidence is reproducible via scripts/train_model.py and stored artifacts under Backend/models/.</a:t>
+              <a:t>•  Interpretation: RF ranked higher-risk vs creditworthy cases more reliably; this supports its selection for the prototype.</a:t>
             </a:r>
           </a:p>
         </p:txBody>
@@ -13856,7 +13856,7 @@
                 </a:solidFill>
                 <a:latin typeface="Calibri"/>
               </a:rPr>
-              <a:t>•  k-fold GridSearchCV on the training split reduces overfitting risk.</a:t>
+              <a:t>•  5-fold GridSearchCV on training data only reduces leakage and overfitting risk.</a:t>
             </a:r>
           </a:p>
           <a:p>
@@ -13894,7 +13894,7 @@
                 </a:solidFill>
                 <a:latin typeface="Calibri"/>
               </a:rPr>
-              <a:t>•  Conservative score mapping (~300–680) and explicit risk bands.</a:t>
+              <a:t>•  Score mapping (~300–680) uses explicit Low / Medium / High bands.</a:t>
             </a:r>
           </a:p>
           <a:p>
@@ -13913,7 +13913,7 @@
                 </a:solidFill>
                 <a:latin typeface="Calibri"/>
               </a:rPr>
-              <a:t>•  Financing capped at ~50% of typical (non-outlier) volume — reduces unpaid-loan risk.</a:t>
+              <a:t>•  Financing capped at ~50% of typical non-outlier volume.</a:t>
             </a:r>
           </a:p>
           <a:p>
@@ -13932,102 +13932,7 @@
                 </a:solidFill>
                 <a:latin typeface="Calibri"/>
               </a:rPr>
-              <a:t>•  Input validation: 20-digit NIDA with DOB match (DD-MM-YYYY), +255 phone, live email checks, and no future dates.</a:t>
-            </a:r>
-          </a:p>
-          <a:p>
-            <a:pPr algn="l">
-              <a:spcBef>
-                <a:spcPts val="400"/>
-              </a:spcBef>
-              <a:spcAft>
-                <a:spcPts val="400"/>
-              </a:spcAft>
-            </a:pPr>
-            <a:r>
-              <a:rPr sz="1300" b="0">
-                <a:solidFill>
-                  <a:srgbClr val="0F2830"/>
-                </a:solidFill>
-                <a:latin typeface="Calibri"/>
-              </a:rPr>
-              <a:t>•  Instant per-field errors: forms flag mistakes on the field itself and PIN recovery enforces step-by-step completion.</a:t>
-            </a:r>
-          </a:p>
-          <a:p>
-            <a:pPr algn="l">
-              <a:spcBef>
-                <a:spcPts val="400"/>
-              </a:spcBef>
-              <a:spcAft>
-                <a:spcPts val="400"/>
-              </a:spcAft>
-            </a:pPr>
-            <a:r>
-              <a:rPr sz="1300" b="0">
-                <a:solidFill>
-                  <a:srgbClr val="0F2830"/>
-                </a:solidFill>
-                <a:latin typeface="Calibri"/>
-              </a:rPr>
-              <a:t>•  Counterparty TIN optional on transactions — informal buyers/sellers without TIN are supported.</a:t>
-            </a:r>
-          </a:p>
-          <a:p>
-            <a:pPr algn="l">
-              <a:spcBef>
-                <a:spcPts val="400"/>
-              </a:spcBef>
-              <a:spcAft>
-                <a:spcPts val="400"/>
-              </a:spcAft>
-            </a:pPr>
-            <a:r>
-              <a:rPr sz="1300" b="0">
-                <a:solidFill>
-                  <a:srgbClr val="0F2830"/>
-                </a:solidFill>
-                <a:latin typeface="Calibri"/>
-              </a:rPr>
-              <a:t>•  PIN recovery verifies both birth date and registered phone number before a reset.</a:t>
-            </a:r>
-          </a:p>
-          <a:p>
-            <a:pPr algn="l">
-              <a:spcBef>
-                <a:spcPts val="400"/>
-              </a:spcBef>
-              <a:spcAft>
-                <a:spcPts val="400"/>
-              </a:spcAft>
-            </a:pPr>
-            <a:r>
-              <a:rPr sz="1300" b="0">
-                <a:solidFill>
-                  <a:srgbClr val="0F2830"/>
-                </a:solidFill>
-                <a:latin typeface="Calibri"/>
-              </a:rPr>
-              <a:t>•  Stable sessions: 4-hour tokens, reliable 90-second idle sign-out across device sleep/wake, and clean expiry redirects.</a:t>
-            </a:r>
-          </a:p>
-          <a:p>
-            <a:pPr algn="l">
-              <a:spcBef>
-                <a:spcPts val="400"/>
-              </a:spcBef>
-              <a:spcAft>
-                <a:spcPts val="400"/>
-              </a:spcAft>
-            </a:pPr>
-            <a:r>
-              <a:rPr sz="1300" b="0">
-                <a:solidFill>
-                  <a:srgbClr val="0F2830"/>
-                </a:solidFill>
-                <a:latin typeface="Calibri"/>
-              </a:rPr>
-              <a:t>•  Technical Performance Report documents honesty of evaluation.</a:t>
+              <a:t>•  PII is excluded from ML features; counterparties are pseudonymised.</a:t>
             </a:r>
           </a:p>
         </p:txBody>
@@ -14172,7 +14077,7 @@
                 </a:solidFill>
                 <a:latin typeface="Calibri"/>
               </a:rPr>
-              <a:t>•  Eligible financing (TZS) with 25% outlier-aware caps.</a:t>
+              <a:t>•  Creditworthy probability + indicative financing (TZS).</a:t>
             </a:r>
           </a:p>
           <a:p>
@@ -14191,7 +14096,7 @@
                 </a:solidFill>
                 <a:latin typeface="Calibri"/>
               </a:rPr>
-              <a:t>•  Crucial score signals only (not every engineered feature).</a:t>
+              <a:t>•  Explainable behavioural signals for each SME.</a:t>
             </a:r>
           </a:p>
           <a:p>
@@ -14210,7 +14115,7 @@
                 </a:solidFill>
                 <a:latin typeface="Calibri"/>
               </a:rPr>
-              <a:t>•  Lender: progressive NIDA search + tabbed SME analytics.</a:t>
+              <a:t>•  Bilingual SME, lender, admin and sub-admin workflows.</a:t>
             </a:r>
           </a:p>
           <a:p>
@@ -14229,7 +14134,7 @@
                 </a:solidFill>
                 <a:latin typeface="Calibri"/>
               </a:rPr>
-              <a:t>•  TIN shown on SME profile (SME + Lender views).</a:t>
+              <a:t>•  English / Kiswahili CSV templates and manual entry.</a:t>
             </a:r>
           </a:p>
           <a:p>
@@ -14248,7 +14153,7 @@
                 </a:solidFill>
                 <a:latin typeface="Calibri"/>
               </a:rPr>
-              <a:t>•  Fully bilingual account dashboards, headers, forms, and language-matched CSV templates.</a:t>
+              <a:t>•  Optional counterparty TIN supports informal trading partners.</a:t>
             </a:r>
           </a:p>
         </p:txBody>

</xml_diff>

<commit_message>
Add cascading Tanzania district selection after region.
Clients pick a region then a matching district on registration, admin create/edit, and profile forms, with backend validation and schema migration.

Co-authored-by: Cursor <cursoragent@cursor.com>
</commit_message>
<xml_diff>
--- a/Presentation/Ushirika_Group15_Defence_Presentation.pptx
+++ b/Presentation/Ushirika_Group15_Defence_Presentation.pptx
@@ -5,20 +5,20 @@
     <p:sldMasterId id="2147483648" r:id="rId1"/>
   </p:sldMasterIdLst>
   <p:sldIdLst>
-    <p:sldId id="256" r:id="rId2"/>
-    <p:sldId id="257" r:id="rId3"/>
-    <p:sldId id="258" r:id="rId4"/>
-    <p:sldId id="259" r:id="rId5"/>
-    <p:sldId id="260" r:id="rId6"/>
-    <p:sldId id="261" r:id="rId7"/>
-    <p:sldId id="262" r:id="rId8"/>
-    <p:sldId id="263" r:id="rId9"/>
-    <p:sldId id="264" r:id="rId10"/>
-    <p:sldId id="265" r:id="rId11"/>
-    <p:sldId id="266" r:id="rId12"/>
-    <p:sldId id="267" r:id="rId13"/>
+    <p:sldId id="256" r:id="rId7"/>
+    <p:sldId id="257" r:id="rId8"/>
+    <p:sldId id="258" r:id="rId9"/>
+    <p:sldId id="259" r:id="rId10"/>
+    <p:sldId id="260" r:id="rId11"/>
+    <p:sldId id="261" r:id="rId12"/>
+    <p:sldId id="262" r:id="rId13"/>
+    <p:sldId id="263" r:id="rId14"/>
+    <p:sldId id="264" r:id="rId15"/>
+    <p:sldId id="265" r:id="rId16"/>
+    <p:sldId id="266" r:id="rId17"/>
+    <p:sldId id="267" r:id="rId18"/>
   </p:sldIdLst>
-  <p:sldSz cx="12192000" cy="6858000"/>
+  <p:sldSz cx="12191695" cy="6858000" type="screen4x3"/>
   <p:notesSz cx="6858000" cy="9144000"/>
   <p:defaultTextStyle>
     <a:defPPr>
@@ -115,22 +115,6 @@
       </a:defRPr>
     </a:lvl9pPr>
   </p:defaultTextStyle>
-  <p:extLst>
-    <p:ext uri="{EFAFB233-063F-42B5-8137-9DF3F51BA10A}">
-      <p15:sldGuideLst xmlns:p15="http://schemas.microsoft.com/office/powerpoint/2012/main">
-        <p15:guide id="1" orient="horz" pos="2160">
-          <p15:clr>
-            <a:srgbClr val="A4A3A4"/>
-          </p15:clr>
-        </p15:guide>
-        <p15:guide id="2" pos="2880">
-          <p15:clr>
-            <a:srgbClr val="A4A3A4"/>
-          </p15:clr>
-        </p15:guide>
-      </p15:sldGuideLst>
-    </p:ext>
-  </p:extLst>
 </p:presentation>
 </file>
 
@@ -172,9 +156,10 @@
           <a:lstStyle/>
           <a:p>
             <a:r>
-              <a:rPr lang="en-US"/>
+              <a:rPr lang="en-US" smtClean="0"/>
               <a:t>Click to edit Master title style</a:t>
             </a:r>
+            <a:endParaRPr lang="en-US"/>
           </a:p>
         </p:txBody>
       </p:sp>
@@ -290,9 +275,10 @@
           </a:lstStyle>
           <a:p>
             <a:r>
-              <a:rPr lang="en-US"/>
+              <a:rPr lang="en-US" smtClean="0"/>
               <a:t>Click to edit Master subtitle style</a:t>
             </a:r>
+            <a:endParaRPr lang="en-US"/>
           </a:p>
         </p:txBody>
       </p:sp>
@@ -313,7 +299,7 @@
           <a:p>
             <a:fld id="{5BCAD085-E8A6-8845-BD4E-CB4CCA059FC4}" type="datetimeFigureOut">
               <a:rPr lang="en-US" smtClean="0"/>
-              <a:t>7/22/2026</a:t>
+              <a:t>1/27/13</a:t>
             </a:fld>
             <a:endParaRPr lang="en-US"/>
           </a:p>
@@ -407,9 +393,10 @@
           <a:lstStyle/>
           <a:p>
             <a:r>
-              <a:rPr lang="en-US"/>
+              <a:rPr lang="en-US" smtClean="0"/>
               <a:t>Click to edit Master title style</a:t>
             </a:r>
+            <a:endParaRPr lang="en-US"/>
           </a:p>
         </p:txBody>
       </p:sp>
@@ -430,37 +417,38 @@
           <a:p>
             <a:pPr lvl="0"/>
             <a:r>
-              <a:rPr lang="en-US"/>
+              <a:rPr lang="en-US" smtClean="0"/>
               <a:t>Click to edit Master text styles</a:t>
             </a:r>
           </a:p>
           <a:p>
             <a:pPr lvl="1"/>
             <a:r>
-              <a:rPr lang="en-US"/>
+              <a:rPr lang="en-US" smtClean="0"/>
               <a:t>Second level</a:t>
             </a:r>
           </a:p>
           <a:p>
             <a:pPr lvl="2"/>
             <a:r>
-              <a:rPr lang="en-US"/>
+              <a:rPr lang="en-US" smtClean="0"/>
               <a:t>Third level</a:t>
             </a:r>
           </a:p>
           <a:p>
             <a:pPr lvl="3"/>
             <a:r>
-              <a:rPr lang="en-US"/>
+              <a:rPr lang="en-US" smtClean="0"/>
               <a:t>Fourth level</a:t>
             </a:r>
           </a:p>
           <a:p>
             <a:pPr lvl="4"/>
             <a:r>
-              <a:rPr lang="en-US"/>
+              <a:rPr lang="en-US" smtClean="0"/>
               <a:t>Fifth level</a:t>
             </a:r>
+            <a:endParaRPr lang="en-US"/>
           </a:p>
         </p:txBody>
       </p:sp>
@@ -481,7 +469,7 @@
           <a:p>
             <a:fld id="{5BCAD085-E8A6-8845-BD4E-CB4CCA059FC4}" type="datetimeFigureOut">
               <a:rPr lang="en-US" smtClean="0"/>
-              <a:t>7/22/2026</a:t>
+              <a:t>1/27/13</a:t>
             </a:fld>
             <a:endParaRPr lang="en-US"/>
           </a:p>
@@ -580,9 +568,10 @@
           <a:lstStyle/>
           <a:p>
             <a:r>
-              <a:rPr lang="en-US"/>
+              <a:rPr lang="en-US" smtClean="0"/>
               <a:t>Click to edit Master title style</a:t>
             </a:r>
+            <a:endParaRPr lang="en-US"/>
           </a:p>
         </p:txBody>
       </p:sp>
@@ -608,37 +597,38 @@
           <a:p>
             <a:pPr lvl="0"/>
             <a:r>
-              <a:rPr lang="en-US"/>
+              <a:rPr lang="en-US" smtClean="0"/>
               <a:t>Click to edit Master text styles</a:t>
             </a:r>
           </a:p>
           <a:p>
             <a:pPr lvl="1"/>
             <a:r>
-              <a:rPr lang="en-US"/>
+              <a:rPr lang="en-US" smtClean="0"/>
               <a:t>Second level</a:t>
             </a:r>
           </a:p>
           <a:p>
             <a:pPr lvl="2"/>
             <a:r>
-              <a:rPr lang="en-US"/>
+              <a:rPr lang="en-US" smtClean="0"/>
               <a:t>Third level</a:t>
             </a:r>
           </a:p>
           <a:p>
             <a:pPr lvl="3"/>
             <a:r>
-              <a:rPr lang="en-US"/>
+              <a:rPr lang="en-US" smtClean="0"/>
               <a:t>Fourth level</a:t>
             </a:r>
           </a:p>
           <a:p>
             <a:pPr lvl="4"/>
             <a:r>
-              <a:rPr lang="en-US"/>
+              <a:rPr lang="en-US" smtClean="0"/>
               <a:t>Fifth level</a:t>
             </a:r>
+            <a:endParaRPr lang="en-US"/>
           </a:p>
         </p:txBody>
       </p:sp>
@@ -659,7 +649,7 @@
           <a:p>
             <a:fld id="{5BCAD085-E8A6-8845-BD4E-CB4CCA059FC4}" type="datetimeFigureOut">
               <a:rPr lang="en-US" smtClean="0"/>
-              <a:t>7/22/2026</a:t>
+              <a:t>1/27/13</a:t>
             </a:fld>
             <a:endParaRPr lang="en-US"/>
           </a:p>
@@ -753,9 +743,10 @@
           <a:lstStyle/>
           <a:p>
             <a:r>
-              <a:rPr lang="en-US"/>
+              <a:rPr lang="en-US" smtClean="0"/>
               <a:t>Click to edit Master title style</a:t>
             </a:r>
+            <a:endParaRPr lang="en-US"/>
           </a:p>
         </p:txBody>
       </p:sp>
@@ -776,37 +767,38 @@
           <a:p>
             <a:pPr lvl="0"/>
             <a:r>
-              <a:rPr lang="en-US"/>
+              <a:rPr lang="en-US" smtClean="0"/>
               <a:t>Click to edit Master text styles</a:t>
             </a:r>
           </a:p>
           <a:p>
             <a:pPr lvl="1"/>
             <a:r>
-              <a:rPr lang="en-US"/>
+              <a:rPr lang="en-US" smtClean="0"/>
               <a:t>Second level</a:t>
             </a:r>
           </a:p>
           <a:p>
             <a:pPr lvl="2"/>
             <a:r>
-              <a:rPr lang="en-US"/>
+              <a:rPr lang="en-US" smtClean="0"/>
               <a:t>Third level</a:t>
             </a:r>
           </a:p>
           <a:p>
             <a:pPr lvl="3"/>
             <a:r>
-              <a:rPr lang="en-US"/>
+              <a:rPr lang="en-US" smtClean="0"/>
               <a:t>Fourth level</a:t>
             </a:r>
           </a:p>
           <a:p>
             <a:pPr lvl="4"/>
             <a:r>
-              <a:rPr lang="en-US"/>
+              <a:rPr lang="en-US" smtClean="0"/>
               <a:t>Fifth level</a:t>
             </a:r>
+            <a:endParaRPr lang="en-US"/>
           </a:p>
         </p:txBody>
       </p:sp>
@@ -827,7 +819,7 @@
           <a:p>
             <a:fld id="{5BCAD085-E8A6-8845-BD4E-CB4CCA059FC4}" type="datetimeFigureOut">
               <a:rPr lang="en-US" smtClean="0"/>
-              <a:t>7/22/2026</a:t>
+              <a:t>1/27/13</a:t>
             </a:fld>
             <a:endParaRPr lang="en-US"/>
           </a:p>
@@ -930,9 +922,10 @@
           </a:lstStyle>
           <a:p>
             <a:r>
-              <a:rPr lang="en-US"/>
+              <a:rPr lang="en-US" smtClean="0"/>
               <a:t>Click to edit Master title style</a:t>
             </a:r>
+            <a:endParaRPr lang="en-US"/>
           </a:p>
         </p:txBody>
       </p:sp>
@@ -1049,7 +1042,7 @@
           <a:p>
             <a:pPr lvl="0"/>
             <a:r>
-              <a:rPr lang="en-US"/>
+              <a:rPr lang="en-US" smtClean="0"/>
               <a:t>Click to edit Master text styles</a:t>
             </a:r>
           </a:p>
@@ -1072,7 +1065,7 @@
           <a:p>
             <a:fld id="{5BCAD085-E8A6-8845-BD4E-CB4CCA059FC4}" type="datetimeFigureOut">
               <a:rPr lang="en-US" smtClean="0"/>
-              <a:t>7/22/2026</a:t>
+              <a:t>1/27/13</a:t>
             </a:fld>
             <a:endParaRPr lang="en-US"/>
           </a:p>
@@ -1166,9 +1159,10 @@
           <a:lstStyle/>
           <a:p>
             <a:r>
-              <a:rPr lang="en-US"/>
+              <a:rPr lang="en-US" smtClean="0"/>
               <a:t>Click to edit Master title style</a:t>
             </a:r>
+            <a:endParaRPr lang="en-US"/>
           </a:p>
         </p:txBody>
       </p:sp>
@@ -1222,37 +1216,38 @@
           <a:p>
             <a:pPr lvl="0"/>
             <a:r>
-              <a:rPr lang="en-US"/>
+              <a:rPr lang="en-US" smtClean="0"/>
               <a:t>Click to edit Master text styles</a:t>
             </a:r>
           </a:p>
           <a:p>
             <a:pPr lvl="1"/>
             <a:r>
-              <a:rPr lang="en-US"/>
+              <a:rPr lang="en-US" smtClean="0"/>
               <a:t>Second level</a:t>
             </a:r>
           </a:p>
           <a:p>
             <a:pPr lvl="2"/>
             <a:r>
-              <a:rPr lang="en-US"/>
+              <a:rPr lang="en-US" smtClean="0"/>
               <a:t>Third level</a:t>
             </a:r>
           </a:p>
           <a:p>
             <a:pPr lvl="3"/>
             <a:r>
-              <a:rPr lang="en-US"/>
+              <a:rPr lang="en-US" smtClean="0"/>
               <a:t>Fourth level</a:t>
             </a:r>
           </a:p>
           <a:p>
             <a:pPr lvl="4"/>
             <a:r>
-              <a:rPr lang="en-US"/>
+              <a:rPr lang="en-US" smtClean="0"/>
               <a:t>Fifth level</a:t>
             </a:r>
+            <a:endParaRPr lang="en-US"/>
           </a:p>
         </p:txBody>
       </p:sp>
@@ -1306,37 +1301,38 @@
           <a:p>
             <a:pPr lvl="0"/>
             <a:r>
-              <a:rPr lang="en-US"/>
+              <a:rPr lang="en-US" smtClean="0"/>
               <a:t>Click to edit Master text styles</a:t>
             </a:r>
           </a:p>
           <a:p>
             <a:pPr lvl="1"/>
             <a:r>
-              <a:rPr lang="en-US"/>
+              <a:rPr lang="en-US" smtClean="0"/>
               <a:t>Second level</a:t>
             </a:r>
           </a:p>
           <a:p>
             <a:pPr lvl="2"/>
             <a:r>
-              <a:rPr lang="en-US"/>
+              <a:rPr lang="en-US" smtClean="0"/>
               <a:t>Third level</a:t>
             </a:r>
           </a:p>
           <a:p>
             <a:pPr lvl="3"/>
             <a:r>
-              <a:rPr lang="en-US"/>
+              <a:rPr lang="en-US" smtClean="0"/>
               <a:t>Fourth level</a:t>
             </a:r>
           </a:p>
           <a:p>
             <a:pPr lvl="4"/>
             <a:r>
-              <a:rPr lang="en-US"/>
+              <a:rPr lang="en-US" smtClean="0"/>
               <a:t>Fifth level</a:t>
             </a:r>
+            <a:endParaRPr lang="en-US"/>
           </a:p>
         </p:txBody>
       </p:sp>
@@ -1357,7 +1353,7 @@
           <a:p>
             <a:fld id="{5BCAD085-E8A6-8845-BD4E-CB4CCA059FC4}" type="datetimeFigureOut">
               <a:rPr lang="en-US" smtClean="0"/>
-              <a:t>7/22/2026</a:t>
+              <a:t>1/27/13</a:t>
             </a:fld>
             <a:endParaRPr lang="en-US"/>
           </a:p>
@@ -1455,9 +1451,10 @@
           </a:lstStyle>
           <a:p>
             <a:r>
-              <a:rPr lang="en-US"/>
+              <a:rPr lang="en-US" smtClean="0"/>
               <a:t>Click to edit Master title style</a:t>
             </a:r>
+            <a:endParaRPr lang="en-US"/>
           </a:p>
         </p:txBody>
       </p:sp>
@@ -1520,7 +1517,7 @@
           <a:p>
             <a:pPr lvl="0"/>
             <a:r>
-              <a:rPr lang="en-US"/>
+              <a:rPr lang="en-US" smtClean="0"/>
               <a:t>Click to edit Master text styles</a:t>
             </a:r>
           </a:p>
@@ -1576,37 +1573,38 @@
           <a:p>
             <a:pPr lvl="0"/>
             <a:r>
-              <a:rPr lang="en-US"/>
+              <a:rPr lang="en-US" smtClean="0"/>
               <a:t>Click to edit Master text styles</a:t>
             </a:r>
           </a:p>
           <a:p>
             <a:pPr lvl="1"/>
             <a:r>
-              <a:rPr lang="en-US"/>
+              <a:rPr lang="en-US" smtClean="0"/>
               <a:t>Second level</a:t>
             </a:r>
           </a:p>
           <a:p>
             <a:pPr lvl="2"/>
             <a:r>
-              <a:rPr lang="en-US"/>
+              <a:rPr lang="en-US" smtClean="0"/>
               <a:t>Third level</a:t>
             </a:r>
           </a:p>
           <a:p>
             <a:pPr lvl="3"/>
             <a:r>
-              <a:rPr lang="en-US"/>
+              <a:rPr lang="en-US" smtClean="0"/>
               <a:t>Fourth level</a:t>
             </a:r>
           </a:p>
           <a:p>
             <a:pPr lvl="4"/>
             <a:r>
-              <a:rPr lang="en-US"/>
+              <a:rPr lang="en-US" smtClean="0"/>
               <a:t>Fifth level</a:t>
             </a:r>
+            <a:endParaRPr lang="en-US"/>
           </a:p>
         </p:txBody>
       </p:sp>
@@ -1669,7 +1667,7 @@
           <a:p>
             <a:pPr lvl="0"/>
             <a:r>
-              <a:rPr lang="en-US"/>
+              <a:rPr lang="en-US" smtClean="0"/>
               <a:t>Click to edit Master text styles</a:t>
             </a:r>
           </a:p>
@@ -1725,37 +1723,38 @@
           <a:p>
             <a:pPr lvl="0"/>
             <a:r>
-              <a:rPr lang="en-US"/>
+              <a:rPr lang="en-US" smtClean="0"/>
               <a:t>Click to edit Master text styles</a:t>
             </a:r>
           </a:p>
           <a:p>
             <a:pPr lvl="1"/>
             <a:r>
-              <a:rPr lang="en-US"/>
+              <a:rPr lang="en-US" smtClean="0"/>
               <a:t>Second level</a:t>
             </a:r>
           </a:p>
           <a:p>
             <a:pPr lvl="2"/>
             <a:r>
-              <a:rPr lang="en-US"/>
+              <a:rPr lang="en-US" smtClean="0"/>
               <a:t>Third level</a:t>
             </a:r>
           </a:p>
           <a:p>
             <a:pPr lvl="3"/>
             <a:r>
-              <a:rPr lang="en-US"/>
+              <a:rPr lang="en-US" smtClean="0"/>
               <a:t>Fourth level</a:t>
             </a:r>
           </a:p>
           <a:p>
             <a:pPr lvl="4"/>
             <a:r>
-              <a:rPr lang="en-US"/>
+              <a:rPr lang="en-US" smtClean="0"/>
               <a:t>Fifth level</a:t>
             </a:r>
+            <a:endParaRPr lang="en-US"/>
           </a:p>
         </p:txBody>
       </p:sp>
@@ -1776,7 +1775,7 @@
           <a:p>
             <a:fld id="{5BCAD085-E8A6-8845-BD4E-CB4CCA059FC4}" type="datetimeFigureOut">
               <a:rPr lang="en-US" smtClean="0"/>
-              <a:t>7/22/2026</a:t>
+              <a:t>1/27/13</a:t>
             </a:fld>
             <a:endParaRPr lang="en-US"/>
           </a:p>
@@ -1870,9 +1869,10 @@
           <a:lstStyle/>
           <a:p>
             <a:r>
-              <a:rPr lang="en-US"/>
+              <a:rPr lang="en-US" smtClean="0"/>
               <a:t>Click to edit Master title style</a:t>
             </a:r>
+            <a:endParaRPr lang="en-US"/>
           </a:p>
         </p:txBody>
       </p:sp>
@@ -1893,7 +1893,7 @@
           <a:p>
             <a:fld id="{5BCAD085-E8A6-8845-BD4E-CB4CCA059FC4}" type="datetimeFigureOut">
               <a:rPr lang="en-US" smtClean="0"/>
-              <a:t>7/22/2026</a:t>
+              <a:t>1/27/13</a:t>
             </a:fld>
             <a:endParaRPr lang="en-US"/>
           </a:p>
@@ -1988,7 +1988,7 @@
           <a:p>
             <a:fld id="{5BCAD085-E8A6-8845-BD4E-CB4CCA059FC4}" type="datetimeFigureOut">
               <a:rPr lang="en-US" smtClean="0"/>
-              <a:t>7/22/2026</a:t>
+              <a:t>1/27/13</a:t>
             </a:fld>
             <a:endParaRPr lang="en-US"/>
           </a:p>
@@ -2091,9 +2091,10 @@
           </a:lstStyle>
           <a:p>
             <a:r>
-              <a:rPr lang="en-US"/>
+              <a:rPr lang="en-US" smtClean="0"/>
               <a:t>Click to edit Master title style</a:t>
             </a:r>
+            <a:endParaRPr lang="en-US"/>
           </a:p>
         </p:txBody>
       </p:sp>
@@ -2147,37 +2148,38 @@
           <a:p>
             <a:pPr lvl="0"/>
             <a:r>
-              <a:rPr lang="en-US"/>
+              <a:rPr lang="en-US" smtClean="0"/>
               <a:t>Click to edit Master text styles</a:t>
             </a:r>
           </a:p>
           <a:p>
             <a:pPr lvl="1"/>
             <a:r>
-              <a:rPr lang="en-US"/>
+              <a:rPr lang="en-US" smtClean="0"/>
               <a:t>Second level</a:t>
             </a:r>
           </a:p>
           <a:p>
             <a:pPr lvl="2"/>
             <a:r>
-              <a:rPr lang="en-US"/>
+              <a:rPr lang="en-US" smtClean="0"/>
               <a:t>Third level</a:t>
             </a:r>
           </a:p>
           <a:p>
             <a:pPr lvl="3"/>
             <a:r>
-              <a:rPr lang="en-US"/>
+              <a:rPr lang="en-US" smtClean="0"/>
               <a:t>Fourth level</a:t>
             </a:r>
           </a:p>
           <a:p>
             <a:pPr lvl="4"/>
             <a:r>
-              <a:rPr lang="en-US"/>
+              <a:rPr lang="en-US" smtClean="0"/>
               <a:t>Fifth level</a:t>
             </a:r>
+            <a:endParaRPr lang="en-US"/>
           </a:p>
         </p:txBody>
       </p:sp>
@@ -2240,7 +2242,7 @@
           <a:p>
             <a:pPr lvl="0"/>
             <a:r>
-              <a:rPr lang="en-US"/>
+              <a:rPr lang="en-US" smtClean="0"/>
               <a:t>Click to edit Master text styles</a:t>
             </a:r>
           </a:p>
@@ -2263,7 +2265,7 @@
           <a:p>
             <a:fld id="{5BCAD085-E8A6-8845-BD4E-CB4CCA059FC4}" type="datetimeFigureOut">
               <a:rPr lang="en-US" smtClean="0"/>
-              <a:t>7/22/2026</a:t>
+              <a:t>1/27/13</a:t>
             </a:fld>
             <a:endParaRPr lang="en-US"/>
           </a:p>
@@ -2366,9 +2368,10 @@
           </a:lstStyle>
           <a:p>
             <a:r>
-              <a:rPr lang="en-US"/>
+              <a:rPr lang="en-US" smtClean="0"/>
               <a:t>Click to edit Master title style</a:t>
             </a:r>
+            <a:endParaRPr lang="en-US"/>
           </a:p>
         </p:txBody>
       </p:sp>
@@ -2492,7 +2495,7 @@
           <a:p>
             <a:pPr lvl="0"/>
             <a:r>
-              <a:rPr lang="en-US"/>
+              <a:rPr lang="en-US" smtClean="0"/>
               <a:t>Click to edit Master text styles</a:t>
             </a:r>
           </a:p>
@@ -2515,7 +2518,7 @@
           <a:p>
             <a:fld id="{5BCAD085-E8A6-8845-BD4E-CB4CCA059FC4}" type="datetimeFigureOut">
               <a:rPr lang="en-US" smtClean="0"/>
-              <a:t>7/22/2026</a:t>
+              <a:t>1/27/13</a:t>
             </a:fld>
             <a:endParaRPr lang="en-US"/>
           </a:p>
@@ -2624,9 +2627,10 @@
           <a:lstStyle/>
           <a:p>
             <a:r>
-              <a:rPr lang="en-US"/>
+              <a:rPr lang="en-US" smtClean="0"/>
               <a:t>Click to edit Master title style</a:t>
             </a:r>
+            <a:endParaRPr lang="en-US"/>
           </a:p>
         </p:txBody>
       </p:sp>
@@ -2657,37 +2661,38 @@
           <a:p>
             <a:pPr lvl="0"/>
             <a:r>
-              <a:rPr lang="en-US"/>
+              <a:rPr lang="en-US" smtClean="0"/>
               <a:t>Click to edit Master text styles</a:t>
             </a:r>
           </a:p>
           <a:p>
             <a:pPr lvl="1"/>
             <a:r>
-              <a:rPr lang="en-US"/>
+              <a:rPr lang="en-US" smtClean="0"/>
               <a:t>Second level</a:t>
             </a:r>
           </a:p>
           <a:p>
             <a:pPr lvl="2"/>
             <a:r>
-              <a:rPr lang="en-US"/>
+              <a:rPr lang="en-US" smtClean="0"/>
               <a:t>Third level</a:t>
             </a:r>
           </a:p>
           <a:p>
             <a:pPr lvl="3"/>
             <a:r>
-              <a:rPr lang="en-US"/>
+              <a:rPr lang="en-US" smtClean="0"/>
               <a:t>Fourth level</a:t>
             </a:r>
           </a:p>
           <a:p>
             <a:pPr lvl="4"/>
             <a:r>
-              <a:rPr lang="en-US"/>
+              <a:rPr lang="en-US" smtClean="0"/>
               <a:t>Fifth level</a:t>
             </a:r>
+            <a:endParaRPr lang="en-US"/>
           </a:p>
         </p:txBody>
       </p:sp>
@@ -2726,7 +2731,7 @@
           <a:p>
             <a:fld id="{5BCAD085-E8A6-8845-BD4E-CB4CCA059FC4}" type="datetimeFigureOut">
               <a:rPr lang="en-US" smtClean="0"/>
-              <a:t>7/22/2026</a:t>
+              <a:t>1/27/13</a:t>
             </a:fld>
             <a:endParaRPr lang="en-US"/>
           </a:p>
@@ -3085,7 +3090,7 @@
 </file>
 
 <file path=ppt/slides/slide1.xml><?xml version="1.0" encoding="utf-8"?>
-<p:sld xmlns:a="http://schemas.openxmlformats.org/drawingml/2006/main" xmlns:r="http://schemas.openxmlformats.org/officeDocument/2006/relationships" xmlns:p="http://schemas.openxmlformats.org/presentationml/2006/main">
+<p:sld xmlns:a="http://schemas.openxmlformats.org/drawingml/2006/main" xmlns:p="http://schemas.openxmlformats.org/presentationml/2006/main" xmlns:r="http://schemas.openxmlformats.org/officeDocument/2006/relationships">
   <p:cSld>
     <p:spTree>
       <p:nvGrpSpPr>
@@ -3093,14 +3098,7 @@
         <p:cNvGrpSpPr/>
         <p:nvPr/>
       </p:nvGrpSpPr>
-      <p:grpSpPr>
-        <a:xfrm>
-          <a:off x="0" y="0"/>
-          <a:ext cx="0" cy="0"/>
-          <a:chOff x="0" y="0"/>
-          <a:chExt cx="0" cy="0"/>
-        </a:xfrm>
-      </p:grpSpPr>
+      <p:grpSpPr/>
       <p:sp>
         <p:nvSpPr>
           <p:cNvPr id="2" name="Rectangle 1"/>
@@ -3141,7 +3139,6 @@
           <a:lstStyle/>
           <a:p>
             <a:pPr algn="ctr"/>
-            <a:endParaRPr/>
           </a:p>
         </p:txBody>
       </p:sp>
@@ -3185,7 +3182,6 @@
           <a:lstStyle/>
           <a:p>
             <a:pPr algn="ctr"/>
-            <a:endParaRPr/>
           </a:p>
         </p:txBody>
       </p:sp>
@@ -3197,8 +3193,8 @@
         </p:nvSpPr>
         <p:spPr>
           <a:xfrm>
-            <a:off x="2553788" y="228600"/>
-            <a:ext cx="7171509" cy="292388"/>
+            <a:off x="731520" y="640080"/>
+            <a:ext cx="10515600" cy="320040"/>
           </a:xfrm>
           <a:prstGeom prst="rect">
             <a:avLst/>
@@ -3217,12 +3213,11 @@
               </a:spcAft>
             </a:pPr>
             <a:r>
-              <a:rPr sz="1300" b="1" dirty="0">
+              <a:rPr sz="1200" b="1">
                 <a:solidFill>
                   <a:srgbClr val="239688"/>
                 </a:solidFill>
-                <a:latin typeface="Times New Roman" panose="02020603050405020304" pitchFamily="18" charset="0"/>
-                <a:cs typeface="Times New Roman" panose="02020603050405020304" pitchFamily="18" charset="0"/>
+                <a:latin typeface="Calibri"/>
               </a:rPr>
               <a:t>EASTERN AFRICA STATISTICAL TRAINING CENTRE  ·  CAPSTONE PROJECT DEFENCE</a:t>
             </a:r>
@@ -3237,7 +3232,7 @@
         </p:nvSpPr>
         <p:spPr>
           <a:xfrm>
-            <a:off x="731520" y="886748"/>
+            <a:off x="731520" y="1143000"/>
             <a:ext cx="10515600" cy="1188720"/>
           </a:xfrm>
           <a:prstGeom prst="rect">
@@ -3257,7 +3252,7 @@
               </a:spcAft>
             </a:pPr>
             <a:r>
-              <a:rPr sz="2800" b="1" dirty="0">
+              <a:rPr sz="2800" b="1">
                 <a:solidFill>
                   <a:srgbClr val="FFFFFF"/>
                 </a:solidFill>
@@ -3273,7 +3268,7 @@
               </a:spcAft>
             </a:pPr>
             <a:r>
-              <a:rPr sz="2800" b="1" dirty="0">
+              <a:rPr sz="2800" b="1">
                 <a:solidFill>
                   <a:srgbClr val="FFFFFF"/>
                 </a:solidFill>
@@ -3289,7 +3284,7 @@
               </a:spcAft>
             </a:pPr>
             <a:r>
-              <a:rPr sz="2800" b="1" dirty="0">
+              <a:rPr sz="2800" b="1">
                 <a:solidFill>
                   <a:srgbClr val="FFFFFF"/>
                 </a:solidFill>
@@ -3308,7 +3303,7 @@
         </p:nvSpPr>
         <p:spPr>
           <a:xfrm>
-            <a:off x="731520" y="2375151"/>
+            <a:off x="731520" y="2514600"/>
             <a:ext cx="10515600" cy="365760"/>
           </a:xfrm>
           <a:prstGeom prst="rect">
@@ -3348,7 +3343,7 @@
         <p:spPr>
           <a:xfrm>
             <a:off x="731520" y="3108960"/>
-            <a:ext cx="10515600" cy="3054682"/>
+            <a:ext cx="10515600" cy="1463040"/>
           </a:xfrm>
           <a:prstGeom prst="rect">
             <a:avLst/>
@@ -3361,199 +3356,97 @@
           </a:bodyPr>
           <a:lstStyle/>
           <a:p>
-            <a:pPr algn="ctr">
-              <a:spcAft>
-                <a:spcPts val="300"/>
-              </a:spcAft>
-            </a:pPr>
-            <a:r>
-              <a:rPr sz="1300" b="0" dirty="0">
+            <a:pPr algn="l">
+              <a:spcAft>
+                <a:spcPts val="300"/>
+              </a:spcAft>
+            </a:pPr>
+            <a:r>
+              <a:rPr sz="1300" b="0">
                 <a:solidFill>
                   <a:srgbClr val="B8D0C8"/>
                 </a:solidFill>
-                <a:latin typeface="Times New Roman" panose="02020603050405020304" pitchFamily="18" charset="0"/>
-                <a:cs typeface="Times New Roman" panose="02020603050405020304" pitchFamily="18" charset="0"/>
+                <a:latin typeface="Calibri"/>
               </a:rPr>
               <a:t>PRESENTED BY — GROUP 15</a:t>
             </a:r>
-            <a:endParaRPr lang="en-US" sz="1300" b="0" dirty="0">
-              <a:solidFill>
-                <a:srgbClr val="B8D0C8"/>
-              </a:solidFill>
-              <a:latin typeface="Times New Roman" panose="02020603050405020304" pitchFamily="18" charset="0"/>
-              <a:cs typeface="Times New Roman" panose="02020603050405020304" pitchFamily="18" charset="0"/>
-            </a:endParaRPr>
-          </a:p>
-          <a:p>
-            <a:pPr algn="l">
-              <a:spcAft>
-                <a:spcPts val="300"/>
-              </a:spcAft>
-            </a:pPr>
-            <a:endParaRPr sz="1300" b="0" dirty="0">
-              <a:solidFill>
-                <a:srgbClr val="B8D0C8"/>
-              </a:solidFill>
-              <a:latin typeface="Calibri"/>
-            </a:endParaRPr>
-          </a:p>
-          <a:p>
-            <a:pPr algn="l">
-              <a:spcAft>
-                <a:spcPts val="300"/>
-              </a:spcAft>
-            </a:pPr>
-            <a:r>
-              <a:rPr b="0" dirty="0">
+          </a:p>
+          <a:p>
+            <a:pPr algn="l">
+              <a:spcAft>
+                <a:spcPts val="300"/>
+              </a:spcAft>
+            </a:pPr>
+            <a:r>
+              <a:rPr sz="1300" b="0">
                 <a:solidFill>
                   <a:srgbClr val="B8D0C8"/>
                 </a:solidFill>
-                <a:latin typeface="Times New Roman" panose="02020603050405020304" pitchFamily="18" charset="0"/>
-                <a:cs typeface="Times New Roman" panose="02020603050405020304" pitchFamily="18" charset="0"/>
-              </a:rPr>
-              <a:t>Herman Edward Mkumbwa  </a:t>
-            </a:r>
-            <a:endParaRPr lang="en-US" b="0" dirty="0">
-              <a:solidFill>
-                <a:srgbClr val="B8D0C8"/>
-              </a:solidFill>
-              <a:latin typeface="Times New Roman" panose="02020603050405020304" pitchFamily="18" charset="0"/>
-              <a:cs typeface="Times New Roman" panose="02020603050405020304" pitchFamily="18" charset="0"/>
-            </a:endParaRPr>
-          </a:p>
-          <a:p>
-            <a:pPr algn="l">
-              <a:spcAft>
-                <a:spcPts val="300"/>
-              </a:spcAft>
-            </a:pPr>
-            <a:r>
-              <a:rPr b="0" dirty="0">
+                <a:latin typeface="Calibri"/>
+              </a:rPr>
+              <a:t>Herman Edward Mkumbwa  ·  Raymond Elphance Tungaraza  ·  Edwin Celestin Silayo</a:t>
+            </a:r>
+          </a:p>
+          <a:p>
+            <a:pPr algn="l">
+              <a:spcAft>
+                <a:spcPts val="300"/>
+              </a:spcAft>
+            </a:pPr>
+            <a:r>
+              <a:rPr sz="1300" b="0">
                 <a:solidFill>
                   <a:srgbClr val="B8D0C8"/>
                 </a:solidFill>
-                <a:latin typeface="Times New Roman" panose="02020603050405020304" pitchFamily="18" charset="0"/>
-                <a:cs typeface="Times New Roman" panose="02020603050405020304" pitchFamily="18" charset="0"/>
-              </a:rPr>
-              <a:t>Raymond Elphance Tungaraza </a:t>
-            </a:r>
-            <a:endParaRPr lang="en-US" b="0" dirty="0">
-              <a:solidFill>
-                <a:srgbClr val="B8D0C8"/>
-              </a:solidFill>
-              <a:latin typeface="Times New Roman" panose="02020603050405020304" pitchFamily="18" charset="0"/>
-              <a:cs typeface="Times New Roman" panose="02020603050405020304" pitchFamily="18" charset="0"/>
-            </a:endParaRPr>
-          </a:p>
-          <a:p>
-            <a:pPr algn="l">
-              <a:spcAft>
-                <a:spcPts val="300"/>
-              </a:spcAft>
-            </a:pPr>
-            <a:r>
-              <a:rPr b="0" dirty="0">
+                <a:latin typeface="Calibri"/>
+              </a:rPr>
+              <a:t>Grace Joachim Mohammed  ·  Priscila Nestor Mpembela</a:t>
+            </a:r>
+          </a:p>
+          <a:p>
+            <a:pPr algn="l">
+              <a:spcAft>
+                <a:spcPts val="300"/>
+              </a:spcAft>
+            </a:pPr>
+            <a:r>
+              <a:rPr sz="1300" b="0">
                 <a:solidFill>
                   <a:srgbClr val="B8D0C8"/>
                 </a:solidFill>
-                <a:latin typeface="Times New Roman" panose="02020603050405020304" pitchFamily="18" charset="0"/>
-                <a:cs typeface="Times New Roman" panose="02020603050405020304" pitchFamily="18" charset="0"/>
-              </a:rPr>
-              <a:t>Edwin Celestin Silayo</a:t>
-            </a:r>
-          </a:p>
-          <a:p>
-            <a:pPr algn="l">
-              <a:spcAft>
-                <a:spcPts val="300"/>
-              </a:spcAft>
-            </a:pPr>
-            <a:r>
-              <a:rPr b="0" dirty="0">
+                <a:latin typeface="Calibri"/>
+              </a:rPr>
+              <a:t/>
+            </a:r>
+          </a:p>
+          <a:p>
+            <a:pPr algn="l">
+              <a:spcAft>
+                <a:spcPts val="300"/>
+              </a:spcAft>
+            </a:pPr>
+            <a:r>
+              <a:rPr sz="1300" b="0">
                 <a:solidFill>
                   <a:srgbClr val="B8D0C8"/>
                 </a:solidFill>
-                <a:latin typeface="Times New Roman" panose="02020603050405020304" pitchFamily="18" charset="0"/>
-                <a:cs typeface="Times New Roman" panose="02020603050405020304" pitchFamily="18" charset="0"/>
-              </a:rPr>
-              <a:t>Grace Joachim Mohammed </a:t>
-            </a:r>
-            <a:endParaRPr lang="en-US" b="0" dirty="0">
-              <a:solidFill>
-                <a:srgbClr val="B8D0C8"/>
-              </a:solidFill>
-              <a:latin typeface="Times New Roman" panose="02020603050405020304" pitchFamily="18" charset="0"/>
-              <a:cs typeface="Times New Roman" panose="02020603050405020304" pitchFamily="18" charset="0"/>
-            </a:endParaRPr>
-          </a:p>
-          <a:p>
-            <a:pPr algn="l">
-              <a:spcAft>
-                <a:spcPts val="300"/>
-              </a:spcAft>
-            </a:pPr>
-            <a:r>
-              <a:rPr b="0" dirty="0">
+                <a:latin typeface="Calibri"/>
+              </a:rPr>
+              <a:t>SUPERVISOR: Mr. Rajabu Msangi</a:t>
+            </a:r>
+          </a:p>
+          <a:p>
+            <a:pPr algn="l">
+              <a:spcAft>
+                <a:spcPts val="300"/>
+              </a:spcAft>
+            </a:pPr>
+            <a:r>
+              <a:rPr sz="1300" b="0">
                 <a:solidFill>
                   <a:srgbClr val="B8D0C8"/>
                 </a:solidFill>
-                <a:latin typeface="Times New Roman" panose="02020603050405020304" pitchFamily="18" charset="0"/>
-                <a:cs typeface="Times New Roman" panose="02020603050405020304" pitchFamily="18" charset="0"/>
-              </a:rPr>
-              <a:t>Priscila Nestor Mpembela</a:t>
-            </a:r>
-            <a:endParaRPr lang="en-US" b="0" dirty="0">
-              <a:solidFill>
-                <a:srgbClr val="B8D0C8"/>
-              </a:solidFill>
-              <a:latin typeface="Times New Roman" panose="02020603050405020304" pitchFamily="18" charset="0"/>
-              <a:cs typeface="Times New Roman" panose="02020603050405020304" pitchFamily="18" charset="0"/>
-            </a:endParaRPr>
-          </a:p>
-          <a:p>
-            <a:pPr algn="r">
-              <a:spcAft>
-                <a:spcPts val="300"/>
-              </a:spcAft>
-            </a:pPr>
-            <a:r>
-              <a:rPr lang="en-US" b="0" dirty="0">
-                <a:solidFill>
-                  <a:srgbClr val="B8D0C8"/>
-                </a:solidFill>
-                <a:latin typeface="Times New Roman" panose="02020603050405020304" pitchFamily="18" charset="0"/>
-                <a:cs typeface="Times New Roman" panose="02020603050405020304" pitchFamily="18" charset="0"/>
-              </a:rPr>
-              <a:t>SUPERVISOR: Mr. Rajabu Msangi</a:t>
-            </a:r>
-          </a:p>
-          <a:p>
-            <a:pPr algn="r">
-              <a:spcAft>
-                <a:spcPts val="300"/>
-              </a:spcAft>
-            </a:pPr>
-            <a:endParaRPr lang="en-US" b="0" dirty="0">
-              <a:solidFill>
-                <a:srgbClr val="B8D0C8"/>
-              </a:solidFill>
-              <a:latin typeface="Times New Roman" panose="02020603050405020304" pitchFamily="18" charset="0"/>
-              <a:cs typeface="Times New Roman" panose="02020603050405020304" pitchFamily="18" charset="0"/>
-            </a:endParaRPr>
-          </a:p>
-          <a:p>
-            <a:pPr algn="l">
-              <a:spcAft>
-                <a:spcPts val="300"/>
-              </a:spcAft>
-            </a:pPr>
-            <a:r>
-              <a:rPr b="0" dirty="0">
-                <a:solidFill>
-                  <a:srgbClr val="B8D0C8"/>
-                </a:solidFill>
-                <a:latin typeface="Times New Roman" panose="02020603050405020304" pitchFamily="18" charset="0"/>
-                <a:cs typeface="Times New Roman" panose="02020603050405020304" pitchFamily="18" charset="0"/>
+                <a:latin typeface="Calibri"/>
               </a:rPr>
               <a:t>Bachelor of Data Science (Year III)  ·  Academic Year 2025/2026</a:t>
             </a:r>
@@ -3568,7 +3461,7 @@
         </p:nvSpPr>
         <p:spPr>
           <a:xfrm>
-            <a:off x="581297" y="6400800"/>
+            <a:off x="731520" y="6126480"/>
             <a:ext cx="9144000" cy="274320"/>
           </a:xfrm>
           <a:prstGeom prst="rect">
@@ -3588,7 +3481,7 @@
               </a:spcAft>
             </a:pPr>
             <a:r>
-              <a:rPr sz="1200" b="0" dirty="0">
+              <a:rPr sz="1100" b="0">
                 <a:solidFill>
                   <a:srgbClr val="9BC4BA"/>
                 </a:solidFill>
@@ -3607,7 +3500,7 @@
         </p:nvSpPr>
         <p:spPr>
           <a:xfrm>
-            <a:off x="10502537" y="6359585"/>
+            <a:off x="10424160" y="6126480"/>
             <a:ext cx="1371600" cy="274320"/>
           </a:xfrm>
           <a:prstGeom prst="rect">
@@ -3627,7 +3520,7 @@
               </a:spcAft>
             </a:pPr>
             <a:r>
-              <a:rPr sz="1100" b="0" dirty="0">
+              <a:rPr sz="1100" b="0">
                 <a:solidFill>
                   <a:srgbClr val="B8D0C8"/>
                 </a:solidFill>
@@ -3643,190 +3536,11 @@
   <p:clrMapOvr>
     <a:masterClrMapping/>
   </p:clrMapOvr>
-  <p:transition spd="slow">
-    <p:circle/>
-  </p:transition>
-  <p:timing>
-    <p:tnLst>
-      <p:par>
-        <p:cTn id="1" dur="indefinite" restart="never" nodeType="tmRoot">
-          <p:childTnLst>
-            <p:seq concurrent="1" nextAc="seek">
-              <p:cTn id="2" dur="indefinite" nodeType="mainSeq">
-                <p:childTnLst>
-                  <p:par>
-                    <p:cTn id="3" fill="hold">
-                      <p:stCondLst>
-                        <p:cond delay="indefinite"/>
-                      </p:stCondLst>
-                      <p:childTnLst>
-                        <p:par>
-                          <p:cTn id="4" fill="hold">
-                            <p:stCondLst>
-                              <p:cond delay="0"/>
-                            </p:stCondLst>
-                            <p:childTnLst>
-                              <p:par>
-                                <p:cTn id="5" presetID="10" presetClass="entr" presetSubtype="0" fill="hold" grpId="0" nodeType="clickEffect">
-                                  <p:stCondLst>
-                                    <p:cond delay="0"/>
-                                  </p:stCondLst>
-                                  <p:childTnLst>
-                                    <p:set>
-                                      <p:cBhvr>
-                                        <p:cTn id="6" dur="1" fill="hold">
-                                          <p:stCondLst>
-                                            <p:cond delay="0"/>
-                                          </p:stCondLst>
-                                        </p:cTn>
-                                        <p:tgtEl>
-                                          <p:spTgt spid="2"/>
-                                        </p:tgtEl>
-                                        <p:attrNameLst>
-                                          <p:attrName>style.visibility</p:attrName>
-                                        </p:attrNameLst>
-                                      </p:cBhvr>
-                                      <p:to>
-                                        <p:strVal val="visible"/>
-                                      </p:to>
-                                    </p:set>
-                                    <p:animEffect transition="in" filter="fade">
-                                      <p:cBhvr>
-                                        <p:cTn id="7" dur="550"/>
-                                        <p:tgtEl>
-                                          <p:spTgt spid="2"/>
-                                        </p:tgtEl>
-                                      </p:cBhvr>
-                                    </p:animEffect>
-                                  </p:childTnLst>
-                                </p:cTn>
-                              </p:par>
-                            </p:childTnLst>
-                          </p:cTn>
-                        </p:par>
-                        <p:par>
-                          <p:cTn id="8" fill="hold">
-                            <p:stCondLst>
-                              <p:cond delay="550"/>
-                            </p:stCondLst>
-                            <p:childTnLst>
-                              <p:par>
-                                <p:cTn id="9" presetID="10" presetClass="entr" presetSubtype="0" fill="hold" grpId="0" nodeType="afterEffect">
-                                  <p:stCondLst>
-                                    <p:cond delay="80"/>
-                                  </p:stCondLst>
-                                  <p:childTnLst>
-                                    <p:set>
-                                      <p:cBhvr>
-                                        <p:cTn id="10" dur="1" fill="hold">
-                                          <p:stCondLst>
-                                            <p:cond delay="0"/>
-                                          </p:stCondLst>
-                                        </p:cTn>
-                                        <p:tgtEl>
-                                          <p:spTgt spid="5"/>
-                                        </p:tgtEl>
-                                        <p:attrNameLst>
-                                          <p:attrName>style.visibility</p:attrName>
-                                        </p:attrNameLst>
-                                      </p:cBhvr>
-                                      <p:to>
-                                        <p:strVal val="visible"/>
-                                      </p:to>
-                                    </p:set>
-                                    <p:animEffect transition="in" filter="fade">
-                                      <p:cBhvr>
-                                        <p:cTn id="11" dur="400"/>
-                                        <p:tgtEl>
-                                          <p:spTgt spid="5"/>
-                                        </p:tgtEl>
-                                      </p:cBhvr>
-                                    </p:animEffect>
-                                  </p:childTnLst>
-                                </p:cTn>
-                              </p:par>
-                            </p:childTnLst>
-                          </p:cTn>
-                        </p:par>
-                        <p:par>
-                          <p:cTn id="12" fill="hold">
-                            <p:stCondLst>
-                              <p:cond delay="1030"/>
-                            </p:stCondLst>
-                            <p:childTnLst>
-                              <p:par>
-                                <p:cTn id="13" presetID="10" presetClass="entr" presetSubtype="0" fill="hold" grpId="0" nodeType="afterEffect">
-                                  <p:stCondLst>
-                                    <p:cond delay="80"/>
-                                  </p:stCondLst>
-                                  <p:childTnLst>
-                                    <p:set>
-                                      <p:cBhvr>
-                                        <p:cTn id="14" dur="1" fill="hold">
-                                          <p:stCondLst>
-                                            <p:cond delay="0"/>
-                                          </p:stCondLst>
-                                        </p:cTn>
-                                        <p:tgtEl>
-                                          <p:spTgt spid="7"/>
-                                        </p:tgtEl>
-                                        <p:attrNameLst>
-                                          <p:attrName>style.visibility</p:attrName>
-                                        </p:attrNameLst>
-                                      </p:cBhvr>
-                                      <p:to>
-                                        <p:strVal val="visible"/>
-                                      </p:to>
-                                    </p:set>
-                                    <p:animEffect transition="in" filter="fade">
-                                      <p:cBhvr>
-                                        <p:cTn id="15" dur="400"/>
-                                        <p:tgtEl>
-                                          <p:spTgt spid="7"/>
-                                        </p:tgtEl>
-                                      </p:cBhvr>
-                                    </p:animEffect>
-                                  </p:childTnLst>
-                                </p:cTn>
-                              </p:par>
-                            </p:childTnLst>
-                          </p:cTn>
-                        </p:par>
-                      </p:childTnLst>
-                    </p:cTn>
-                  </p:par>
-                </p:childTnLst>
-              </p:cTn>
-              <p:prevCondLst>
-                <p:cond evt="onPrev" delay="0">
-                  <p:tgtEl>
-                    <p:sldTgt/>
-                  </p:tgtEl>
-                </p:cond>
-              </p:prevCondLst>
-              <p:nextCondLst>
-                <p:cond evt="onNext" delay="0">
-                  <p:tgtEl>
-                    <p:sldTgt/>
-                  </p:tgtEl>
-                </p:cond>
-              </p:nextCondLst>
-            </p:seq>
-          </p:childTnLst>
-        </p:cTn>
-      </p:par>
-    </p:tnLst>
-    <p:bldLst>
-      <p:bldP spid="2" grpId="0" animBg="1"/>
-      <p:bldP spid="5" grpId="0"/>
-      <p:bldP spid="7" grpId="0"/>
-    </p:bldLst>
-  </p:timing>
 </p:sld>
 </file>
 
 <file path=ppt/slides/slide10.xml><?xml version="1.0" encoding="utf-8"?>
-<p:sld xmlns:a="http://schemas.openxmlformats.org/drawingml/2006/main" xmlns:r="http://schemas.openxmlformats.org/officeDocument/2006/relationships" xmlns:p="http://schemas.openxmlformats.org/presentationml/2006/main">
+<p:sld xmlns:a="http://schemas.openxmlformats.org/drawingml/2006/main" xmlns:p="http://schemas.openxmlformats.org/presentationml/2006/main" xmlns:r="http://schemas.openxmlformats.org/officeDocument/2006/relationships">
   <p:cSld>
     <p:spTree>
       <p:nvGrpSpPr>
@@ -3834,14 +3548,7 @@
         <p:cNvGrpSpPr/>
         <p:nvPr/>
       </p:nvGrpSpPr>
-      <p:grpSpPr>
-        <a:xfrm>
-          <a:off x="0" y="0"/>
-          <a:ext cx="0" cy="0"/>
-          <a:chOff x="0" y="0"/>
-          <a:chExt cx="0" cy="0"/>
-        </a:xfrm>
-      </p:grpSpPr>
+      <p:grpSpPr/>
       <p:sp>
         <p:nvSpPr>
           <p:cNvPr id="2" name="Rectangle 1"/>
@@ -3882,7 +3589,6 @@
           <a:lstStyle/>
           <a:p>
             <a:pPr algn="ctr"/>
-            <a:endParaRPr/>
           </a:p>
         </p:txBody>
       </p:sp>
@@ -3965,7 +3671,6 @@
           <a:lstStyle/>
           <a:p>
             <a:pPr algn="ctr"/>
-            <a:endParaRPr/>
           </a:p>
         </p:txBody>
       </p:sp>
@@ -4050,7 +3755,6 @@
           <a:lstStyle/>
           <a:p>
             <a:pPr algn="ctr"/>
-            <a:endParaRPr/>
           </a:p>
         </p:txBody>
       </p:sp>
@@ -4094,7 +3798,6 @@
           <a:lstStyle/>
           <a:p>
             <a:pPr algn="ctr"/>
-            <a:endParaRPr/>
           </a:p>
         </p:txBody>
       </p:sp>
@@ -4257,7 +3960,6 @@
           <a:lstStyle/>
           <a:p>
             <a:pPr algn="ctr"/>
-            <a:endParaRPr/>
           </a:p>
         </p:txBody>
       </p:sp>
@@ -4342,7 +4044,6 @@
           <a:lstStyle/>
           <a:p>
             <a:pPr algn="ctr"/>
-            <a:endParaRPr/>
           </a:p>
         </p:txBody>
       </p:sp>
@@ -4386,7 +4087,6 @@
           <a:lstStyle/>
           <a:p>
             <a:pPr algn="ctr"/>
-            <a:endParaRPr/>
           </a:p>
         </p:txBody>
       </p:sp>
@@ -4549,7 +4249,6 @@
           <a:lstStyle/>
           <a:p>
             <a:pPr algn="ctr"/>
-            <a:endParaRPr/>
           </a:p>
         </p:txBody>
       </p:sp>
@@ -4634,7 +4333,6 @@
           <a:lstStyle/>
           <a:p>
             <a:pPr algn="ctr"/>
-            <a:endParaRPr/>
           </a:p>
         </p:txBody>
       </p:sp>
@@ -4678,7 +4376,6 @@
           <a:lstStyle/>
           <a:p>
             <a:pPr algn="ctr"/>
-            <a:endParaRPr/>
           </a:p>
         </p:txBody>
       </p:sp>
@@ -4841,7 +4538,6 @@
           <a:lstStyle/>
           <a:p>
             <a:pPr algn="ctr"/>
-            <a:endParaRPr/>
           </a:p>
         </p:txBody>
       </p:sp>
@@ -4924,7 +4620,6 @@
           <a:lstStyle/>
           <a:p>
             <a:pPr algn="ctr"/>
-            <a:endParaRPr/>
           </a:p>
         </p:txBody>
       </p:sp>
@@ -5011,217 +4706,11 @@
   <p:clrMapOvr>
     <a:masterClrMapping/>
   </p:clrMapOvr>
-  <p:transition spd="med">
-    <p:push dir="r"/>
-  </p:transition>
-  <p:timing>
-    <p:tnLst>
-      <p:par>
-        <p:cTn id="1" dur="indefinite" restart="never" nodeType="tmRoot">
-          <p:childTnLst>
-            <p:seq concurrent="1" nextAc="seek">
-              <p:cTn id="2" dur="indefinite" nodeType="mainSeq">
-                <p:childTnLst>
-                  <p:par>
-                    <p:cTn id="3" fill="hold">
-                      <p:stCondLst>
-                        <p:cond delay="indefinite"/>
-                      </p:stCondLst>
-                      <p:childTnLst>
-                        <p:par>
-                          <p:cTn id="4" fill="hold">
-                            <p:stCondLst>
-                              <p:cond delay="0"/>
-                            </p:stCondLst>
-                            <p:childTnLst>
-                              <p:par>
-                                <p:cTn id="5" presetID="10" presetClass="entr" presetSubtype="0" fill="hold" grpId="0" nodeType="clickEffect">
-                                  <p:stCondLst>
-                                    <p:cond delay="0"/>
-                                  </p:stCondLst>
-                                  <p:childTnLst>
-                                    <p:set>
-                                      <p:cBhvr>
-                                        <p:cTn id="6" dur="1" fill="hold">
-                                          <p:stCondLst>
-                                            <p:cond delay="0"/>
-                                          </p:stCondLst>
-                                        </p:cTn>
-                                        <p:tgtEl>
-                                          <p:spTgt spid="2"/>
-                                        </p:tgtEl>
-                                        <p:attrNameLst>
-                                          <p:attrName>style.visibility</p:attrName>
-                                        </p:attrNameLst>
-                                      </p:cBhvr>
-                                      <p:to>
-                                        <p:strVal val="visible"/>
-                                      </p:to>
-                                    </p:set>
-                                    <p:animEffect transition="in" filter="fade">
-                                      <p:cBhvr>
-                                        <p:cTn id="7" dur="400"/>
-                                        <p:tgtEl>
-                                          <p:spTgt spid="2"/>
-                                        </p:tgtEl>
-                                      </p:cBhvr>
-                                    </p:animEffect>
-                                  </p:childTnLst>
-                                </p:cTn>
-                              </p:par>
-                            </p:childTnLst>
-                          </p:cTn>
-                        </p:par>
-                        <p:par>
-                          <p:cTn id="8" fill="hold">
-                            <p:stCondLst>
-                              <p:cond delay="400"/>
-                            </p:stCondLst>
-                            <p:childTnLst>
-                              <p:par>
-                                <p:cTn id="9" presetID="10" presetClass="entr" presetSubtype="0" fill="hold" grpId="0" nodeType="afterEffect">
-                                  <p:stCondLst>
-                                    <p:cond delay="50"/>
-                                  </p:stCondLst>
-                                  <p:childTnLst>
-                                    <p:set>
-                                      <p:cBhvr>
-                                        <p:cTn id="10" dur="1" fill="hold">
-                                          <p:stCondLst>
-                                            <p:cond delay="0"/>
-                                          </p:stCondLst>
-                                        </p:cTn>
-                                        <p:tgtEl>
-                                          <p:spTgt spid="6"/>
-                                        </p:tgtEl>
-                                        <p:attrNameLst>
-                                          <p:attrName>style.visibility</p:attrName>
-                                        </p:attrNameLst>
-                                      </p:cBhvr>
-                                      <p:to>
-                                        <p:strVal val="visible"/>
-                                      </p:to>
-                                    </p:set>
-                                    <p:animEffect transition="in" filter="fade">
-                                      <p:cBhvr>
-                                        <p:cTn id="11" dur="400"/>
-                                        <p:tgtEl>
-                                          <p:spTgt spid="6"/>
-                                        </p:tgtEl>
-                                      </p:cBhvr>
-                                    </p:animEffect>
-                                  </p:childTnLst>
-                                </p:cTn>
-                              </p:par>
-                              <p:par>
-                                <p:cTn id="12" presetID="10" presetClass="entr" presetSubtype="0" fill="hold" grpId="0" nodeType="withEffect">
-                                  <p:stCondLst>
-                                    <p:cond delay="100"/>
-                                  </p:stCondLst>
-                                  <p:childTnLst>
-                                    <p:set>
-                                      <p:cBhvr>
-                                        <p:cTn id="13" dur="1" fill="hold">
-                                          <p:stCondLst>
-                                            <p:cond delay="0"/>
-                                          </p:stCondLst>
-                                        </p:cTn>
-                                        <p:tgtEl>
-                                          <p:spTgt spid="13"/>
-                                        </p:tgtEl>
-                                        <p:attrNameLst>
-                                          <p:attrName>style.visibility</p:attrName>
-                                        </p:attrNameLst>
-                                      </p:cBhvr>
-                                      <p:to>
-                                        <p:strVal val="visible"/>
-                                      </p:to>
-                                    </p:set>
-                                    <p:animEffect transition="in" filter="fade">
-                                      <p:cBhvr>
-                                        <p:cTn id="14" dur="400"/>
-                                        <p:tgtEl>
-                                          <p:spTgt spid="13"/>
-                                        </p:tgtEl>
-                                      </p:cBhvr>
-                                    </p:animEffect>
-                                  </p:childTnLst>
-                                </p:cTn>
-                              </p:par>
-                              <p:par>
-                                <p:cTn id="15" presetID="10" presetClass="entr" presetSubtype="0" fill="hold" grpId="0" nodeType="withEffect">
-                                  <p:stCondLst>
-                                    <p:cond delay="100"/>
-                                  </p:stCondLst>
-                                  <p:childTnLst>
-                                    <p:set>
-                                      <p:cBhvr>
-                                        <p:cTn id="16" dur="1" fill="hold">
-                                          <p:stCondLst>
-                                            <p:cond delay="0"/>
-                                          </p:stCondLst>
-                                        </p:cTn>
-                                        <p:tgtEl>
-                                          <p:spTgt spid="20"/>
-                                        </p:tgtEl>
-                                        <p:attrNameLst>
-                                          <p:attrName>style.visibility</p:attrName>
-                                        </p:attrNameLst>
-                                      </p:cBhvr>
-                                      <p:to>
-                                        <p:strVal val="visible"/>
-                                      </p:to>
-                                    </p:set>
-                                    <p:animEffect transition="in" filter="fade">
-                                      <p:cBhvr>
-                                        <p:cTn id="17" dur="400"/>
-                                        <p:tgtEl>
-                                          <p:spTgt spid="20"/>
-                                        </p:tgtEl>
-                                      </p:cBhvr>
-                                    </p:animEffect>
-                                  </p:childTnLst>
-                                </p:cTn>
-                              </p:par>
-                            </p:childTnLst>
-                          </p:cTn>
-                        </p:par>
-                      </p:childTnLst>
-                    </p:cTn>
-                  </p:par>
-                </p:childTnLst>
-              </p:cTn>
-              <p:prevCondLst>
-                <p:cond evt="onPrev" delay="0">
-                  <p:tgtEl>
-                    <p:sldTgt/>
-                  </p:tgtEl>
-                </p:cond>
-              </p:prevCondLst>
-              <p:nextCondLst>
-                <p:cond evt="onNext" delay="0">
-                  <p:tgtEl>
-                    <p:sldTgt/>
-                  </p:tgtEl>
-                </p:cond>
-              </p:nextCondLst>
-            </p:seq>
-          </p:childTnLst>
-        </p:cTn>
-      </p:par>
-    </p:tnLst>
-    <p:bldLst>
-      <p:bldP spid="2" grpId="0" animBg="1"/>
-      <p:bldP spid="6" grpId="0" animBg="1"/>
-      <p:bldP spid="13" grpId="0" animBg="1"/>
-      <p:bldP spid="20" grpId="0" animBg="1"/>
-    </p:bldLst>
-  </p:timing>
 </p:sld>
 </file>
 
 <file path=ppt/slides/slide11.xml><?xml version="1.0" encoding="utf-8"?>
-<p:sld xmlns:a="http://schemas.openxmlformats.org/drawingml/2006/main" xmlns:r="http://schemas.openxmlformats.org/officeDocument/2006/relationships" xmlns:p="http://schemas.openxmlformats.org/presentationml/2006/main">
+<p:sld xmlns:a="http://schemas.openxmlformats.org/drawingml/2006/main" xmlns:p="http://schemas.openxmlformats.org/presentationml/2006/main" xmlns:r="http://schemas.openxmlformats.org/officeDocument/2006/relationships">
   <p:cSld>
     <p:spTree>
       <p:nvGrpSpPr>
@@ -5229,14 +4718,7 @@
         <p:cNvGrpSpPr/>
         <p:nvPr/>
       </p:nvGrpSpPr>
-      <p:grpSpPr>
-        <a:xfrm>
-          <a:off x="0" y="0"/>
-          <a:ext cx="0" cy="0"/>
-          <a:chOff x="0" y="0"/>
-          <a:chExt cx="0" cy="0"/>
-        </a:xfrm>
-      </p:grpSpPr>
+      <p:grpSpPr/>
       <p:sp>
         <p:nvSpPr>
           <p:cNvPr id="2" name="Rectangle 1"/>
@@ -5277,7 +4759,6 @@
           <a:lstStyle/>
           <a:p>
             <a:pPr algn="ctr"/>
-            <a:endParaRPr/>
           </a:p>
         </p:txBody>
       </p:sp>
@@ -5360,7 +4841,6 @@
           <a:lstStyle/>
           <a:p>
             <a:pPr algn="ctr"/>
-            <a:endParaRPr/>
           </a:p>
         </p:txBody>
       </p:sp>
@@ -5445,7 +4925,6 @@
           <a:lstStyle/>
           <a:p>
             <a:pPr algn="ctr"/>
-            <a:endParaRPr/>
           </a:p>
         </p:txBody>
       </p:sp>
@@ -5519,7 +4998,7 @@
               </a:spcAft>
             </a:pPr>
             <a:r>
-              <a:rPr sz="1300" b="0" dirty="0">
+              <a:rPr sz="1300" b="0">
                 <a:solidFill>
                   <a:srgbClr val="0F2830"/>
                 </a:solidFill>
@@ -5538,7 +5017,7 @@
               </a:spcAft>
             </a:pPr>
             <a:r>
-              <a:rPr sz="1300" b="0" dirty="0">
+              <a:rPr sz="1300" b="0">
                 <a:solidFill>
                   <a:srgbClr val="0F2830"/>
                 </a:solidFill>
@@ -5557,7 +5036,7 @@
               </a:spcAft>
             </a:pPr>
             <a:r>
-              <a:rPr sz="1300" b="0" dirty="0">
+              <a:rPr sz="1300" b="0">
                 <a:solidFill>
                   <a:srgbClr val="0F2830"/>
                 </a:solidFill>
@@ -5576,31 +5055,13 @@
               </a:spcAft>
             </a:pPr>
             <a:r>
-              <a:rPr sz="1300" b="0" dirty="0">
+              <a:rPr sz="1300" b="0">
                 <a:solidFill>
                   <a:srgbClr val="0F2830"/>
                 </a:solidFill>
                 <a:latin typeface="Calibri"/>
               </a:rPr>
-              <a:t>•  Altman tradition extended: from static ratios to dynamic </a:t>
-            </a:r>
-            <a:r>
-              <a:rPr sz="1300" b="0" dirty="0" err="1">
-                <a:solidFill>
-                  <a:srgbClr val="0F2830"/>
-                </a:solidFill>
-                <a:latin typeface="Calibri"/>
-              </a:rPr>
-              <a:t>behavioural</a:t>
-            </a:r>
-            <a:r>
-              <a:rPr sz="1300" b="0" dirty="0">
-                <a:solidFill>
-                  <a:srgbClr val="0F2830"/>
-                </a:solidFill>
-                <a:latin typeface="Calibri"/>
-              </a:rPr>
-              <a:t> classification.</a:t>
+              <a:t>•  Altman tradition extended: from static ratios to dynamic behavioural classification.</a:t>
             </a:r>
           </a:p>
         </p:txBody>
@@ -5647,7 +5108,6 @@
           <a:lstStyle/>
           <a:p>
             <a:pPr algn="ctr"/>
-            <a:endParaRPr/>
           </a:p>
         </p:txBody>
       </p:sp>
@@ -5721,7 +5181,7 @@
               </a:spcAft>
             </a:pPr>
             <a:r>
-              <a:rPr sz="1300" b="0" dirty="0">
+              <a:rPr sz="1300" b="0">
                 <a:solidFill>
                   <a:srgbClr val="0F2830"/>
                 </a:solidFill>
@@ -5740,7 +5200,7 @@
               </a:spcAft>
             </a:pPr>
             <a:r>
-              <a:rPr sz="1300" b="0" dirty="0">
+              <a:rPr sz="1300" b="0">
                 <a:solidFill>
                   <a:srgbClr val="0F2830"/>
                 </a:solidFill>
@@ -5759,7 +5219,7 @@
               </a:spcAft>
             </a:pPr>
             <a:r>
-              <a:rPr sz="1300" b="0" dirty="0">
+              <a:rPr sz="1300" b="0">
                 <a:solidFill>
                   <a:srgbClr val="0F2830"/>
                 </a:solidFill>
@@ -5778,7 +5238,7 @@
               </a:spcAft>
             </a:pPr>
             <a:r>
-              <a:rPr sz="1300" b="0" dirty="0">
+              <a:rPr sz="1300" b="0">
                 <a:solidFill>
                   <a:srgbClr val="0F2830"/>
                 </a:solidFill>
@@ -5797,7 +5257,7 @@
               </a:spcAft>
             </a:pPr>
             <a:r>
-              <a:rPr sz="1300" b="0" dirty="0">
+              <a:rPr sz="1300" b="0">
                 <a:solidFill>
                   <a:srgbClr val="0F2830"/>
                 </a:solidFill>
@@ -5848,7 +5308,6 @@
           <a:lstStyle/>
           <a:p>
             <a:pPr algn="ctr"/>
-            <a:endParaRPr/>
           </a:p>
         </p:txBody>
       </p:sp>
@@ -5935,23 +5394,11 @@
   <p:clrMapOvr>
     <a:masterClrMapping/>
   </p:clrMapOvr>
-  <mc:AlternateContent xmlns:mc="http://schemas.openxmlformats.org/markup-compatibility/2006">
-    <mc:Choice xmlns:p14="http://schemas.microsoft.com/office/powerpoint/2010/main" Requires="p14">
-      <p:transition spd="med">
-        <p14:wheelReverse spokes="1"/>
-      </p:transition>
-    </mc:Choice>
-    <mc:Fallback>
-      <p:transition spd="med">
-        <p:fade/>
-      </p:transition>
-    </mc:Fallback>
-  </mc:AlternateContent>
 </p:sld>
 </file>
 
 <file path=ppt/slides/slide12.xml><?xml version="1.0" encoding="utf-8"?>
-<p:sld xmlns:a="http://schemas.openxmlformats.org/drawingml/2006/main" xmlns:r="http://schemas.openxmlformats.org/officeDocument/2006/relationships" xmlns:p="http://schemas.openxmlformats.org/presentationml/2006/main">
+<p:sld xmlns:a="http://schemas.openxmlformats.org/drawingml/2006/main" xmlns:p="http://schemas.openxmlformats.org/presentationml/2006/main" xmlns:r="http://schemas.openxmlformats.org/officeDocument/2006/relationships">
   <p:cSld>
     <p:spTree>
       <p:nvGrpSpPr>
@@ -5959,14 +5406,7 @@
         <p:cNvGrpSpPr/>
         <p:nvPr/>
       </p:nvGrpSpPr>
-      <p:grpSpPr>
-        <a:xfrm>
-          <a:off x="0" y="0"/>
-          <a:ext cx="0" cy="0"/>
-          <a:chOff x="0" y="0"/>
-          <a:chExt cx="0" cy="0"/>
-        </a:xfrm>
-      </p:grpSpPr>
+      <p:grpSpPr/>
       <p:sp>
         <p:nvSpPr>
           <p:cNvPr id="2" name="Rectangle 1"/>
@@ -6007,7 +5447,6 @@
           <a:lstStyle/>
           <a:p>
             <a:pPr algn="ctr"/>
-            <a:endParaRPr/>
           </a:p>
         </p:txBody>
       </p:sp>
@@ -6051,7 +5490,6 @@
           <a:lstStyle/>
           <a:p>
             <a:pPr algn="ctr"/>
-            <a:endParaRPr/>
           </a:p>
         </p:txBody>
       </p:sp>
@@ -6064,7 +5502,7 @@
         <p:spPr>
           <a:xfrm>
             <a:off x="731520" y="640080"/>
-            <a:ext cx="10515600" cy="338554"/>
+            <a:ext cx="10515600" cy="274320"/>
           </a:xfrm>
           <a:prstGeom prst="rect">
             <a:avLst/>
@@ -6077,13 +5515,13 @@
           </a:bodyPr>
           <a:lstStyle/>
           <a:p>
-            <a:pPr algn="ctr">
-              <a:spcAft>
-                <a:spcPts val="300"/>
-              </a:spcAft>
-            </a:pPr>
-            <a:r>
-              <a:rPr sz="1600" b="1" dirty="0">
+            <a:pPr algn="l">
+              <a:spcAft>
+                <a:spcPts val="300"/>
+              </a:spcAft>
+            </a:pPr>
+            <a:r>
+              <a:rPr sz="1200" b="1">
                 <a:solidFill>
                   <a:srgbClr val="239688"/>
                 </a:solidFill>
@@ -6122,7 +5560,7 @@
               </a:spcAft>
             </a:pPr>
             <a:r>
-              <a:rPr sz="3000" b="1" dirty="0">
+              <a:rPr sz="3000" b="1">
                 <a:solidFill>
                   <a:srgbClr val="FFFFFF"/>
                 </a:solidFill>
@@ -6142,7 +5580,7 @@
         <p:spPr>
           <a:xfrm>
             <a:off x="731520" y="1965960"/>
-            <a:ext cx="10515600" cy="584775"/>
+            <a:ext cx="10515600" cy="1005840"/>
           </a:xfrm>
           <a:prstGeom prst="rect">
             <a:avLst/>
@@ -6155,55 +5593,19 @@
           </a:bodyPr>
           <a:lstStyle/>
           <a:p>
-            <a:pPr algn="ctr">
-              <a:spcAft>
-                <a:spcPts val="300"/>
-              </a:spcAft>
-            </a:pPr>
-            <a:r>
-              <a:rPr sz="1600" b="0" dirty="0">
+            <a:pPr algn="l">
+              <a:spcAft>
+                <a:spcPts val="300"/>
+              </a:spcAft>
+            </a:pPr>
+            <a:r>
+              <a:rPr sz="1500" b="0">
                 <a:solidFill>
                   <a:srgbClr val="E6EEF0"/>
                 </a:solidFill>
                 <a:latin typeface="Calibri"/>
               </a:rPr>
-              <a:t>Ushirika is a working prototype that turns supply-chain transactions into objective credit scores — with real train/test ML, RF vs LR evidence, and a live portal for </a:t>
-            </a:r>
-            <a:r>
-              <a:rPr lang="en-US" sz="1600" dirty="0">
-                <a:solidFill>
-                  <a:srgbClr val="E6EEF0"/>
-                </a:solidFill>
-                <a:latin typeface="Calibri"/>
-              </a:rPr>
-              <a:t>SMEs</a:t>
-            </a:r>
-            <a:r>
-              <a:rPr sz="1600" b="0" dirty="0">
-                <a:solidFill>
-                  <a:srgbClr val="E6EEF0"/>
-                </a:solidFill>
-                <a:latin typeface="Calibri"/>
-              </a:rPr>
-              <a:t>, </a:t>
-            </a:r>
-            <a:r>
-              <a:rPr lang="en-US" sz="1600" b="0" dirty="0">
-                <a:solidFill>
-                  <a:srgbClr val="E6EEF0"/>
-                </a:solidFill>
-                <a:latin typeface="Calibri"/>
-              </a:rPr>
-              <a:t>Lender</a:t>
-            </a:r>
-            <a:r>
-              <a:rPr sz="1600" b="0" dirty="0">
-                <a:solidFill>
-                  <a:srgbClr val="E6EEF0"/>
-                </a:solidFill>
-                <a:latin typeface="Calibri"/>
-              </a:rPr>
-              <a:t>, and Admin.</a:t>
+              <a:t>Ushirika is a working prototype that turns supply-chain transactions into objective credit scores — with real train/test ML, RF vs LR evidence, and a live portal for Mfanyabiashara, Afisa mikopo, and Admin.</a:t>
             </a:r>
           </a:p>
         </p:txBody>
@@ -6450,8 +5852,8 @@
         </p:nvSpPr>
         <p:spPr>
           <a:xfrm>
-            <a:off x="672737" y="5464038"/>
-            <a:ext cx="10515600" cy="1115690"/>
+            <a:off x="731520" y="5943600"/>
+            <a:ext cx="10515600" cy="365760"/>
           </a:xfrm>
           <a:prstGeom prst="rect">
             <a:avLst/>
@@ -6464,54 +5866,19 @@
           </a:bodyPr>
           <a:lstStyle/>
           <a:p>
-            <a:pPr algn="ctr">
-              <a:spcAft>
-                <a:spcPts val="300"/>
-              </a:spcAft>
-            </a:pPr>
-            <a:r>
-              <a:rPr lang="en-US" sz="3200" b="1" dirty="0">
+            <a:pPr algn="l">
+              <a:spcAft>
+                <a:spcPts val="300"/>
+              </a:spcAft>
+            </a:pPr>
+            <a:r>
+              <a:rPr sz="1600" b="1">
                 <a:solidFill>
                   <a:srgbClr val="239688"/>
                 </a:solidFill>
-                <a:latin typeface="Times New Roman" panose="02020603050405020304" pitchFamily="18" charset="0"/>
-                <a:cs typeface="Times New Roman" panose="02020603050405020304" pitchFamily="18" charset="0"/>
-              </a:rPr>
-              <a:t>Thank YOU</a:t>
-            </a:r>
-            <a:r>
-              <a:rPr sz="3200" b="1" dirty="0">
-                <a:solidFill>
-                  <a:srgbClr val="239688"/>
-                </a:solidFill>
-                <a:latin typeface="Times New Roman" panose="02020603050405020304" pitchFamily="18" charset="0"/>
-                <a:cs typeface="Times New Roman" panose="02020603050405020304" pitchFamily="18" charset="0"/>
-              </a:rPr>
-              <a:t> </a:t>
-            </a:r>
-            <a:endParaRPr lang="en-US" sz="3200" b="1" dirty="0">
-              <a:solidFill>
-                <a:srgbClr val="239688"/>
-              </a:solidFill>
-              <a:latin typeface="Times New Roman" panose="02020603050405020304" pitchFamily="18" charset="0"/>
-              <a:cs typeface="Times New Roman" panose="02020603050405020304" pitchFamily="18" charset="0"/>
-            </a:endParaRPr>
-          </a:p>
-          <a:p>
-            <a:pPr algn="ctr">
-              <a:spcAft>
-                <a:spcPts val="300"/>
-              </a:spcAft>
-            </a:pPr>
-            <a:r>
-              <a:rPr sz="3200" b="1" dirty="0">
-                <a:solidFill>
-                  <a:srgbClr val="239688"/>
-                </a:solidFill>
-                <a:latin typeface="Times New Roman" panose="02020603050405020304" pitchFamily="18" charset="0"/>
-                <a:cs typeface="Times New Roman" panose="02020603050405020304" pitchFamily="18" charset="0"/>
-              </a:rPr>
-              <a:t> Questions and discussion</a:t>
+                <a:latin typeface="Calibri"/>
+              </a:rPr>
+              <a:t>Asanteni  ·  Questions and discussion</a:t>
             </a:r>
           </a:p>
         </p:txBody>
@@ -6560,190 +5927,11 @@
   <p:clrMapOvr>
     <a:masterClrMapping/>
   </p:clrMapOvr>
-  <p:transition spd="slow">
-    <p:circle/>
-  </p:transition>
-  <p:timing>
-    <p:tnLst>
-      <p:par>
-        <p:cTn id="1" dur="indefinite" restart="never" nodeType="tmRoot">
-          <p:childTnLst>
-            <p:seq concurrent="1" nextAc="seek">
-              <p:cTn id="2" dur="indefinite" nodeType="mainSeq">
-                <p:childTnLst>
-                  <p:par>
-                    <p:cTn id="3" fill="hold">
-                      <p:stCondLst>
-                        <p:cond delay="indefinite"/>
-                      </p:stCondLst>
-                      <p:childTnLst>
-                        <p:par>
-                          <p:cTn id="4" fill="hold">
-                            <p:stCondLst>
-                              <p:cond delay="0"/>
-                            </p:stCondLst>
-                            <p:childTnLst>
-                              <p:par>
-                                <p:cTn id="5" presetID="10" presetClass="entr" presetSubtype="0" fill="hold" grpId="0" nodeType="clickEffect">
-                                  <p:stCondLst>
-                                    <p:cond delay="0"/>
-                                  </p:stCondLst>
-                                  <p:childTnLst>
-                                    <p:set>
-                                      <p:cBhvr>
-                                        <p:cTn id="6" dur="1" fill="hold">
-                                          <p:stCondLst>
-                                            <p:cond delay="0"/>
-                                          </p:stCondLst>
-                                        </p:cTn>
-                                        <p:tgtEl>
-                                          <p:spTgt spid="2"/>
-                                        </p:tgtEl>
-                                        <p:attrNameLst>
-                                          <p:attrName>style.visibility</p:attrName>
-                                        </p:attrNameLst>
-                                      </p:cBhvr>
-                                      <p:to>
-                                        <p:strVal val="visible"/>
-                                      </p:to>
-                                    </p:set>
-                                    <p:animEffect transition="in" filter="fade">
-                                      <p:cBhvr>
-                                        <p:cTn id="7" dur="500"/>
-                                        <p:tgtEl>
-                                          <p:spTgt spid="2"/>
-                                        </p:tgtEl>
-                                      </p:cBhvr>
-                                    </p:animEffect>
-                                  </p:childTnLst>
-                                </p:cTn>
-                              </p:par>
-                            </p:childTnLst>
-                          </p:cTn>
-                        </p:par>
-                        <p:par>
-                          <p:cTn id="8" fill="hold">
-                            <p:stCondLst>
-                              <p:cond delay="500"/>
-                            </p:stCondLst>
-                            <p:childTnLst>
-                              <p:par>
-                                <p:cTn id="9" presetID="10" presetClass="entr" presetSubtype="0" fill="hold" grpId="0" nodeType="afterEffect">
-                                  <p:stCondLst>
-                                    <p:cond delay="60"/>
-                                  </p:stCondLst>
-                                  <p:childTnLst>
-                                    <p:set>
-                                      <p:cBhvr>
-                                        <p:cTn id="10" dur="1" fill="hold">
-                                          <p:stCondLst>
-                                            <p:cond delay="0"/>
-                                          </p:stCondLst>
-                                        </p:cTn>
-                                        <p:tgtEl>
-                                          <p:spTgt spid="5"/>
-                                        </p:tgtEl>
-                                        <p:attrNameLst>
-                                          <p:attrName>style.visibility</p:attrName>
-                                        </p:attrNameLst>
-                                      </p:cBhvr>
-                                      <p:to>
-                                        <p:strVal val="visible"/>
-                                      </p:to>
-                                    </p:set>
-                                    <p:animEffect transition="in" filter="fade">
-                                      <p:cBhvr>
-                                        <p:cTn id="11" dur="350"/>
-                                        <p:tgtEl>
-                                          <p:spTgt spid="5"/>
-                                        </p:tgtEl>
-                                      </p:cBhvr>
-                                    </p:animEffect>
-                                  </p:childTnLst>
-                                </p:cTn>
-                              </p:par>
-                            </p:childTnLst>
-                          </p:cTn>
-                        </p:par>
-                        <p:par>
-                          <p:cTn id="12" fill="hold">
-                            <p:stCondLst>
-                              <p:cond delay="910"/>
-                            </p:stCondLst>
-                            <p:childTnLst>
-                              <p:par>
-                                <p:cTn id="13" presetID="10" presetClass="entr" presetSubtype="0" fill="hold" grpId="0" nodeType="afterEffect">
-                                  <p:stCondLst>
-                                    <p:cond delay="60"/>
-                                  </p:stCondLst>
-                                  <p:childTnLst>
-                                    <p:set>
-                                      <p:cBhvr>
-                                        <p:cTn id="14" dur="1" fill="hold">
-                                          <p:stCondLst>
-                                            <p:cond delay="0"/>
-                                          </p:stCondLst>
-                                        </p:cTn>
-                                        <p:tgtEl>
-                                          <p:spTgt spid="13"/>
-                                        </p:tgtEl>
-                                        <p:attrNameLst>
-                                          <p:attrName>style.visibility</p:attrName>
-                                        </p:attrNameLst>
-                                      </p:cBhvr>
-                                      <p:to>
-                                        <p:strVal val="visible"/>
-                                      </p:to>
-                                    </p:set>
-                                    <p:animEffect transition="in" filter="fade">
-                                      <p:cBhvr>
-                                        <p:cTn id="15" dur="350"/>
-                                        <p:tgtEl>
-                                          <p:spTgt spid="13"/>
-                                        </p:tgtEl>
-                                      </p:cBhvr>
-                                    </p:animEffect>
-                                  </p:childTnLst>
-                                </p:cTn>
-                              </p:par>
-                            </p:childTnLst>
-                          </p:cTn>
-                        </p:par>
-                      </p:childTnLst>
-                    </p:cTn>
-                  </p:par>
-                </p:childTnLst>
-              </p:cTn>
-              <p:prevCondLst>
-                <p:cond evt="onPrev" delay="0">
-                  <p:tgtEl>
-                    <p:sldTgt/>
-                  </p:tgtEl>
-                </p:cond>
-              </p:prevCondLst>
-              <p:nextCondLst>
-                <p:cond evt="onNext" delay="0">
-                  <p:tgtEl>
-                    <p:sldTgt/>
-                  </p:tgtEl>
-                </p:cond>
-              </p:nextCondLst>
-            </p:seq>
-          </p:childTnLst>
-        </p:cTn>
-      </p:par>
-    </p:tnLst>
-    <p:bldLst>
-      <p:bldP spid="2" grpId="0" animBg="1"/>
-      <p:bldP spid="5" grpId="0"/>
-      <p:bldP spid="13" grpId="0"/>
-    </p:bldLst>
-  </p:timing>
 </p:sld>
 </file>
 
 <file path=ppt/slides/slide2.xml><?xml version="1.0" encoding="utf-8"?>
-<p:sld xmlns:a="http://schemas.openxmlformats.org/drawingml/2006/main" xmlns:r="http://schemas.openxmlformats.org/officeDocument/2006/relationships" xmlns:p="http://schemas.openxmlformats.org/presentationml/2006/main">
+<p:sld xmlns:a="http://schemas.openxmlformats.org/drawingml/2006/main" xmlns:p="http://schemas.openxmlformats.org/presentationml/2006/main" xmlns:r="http://schemas.openxmlformats.org/officeDocument/2006/relationships">
   <p:cSld>
     <p:spTree>
       <p:nvGrpSpPr>
@@ -6751,14 +5939,7 @@
         <p:cNvGrpSpPr/>
         <p:nvPr/>
       </p:nvGrpSpPr>
-      <p:grpSpPr>
-        <a:xfrm>
-          <a:off x="0" y="0"/>
-          <a:ext cx="0" cy="0"/>
-          <a:chOff x="0" y="0"/>
-          <a:chExt cx="0" cy="0"/>
-        </a:xfrm>
-      </p:grpSpPr>
+      <p:grpSpPr/>
       <p:sp>
         <p:nvSpPr>
           <p:cNvPr id="2" name="Rectangle 1"/>
@@ -6799,7 +5980,6 @@
           <a:lstStyle/>
           <a:p>
             <a:pPr algn="ctr"/>
-            <a:endParaRPr/>
           </a:p>
         </p:txBody>
       </p:sp>
@@ -6882,7 +6062,6 @@
           <a:lstStyle/>
           <a:p>
             <a:pPr algn="ctr"/>
-            <a:endParaRPr/>
           </a:p>
         </p:txBody>
       </p:sp>
@@ -6914,13 +6093,52 @@
               </a:spcAft>
             </a:pPr>
             <a:r>
-              <a:rPr sz="2600" b="1" dirty="0">
+              <a:rPr sz="2600" b="1">
                 <a:solidFill>
                   <a:srgbClr val="0B3D2E"/>
                 </a:solidFill>
                 <a:latin typeface="Georgia"/>
               </a:rPr>
               <a:t>Why Tanzanian SMEs still struggle to get fair credit</a:t>
+            </a:r>
+          </a:p>
+        </p:txBody>
+      </p:sp>
+      <p:sp>
+        <p:nvSpPr>
+          <p:cNvPr id="6" name="TextBox 5"/>
+          <p:cNvSpPr txBox="1"/>
+          <p:nvPr/>
+        </p:nvSpPr>
+        <p:spPr>
+          <a:xfrm>
+            <a:off x="502920" y="1051560"/>
+            <a:ext cx="11155680" cy="320040"/>
+          </a:xfrm>
+          <a:prstGeom prst="rect">
+            <a:avLst/>
+          </a:prstGeom>
+          <a:noFill/>
+        </p:spPr>
+        <p:txBody>
+          <a:bodyPr wrap="square">
+            <a:spAutoFit/>
+          </a:bodyPr>
+          <a:lstStyle/>
+          <a:p>
+            <a:pPr algn="l">
+              <a:spcAft>
+                <a:spcPts val="300"/>
+              </a:spcAft>
+            </a:pPr>
+            <a:r>
+              <a:rPr sz="1300" b="0">
+                <a:solidFill>
+                  <a:srgbClr val="4A5E66"/>
+                </a:solidFill>
+                <a:latin typeface="Calibri"/>
+              </a:rPr>
+              <a:t>Grounded in the Group 15 problem statement (Section 1.2)</a:t>
             </a:r>
           </a:p>
         </p:txBody>
@@ -6967,7 +6185,6 @@
           <a:lstStyle/>
           <a:p>
             <a:pPr algn="ctr"/>
-            <a:endParaRPr/>
           </a:p>
         </p:txBody>
       </p:sp>
@@ -7011,7 +6228,6 @@
           <a:lstStyle/>
           <a:p>
             <a:pPr algn="ctr"/>
-            <a:endParaRPr/>
           </a:p>
         </p:txBody>
       </p:sp>
@@ -7082,7 +6298,7 @@
               </a:spcAft>
             </a:pPr>
             <a:r>
-              <a:rPr sz="1600" b="1" dirty="0">
+              <a:rPr sz="1600" b="1">
                 <a:solidFill>
                   <a:srgbClr val="0B3D2E"/>
                 </a:solidFill>
@@ -7121,7 +6337,7 @@
               </a:spcAft>
             </a:pPr>
             <a:r>
-              <a:rPr sz="1300" b="0" dirty="0">
+              <a:rPr sz="1300" b="0">
                 <a:solidFill>
                   <a:srgbClr val="4A5E66"/>
                 </a:solidFill>
@@ -7174,7 +6390,6 @@
           <a:lstStyle/>
           <a:p>
             <a:pPr algn="ctr"/>
-            <a:endParaRPr/>
           </a:p>
         </p:txBody>
       </p:sp>
@@ -7218,7 +6433,6 @@
           <a:lstStyle/>
           <a:p>
             <a:pPr algn="ctr"/>
-            <a:endParaRPr/>
           </a:p>
         </p:txBody>
       </p:sp>
@@ -7381,7 +6595,6 @@
           <a:lstStyle/>
           <a:p>
             <a:pPr algn="ctr"/>
-            <a:endParaRPr/>
           </a:p>
         </p:txBody>
       </p:sp>
@@ -7425,7 +6638,6 @@
           <a:lstStyle/>
           <a:p>
             <a:pPr algn="ctr"/>
-            <a:endParaRPr/>
           </a:p>
         </p:txBody>
       </p:sp>
@@ -7588,7 +6800,6 @@
           <a:lstStyle/>
           <a:p>
             <a:pPr algn="ctr"/>
-            <a:endParaRPr/>
           </a:p>
         </p:txBody>
       </p:sp>
@@ -7632,7 +6843,6 @@
           <a:lstStyle/>
           <a:p>
             <a:pPr algn="ctr"/>
-            <a:endParaRPr/>
           </a:p>
         </p:txBody>
       </p:sp>
@@ -7793,7 +7003,6 @@
           <a:lstStyle/>
           <a:p>
             <a:pPr algn="ctr"/>
-            <a:endParaRPr/>
           </a:p>
         </p:txBody>
       </p:sp>
@@ -7880,23 +7089,11 @@
   <p:clrMapOvr>
     <a:masterClrMapping/>
   </p:clrMapOvr>
-  <mc:AlternateContent xmlns:mc="http://schemas.openxmlformats.org/markup-compatibility/2006">
-    <mc:Choice xmlns:p14="http://schemas.microsoft.com/office/powerpoint/2010/main" Requires="p14">
-      <p:transition spd="med">
-        <p14:vortex dir="u"/>
-      </p:transition>
-    </mc:Choice>
-    <mc:Fallback>
-      <p:transition spd="med">
-        <p:fade/>
-      </p:transition>
-    </mc:Fallback>
-  </mc:AlternateContent>
 </p:sld>
 </file>
 
 <file path=ppt/slides/slide3.xml><?xml version="1.0" encoding="utf-8"?>
-<p:sld xmlns:a="http://schemas.openxmlformats.org/drawingml/2006/main" xmlns:r="http://schemas.openxmlformats.org/officeDocument/2006/relationships" xmlns:p="http://schemas.openxmlformats.org/presentationml/2006/main">
+<p:sld xmlns:a="http://schemas.openxmlformats.org/drawingml/2006/main" xmlns:p="http://schemas.openxmlformats.org/presentationml/2006/main" xmlns:r="http://schemas.openxmlformats.org/officeDocument/2006/relationships">
   <p:cSld>
     <p:spTree>
       <p:nvGrpSpPr>
@@ -7904,14 +7101,7 @@
         <p:cNvGrpSpPr/>
         <p:nvPr/>
       </p:nvGrpSpPr>
-      <p:grpSpPr>
-        <a:xfrm>
-          <a:off x="0" y="0"/>
-          <a:ext cx="0" cy="0"/>
-          <a:chOff x="0" y="0"/>
-          <a:chExt cx="0" cy="0"/>
-        </a:xfrm>
-      </p:grpSpPr>
+      <p:grpSpPr/>
       <p:sp>
         <p:nvSpPr>
           <p:cNvPr id="2" name="Rectangle 1"/>
@@ -7952,7 +7142,6 @@
           <a:lstStyle/>
           <a:p>
             <a:pPr algn="ctr"/>
-            <a:endParaRPr/>
           </a:p>
         </p:txBody>
       </p:sp>
@@ -8035,7 +7224,6 @@
           <a:lstStyle/>
           <a:p>
             <a:pPr algn="ctr"/>
-            <a:endParaRPr/>
           </a:p>
         </p:txBody>
       </p:sp>
@@ -8120,7 +7308,6 @@
           <a:lstStyle/>
           <a:p>
             <a:pPr algn="ctr"/>
-            <a:endParaRPr/>
           </a:p>
         </p:txBody>
       </p:sp>
@@ -8244,7 +7431,6 @@
           <a:lstStyle/>
           <a:p>
             <a:pPr algn="ctr"/>
-            <a:endParaRPr/>
           </a:p>
         </p:txBody>
       </p:sp>
@@ -8288,7 +7474,6 @@
           <a:lstStyle/>
           <a:p>
             <a:pPr algn="ctr"/>
-            <a:endParaRPr/>
           </a:p>
         </p:txBody>
       </p:sp>
@@ -8412,7 +7597,6 @@
           <a:lstStyle/>
           <a:p>
             <a:pPr algn="ctr"/>
-            <a:endParaRPr/>
           </a:p>
         </p:txBody>
       </p:sp>
@@ -8456,7 +7640,6 @@
           <a:lstStyle/>
           <a:p>
             <a:pPr algn="ctr"/>
-            <a:endParaRPr/>
           </a:p>
         </p:txBody>
       </p:sp>
@@ -8580,7 +7763,6 @@
           <a:lstStyle/>
           <a:p>
             <a:pPr algn="ctr"/>
-            <a:endParaRPr/>
           </a:p>
         </p:txBody>
       </p:sp>
@@ -8624,7 +7806,6 @@
           <a:lstStyle/>
           <a:p>
             <a:pPr algn="ctr"/>
-            <a:endParaRPr/>
           </a:p>
         </p:txBody>
       </p:sp>
@@ -8746,7 +7927,6 @@
           <a:lstStyle/>
           <a:p>
             <a:pPr algn="ctr"/>
-            <a:endParaRPr/>
           </a:p>
         </p:txBody>
       </p:sp>
@@ -8833,14 +8013,11 @@
   <p:clrMapOvr>
     <a:masterClrMapping/>
   </p:clrMapOvr>
-  <p:transition spd="med">
-    <p:circle/>
-  </p:transition>
 </p:sld>
 </file>
 
 <file path=ppt/slides/slide4.xml><?xml version="1.0" encoding="utf-8"?>
-<p:sld xmlns:a="http://schemas.openxmlformats.org/drawingml/2006/main" xmlns:r="http://schemas.openxmlformats.org/officeDocument/2006/relationships" xmlns:p="http://schemas.openxmlformats.org/presentationml/2006/main">
+<p:sld xmlns:a="http://schemas.openxmlformats.org/drawingml/2006/main" xmlns:p="http://schemas.openxmlformats.org/presentationml/2006/main" xmlns:r="http://schemas.openxmlformats.org/officeDocument/2006/relationships">
   <p:cSld>
     <p:spTree>
       <p:nvGrpSpPr>
@@ -8848,14 +8025,7 @@
         <p:cNvGrpSpPr/>
         <p:nvPr/>
       </p:nvGrpSpPr>
-      <p:grpSpPr>
-        <a:xfrm>
-          <a:off x="0" y="0"/>
-          <a:ext cx="0" cy="0"/>
-          <a:chOff x="0" y="0"/>
-          <a:chExt cx="0" cy="0"/>
-        </a:xfrm>
-      </p:grpSpPr>
+      <p:grpSpPr/>
       <p:sp>
         <p:nvSpPr>
           <p:cNvPr id="2" name="Rectangle 1"/>
@@ -8896,7 +8066,6 @@
           <a:lstStyle/>
           <a:p>
             <a:pPr algn="ctr"/>
-            <a:endParaRPr/>
           </a:p>
         </p:txBody>
       </p:sp>
@@ -8979,7 +8148,6 @@
           <a:lstStyle/>
           <a:p>
             <a:pPr algn="ctr"/>
-            <a:endParaRPr/>
           </a:p>
         </p:txBody>
       </p:sp>
@@ -9018,6 +8186,45 @@
                 <a:latin typeface="Georgia"/>
               </a:rPr>
               <a:t>Ushirika — a working credit platform for SMEs and lenders</a:t>
+            </a:r>
+          </a:p>
+        </p:txBody>
+      </p:sp>
+      <p:sp>
+        <p:nvSpPr>
+          <p:cNvPr id="6" name="TextBox 5"/>
+          <p:cNvSpPr txBox="1"/>
+          <p:nvPr/>
+        </p:nvSpPr>
+        <p:spPr>
+          <a:xfrm>
+            <a:off x="502920" y="1051560"/>
+            <a:ext cx="11155680" cy="320040"/>
+          </a:xfrm>
+          <a:prstGeom prst="rect">
+            <a:avLst/>
+          </a:prstGeom>
+          <a:noFill/>
+        </p:spPr>
+        <p:txBody>
+          <a:bodyPr wrap="square">
+            <a:spAutoFit/>
+          </a:bodyPr>
+          <a:lstStyle/>
+          <a:p>
+            <a:pPr algn="l">
+              <a:spcAft>
+                <a:spcPts val="300"/>
+              </a:spcAft>
+            </a:pPr>
+            <a:r>
+              <a:rPr sz="1300" b="0">
+                <a:solidFill>
+                  <a:srgbClr val="4A5E66"/>
+                </a:solidFill>
+                <a:latin typeface="Calibri"/>
+              </a:rPr>
+              <a:t>Deliverables match proposal Section 3.10</a:t>
             </a:r>
           </a:p>
         </p:txBody>
@@ -9064,7 +8271,6 @@
           <a:lstStyle/>
           <a:p>
             <a:pPr algn="ctr"/>
-            <a:endParaRPr/>
           </a:p>
         </p:txBody>
       </p:sp>
@@ -9108,7 +8314,6 @@
           <a:lstStyle/>
           <a:p>
             <a:pPr algn="ctr"/>
-            <a:endParaRPr/>
           </a:p>
         </p:txBody>
       </p:sp>
@@ -9319,7 +8524,6 @@
           <a:lstStyle/>
           <a:p>
             <a:pPr algn="ctr"/>
-            <a:endParaRPr/>
           </a:p>
         </p:txBody>
       </p:sp>
@@ -9363,7 +8567,6 @@
           <a:lstStyle/>
           <a:p>
             <a:pPr algn="ctr"/>
-            <a:endParaRPr/>
           </a:p>
         </p:txBody>
       </p:sp>
@@ -9558,7 +8761,6 @@
           <a:lstStyle/>
           <a:p>
             <a:pPr algn="ctr"/>
-            <a:endParaRPr/>
           </a:p>
         </p:txBody>
       </p:sp>
@@ -9602,7 +8804,6 @@
           <a:lstStyle/>
           <a:p>
             <a:pPr algn="ctr"/>
-            <a:endParaRPr/>
           </a:p>
         </p:txBody>
       </p:sp>
@@ -9797,7 +8998,6 @@
           <a:lstStyle/>
           <a:p>
             <a:pPr algn="ctr"/>
-            <a:endParaRPr/>
           </a:p>
         </p:txBody>
       </p:sp>
@@ -9841,7 +9041,6 @@
           <a:lstStyle/>
           <a:p>
             <a:pPr algn="ctr"/>
-            <a:endParaRPr/>
           </a:p>
         </p:txBody>
       </p:sp>
@@ -10037,7 +9236,23 @@
                 </a:solidFill>
                 <a:latin typeface="Calibri"/>
               </a:rPr>
-              <a:t>Inclusive controls: NIDA-DOB matching, +255 phone entry, bilingual gender/business labels, live email checks, and clear forms.</a:t>
+              <a:t>Inclusive controls: NIDA-DOB matching, +255 phone entry, cascading Tanzania region→district dropdowns, bilingual labels, live email checks, and clear forms.</a:t>
+            </a:r>
+          </a:p>
+          <a:p>
+            <a:pPr algn="l">
+              <a:spcAft>
+                <a:spcPts val="300"/>
+              </a:spcAft>
+            </a:pPr>
+            <a:r>
+              <a:rPr sz="1300" b="0">
+                <a:solidFill>
+                  <a:srgbClr val="4A5E66"/>
+                </a:solidFill>
+                <a:latin typeface="Calibri"/>
+              </a:rPr>
+              <a:t>Responsive UI: the same portal is usable on desktop computers and mobile phones.</a:t>
             </a:r>
           </a:p>
         </p:txBody>
@@ -10082,7 +9297,6 @@
           <a:lstStyle/>
           <a:p>
             <a:pPr algn="ctr"/>
-            <a:endParaRPr/>
           </a:p>
         </p:txBody>
       </p:sp>
@@ -10169,14 +9383,11 @@
   <p:clrMapOvr>
     <a:masterClrMapping/>
   </p:clrMapOvr>
-  <p:transition spd="med">
-    <p:wheel spokes="1"/>
-  </p:transition>
 </p:sld>
 </file>
 
 <file path=ppt/slides/slide5.xml><?xml version="1.0" encoding="utf-8"?>
-<p:sld xmlns:a="http://schemas.openxmlformats.org/drawingml/2006/main" xmlns:r="http://schemas.openxmlformats.org/officeDocument/2006/relationships" xmlns:p="http://schemas.openxmlformats.org/presentationml/2006/main">
+<p:sld xmlns:a="http://schemas.openxmlformats.org/drawingml/2006/main" xmlns:p="http://schemas.openxmlformats.org/presentationml/2006/main" xmlns:r="http://schemas.openxmlformats.org/officeDocument/2006/relationships">
   <p:cSld>
     <p:spTree>
       <p:nvGrpSpPr>
@@ -10184,14 +9395,7 @@
         <p:cNvGrpSpPr/>
         <p:nvPr/>
       </p:nvGrpSpPr>
-      <p:grpSpPr>
-        <a:xfrm>
-          <a:off x="0" y="0"/>
-          <a:ext cx="0" cy="0"/>
-          <a:chOff x="0" y="0"/>
-          <a:chExt cx="0" cy="0"/>
-        </a:xfrm>
-      </p:grpSpPr>
+      <p:grpSpPr/>
       <p:sp>
         <p:nvSpPr>
           <p:cNvPr id="2" name="Rectangle 1"/>
@@ -10232,7 +9436,6 @@
           <a:lstStyle/>
           <a:p>
             <a:pPr algn="ctr"/>
-            <a:endParaRPr/>
           </a:p>
         </p:txBody>
       </p:sp>
@@ -10315,7 +9518,6 @@
           <a:lstStyle/>
           <a:p>
             <a:pPr algn="ctr"/>
-            <a:endParaRPr/>
           </a:p>
         </p:txBody>
       </p:sp>
@@ -10400,7 +9602,6 @@
           <a:lstStyle/>
           <a:p>
             <a:pPr algn="ctr"/>
-            <a:endParaRPr/>
           </a:p>
         </p:txBody>
       </p:sp>
@@ -10524,7 +9725,6 @@
           <a:lstStyle/>
           <a:p>
             <a:pPr algn="ctr"/>
-            <a:endParaRPr/>
           </a:p>
         </p:txBody>
       </p:sp>
@@ -10648,7 +9848,6 @@
           <a:lstStyle/>
           <a:p>
             <a:pPr algn="ctr"/>
-            <a:endParaRPr/>
           </a:p>
         </p:txBody>
       </p:sp>
@@ -10772,7 +9971,6 @@
           <a:lstStyle/>
           <a:p>
             <a:pPr algn="ctr"/>
-            <a:endParaRPr/>
           </a:p>
         </p:txBody>
       </p:sp>
@@ -10896,7 +10094,6 @@
           <a:lstStyle/>
           <a:p>
             <a:pPr algn="ctr"/>
-            <a:endParaRPr/>
           </a:p>
         </p:txBody>
       </p:sp>
@@ -11078,7 +10275,6 @@
           <a:lstStyle/>
           <a:p>
             <a:pPr algn="ctr"/>
-            <a:endParaRPr/>
           </a:p>
         </p:txBody>
       </p:sp>
@@ -11165,14 +10361,11 @@
   <p:clrMapOvr>
     <a:masterClrMapping/>
   </p:clrMapOvr>
-  <p:transition spd="med">
-    <p:push/>
-  </p:transition>
 </p:sld>
 </file>
 
 <file path=ppt/slides/slide6.xml><?xml version="1.0" encoding="utf-8"?>
-<p:sld xmlns:a="http://schemas.openxmlformats.org/drawingml/2006/main" xmlns:r="http://schemas.openxmlformats.org/officeDocument/2006/relationships" xmlns:p="http://schemas.openxmlformats.org/presentationml/2006/main">
+<p:sld xmlns:a="http://schemas.openxmlformats.org/drawingml/2006/main" xmlns:p="http://schemas.openxmlformats.org/presentationml/2006/main" xmlns:r="http://schemas.openxmlformats.org/officeDocument/2006/relationships">
   <p:cSld>
     <p:spTree>
       <p:nvGrpSpPr>
@@ -11180,14 +10373,7 @@
         <p:cNvGrpSpPr/>
         <p:nvPr/>
       </p:nvGrpSpPr>
-      <p:grpSpPr>
-        <a:xfrm>
-          <a:off x="0" y="0"/>
-          <a:ext cx="0" cy="0"/>
-          <a:chOff x="0" y="0"/>
-          <a:chExt cx="0" cy="0"/>
-        </a:xfrm>
-      </p:grpSpPr>
+      <p:grpSpPr/>
       <p:sp>
         <p:nvSpPr>
           <p:cNvPr id="2" name="Rectangle 1"/>
@@ -11228,7 +10414,6 @@
           <a:lstStyle/>
           <a:p>
             <a:pPr algn="ctr"/>
-            <a:endParaRPr/>
           </a:p>
         </p:txBody>
       </p:sp>
@@ -11311,7 +10496,6 @@
           <a:lstStyle/>
           <a:p>
             <a:pPr algn="ctr"/>
-            <a:endParaRPr/>
           </a:p>
         </p:txBody>
       </p:sp>
@@ -11396,7 +10580,6 @@
           <a:lstStyle/>
           <a:p>
             <a:pPr algn="ctr"/>
-            <a:endParaRPr/>
           </a:p>
         </p:txBody>
       </p:sp>
@@ -11618,7 +10801,6 @@
           <a:lstStyle/>
           <a:p>
             <a:pPr algn="ctr"/>
-            <a:endParaRPr/>
           </a:p>
         </p:txBody>
       </p:sp>
@@ -11838,7 +11020,6 @@
           <a:lstStyle/>
           <a:p>
             <a:pPr algn="ctr"/>
-            <a:endParaRPr/>
           </a:p>
         </p:txBody>
       </p:sp>
@@ -11925,14 +11106,11 @@
   <p:clrMapOvr>
     <a:masterClrMapping/>
   </p:clrMapOvr>
-  <p:transition spd="med">
-    <p:fade thruBlk="1"/>
-  </p:transition>
 </p:sld>
 </file>
 
 <file path=ppt/slides/slide7.xml><?xml version="1.0" encoding="utf-8"?>
-<p:sld xmlns:a="http://schemas.openxmlformats.org/drawingml/2006/main" xmlns:r="http://schemas.openxmlformats.org/officeDocument/2006/relationships" xmlns:p="http://schemas.openxmlformats.org/presentationml/2006/main">
+<p:sld xmlns:a="http://schemas.openxmlformats.org/drawingml/2006/main" xmlns:p="http://schemas.openxmlformats.org/presentationml/2006/main" xmlns:r="http://schemas.openxmlformats.org/officeDocument/2006/relationships">
   <p:cSld>
     <p:spTree>
       <p:nvGrpSpPr>
@@ -11940,14 +11118,7 @@
         <p:cNvGrpSpPr/>
         <p:nvPr/>
       </p:nvGrpSpPr>
-      <p:grpSpPr>
-        <a:xfrm>
-          <a:off x="0" y="0"/>
-          <a:ext cx="0" cy="0"/>
-          <a:chOff x="0" y="0"/>
-          <a:chExt cx="0" cy="0"/>
-        </a:xfrm>
-      </p:grpSpPr>
+      <p:grpSpPr/>
       <p:sp>
         <p:nvSpPr>
           <p:cNvPr id="2" name="Rectangle 1"/>
@@ -11988,7 +11159,6 @@
           <a:lstStyle/>
           <a:p>
             <a:pPr algn="ctr"/>
-            <a:endParaRPr/>
           </a:p>
         </p:txBody>
       </p:sp>
@@ -12071,7 +11241,6 @@
           <a:lstStyle/>
           <a:p>
             <a:pPr algn="ctr"/>
-            <a:endParaRPr/>
           </a:p>
         </p:txBody>
       </p:sp>
@@ -12156,7 +11325,6 @@
           <a:lstStyle/>
           <a:p>
             <a:pPr algn="ctr"/>
-            <a:endParaRPr/>
           </a:p>
         </p:txBody>
       </p:sp>
@@ -12200,7 +11368,6 @@
           <a:lstStyle/>
           <a:p>
             <a:pPr algn="ctr"/>
-            <a:endParaRPr/>
           </a:p>
         </p:txBody>
       </p:sp>
@@ -12324,7 +11491,6 @@
           <a:lstStyle/>
           <a:p>
             <a:pPr algn="ctr"/>
-            <a:endParaRPr/>
           </a:p>
         </p:txBody>
       </p:sp>
@@ -12368,7 +11534,6 @@
           <a:lstStyle/>
           <a:p>
             <a:pPr algn="ctr"/>
-            <a:endParaRPr/>
           </a:p>
         </p:txBody>
       </p:sp>
@@ -12492,7 +11657,6 @@
           <a:lstStyle/>
           <a:p>
             <a:pPr algn="ctr"/>
-            <a:endParaRPr/>
           </a:p>
         </p:txBody>
       </p:sp>
@@ -12536,7 +11700,6 @@
           <a:lstStyle/>
           <a:p>
             <a:pPr algn="ctr"/>
-            <a:endParaRPr/>
           </a:p>
         </p:txBody>
       </p:sp>
@@ -12660,7 +11823,6 @@
           <a:lstStyle/>
           <a:p>
             <a:pPr algn="ctr"/>
-            <a:endParaRPr/>
           </a:p>
         </p:txBody>
       </p:sp>
@@ -12704,7 +11866,6 @@
           <a:lstStyle/>
           <a:p>
             <a:pPr algn="ctr"/>
-            <a:endParaRPr/>
           </a:p>
         </p:txBody>
       </p:sp>
@@ -12828,7 +11989,6 @@
           <a:lstStyle/>
           <a:p>
             <a:pPr algn="ctr"/>
-            <a:endParaRPr/>
           </a:p>
         </p:txBody>
       </p:sp>
@@ -12872,7 +12032,6 @@
           <a:lstStyle/>
           <a:p>
             <a:pPr algn="ctr"/>
-            <a:endParaRPr/>
           </a:p>
         </p:txBody>
       </p:sp>
@@ -12996,7 +12155,6 @@
           <a:lstStyle/>
           <a:p>
             <a:pPr algn="ctr"/>
-            <a:endParaRPr/>
           </a:p>
         </p:txBody>
       </p:sp>
@@ -13040,7 +12198,6 @@
           <a:lstStyle/>
           <a:p>
             <a:pPr algn="ctr"/>
-            <a:endParaRPr/>
           </a:p>
         </p:txBody>
       </p:sp>
@@ -13162,7 +12319,6 @@
           <a:lstStyle/>
           <a:p>
             <a:pPr algn="ctr"/>
-            <a:endParaRPr/>
           </a:p>
         </p:txBody>
       </p:sp>
@@ -13249,14 +12405,11 @@
   <p:clrMapOvr>
     <a:masterClrMapping/>
   </p:clrMapOvr>
-  <p:transition spd="med">
-    <p:wedge/>
-  </p:transition>
 </p:sld>
 </file>
 
 <file path=ppt/slides/slide8.xml><?xml version="1.0" encoding="utf-8"?>
-<p:sld xmlns:a="http://schemas.openxmlformats.org/drawingml/2006/main" xmlns:r="http://schemas.openxmlformats.org/officeDocument/2006/relationships" xmlns:p="http://schemas.openxmlformats.org/presentationml/2006/main">
+<p:sld xmlns:a="http://schemas.openxmlformats.org/drawingml/2006/main" xmlns:p="http://schemas.openxmlformats.org/presentationml/2006/main" xmlns:r="http://schemas.openxmlformats.org/officeDocument/2006/relationships">
   <p:cSld>
     <p:spTree>
       <p:nvGrpSpPr>
@@ -13264,14 +12417,7 @@
         <p:cNvGrpSpPr/>
         <p:nvPr/>
       </p:nvGrpSpPr>
-      <p:grpSpPr>
-        <a:xfrm>
-          <a:off x="0" y="0"/>
-          <a:ext cx="0" cy="0"/>
-          <a:chOff x="0" y="0"/>
-          <a:chExt cx="0" cy="0"/>
-        </a:xfrm>
-      </p:grpSpPr>
+      <p:grpSpPr/>
       <p:sp>
         <p:nvSpPr>
           <p:cNvPr id="2" name="Rectangle 1"/>
@@ -13312,7 +12458,6 @@
           <a:lstStyle/>
           <a:p>
             <a:pPr algn="ctr"/>
-            <a:endParaRPr/>
           </a:p>
         </p:txBody>
       </p:sp>
@@ -13395,7 +12540,6 @@
           <a:lstStyle/>
           <a:p>
             <a:pPr algn="ctr"/>
-            <a:endParaRPr/>
           </a:p>
         </p:txBody>
       </p:sp>
@@ -13480,7 +12624,6 @@
           <a:lstStyle/>
           <a:p>
             <a:pPr algn="ctr"/>
-            <a:endParaRPr/>
           </a:p>
         </p:txBody>
       </p:sp>
@@ -13524,7 +12667,6 @@
           <a:lstStyle/>
           <a:p>
             <a:pPr algn="ctr"/>
-            <a:endParaRPr/>
           </a:p>
         </p:txBody>
       </p:sp>
@@ -13648,7 +12790,6 @@
           <a:lstStyle/>
           <a:p>
             <a:pPr algn="ctr"/>
-            <a:endParaRPr/>
           </a:p>
         </p:txBody>
       </p:sp>
@@ -13692,7 +12833,6 @@
           <a:lstStyle/>
           <a:p>
             <a:pPr algn="ctr"/>
-            <a:endParaRPr/>
           </a:p>
         </p:txBody>
       </p:sp>
@@ -13816,7 +12956,6 @@
           <a:lstStyle/>
           <a:p>
             <a:pPr algn="ctr"/>
-            <a:endParaRPr/>
           </a:p>
         </p:txBody>
       </p:sp>
@@ -13860,7 +12999,6 @@
           <a:lstStyle/>
           <a:p>
             <a:pPr algn="ctr"/>
-            <a:endParaRPr/>
           </a:p>
         </p:txBody>
       </p:sp>
@@ -13984,7 +13122,6 @@
           <a:lstStyle/>
           <a:p>
             <a:pPr algn="ctr"/>
-            <a:endParaRPr/>
           </a:p>
         </p:txBody>
       </p:sp>
@@ -14028,7 +13165,6 @@
           <a:lstStyle/>
           <a:p>
             <a:pPr algn="ctr"/>
-            <a:endParaRPr/>
           </a:p>
         </p:txBody>
       </p:sp>
@@ -14152,7 +13288,6 @@
           <a:lstStyle/>
           <a:p>
             <a:pPr algn="ctr"/>
-            <a:endParaRPr/>
           </a:p>
         </p:txBody>
       </p:sp>
@@ -14334,7 +13469,6 @@
           <a:lstStyle/>
           <a:p>
             <a:pPr algn="ctr"/>
-            <a:endParaRPr/>
           </a:p>
         </p:txBody>
       </p:sp>
@@ -14421,181 +13555,11 @@
   <p:clrMapOvr>
     <a:masterClrMapping/>
   </p:clrMapOvr>
-  <p:transition spd="med">
-    <p:wheel spokes="3"/>
-  </p:transition>
-  <p:timing>
-    <p:tnLst>
-      <p:par>
-        <p:cTn id="1" dur="indefinite" restart="never" nodeType="tmRoot">
-          <p:childTnLst>
-            <p:seq concurrent="1" nextAc="seek">
-              <p:cTn id="2" dur="indefinite" nodeType="mainSeq">
-                <p:childTnLst>
-                  <p:par>
-                    <p:cTn id="3" fill="hold">
-                      <p:stCondLst>
-                        <p:cond delay="indefinite"/>
-                      </p:stCondLst>
-                      <p:childTnLst>
-                        <p:par>
-                          <p:cTn id="4" fill="hold">
-                            <p:stCondLst>
-                              <p:cond delay="0"/>
-                            </p:stCondLst>
-                            <p:childTnLst>
-                              <p:par>
-                                <p:cTn id="5" presetID="10" presetClass="entr" presetSubtype="0" fill="hold" grpId="0" nodeType="clickEffect">
-                                  <p:stCondLst>
-                                    <p:cond delay="0"/>
-                                  </p:stCondLst>
-                                  <p:childTnLst>
-                                    <p:set>
-                                      <p:cBhvr>
-                                        <p:cTn id="6" dur="1" fill="hold">
-                                          <p:stCondLst>
-                                            <p:cond delay="0"/>
-                                          </p:stCondLst>
-                                        </p:cTn>
-                                        <p:tgtEl>
-                                          <p:spTgt spid="2"/>
-                                        </p:tgtEl>
-                                        <p:attrNameLst>
-                                          <p:attrName>style.visibility</p:attrName>
-                                        </p:attrNameLst>
-                                      </p:cBhvr>
-                                      <p:to>
-                                        <p:strVal val="visible"/>
-                                      </p:to>
-                                    </p:set>
-                                    <p:animEffect transition="in" filter="fade">
-                                      <p:cBhvr>
-                                        <p:cTn id="7" dur="400"/>
-                                        <p:tgtEl>
-                                          <p:spTgt spid="2"/>
-                                        </p:tgtEl>
-                                      </p:cBhvr>
-                                    </p:animEffect>
-                                  </p:childTnLst>
-                                </p:cTn>
-                              </p:par>
-                            </p:childTnLst>
-                          </p:cTn>
-                        </p:par>
-                        <p:par>
-                          <p:cTn id="8" fill="hold">
-                            <p:stCondLst>
-                              <p:cond delay="400"/>
-                            </p:stCondLst>
-                            <p:childTnLst>
-                              <p:par>
-                                <p:cTn id="9" presetID="10" presetClass="entr" presetSubtype="0" fill="hold" grpId="0" nodeType="afterEffect">
-                                  <p:stCondLst>
-                                    <p:cond delay="50"/>
-                                  </p:stCondLst>
-                                  <p:childTnLst>
-                                    <p:set>
-                                      <p:cBhvr>
-                                        <p:cTn id="10" dur="1" fill="hold">
-                                          <p:stCondLst>
-                                            <p:cond delay="0"/>
-                                          </p:stCondLst>
-                                        </p:cTn>
-                                        <p:tgtEl>
-                                          <p:spTgt spid="22"/>
-                                        </p:tgtEl>
-                                        <p:attrNameLst>
-                                          <p:attrName>style.visibility</p:attrName>
-                                        </p:attrNameLst>
-                                      </p:cBhvr>
-                                      <p:to>
-                                        <p:strVal val="visible"/>
-                                      </p:to>
-                                    </p:set>
-                                    <p:animEffect transition="in" filter="fade">
-                                      <p:cBhvr>
-                                        <p:cTn id="11" dur="400"/>
-                                        <p:tgtEl>
-                                          <p:spTgt spid="22"/>
-                                        </p:tgtEl>
-                                      </p:cBhvr>
-                                    </p:animEffect>
-                                  </p:childTnLst>
-                                </p:cTn>
-                              </p:par>
-                              <p:par>
-                                <p:cTn id="12" presetID="10" presetClass="entr" presetSubtype="0" fill="hold" grpId="0" nodeType="withEffect">
-                                  <p:stCondLst>
-                                    <p:cond delay="100"/>
-                                  </p:stCondLst>
-                                  <p:childTnLst>
-                                    <p:set>
-                                      <p:cBhvr>
-                                        <p:cTn id="13" dur="1" fill="hold">
-                                          <p:stCondLst>
-                                            <p:cond delay="0"/>
-                                          </p:stCondLst>
-                                        </p:cTn>
-                                        <p:tgtEl>
-                                          <p:spTgt spid="24"/>
-                                        </p:tgtEl>
-                                        <p:attrNameLst>
-                                          <p:attrName>style.visibility</p:attrName>
-                                        </p:attrNameLst>
-                                      </p:cBhvr>
-                                      <p:to>
-                                        <p:strVal val="visible"/>
-                                      </p:to>
-                                    </p:set>
-                                    <p:animEffect transition="in" filter="fade">
-                                      <p:cBhvr>
-                                        <p:cTn id="14" dur="400"/>
-                                        <p:tgtEl>
-                                          <p:spTgt spid="24"/>
-                                        </p:tgtEl>
-                                      </p:cBhvr>
-                                    </p:animEffect>
-                                  </p:childTnLst>
-                                </p:cTn>
-                              </p:par>
-                            </p:childTnLst>
-                          </p:cTn>
-                        </p:par>
-                      </p:childTnLst>
-                    </p:cTn>
-                  </p:par>
-                </p:childTnLst>
-              </p:cTn>
-              <p:prevCondLst>
-                <p:cond evt="onPrev" delay="0">
-                  <p:tgtEl>
-                    <p:sldTgt/>
-                  </p:tgtEl>
-                </p:cond>
-              </p:prevCondLst>
-              <p:nextCondLst>
-                <p:cond evt="onNext" delay="0">
-                  <p:tgtEl>
-                    <p:sldTgt/>
-                  </p:tgtEl>
-                </p:cond>
-              </p:nextCondLst>
-            </p:seq>
-          </p:childTnLst>
-        </p:cTn>
-      </p:par>
-    </p:tnLst>
-    <p:bldLst>
-      <p:bldP spid="2" grpId="0" animBg="1"/>
-      <p:bldP spid="22" grpId="0" animBg="1"/>
-      <p:bldP spid="24" grpId="0"/>
-    </p:bldLst>
-  </p:timing>
 </p:sld>
 </file>
 
 <file path=ppt/slides/slide9.xml><?xml version="1.0" encoding="utf-8"?>
-<p:sld xmlns:a="http://schemas.openxmlformats.org/drawingml/2006/main" xmlns:r="http://schemas.openxmlformats.org/officeDocument/2006/relationships" xmlns:p="http://schemas.openxmlformats.org/presentationml/2006/main">
+<p:sld xmlns:a="http://schemas.openxmlformats.org/drawingml/2006/main" xmlns:p="http://schemas.openxmlformats.org/presentationml/2006/main" xmlns:r="http://schemas.openxmlformats.org/officeDocument/2006/relationships">
   <p:cSld>
     <p:spTree>
       <p:nvGrpSpPr>
@@ -14603,14 +13567,7 @@
         <p:cNvGrpSpPr/>
         <p:nvPr/>
       </p:nvGrpSpPr>
-      <p:grpSpPr>
-        <a:xfrm>
-          <a:off x="0" y="0"/>
-          <a:ext cx="0" cy="0"/>
-          <a:chOff x="0" y="0"/>
-          <a:chExt cx="0" cy="0"/>
-        </a:xfrm>
-      </p:grpSpPr>
+      <p:grpSpPr/>
       <p:sp>
         <p:nvSpPr>
           <p:cNvPr id="2" name="Rectangle 1"/>
@@ -14651,7 +13608,6 @@
           <a:lstStyle/>
           <a:p>
             <a:pPr algn="ctr"/>
-            <a:endParaRPr/>
           </a:p>
         </p:txBody>
       </p:sp>
@@ -14734,7 +13690,6 @@
           <a:lstStyle/>
           <a:p>
             <a:pPr algn="ctr"/>
-            <a:endParaRPr/>
           </a:p>
         </p:txBody>
       </p:sp>
@@ -14819,7 +13774,6 @@
           <a:lstStyle/>
           <a:p>
             <a:pPr algn="ctr"/>
-            <a:endParaRPr/>
           </a:p>
         </p:txBody>
       </p:sp>
@@ -15041,7 +13995,6 @@
           <a:lstStyle/>
           <a:p>
             <a:pPr algn="ctr"/>
-            <a:endParaRPr/>
           </a:p>
         </p:txBody>
       </p:sp>
@@ -15261,7 +14214,6 @@
           <a:lstStyle/>
           <a:p>
             <a:pPr algn="ctr"/>
-            <a:endParaRPr/>
           </a:p>
         </p:txBody>
       </p:sp>
@@ -15348,18 +14300,6 @@
   <p:clrMapOvr>
     <a:masterClrMapping/>
   </p:clrMapOvr>
-  <mc:AlternateContent xmlns:mc="http://schemas.openxmlformats.org/markup-compatibility/2006">
-    <mc:Choice xmlns:p14="http://schemas.microsoft.com/office/powerpoint/2010/main" Requires="p14">
-      <p:transition spd="med">
-        <p14:vortex dir="r"/>
-      </p:transition>
-    </mc:Choice>
-    <mc:Fallback>
-      <p:transition spd="med">
-        <p:fade/>
-      </p:transition>
-    </mc:Fallback>
-  </mc:AlternateContent>
 </p:sld>
 </file>
 

</xml_diff>

<commit_message>
Harden production security against abuse and code exposure.
Disable public API docs, rate-limit auth, tighten CORS and headers, stop boot-time PIN resets, and hide production source maps.

Co-authored-by: Cursor <cursoragent@cursor.com>
</commit_message>
<xml_diff>
--- a/Presentation/Ushirika_Group15_Defence_Presentation.pptx
+++ b/Presentation/Ushirika_Group15_Defence_Presentation.pptx
@@ -8659,7 +8659,7 @@
                 </a:solidFill>
                 <a:latin typeface="Calibri"/>
               </a:rPr>
-              <a:t>NIDA-DOB, phone, email</a:t>
+              <a:t>Rate limits + hardened headers</a:t>
             </a:r>
           </a:p>
           <a:p>
@@ -8675,7 +8675,7 @@
                 </a:solidFill>
                 <a:latin typeface="Calibri"/>
               </a:rPr>
-              <a:t>No future transactions</a:t>
+              <a:t>No public API docs in prod</a:t>
             </a:r>
           </a:p>
         </p:txBody>
@@ -9237,6 +9237,22 @@
                 <a:latin typeface="Calibri"/>
               </a:rPr>
               <a:t>Inclusive controls: NIDA-DOB matching, +255 phone entry, cascading Tanzania region→district dropdowns, bilingual labels, live email checks, and clear forms.</a:t>
+            </a:r>
+          </a:p>
+          <a:p>
+            <a:pPr algn="l">
+              <a:spcAft>
+                <a:spcPts val="300"/>
+              </a:spcAft>
+            </a:pPr>
+            <a:r>
+              <a:rPr sz="1300" b="0">
+                <a:solidFill>
+                  <a:srgbClr val="4A5E66"/>
+                </a:solidFill>
+                <a:latin typeface="Calibri"/>
+              </a:rPr>
+              <a:t>Security: production API docs disabled, auth rate limits, short-lived JWTs, strict CORS, security headers, no production source maps, and no boot-time PIN resets.</a:t>
             </a:r>
           </a:p>
           <a:p>

</xml_diff>

<commit_message>
Harden admin delete, ML clarity, and privacy-safe documentation shots.
Permanent account deletion, post-create redirect, stronger Random Forest scoring with plain-language signals, hide technical model chips, and blurred screenshots for the proposal/PPT.

Co-authored-by: Cursor <cursoragent@cursor.com>
</commit_message>
<xml_diff>
--- a/Presentation/Ushirika_Group15_Defence_Presentation.pptx
+++ b/Presentation/Ushirika_Group15_Defence_Presentation.pptx
@@ -9253,6 +9253,22 @@
                 <a:latin typeface="Calibri"/>
               </a:rPr>
               <a:t>Security: production API docs disabled, auth rate limits, short-lived JWTs, strict CORS, security headers, no production source maps, and no boot-time PIN resets.</a:t>
+            </a:r>
+          </a:p>
+          <a:p>
+            <a:pPr algn="l">
+              <a:spcAft>
+                <a:spcPts val="300"/>
+              </a:spcAft>
+            </a:pPr>
+            <a:r>
+              <a:rPr sz="1300" b="0">
+                <a:solidFill>
+                  <a:srgbClr val="4A5E66"/>
+                </a:solidFill>
+                <a:latin typeface="Calibri"/>
+              </a:rPr>
+              <a:t>Admin hard-delete removes accounts permanently; create-account flows return to the accounts list; ML uses stronger Random Forest tuning with plain-language repayment signals (no technical model-version chips in the UI).</a:t>
             </a:r>
           </a:p>
           <a:p>

</xml_diff>

<commit_message>
Clarify slide 7 findings with hold-out table, confusion matrix, and feature proof.
Co-authored-by: Cursor <cursoragent@cursor.com>
</commit_message>
<xml_diff>
--- a/Presentation/Ushirika_Group15_Defence_Presentation.pptx
+++ b/Presentation/Ushirika_Group15_Defence_Presentation.pptx
@@ -9747,7 +9747,7 @@
                 </a:solidFill>
                 <a:latin typeface="Calibri"/>
               </a:rPr>
-              <a:t>FINDINGS</a:t>
+              <a:t>FINDINGS  ·  HOLD-OUT PROOF</a:t>
             </a:r>
           </a:p>
         </p:txBody>
@@ -9837,14 +9837,53 @@
       </p:sp>
       <p:sp>
         <p:nvSpPr>
-          <p:cNvPr id="6" name="Rounded Rectangle 5"/>
+          <p:cNvPr id="6" name="TextBox 5"/>
+          <p:cNvSpPr txBox="1"/>
+          <p:nvPr/>
+        </p:nvSpPr>
+        <p:spPr>
+          <a:xfrm>
+            <a:off x="502920" y="1005840"/>
+            <a:ext cx="11155680" cy="320040"/>
+          </a:xfrm>
+          <a:prstGeom prst="rect">
+            <a:avLst/>
+          </a:prstGeom>
+          <a:noFill/>
+        </p:spPr>
+        <p:txBody>
+          <a:bodyPr wrap="square">
+            <a:spAutoFit/>
+          </a:bodyPr>
+          <a:lstStyle/>
+          <a:p>
+            <a:pPr algn="l">
+              <a:spcAft>
+                <a:spcPts val="400"/>
+              </a:spcAft>
+            </a:pPr>
+            <a:r>
+              <a:rPr sz="1500" b="0">
+                <a:solidFill>
+                  <a:srgbClr val="3D525A"/>
+                </a:solidFill>
+                <a:latin typeface="Calibri"/>
+              </a:rPr>
+              <a:t>From the project hold-out evaluation  ·  80/20 stratified split  ·  test n = 280 SMEs</a:t>
+            </a:r>
+          </a:p>
+        </p:txBody>
+      </p:sp>
+      <p:sp>
+        <p:nvSpPr>
+          <p:cNvPr id="7" name="Rounded Rectangle 6"/>
           <p:cNvSpPr/>
           <p:nvPr/>
         </p:nvSpPr>
         <p:spPr>
           <a:xfrm>
             <a:off x="411480" y="1417320"/>
-            <a:ext cx="2788920" cy="1280160"/>
+            <a:ext cx="7635240" cy="3063240"/>
           </a:xfrm>
           <a:prstGeom prst="roundRect">
             <a:avLst>
@@ -9883,20 +9922,59 @@
       </p:sp>
       <p:sp>
         <p:nvSpPr>
-          <p:cNvPr id="7" name="Rectangle 6"/>
+          <p:cNvPr id="8" name="TextBox 7"/>
+          <p:cNvSpPr txBox="1"/>
+          <p:nvPr/>
+        </p:nvSpPr>
+        <p:spPr>
+          <a:xfrm>
+            <a:off x="640080" y="1536192"/>
+            <a:ext cx="7223760" cy="320040"/>
+          </a:xfrm>
+          <a:prstGeom prst="rect">
+            <a:avLst/>
+          </a:prstGeom>
+          <a:noFill/>
+        </p:spPr>
+        <p:txBody>
+          <a:bodyPr wrap="square">
+            <a:spAutoFit/>
+          </a:bodyPr>
+          <a:lstStyle/>
+          <a:p>
+            <a:pPr algn="l">
+              <a:spcAft>
+                <a:spcPts val="400"/>
+              </a:spcAft>
+            </a:pPr>
+            <a:r>
+              <a:rPr sz="1400" b="1">
+                <a:solidFill>
+                  <a:srgbClr val="0B3D2E"/>
+                </a:solidFill>
+                <a:latin typeface="Calibri"/>
+              </a:rPr>
+              <a:t>Side-by-side hold-out metrics (creditworthy = positive class)</a:t>
+            </a:r>
+          </a:p>
+        </p:txBody>
+      </p:sp>
+      <p:sp>
+        <p:nvSpPr>
+          <p:cNvPr id="9" name="Rectangle 8"/>
           <p:cNvSpPr/>
           <p:nvPr/>
         </p:nvSpPr>
         <p:spPr>
           <a:xfrm>
-            <a:off x="411480" y="1417320"/>
-            <a:ext cx="109728" cy="1280160"/>
+            <a:off x="594360" y="1965960"/>
+            <a:ext cx="7269480" cy="384048"/>
           </a:xfrm>
           <a:prstGeom prst="rect">
             <a:avLst/>
           </a:prstGeom>
           <a:solidFill>
-            <a:srgbClr val="1A6B45"/>
+            <a:srgbClr val="0B3D2E"/>
           </a:solidFill>
           <a:ln>
             <a:noFill/>
@@ -9927,14 +10005,760 @@
       </p:sp>
       <p:sp>
         <p:nvSpPr>
-          <p:cNvPr id="8" name="TextBox 7"/>
-          <p:cNvSpPr txBox="1"/>
-          <p:nvPr/>
-        </p:nvSpPr>
-        <p:spPr>
-          <a:xfrm>
-            <a:off x="667512" y="1618488"/>
-            <a:ext cx="2423160" cy="411480"/>
+          <p:cNvPr id="10" name="TextBox 9"/>
+          <p:cNvSpPr txBox="1"/>
+          <p:nvPr/>
+        </p:nvSpPr>
+        <p:spPr>
+          <a:xfrm>
+            <a:off x="640080" y="2011680"/>
+            <a:ext cx="1554480" cy="320040"/>
+          </a:xfrm>
+          <a:prstGeom prst="rect">
+            <a:avLst/>
+          </a:prstGeom>
+          <a:noFill/>
+        </p:spPr>
+        <p:txBody>
+          <a:bodyPr wrap="square">
+            <a:spAutoFit/>
+          </a:bodyPr>
+          <a:lstStyle/>
+          <a:p>
+            <a:pPr algn="ctr">
+              <a:spcAft>
+                <a:spcPts val="400"/>
+              </a:spcAft>
+            </a:pPr>
+            <a:r>
+              <a:rPr sz="1300" b="1">
+                <a:solidFill>
+                  <a:srgbClr val="FFFFFF"/>
+                </a:solidFill>
+                <a:latin typeface="Calibri"/>
+              </a:rPr>
+              <a:t>Model</a:t>
+            </a:r>
+          </a:p>
+        </p:txBody>
+      </p:sp>
+      <p:sp>
+        <p:nvSpPr>
+          <p:cNvPr id="11" name="TextBox 10"/>
+          <p:cNvSpPr txBox="1"/>
+          <p:nvPr/>
+        </p:nvSpPr>
+        <p:spPr>
+          <a:xfrm>
+            <a:off x="2194560" y="2011680"/>
+            <a:ext cx="1097280" cy="320040"/>
+          </a:xfrm>
+          <a:prstGeom prst="rect">
+            <a:avLst/>
+          </a:prstGeom>
+          <a:noFill/>
+        </p:spPr>
+        <p:txBody>
+          <a:bodyPr wrap="square">
+            <a:spAutoFit/>
+          </a:bodyPr>
+          <a:lstStyle/>
+          <a:p>
+            <a:pPr algn="ctr">
+              <a:spcAft>
+                <a:spcPts val="400"/>
+              </a:spcAft>
+            </a:pPr>
+            <a:r>
+              <a:rPr sz="1300" b="1">
+                <a:solidFill>
+                  <a:srgbClr val="FFFFFF"/>
+                </a:solidFill>
+                <a:latin typeface="Calibri"/>
+              </a:rPr>
+              <a:t>Accuracy</a:t>
+            </a:r>
+          </a:p>
+        </p:txBody>
+      </p:sp>
+      <p:sp>
+        <p:nvSpPr>
+          <p:cNvPr id="12" name="TextBox 11"/>
+          <p:cNvSpPr txBox="1"/>
+          <p:nvPr/>
+        </p:nvSpPr>
+        <p:spPr>
+          <a:xfrm>
+            <a:off x="3291839" y="2011680"/>
+            <a:ext cx="1143000" cy="320040"/>
+          </a:xfrm>
+          <a:prstGeom prst="rect">
+            <a:avLst/>
+          </a:prstGeom>
+          <a:noFill/>
+        </p:spPr>
+        <p:txBody>
+          <a:bodyPr wrap="square">
+            <a:spAutoFit/>
+          </a:bodyPr>
+          <a:lstStyle/>
+          <a:p>
+            <a:pPr algn="ctr">
+              <a:spcAft>
+                <a:spcPts val="400"/>
+              </a:spcAft>
+            </a:pPr>
+            <a:r>
+              <a:rPr sz="1300" b="1">
+                <a:solidFill>
+                  <a:srgbClr val="FFFFFF"/>
+                </a:solidFill>
+                <a:latin typeface="Calibri"/>
+              </a:rPr>
+              <a:t>Precision</a:t>
+            </a:r>
+          </a:p>
+        </p:txBody>
+      </p:sp>
+      <p:sp>
+        <p:nvSpPr>
+          <p:cNvPr id="13" name="TextBox 12"/>
+          <p:cNvSpPr txBox="1"/>
+          <p:nvPr/>
+        </p:nvSpPr>
+        <p:spPr>
+          <a:xfrm>
+            <a:off x="4434840" y="2011680"/>
+            <a:ext cx="1051560" cy="320040"/>
+          </a:xfrm>
+          <a:prstGeom prst="rect">
+            <a:avLst/>
+          </a:prstGeom>
+          <a:noFill/>
+        </p:spPr>
+        <p:txBody>
+          <a:bodyPr wrap="square">
+            <a:spAutoFit/>
+          </a:bodyPr>
+          <a:lstStyle/>
+          <a:p>
+            <a:pPr algn="ctr">
+              <a:spcAft>
+                <a:spcPts val="400"/>
+              </a:spcAft>
+            </a:pPr>
+            <a:r>
+              <a:rPr sz="1300" b="1">
+                <a:solidFill>
+                  <a:srgbClr val="FFFFFF"/>
+                </a:solidFill>
+                <a:latin typeface="Calibri"/>
+              </a:rPr>
+              <a:t>Recall</a:t>
+            </a:r>
+          </a:p>
+        </p:txBody>
+      </p:sp>
+      <p:sp>
+        <p:nvSpPr>
+          <p:cNvPr id="14" name="TextBox 13"/>
+          <p:cNvSpPr txBox="1"/>
+          <p:nvPr/>
+        </p:nvSpPr>
+        <p:spPr>
+          <a:xfrm>
+            <a:off x="5486400" y="2011680"/>
+            <a:ext cx="1005840" cy="320040"/>
+          </a:xfrm>
+          <a:prstGeom prst="rect">
+            <a:avLst/>
+          </a:prstGeom>
+          <a:noFill/>
+        </p:spPr>
+        <p:txBody>
+          <a:bodyPr wrap="square">
+            <a:spAutoFit/>
+          </a:bodyPr>
+          <a:lstStyle/>
+          <a:p>
+            <a:pPr algn="ctr">
+              <a:spcAft>
+                <a:spcPts val="400"/>
+              </a:spcAft>
+            </a:pPr>
+            <a:r>
+              <a:rPr sz="1300" b="1">
+                <a:solidFill>
+                  <a:srgbClr val="FFFFFF"/>
+                </a:solidFill>
+                <a:latin typeface="Calibri"/>
+              </a:rPr>
+              <a:t>F1</a:t>
+            </a:r>
+          </a:p>
+        </p:txBody>
+      </p:sp>
+      <p:sp>
+        <p:nvSpPr>
+          <p:cNvPr id="15" name="TextBox 14"/>
+          <p:cNvSpPr txBox="1"/>
+          <p:nvPr/>
+        </p:nvSpPr>
+        <p:spPr>
+          <a:xfrm>
+            <a:off x="6492240" y="2011680"/>
+            <a:ext cx="1143000" cy="320040"/>
+          </a:xfrm>
+          <a:prstGeom prst="rect">
+            <a:avLst/>
+          </a:prstGeom>
+          <a:noFill/>
+        </p:spPr>
+        <p:txBody>
+          <a:bodyPr wrap="square">
+            <a:spAutoFit/>
+          </a:bodyPr>
+          <a:lstStyle/>
+          <a:p>
+            <a:pPr algn="ctr">
+              <a:spcAft>
+                <a:spcPts val="400"/>
+              </a:spcAft>
+            </a:pPr>
+            <a:r>
+              <a:rPr sz="1300" b="1">
+                <a:solidFill>
+                  <a:srgbClr val="FFFFFF"/>
+                </a:solidFill>
+                <a:latin typeface="Calibri"/>
+              </a:rPr>
+              <a:t>ROC-AUC</a:t>
+            </a:r>
+          </a:p>
+        </p:txBody>
+      </p:sp>
+      <p:sp>
+        <p:nvSpPr>
+          <p:cNvPr id="16" name="Rectangle 15"/>
+          <p:cNvSpPr/>
+          <p:nvPr/>
+        </p:nvSpPr>
+        <p:spPr>
+          <a:xfrm>
+            <a:off x="594360" y="2350008"/>
+            <a:ext cx="7269480" cy="502920"/>
+          </a:xfrm>
+          <a:prstGeom prst="rect">
+            <a:avLst/>
+          </a:prstGeom>
+          <a:solidFill>
+            <a:srgbClr val="D8E8E4"/>
+          </a:solidFill>
+          <a:ln>
+            <a:noFill/>
+          </a:ln>
+        </p:spPr>
+        <p:style>
+          <a:lnRef idx="1">
+            <a:schemeClr val="accent1"/>
+          </a:lnRef>
+          <a:fillRef idx="3">
+            <a:schemeClr val="accent1"/>
+          </a:fillRef>
+          <a:effectRef idx="2">
+            <a:schemeClr val="accent1"/>
+          </a:effectRef>
+          <a:fontRef idx="minor">
+            <a:schemeClr val="lt1"/>
+          </a:fontRef>
+        </p:style>
+        <p:txBody>
+          <a:bodyPr rtlCol="0" anchor="ctr"/>
+          <a:lstStyle/>
+          <a:p>
+            <a:pPr algn="ctr"/>
+            <a:endParaRPr/>
+          </a:p>
+        </p:txBody>
+      </p:sp>
+      <p:sp>
+        <p:nvSpPr>
+          <p:cNvPr id="17" name="TextBox 16"/>
+          <p:cNvSpPr txBox="1"/>
+          <p:nvPr/>
+        </p:nvSpPr>
+        <p:spPr>
+          <a:xfrm>
+            <a:off x="640080" y="2450592"/>
+            <a:ext cx="1554480" cy="320040"/>
+          </a:xfrm>
+          <a:prstGeom prst="rect">
+            <a:avLst/>
+          </a:prstGeom>
+          <a:noFill/>
+        </p:spPr>
+        <p:txBody>
+          <a:bodyPr wrap="square">
+            <a:spAutoFit/>
+          </a:bodyPr>
+          <a:lstStyle/>
+          <a:p>
+            <a:pPr algn="ctr">
+              <a:spcAft>
+                <a:spcPts val="400"/>
+              </a:spcAft>
+            </a:pPr>
+            <a:r>
+              <a:rPr sz="1400" b="1">
+                <a:solidFill>
+                  <a:srgbClr val="0B3D2E"/>
+                </a:solidFill>
+                <a:latin typeface="Calibri"/>
+              </a:rPr>
+              <a:t>Random Forest</a:t>
+            </a:r>
+          </a:p>
+        </p:txBody>
+      </p:sp>
+      <p:sp>
+        <p:nvSpPr>
+          <p:cNvPr id="18" name="TextBox 17"/>
+          <p:cNvSpPr txBox="1"/>
+          <p:nvPr/>
+        </p:nvSpPr>
+        <p:spPr>
+          <a:xfrm>
+            <a:off x="2194560" y="2450592"/>
+            <a:ext cx="1097280" cy="320040"/>
+          </a:xfrm>
+          <a:prstGeom prst="rect">
+            <a:avLst/>
+          </a:prstGeom>
+          <a:noFill/>
+        </p:spPr>
+        <p:txBody>
+          <a:bodyPr wrap="square">
+            <a:spAutoFit/>
+          </a:bodyPr>
+          <a:lstStyle/>
+          <a:p>
+            <a:pPr algn="ctr">
+              <a:spcAft>
+                <a:spcPts val="400"/>
+              </a:spcAft>
+            </a:pPr>
+            <a:r>
+              <a:rPr sz="1400" b="1">
+                <a:solidFill>
+                  <a:srgbClr val="0B3D2E"/>
+                </a:solidFill>
+                <a:latin typeface="Calibri"/>
+              </a:rPr>
+              <a:t>88.6%</a:t>
+            </a:r>
+          </a:p>
+        </p:txBody>
+      </p:sp>
+      <p:sp>
+        <p:nvSpPr>
+          <p:cNvPr id="19" name="TextBox 18"/>
+          <p:cNvSpPr txBox="1"/>
+          <p:nvPr/>
+        </p:nvSpPr>
+        <p:spPr>
+          <a:xfrm>
+            <a:off x="3291839" y="2450592"/>
+            <a:ext cx="1143000" cy="320040"/>
+          </a:xfrm>
+          <a:prstGeom prst="rect">
+            <a:avLst/>
+          </a:prstGeom>
+          <a:noFill/>
+        </p:spPr>
+        <p:txBody>
+          <a:bodyPr wrap="square">
+            <a:spAutoFit/>
+          </a:bodyPr>
+          <a:lstStyle/>
+          <a:p>
+            <a:pPr algn="ctr">
+              <a:spcAft>
+                <a:spcPts val="400"/>
+              </a:spcAft>
+            </a:pPr>
+            <a:r>
+              <a:rPr sz="1400" b="1">
+                <a:solidFill>
+                  <a:srgbClr val="0B3D2E"/>
+                </a:solidFill>
+                <a:latin typeface="Calibri"/>
+              </a:rPr>
+              <a:t>93.0%</a:t>
+            </a:r>
+          </a:p>
+        </p:txBody>
+      </p:sp>
+      <p:sp>
+        <p:nvSpPr>
+          <p:cNvPr id="20" name="TextBox 19"/>
+          <p:cNvSpPr txBox="1"/>
+          <p:nvPr/>
+        </p:nvSpPr>
+        <p:spPr>
+          <a:xfrm>
+            <a:off x="4434840" y="2450592"/>
+            <a:ext cx="1051560" cy="320040"/>
+          </a:xfrm>
+          <a:prstGeom prst="rect">
+            <a:avLst/>
+          </a:prstGeom>
+          <a:noFill/>
+        </p:spPr>
+        <p:txBody>
+          <a:bodyPr wrap="square">
+            <a:spAutoFit/>
+          </a:bodyPr>
+          <a:lstStyle/>
+          <a:p>
+            <a:pPr algn="ctr">
+              <a:spcAft>
+                <a:spcPts val="400"/>
+              </a:spcAft>
+            </a:pPr>
+            <a:r>
+              <a:rPr sz="1400" b="1">
+                <a:solidFill>
+                  <a:srgbClr val="0B3D2E"/>
+                </a:solidFill>
+                <a:latin typeface="Calibri"/>
+              </a:rPr>
+              <a:t>85.7%</a:t>
+            </a:r>
+          </a:p>
+        </p:txBody>
+      </p:sp>
+      <p:sp>
+        <p:nvSpPr>
+          <p:cNvPr id="21" name="TextBox 20"/>
+          <p:cNvSpPr txBox="1"/>
+          <p:nvPr/>
+        </p:nvSpPr>
+        <p:spPr>
+          <a:xfrm>
+            <a:off x="5486400" y="2450592"/>
+            <a:ext cx="1005840" cy="320040"/>
+          </a:xfrm>
+          <a:prstGeom prst="rect">
+            <a:avLst/>
+          </a:prstGeom>
+          <a:noFill/>
+        </p:spPr>
+        <p:txBody>
+          <a:bodyPr wrap="square">
+            <a:spAutoFit/>
+          </a:bodyPr>
+          <a:lstStyle/>
+          <a:p>
+            <a:pPr algn="ctr">
+              <a:spcAft>
+                <a:spcPts val="400"/>
+              </a:spcAft>
+            </a:pPr>
+            <a:r>
+              <a:rPr sz="1400" b="1">
+                <a:solidFill>
+                  <a:srgbClr val="0B3D2E"/>
+                </a:solidFill>
+                <a:latin typeface="Calibri"/>
+              </a:rPr>
+              <a:t>89.2%</a:t>
+            </a:r>
+          </a:p>
+        </p:txBody>
+      </p:sp>
+      <p:sp>
+        <p:nvSpPr>
+          <p:cNvPr id="22" name="TextBox 21"/>
+          <p:cNvSpPr txBox="1"/>
+          <p:nvPr/>
+        </p:nvSpPr>
+        <p:spPr>
+          <a:xfrm>
+            <a:off x="6492240" y="2450592"/>
+            <a:ext cx="1143000" cy="320040"/>
+          </a:xfrm>
+          <a:prstGeom prst="rect">
+            <a:avLst/>
+          </a:prstGeom>
+          <a:noFill/>
+        </p:spPr>
+        <p:txBody>
+          <a:bodyPr wrap="square">
+            <a:spAutoFit/>
+          </a:bodyPr>
+          <a:lstStyle/>
+          <a:p>
+            <a:pPr algn="ctr">
+              <a:spcAft>
+                <a:spcPts val="400"/>
+              </a:spcAft>
+            </a:pPr>
+            <a:r>
+              <a:rPr sz="1400" b="1">
+                <a:solidFill>
+                  <a:srgbClr val="0B3D2E"/>
+                </a:solidFill>
+                <a:latin typeface="Calibri"/>
+              </a:rPr>
+              <a:t>95.8%</a:t>
+            </a:r>
+          </a:p>
+        </p:txBody>
+      </p:sp>
+      <p:sp>
+        <p:nvSpPr>
+          <p:cNvPr id="23" name="TextBox 22"/>
+          <p:cNvSpPr txBox="1"/>
+          <p:nvPr/>
+        </p:nvSpPr>
+        <p:spPr>
+          <a:xfrm>
+            <a:off x="640080" y="2971800"/>
+            <a:ext cx="1554480" cy="320040"/>
+          </a:xfrm>
+          <a:prstGeom prst="rect">
+            <a:avLst/>
+          </a:prstGeom>
+          <a:noFill/>
+        </p:spPr>
+        <p:txBody>
+          <a:bodyPr wrap="square">
+            <a:spAutoFit/>
+          </a:bodyPr>
+          <a:lstStyle/>
+          <a:p>
+            <a:pPr algn="ctr">
+              <a:spcAft>
+                <a:spcPts val="400"/>
+              </a:spcAft>
+            </a:pPr>
+            <a:r>
+              <a:rPr sz="1400" b="0">
+                <a:solidFill>
+                  <a:srgbClr val="3D525A"/>
+                </a:solidFill>
+                <a:latin typeface="Calibri"/>
+              </a:rPr>
+              <a:t>Logistic Reg.</a:t>
+            </a:r>
+          </a:p>
+        </p:txBody>
+      </p:sp>
+      <p:sp>
+        <p:nvSpPr>
+          <p:cNvPr id="24" name="TextBox 23"/>
+          <p:cNvSpPr txBox="1"/>
+          <p:nvPr/>
+        </p:nvSpPr>
+        <p:spPr>
+          <a:xfrm>
+            <a:off x="2194560" y="2971800"/>
+            <a:ext cx="1097280" cy="320040"/>
+          </a:xfrm>
+          <a:prstGeom prst="rect">
+            <a:avLst/>
+          </a:prstGeom>
+          <a:noFill/>
+        </p:spPr>
+        <p:txBody>
+          <a:bodyPr wrap="square">
+            <a:spAutoFit/>
+          </a:bodyPr>
+          <a:lstStyle/>
+          <a:p>
+            <a:pPr algn="ctr">
+              <a:spcAft>
+                <a:spcPts val="400"/>
+              </a:spcAft>
+            </a:pPr>
+            <a:r>
+              <a:rPr sz="1400" b="0">
+                <a:solidFill>
+                  <a:srgbClr val="3D525A"/>
+                </a:solidFill>
+                <a:latin typeface="Calibri"/>
+              </a:rPr>
+              <a:t>77.9%</a:t>
+            </a:r>
+          </a:p>
+        </p:txBody>
+      </p:sp>
+      <p:sp>
+        <p:nvSpPr>
+          <p:cNvPr id="25" name="TextBox 24"/>
+          <p:cNvSpPr txBox="1"/>
+          <p:nvPr/>
+        </p:nvSpPr>
+        <p:spPr>
+          <a:xfrm>
+            <a:off x="3291839" y="2971800"/>
+            <a:ext cx="1143000" cy="320040"/>
+          </a:xfrm>
+          <a:prstGeom prst="rect">
+            <a:avLst/>
+          </a:prstGeom>
+          <a:noFill/>
+        </p:spPr>
+        <p:txBody>
+          <a:bodyPr wrap="square">
+            <a:spAutoFit/>
+          </a:bodyPr>
+          <a:lstStyle/>
+          <a:p>
+            <a:pPr algn="ctr">
+              <a:spcAft>
+                <a:spcPts val="400"/>
+              </a:spcAft>
+            </a:pPr>
+            <a:r>
+              <a:rPr sz="1400" b="0">
+                <a:solidFill>
+                  <a:srgbClr val="3D525A"/>
+                </a:solidFill>
+                <a:latin typeface="Calibri"/>
+              </a:rPr>
+              <a:t>75.8%</a:t>
+            </a:r>
+          </a:p>
+        </p:txBody>
+      </p:sp>
+      <p:sp>
+        <p:nvSpPr>
+          <p:cNvPr id="26" name="TextBox 25"/>
+          <p:cNvSpPr txBox="1"/>
+          <p:nvPr/>
+        </p:nvSpPr>
+        <p:spPr>
+          <a:xfrm>
+            <a:off x="4434840" y="2971800"/>
+            <a:ext cx="1051560" cy="320040"/>
+          </a:xfrm>
+          <a:prstGeom prst="rect">
+            <a:avLst/>
+          </a:prstGeom>
+          <a:noFill/>
+        </p:spPr>
+        <p:txBody>
+          <a:bodyPr wrap="square">
+            <a:spAutoFit/>
+          </a:bodyPr>
+          <a:lstStyle/>
+          <a:p>
+            <a:pPr algn="ctr">
+              <a:spcAft>
+                <a:spcPts val="400"/>
+              </a:spcAft>
+            </a:pPr>
+            <a:r>
+              <a:rPr sz="1400" b="0">
+                <a:solidFill>
+                  <a:srgbClr val="3D525A"/>
+                </a:solidFill>
+                <a:latin typeface="Calibri"/>
+              </a:rPr>
+              <a:t>87.7%</a:t>
+            </a:r>
+          </a:p>
+        </p:txBody>
+      </p:sp>
+      <p:sp>
+        <p:nvSpPr>
+          <p:cNvPr id="27" name="TextBox 26"/>
+          <p:cNvSpPr txBox="1"/>
+          <p:nvPr/>
+        </p:nvSpPr>
+        <p:spPr>
+          <a:xfrm>
+            <a:off x="5486400" y="2971800"/>
+            <a:ext cx="1005840" cy="320040"/>
+          </a:xfrm>
+          <a:prstGeom prst="rect">
+            <a:avLst/>
+          </a:prstGeom>
+          <a:noFill/>
+        </p:spPr>
+        <p:txBody>
+          <a:bodyPr wrap="square">
+            <a:spAutoFit/>
+          </a:bodyPr>
+          <a:lstStyle/>
+          <a:p>
+            <a:pPr algn="ctr">
+              <a:spcAft>
+                <a:spcPts val="400"/>
+              </a:spcAft>
+            </a:pPr>
+            <a:r>
+              <a:rPr sz="1400" b="0">
+                <a:solidFill>
+                  <a:srgbClr val="3D525A"/>
+                </a:solidFill>
+                <a:latin typeface="Calibri"/>
+              </a:rPr>
+              <a:t>81.3%</a:t>
+            </a:r>
+          </a:p>
+        </p:txBody>
+      </p:sp>
+      <p:sp>
+        <p:nvSpPr>
+          <p:cNvPr id="28" name="TextBox 27"/>
+          <p:cNvSpPr txBox="1"/>
+          <p:nvPr/>
+        </p:nvSpPr>
+        <p:spPr>
+          <a:xfrm>
+            <a:off x="6492240" y="2971800"/>
+            <a:ext cx="1143000" cy="320040"/>
+          </a:xfrm>
+          <a:prstGeom prst="rect">
+            <a:avLst/>
+          </a:prstGeom>
+          <a:noFill/>
+        </p:spPr>
+        <p:txBody>
+          <a:bodyPr wrap="square">
+            <a:spAutoFit/>
+          </a:bodyPr>
+          <a:lstStyle/>
+          <a:p>
+            <a:pPr algn="ctr">
+              <a:spcAft>
+                <a:spcPts val="400"/>
+              </a:spcAft>
+            </a:pPr>
+            <a:r>
+              <a:rPr sz="1400" b="0">
+                <a:solidFill>
+                  <a:srgbClr val="3D525A"/>
+                </a:solidFill>
+                <a:latin typeface="Calibri"/>
+              </a:rPr>
+              <a:t>87.5%</a:t>
+            </a:r>
+          </a:p>
+        </p:txBody>
+      </p:sp>
+      <p:sp>
+        <p:nvSpPr>
+          <p:cNvPr id="29" name="TextBox 28"/>
+          <p:cNvSpPr txBox="1"/>
+          <p:nvPr/>
+        </p:nvSpPr>
+        <p:spPr>
+          <a:xfrm>
+            <a:off x="640080" y="3520440"/>
+            <a:ext cx="7223760" cy="777240"/>
           </a:xfrm>
           <a:prstGeom prst="rect">
             <a:avLst/>
@@ -9953,38 +10777,15 @@
               </a:spcAft>
             </a:pPr>
             <a:r>
-              <a:rPr sz="2600" b="1">
-                <a:solidFill>
-                  <a:srgbClr val="0B3D2E"/>
-                </a:solidFill>
-                <a:latin typeface="Calibri"/>
-              </a:rPr>
-              <a:t>95.8%</a:t>
-            </a:r>
-          </a:p>
-        </p:txBody>
-      </p:sp>
-      <p:sp>
-        <p:nvSpPr>
-          <p:cNvPr id="9" name="TextBox 8"/>
-          <p:cNvSpPr txBox="1"/>
-          <p:nvPr/>
-        </p:nvSpPr>
-        <p:spPr>
-          <a:xfrm>
-            <a:off x="667512" y="2103120"/>
-            <a:ext cx="2423160" cy="365760"/>
-          </a:xfrm>
-          <a:prstGeom prst="rect">
-            <a:avLst/>
-          </a:prstGeom>
-          <a:noFill/>
-        </p:spPr>
-        <p:txBody>
-          <a:bodyPr wrap="square">
-            <a:spAutoFit/>
-          </a:bodyPr>
-          <a:lstStyle/>
+              <a:rPr sz="1400" b="0">
+                <a:solidFill>
+                  <a:srgbClr val="0F2830"/>
+                </a:solidFill>
+                <a:latin typeface="Calibri"/>
+              </a:rPr>
+              <a:t>Proof of choice: RF ROC-AUC is 8.3 points higher than LR (95.8% vs 87.5%).</a:t>
+            </a:r>
+          </a:p>
           <a:p>
             <a:pPr algn="l">
               <a:spcAft>
@@ -9994,25 +10795,617 @@
             <a:r>
               <a:rPr sz="1400" b="0">
                 <a:solidFill>
-                  <a:srgbClr val="3D525A"/>
-                </a:solidFill>
-                <a:latin typeface="Calibri"/>
-              </a:rPr>
-              <a:t>RF ROC-AUC</a:t>
-            </a:r>
-          </a:p>
-        </p:txBody>
-      </p:sp>
-      <p:sp>
-        <p:nvSpPr>
-          <p:cNvPr id="10" name="Rounded Rectangle 9"/>
+                  <a:srgbClr val="0F2830"/>
+                </a:solidFill>
+                <a:latin typeface="Calibri"/>
+              </a:rPr>
+              <a:t>RF also has higher accuracy (+10.7 pts) and precision (+17.2 pts) — fewer false “creditworthy” labels.</a:t>
+            </a:r>
+          </a:p>
+        </p:txBody>
+      </p:sp>
+      <p:sp>
+        <p:nvSpPr>
+          <p:cNvPr id="30" name="Rounded Rectangle 29"/>
           <p:cNvSpPr/>
           <p:nvPr/>
         </p:nvSpPr>
         <p:spPr>
           <a:xfrm>
-            <a:off x="3383280" y="1417320"/>
-            <a:ext cx="2788920" cy="1280160"/>
+            <a:off x="8229600" y="1417320"/>
+            <a:ext cx="3520440" cy="3063240"/>
+          </a:xfrm>
+          <a:prstGeom prst="roundRect">
+            <a:avLst>
+              <a:gd name="adj" fmla="val 8000"/>
+            </a:avLst>
+          </a:prstGeom>
+          <a:solidFill>
+            <a:srgbClr val="0B3D2E"/>
+          </a:solidFill>
+          <a:ln>
+            <a:noFill/>
+          </a:ln>
+        </p:spPr>
+        <p:style>
+          <a:lnRef idx="1">
+            <a:schemeClr val="accent1"/>
+          </a:lnRef>
+          <a:fillRef idx="3">
+            <a:schemeClr val="accent1"/>
+          </a:fillRef>
+          <a:effectRef idx="2">
+            <a:schemeClr val="accent1"/>
+          </a:effectRef>
+          <a:fontRef idx="minor">
+            <a:schemeClr val="lt1"/>
+          </a:fontRef>
+        </p:style>
+        <p:txBody>
+          <a:bodyPr rtlCol="0" anchor="ctr"/>
+          <a:lstStyle/>
+          <a:p>
+            <a:pPr algn="ctr"/>
+            <a:endParaRPr/>
+          </a:p>
+        </p:txBody>
+      </p:sp>
+      <p:sp>
+        <p:nvSpPr>
+          <p:cNvPr id="31" name="TextBox 30"/>
+          <p:cNvSpPr txBox="1"/>
+          <p:nvPr/>
+        </p:nvSpPr>
+        <p:spPr>
+          <a:xfrm>
+            <a:off x="8412480" y="1554480"/>
+            <a:ext cx="3200400" cy="320040"/>
+          </a:xfrm>
+          <a:prstGeom prst="rect">
+            <a:avLst/>
+          </a:prstGeom>
+          <a:noFill/>
+        </p:spPr>
+        <p:txBody>
+          <a:bodyPr wrap="square">
+            <a:spAutoFit/>
+          </a:bodyPr>
+          <a:lstStyle/>
+          <a:p>
+            <a:pPr algn="l">
+              <a:spcAft>
+                <a:spcPts val="400"/>
+              </a:spcAft>
+            </a:pPr>
+            <a:r>
+              <a:rPr sz="1400" b="1">
+                <a:solidFill>
+                  <a:srgbClr val="239688"/>
+                </a:solidFill>
+                <a:latin typeface="Calibri"/>
+              </a:rPr>
+              <a:t>RF confusion matrix</a:t>
+            </a:r>
+          </a:p>
+        </p:txBody>
+      </p:sp>
+      <p:sp>
+        <p:nvSpPr>
+          <p:cNvPr id="32" name="TextBox 31"/>
+          <p:cNvSpPr txBox="1"/>
+          <p:nvPr/>
+        </p:nvSpPr>
+        <p:spPr>
+          <a:xfrm>
+            <a:off x="8412480" y="1920240"/>
+            <a:ext cx="3200400" cy="320040"/>
+          </a:xfrm>
+          <a:prstGeom prst="rect">
+            <a:avLst/>
+          </a:prstGeom>
+          <a:noFill/>
+        </p:spPr>
+        <p:txBody>
+          <a:bodyPr wrap="square">
+            <a:spAutoFit/>
+          </a:bodyPr>
+          <a:lstStyle/>
+          <a:p>
+            <a:pPr algn="l">
+              <a:spcAft>
+                <a:spcPts val="400"/>
+              </a:spcAft>
+            </a:pPr>
+            <a:r>
+              <a:rPr sz="1300" b="0">
+                <a:solidFill>
+                  <a:srgbClr val="D8E8E4"/>
+                </a:solidFill>
+                <a:latin typeface="Calibri"/>
+              </a:rPr>
+              <a:t>Test set: 280 SMEs</a:t>
+            </a:r>
+          </a:p>
+        </p:txBody>
+      </p:sp>
+      <p:sp>
+        <p:nvSpPr>
+          <p:cNvPr id="33" name="TextBox 32"/>
+          <p:cNvSpPr txBox="1"/>
+          <p:nvPr/>
+        </p:nvSpPr>
+        <p:spPr>
+          <a:xfrm>
+            <a:off x="8412480" y="2331720"/>
+            <a:ext cx="2011680" cy="228600"/>
+          </a:xfrm>
+          <a:prstGeom prst="rect">
+            <a:avLst/>
+          </a:prstGeom>
+          <a:noFill/>
+        </p:spPr>
+        <p:txBody>
+          <a:bodyPr wrap="square">
+            <a:spAutoFit/>
+          </a:bodyPr>
+          <a:lstStyle/>
+          <a:p>
+            <a:pPr algn="l">
+              <a:spcAft>
+                <a:spcPts val="400"/>
+              </a:spcAft>
+            </a:pPr>
+            <a:r>
+              <a:rPr sz="1200" b="0">
+                <a:solidFill>
+                  <a:srgbClr val="D8E8E4"/>
+                </a:solidFill>
+                <a:latin typeface="Calibri"/>
+              </a:rPr>
+              <a:t>True Negative</a:t>
+            </a:r>
+          </a:p>
+        </p:txBody>
+      </p:sp>
+      <p:sp>
+        <p:nvSpPr>
+          <p:cNvPr id="34" name="TextBox 33"/>
+          <p:cNvSpPr txBox="1"/>
+          <p:nvPr/>
+        </p:nvSpPr>
+        <p:spPr>
+          <a:xfrm>
+            <a:off x="10424160" y="2331720"/>
+            <a:ext cx="1097280" cy="228600"/>
+          </a:xfrm>
+          <a:prstGeom prst="rect">
+            <a:avLst/>
+          </a:prstGeom>
+          <a:noFill/>
+        </p:spPr>
+        <p:txBody>
+          <a:bodyPr wrap="square">
+            <a:spAutoFit/>
+          </a:bodyPr>
+          <a:lstStyle/>
+          <a:p>
+            <a:pPr algn="r">
+              <a:spcAft>
+                <a:spcPts val="400"/>
+              </a:spcAft>
+            </a:pPr>
+            <a:r>
+              <a:rPr sz="1400" b="1">
+                <a:solidFill>
+                  <a:srgbClr val="FFFFFF"/>
+                </a:solidFill>
+                <a:latin typeface="Calibri"/>
+              </a:rPr>
+              <a:t>116</a:t>
+            </a:r>
+          </a:p>
+        </p:txBody>
+      </p:sp>
+      <p:sp>
+        <p:nvSpPr>
+          <p:cNvPr id="35" name="TextBox 34"/>
+          <p:cNvSpPr txBox="1"/>
+          <p:nvPr/>
+        </p:nvSpPr>
+        <p:spPr>
+          <a:xfrm>
+            <a:off x="8412480" y="2532888"/>
+            <a:ext cx="3108960" cy="228600"/>
+          </a:xfrm>
+          <a:prstGeom prst="rect">
+            <a:avLst/>
+          </a:prstGeom>
+          <a:noFill/>
+        </p:spPr>
+        <p:txBody>
+          <a:bodyPr wrap="square">
+            <a:spAutoFit/>
+          </a:bodyPr>
+          <a:lstStyle/>
+          <a:p>
+            <a:pPr algn="l">
+              <a:spcAft>
+                <a:spcPts val="400"/>
+              </a:spcAft>
+            </a:pPr>
+            <a:r>
+              <a:rPr sz="1100" b="0">
+                <a:solidFill>
+                  <a:srgbClr val="9BC4BA"/>
+                </a:solidFill>
+                <a:latin typeface="Calibri"/>
+              </a:rPr>
+              <a:t>Correct higher-risk</a:t>
+            </a:r>
+          </a:p>
+        </p:txBody>
+      </p:sp>
+      <p:sp>
+        <p:nvSpPr>
+          <p:cNvPr id="36" name="TextBox 35"/>
+          <p:cNvSpPr txBox="1"/>
+          <p:nvPr/>
+        </p:nvSpPr>
+        <p:spPr>
+          <a:xfrm>
+            <a:off x="8412480" y="2807208"/>
+            <a:ext cx="2011680" cy="228600"/>
+          </a:xfrm>
+          <a:prstGeom prst="rect">
+            <a:avLst/>
+          </a:prstGeom>
+          <a:noFill/>
+        </p:spPr>
+        <p:txBody>
+          <a:bodyPr wrap="square">
+            <a:spAutoFit/>
+          </a:bodyPr>
+          <a:lstStyle/>
+          <a:p>
+            <a:pPr algn="l">
+              <a:spcAft>
+                <a:spcPts val="400"/>
+              </a:spcAft>
+            </a:pPr>
+            <a:r>
+              <a:rPr sz="1200" b="0">
+                <a:solidFill>
+                  <a:srgbClr val="D8E8E4"/>
+                </a:solidFill>
+                <a:latin typeface="Calibri"/>
+              </a:rPr>
+              <a:t>False Positive</a:t>
+            </a:r>
+          </a:p>
+        </p:txBody>
+      </p:sp>
+      <p:sp>
+        <p:nvSpPr>
+          <p:cNvPr id="37" name="TextBox 36"/>
+          <p:cNvSpPr txBox="1"/>
+          <p:nvPr/>
+        </p:nvSpPr>
+        <p:spPr>
+          <a:xfrm>
+            <a:off x="10424160" y="2807208"/>
+            <a:ext cx="1097280" cy="228600"/>
+          </a:xfrm>
+          <a:prstGeom prst="rect">
+            <a:avLst/>
+          </a:prstGeom>
+          <a:noFill/>
+        </p:spPr>
+        <p:txBody>
+          <a:bodyPr wrap="square">
+            <a:spAutoFit/>
+          </a:bodyPr>
+          <a:lstStyle/>
+          <a:p>
+            <a:pPr algn="r">
+              <a:spcAft>
+                <a:spcPts val="400"/>
+              </a:spcAft>
+            </a:pPr>
+            <a:r>
+              <a:rPr sz="1400" b="1">
+                <a:solidFill>
+                  <a:srgbClr val="FFFFFF"/>
+                </a:solidFill>
+                <a:latin typeface="Calibri"/>
+              </a:rPr>
+              <a:t>10</a:t>
+            </a:r>
+          </a:p>
+        </p:txBody>
+      </p:sp>
+      <p:sp>
+        <p:nvSpPr>
+          <p:cNvPr id="38" name="TextBox 37"/>
+          <p:cNvSpPr txBox="1"/>
+          <p:nvPr/>
+        </p:nvSpPr>
+        <p:spPr>
+          <a:xfrm>
+            <a:off x="8412480" y="3008376"/>
+            <a:ext cx="3108960" cy="228600"/>
+          </a:xfrm>
+          <a:prstGeom prst="rect">
+            <a:avLst/>
+          </a:prstGeom>
+          <a:noFill/>
+        </p:spPr>
+        <p:txBody>
+          <a:bodyPr wrap="square">
+            <a:spAutoFit/>
+          </a:bodyPr>
+          <a:lstStyle/>
+          <a:p>
+            <a:pPr algn="l">
+              <a:spcAft>
+                <a:spcPts val="400"/>
+              </a:spcAft>
+            </a:pPr>
+            <a:r>
+              <a:rPr sz="1100" b="0">
+                <a:solidFill>
+                  <a:srgbClr val="9BC4BA"/>
+                </a:solidFill>
+                <a:latin typeface="Calibri"/>
+              </a:rPr>
+              <a:t>Wrongly called safe</a:t>
+            </a:r>
+          </a:p>
+        </p:txBody>
+      </p:sp>
+      <p:sp>
+        <p:nvSpPr>
+          <p:cNvPr id="39" name="TextBox 38"/>
+          <p:cNvSpPr txBox="1"/>
+          <p:nvPr/>
+        </p:nvSpPr>
+        <p:spPr>
+          <a:xfrm>
+            <a:off x="8412480" y="3282696"/>
+            <a:ext cx="2011680" cy="228600"/>
+          </a:xfrm>
+          <a:prstGeom prst="rect">
+            <a:avLst/>
+          </a:prstGeom>
+          <a:noFill/>
+        </p:spPr>
+        <p:txBody>
+          <a:bodyPr wrap="square">
+            <a:spAutoFit/>
+          </a:bodyPr>
+          <a:lstStyle/>
+          <a:p>
+            <a:pPr algn="l">
+              <a:spcAft>
+                <a:spcPts val="400"/>
+              </a:spcAft>
+            </a:pPr>
+            <a:r>
+              <a:rPr sz="1200" b="0">
+                <a:solidFill>
+                  <a:srgbClr val="D8E8E4"/>
+                </a:solidFill>
+                <a:latin typeface="Calibri"/>
+              </a:rPr>
+              <a:t>False Negative</a:t>
+            </a:r>
+          </a:p>
+        </p:txBody>
+      </p:sp>
+      <p:sp>
+        <p:nvSpPr>
+          <p:cNvPr id="40" name="TextBox 39"/>
+          <p:cNvSpPr txBox="1"/>
+          <p:nvPr/>
+        </p:nvSpPr>
+        <p:spPr>
+          <a:xfrm>
+            <a:off x="10424160" y="3282696"/>
+            <a:ext cx="1097280" cy="228600"/>
+          </a:xfrm>
+          <a:prstGeom prst="rect">
+            <a:avLst/>
+          </a:prstGeom>
+          <a:noFill/>
+        </p:spPr>
+        <p:txBody>
+          <a:bodyPr wrap="square">
+            <a:spAutoFit/>
+          </a:bodyPr>
+          <a:lstStyle/>
+          <a:p>
+            <a:pPr algn="r">
+              <a:spcAft>
+                <a:spcPts val="400"/>
+              </a:spcAft>
+            </a:pPr>
+            <a:r>
+              <a:rPr sz="1400" b="1">
+                <a:solidFill>
+                  <a:srgbClr val="FFFFFF"/>
+                </a:solidFill>
+                <a:latin typeface="Calibri"/>
+              </a:rPr>
+              <a:t>22</a:t>
+            </a:r>
+          </a:p>
+        </p:txBody>
+      </p:sp>
+      <p:sp>
+        <p:nvSpPr>
+          <p:cNvPr id="41" name="TextBox 40"/>
+          <p:cNvSpPr txBox="1"/>
+          <p:nvPr/>
+        </p:nvSpPr>
+        <p:spPr>
+          <a:xfrm>
+            <a:off x="8412480" y="3483864"/>
+            <a:ext cx="3108960" cy="228600"/>
+          </a:xfrm>
+          <a:prstGeom prst="rect">
+            <a:avLst/>
+          </a:prstGeom>
+          <a:noFill/>
+        </p:spPr>
+        <p:txBody>
+          <a:bodyPr wrap="square">
+            <a:spAutoFit/>
+          </a:bodyPr>
+          <a:lstStyle/>
+          <a:p>
+            <a:pPr algn="l">
+              <a:spcAft>
+                <a:spcPts val="400"/>
+              </a:spcAft>
+            </a:pPr>
+            <a:r>
+              <a:rPr sz="1100" b="0">
+                <a:solidFill>
+                  <a:srgbClr val="9BC4BA"/>
+                </a:solidFill>
+                <a:latin typeface="Calibri"/>
+              </a:rPr>
+              <a:t>Missed creditworthy</a:t>
+            </a:r>
+          </a:p>
+        </p:txBody>
+      </p:sp>
+      <p:sp>
+        <p:nvSpPr>
+          <p:cNvPr id="42" name="TextBox 41"/>
+          <p:cNvSpPr txBox="1"/>
+          <p:nvPr/>
+        </p:nvSpPr>
+        <p:spPr>
+          <a:xfrm>
+            <a:off x="8412480" y="3758183"/>
+            <a:ext cx="2011680" cy="228600"/>
+          </a:xfrm>
+          <a:prstGeom prst="rect">
+            <a:avLst/>
+          </a:prstGeom>
+          <a:noFill/>
+        </p:spPr>
+        <p:txBody>
+          <a:bodyPr wrap="square">
+            <a:spAutoFit/>
+          </a:bodyPr>
+          <a:lstStyle/>
+          <a:p>
+            <a:pPr algn="l">
+              <a:spcAft>
+                <a:spcPts val="400"/>
+              </a:spcAft>
+            </a:pPr>
+            <a:r>
+              <a:rPr sz="1200" b="0">
+                <a:solidFill>
+                  <a:srgbClr val="D8E8E4"/>
+                </a:solidFill>
+                <a:latin typeface="Calibri"/>
+              </a:rPr>
+              <a:t>True Positive</a:t>
+            </a:r>
+          </a:p>
+        </p:txBody>
+      </p:sp>
+      <p:sp>
+        <p:nvSpPr>
+          <p:cNvPr id="43" name="TextBox 42"/>
+          <p:cNvSpPr txBox="1"/>
+          <p:nvPr/>
+        </p:nvSpPr>
+        <p:spPr>
+          <a:xfrm>
+            <a:off x="10424160" y="3758183"/>
+            <a:ext cx="1097280" cy="228600"/>
+          </a:xfrm>
+          <a:prstGeom prst="rect">
+            <a:avLst/>
+          </a:prstGeom>
+          <a:noFill/>
+        </p:spPr>
+        <p:txBody>
+          <a:bodyPr wrap="square">
+            <a:spAutoFit/>
+          </a:bodyPr>
+          <a:lstStyle/>
+          <a:p>
+            <a:pPr algn="r">
+              <a:spcAft>
+                <a:spcPts val="400"/>
+              </a:spcAft>
+            </a:pPr>
+            <a:r>
+              <a:rPr sz="1400" b="1">
+                <a:solidFill>
+                  <a:srgbClr val="FFFFFF"/>
+                </a:solidFill>
+                <a:latin typeface="Calibri"/>
+              </a:rPr>
+              <a:t>132</a:t>
+            </a:r>
+          </a:p>
+        </p:txBody>
+      </p:sp>
+      <p:sp>
+        <p:nvSpPr>
+          <p:cNvPr id="44" name="TextBox 43"/>
+          <p:cNvSpPr txBox="1"/>
+          <p:nvPr/>
+        </p:nvSpPr>
+        <p:spPr>
+          <a:xfrm>
+            <a:off x="8412480" y="3959351"/>
+            <a:ext cx="3108960" cy="228600"/>
+          </a:xfrm>
+          <a:prstGeom prst="rect">
+            <a:avLst/>
+          </a:prstGeom>
+          <a:noFill/>
+        </p:spPr>
+        <p:txBody>
+          <a:bodyPr wrap="square">
+            <a:spAutoFit/>
+          </a:bodyPr>
+          <a:lstStyle/>
+          <a:p>
+            <a:pPr algn="l">
+              <a:spcAft>
+                <a:spcPts val="400"/>
+              </a:spcAft>
+            </a:pPr>
+            <a:r>
+              <a:rPr sz="1100" b="0">
+                <a:solidFill>
+                  <a:srgbClr val="9BC4BA"/>
+                </a:solidFill>
+                <a:latin typeface="Calibri"/>
+              </a:rPr>
+              <a:t>Correct creditworthy</a:t>
+            </a:r>
+          </a:p>
+        </p:txBody>
+      </p:sp>
+      <p:sp>
+        <p:nvSpPr>
+          <p:cNvPr id="45" name="Rounded Rectangle 44"/>
+          <p:cNvSpPr/>
+          <p:nvPr/>
+        </p:nvSpPr>
+        <p:spPr>
+          <a:xfrm>
+            <a:off x="411480" y="4663440"/>
+            <a:ext cx="11338560" cy="1508760"/>
           </a:xfrm>
           <a:prstGeom prst="roundRect">
             <a:avLst>
@@ -10051,58 +11444,14 @@
       </p:sp>
       <p:sp>
         <p:nvSpPr>
-          <p:cNvPr id="11" name="Rectangle 10"/>
-          <p:cNvSpPr/>
-          <p:nvPr/>
-        </p:nvSpPr>
-        <p:spPr>
-          <a:xfrm>
-            <a:off x="3383280" y="1417320"/>
-            <a:ext cx="109728" cy="1280160"/>
-          </a:xfrm>
-          <a:prstGeom prst="rect">
-            <a:avLst/>
-          </a:prstGeom>
-          <a:solidFill>
-            <a:srgbClr val="1A7A6D"/>
-          </a:solidFill>
-          <a:ln>
-            <a:noFill/>
-          </a:ln>
-        </p:spPr>
-        <p:style>
-          <a:lnRef idx="1">
-            <a:schemeClr val="accent1"/>
-          </a:lnRef>
-          <a:fillRef idx="3">
-            <a:schemeClr val="accent1"/>
-          </a:fillRef>
-          <a:effectRef idx="2">
-            <a:schemeClr val="accent1"/>
-          </a:effectRef>
-          <a:fontRef idx="minor">
-            <a:schemeClr val="lt1"/>
-          </a:fontRef>
-        </p:style>
-        <p:txBody>
-          <a:bodyPr rtlCol="0" anchor="ctr"/>
-          <a:lstStyle/>
-          <a:p>
-            <a:pPr algn="ctr"/>
-            <a:endParaRPr/>
-          </a:p>
-        </p:txBody>
-      </p:sp>
-      <p:sp>
-        <p:nvSpPr>
-          <p:cNvPr id="12" name="TextBox 11"/>
-          <p:cNvSpPr txBox="1"/>
-          <p:nvPr/>
-        </p:nvSpPr>
-        <p:spPr>
-          <a:xfrm>
-            <a:off x="3639312" y="1618488"/>
-            <a:ext cx="2423160" cy="411480"/>
+          <p:cNvPr id="46" name="TextBox 45"/>
+          <p:cNvSpPr txBox="1"/>
+          <p:nvPr/>
+        </p:nvSpPr>
+        <p:spPr>
+          <a:xfrm>
+            <a:off x="640080" y="4754880"/>
+            <a:ext cx="10972800" cy="274320"/>
           </a:xfrm>
           <a:prstGeom prst="rect">
             <a:avLst/>
@@ -10121,461 +11470,274 @@
               </a:spcAft>
             </a:pPr>
             <a:r>
-              <a:rPr sz="2600" b="1">
+              <a:rPr sz="1400" b="1">
                 <a:solidFill>
                   <a:srgbClr val="0B3D2E"/>
                 </a:solidFill>
                 <a:latin typeface="Calibri"/>
               </a:rPr>
-              <a:t>88.6%</a:t>
-            </a:r>
-          </a:p>
-        </p:txBody>
-      </p:sp>
-      <p:sp>
-        <p:nvSpPr>
-          <p:cNvPr id="13" name="TextBox 12"/>
-          <p:cNvSpPr txBox="1"/>
-          <p:nvPr/>
-        </p:nvSpPr>
-        <p:spPr>
-          <a:xfrm>
-            <a:off x="3639312" y="2103120"/>
-            <a:ext cx="2423160" cy="365760"/>
-          </a:xfrm>
-          <a:prstGeom prst="rect">
-            <a:avLst/>
-          </a:prstGeom>
-          <a:noFill/>
-        </p:spPr>
-        <p:txBody>
-          <a:bodyPr wrap="square">
-            <a:spAutoFit/>
-          </a:bodyPr>
-          <a:lstStyle/>
-          <a:p>
-            <a:pPr algn="l">
-              <a:spcAft>
-                <a:spcPts val="400"/>
-              </a:spcAft>
-            </a:pPr>
-            <a:r>
-              <a:rPr sz="1400" b="0">
+              <a:t>What drove the RF decisions (feature importance from the same training run)</a:t>
+            </a:r>
+          </a:p>
+        </p:txBody>
+      </p:sp>
+      <p:sp>
+        <p:nvSpPr>
+          <p:cNvPr id="47" name="TextBox 46"/>
+          <p:cNvSpPr txBox="1"/>
+          <p:nvPr/>
+        </p:nvSpPr>
+        <p:spPr>
+          <a:xfrm>
+            <a:off x="640080" y="5120640"/>
+            <a:ext cx="1783080" cy="274320"/>
+          </a:xfrm>
+          <a:prstGeom prst="rect">
+            <a:avLst/>
+          </a:prstGeom>
+          <a:noFill/>
+        </p:spPr>
+        <p:txBody>
+          <a:bodyPr wrap="square">
+            <a:spAutoFit/>
+          </a:bodyPr>
+          <a:lstStyle/>
+          <a:p>
+            <a:pPr algn="ctr">
+              <a:spcAft>
+                <a:spcPts val="400"/>
+              </a:spcAft>
+            </a:pPr>
+            <a:r>
+              <a:rPr sz="1800" b="1">
+                <a:solidFill>
+                  <a:srgbClr val="1A7A6D"/>
+                </a:solidFill>
+                <a:latin typeface="Calibri"/>
+              </a:rPr>
+              <a:t>19.8%</a:t>
+            </a:r>
+          </a:p>
+        </p:txBody>
+      </p:sp>
+      <p:sp>
+        <p:nvSpPr>
+          <p:cNvPr id="48" name="TextBox 47"/>
+          <p:cNvSpPr txBox="1"/>
+          <p:nvPr/>
+        </p:nvSpPr>
+        <p:spPr>
+          <a:xfrm>
+            <a:off x="640080" y="5486400"/>
+            <a:ext cx="1783080" cy="411480"/>
+          </a:xfrm>
+          <a:prstGeom prst="rect">
+            <a:avLst/>
+          </a:prstGeom>
+          <a:noFill/>
+        </p:spPr>
+        <p:txBody>
+          <a:bodyPr wrap="square">
+            <a:spAutoFit/>
+          </a:bodyPr>
+          <a:lstStyle/>
+          <a:p>
+            <a:pPr algn="ctr">
+              <a:spcAft>
+                <a:spcPts val="400"/>
+              </a:spcAft>
+            </a:pPr>
+            <a:r>
+              <a:rPr sz="1300" b="0">
                 <a:solidFill>
                   <a:srgbClr val="3D525A"/>
                 </a:solidFill>
                 <a:latin typeface="Calibri"/>
               </a:rPr>
-              <a:t>RF Accuracy</a:t>
-            </a:r>
-          </a:p>
-        </p:txBody>
-      </p:sp>
-      <p:sp>
-        <p:nvSpPr>
-          <p:cNvPr id="14" name="Rounded Rectangle 13"/>
-          <p:cNvSpPr/>
-          <p:nvPr/>
-        </p:nvSpPr>
-        <p:spPr>
-          <a:xfrm>
-            <a:off x="6355080" y="1417320"/>
-            <a:ext cx="2788920" cy="1280160"/>
-          </a:xfrm>
-          <a:prstGeom prst="roundRect">
-            <a:avLst>
-              <a:gd name="adj" fmla="val 8000"/>
-            </a:avLst>
-          </a:prstGeom>
-          <a:solidFill>
-            <a:srgbClr val="FFFFFF"/>
-          </a:solidFill>
-          <a:ln>
-            <a:noFill/>
-          </a:ln>
-        </p:spPr>
-        <p:style>
-          <a:lnRef idx="1">
-            <a:schemeClr val="accent1"/>
-          </a:lnRef>
-          <a:fillRef idx="3">
-            <a:schemeClr val="accent1"/>
-          </a:fillRef>
-          <a:effectRef idx="2">
-            <a:schemeClr val="accent1"/>
-          </a:effectRef>
-          <a:fontRef idx="minor">
-            <a:schemeClr val="lt1"/>
-          </a:fontRef>
-        </p:style>
-        <p:txBody>
-          <a:bodyPr rtlCol="0" anchor="ctr"/>
-          <a:lstStyle/>
-          <a:p>
-            <a:pPr algn="ctr"/>
-            <a:endParaRPr/>
-          </a:p>
-        </p:txBody>
-      </p:sp>
-      <p:sp>
-        <p:nvSpPr>
-          <p:cNvPr id="15" name="Rectangle 14"/>
-          <p:cNvSpPr/>
-          <p:nvPr/>
-        </p:nvSpPr>
-        <p:spPr>
-          <a:xfrm>
-            <a:off x="6355080" y="1417320"/>
-            <a:ext cx="109728" cy="1280160"/>
-          </a:xfrm>
-          <a:prstGeom prst="rect">
-            <a:avLst/>
-          </a:prstGeom>
-          <a:solidFill>
-            <a:srgbClr val="8A5A00"/>
-          </a:solidFill>
-          <a:ln>
-            <a:noFill/>
-          </a:ln>
-        </p:spPr>
-        <p:style>
-          <a:lnRef idx="1">
-            <a:schemeClr val="accent1"/>
-          </a:lnRef>
-          <a:fillRef idx="3">
-            <a:schemeClr val="accent1"/>
-          </a:fillRef>
-          <a:effectRef idx="2">
-            <a:schemeClr val="accent1"/>
-          </a:effectRef>
-          <a:fontRef idx="minor">
-            <a:schemeClr val="lt1"/>
-          </a:fontRef>
-        </p:style>
-        <p:txBody>
-          <a:bodyPr rtlCol="0" anchor="ctr"/>
-          <a:lstStyle/>
-          <a:p>
-            <a:pPr algn="ctr"/>
-            <a:endParaRPr/>
-          </a:p>
-        </p:txBody>
-      </p:sp>
-      <p:sp>
-        <p:nvSpPr>
-          <p:cNvPr id="16" name="TextBox 15"/>
-          <p:cNvSpPr txBox="1"/>
-          <p:nvPr/>
-        </p:nvSpPr>
-        <p:spPr>
-          <a:xfrm>
-            <a:off x="6611112" y="1618488"/>
-            <a:ext cx="2423160" cy="411480"/>
-          </a:xfrm>
-          <a:prstGeom prst="rect">
-            <a:avLst/>
-          </a:prstGeom>
-          <a:noFill/>
-        </p:spPr>
-        <p:txBody>
-          <a:bodyPr wrap="square">
-            <a:spAutoFit/>
-          </a:bodyPr>
-          <a:lstStyle/>
-          <a:p>
-            <a:pPr algn="l">
-              <a:spcAft>
-                <a:spcPts val="400"/>
-              </a:spcAft>
-            </a:pPr>
-            <a:r>
-              <a:rPr sz="2600" b="1">
-                <a:solidFill>
-                  <a:srgbClr val="0B3D2E"/>
-                </a:solidFill>
-                <a:latin typeface="Calibri"/>
-              </a:rPr>
-              <a:t>87.5%</a:t>
-            </a:r>
-          </a:p>
-        </p:txBody>
-      </p:sp>
-      <p:sp>
-        <p:nvSpPr>
-          <p:cNvPr id="17" name="TextBox 16"/>
-          <p:cNvSpPr txBox="1"/>
-          <p:nvPr/>
-        </p:nvSpPr>
-        <p:spPr>
-          <a:xfrm>
-            <a:off x="6611112" y="2103120"/>
-            <a:ext cx="2423160" cy="365760"/>
-          </a:xfrm>
-          <a:prstGeom prst="rect">
-            <a:avLst/>
-          </a:prstGeom>
-          <a:noFill/>
-        </p:spPr>
-        <p:txBody>
-          <a:bodyPr wrap="square">
-            <a:spAutoFit/>
-          </a:bodyPr>
-          <a:lstStyle/>
-          <a:p>
-            <a:pPr algn="l">
-              <a:spcAft>
-                <a:spcPts val="400"/>
-              </a:spcAft>
-            </a:pPr>
-            <a:r>
-              <a:rPr sz="1400" b="0">
+              <a:t>On-time rate</a:t>
+            </a:r>
+          </a:p>
+        </p:txBody>
+      </p:sp>
+      <p:sp>
+        <p:nvSpPr>
+          <p:cNvPr id="49" name="TextBox 48"/>
+          <p:cNvSpPr txBox="1"/>
+          <p:nvPr/>
+        </p:nvSpPr>
+        <p:spPr>
+          <a:xfrm>
+            <a:off x="2514600" y="5120640"/>
+            <a:ext cx="1783080" cy="274320"/>
+          </a:xfrm>
+          <a:prstGeom prst="rect">
+            <a:avLst/>
+          </a:prstGeom>
+          <a:noFill/>
+        </p:spPr>
+        <p:txBody>
+          <a:bodyPr wrap="square">
+            <a:spAutoFit/>
+          </a:bodyPr>
+          <a:lstStyle/>
+          <a:p>
+            <a:pPr algn="ctr">
+              <a:spcAft>
+                <a:spcPts val="400"/>
+              </a:spcAft>
+            </a:pPr>
+            <a:r>
+              <a:rPr sz="1800" b="1">
+                <a:solidFill>
+                  <a:srgbClr val="1A7A6D"/>
+                </a:solidFill>
+                <a:latin typeface="Calibri"/>
+              </a:rPr>
+              <a:t>18.7%</a:t>
+            </a:r>
+          </a:p>
+        </p:txBody>
+      </p:sp>
+      <p:sp>
+        <p:nvSpPr>
+          <p:cNvPr id="50" name="TextBox 49"/>
+          <p:cNvSpPr txBox="1"/>
+          <p:nvPr/>
+        </p:nvSpPr>
+        <p:spPr>
+          <a:xfrm>
+            <a:off x="2514600" y="5486400"/>
+            <a:ext cx="1783080" cy="411480"/>
+          </a:xfrm>
+          <a:prstGeom prst="rect">
+            <a:avLst/>
+          </a:prstGeom>
+          <a:noFill/>
+        </p:spPr>
+        <p:txBody>
+          <a:bodyPr wrap="square">
+            <a:spAutoFit/>
+          </a:bodyPr>
+          <a:lstStyle/>
+          <a:p>
+            <a:pPr algn="ctr">
+              <a:spcAft>
+                <a:spcPts val="400"/>
+              </a:spcAft>
+            </a:pPr>
+            <a:r>
+              <a:rPr sz="1300" b="0">
                 <a:solidFill>
                   <a:srgbClr val="3D525A"/>
                 </a:solidFill>
                 <a:latin typeface="Calibri"/>
               </a:rPr>
-              <a:t>LR ROC-AUC</a:t>
-            </a:r>
-          </a:p>
-        </p:txBody>
-      </p:sp>
-      <p:sp>
-        <p:nvSpPr>
-          <p:cNvPr id="18" name="Rounded Rectangle 17"/>
-          <p:cNvSpPr/>
-          <p:nvPr/>
-        </p:nvSpPr>
-        <p:spPr>
-          <a:xfrm>
-            <a:off x="9326880" y="1417320"/>
-            <a:ext cx="2468880" cy="1280160"/>
-          </a:xfrm>
-          <a:prstGeom prst="roundRect">
-            <a:avLst>
-              <a:gd name="adj" fmla="val 8000"/>
-            </a:avLst>
-          </a:prstGeom>
-          <a:solidFill>
-            <a:srgbClr val="FFFFFF"/>
-          </a:solidFill>
-          <a:ln>
-            <a:noFill/>
-          </a:ln>
-        </p:spPr>
-        <p:style>
-          <a:lnRef idx="1">
-            <a:schemeClr val="accent1"/>
-          </a:lnRef>
-          <a:fillRef idx="3">
-            <a:schemeClr val="accent1"/>
-          </a:fillRef>
-          <a:effectRef idx="2">
-            <a:schemeClr val="accent1"/>
-          </a:effectRef>
-          <a:fontRef idx="minor">
-            <a:schemeClr val="lt1"/>
-          </a:fontRef>
-        </p:style>
-        <p:txBody>
-          <a:bodyPr rtlCol="0" anchor="ctr"/>
-          <a:lstStyle/>
-          <a:p>
-            <a:pPr algn="ctr"/>
-            <a:endParaRPr/>
-          </a:p>
-        </p:txBody>
-      </p:sp>
-      <p:sp>
-        <p:nvSpPr>
-          <p:cNvPr id="19" name="Rectangle 18"/>
-          <p:cNvSpPr/>
-          <p:nvPr/>
-        </p:nvSpPr>
-        <p:spPr>
-          <a:xfrm>
-            <a:off x="9326880" y="1417320"/>
-            <a:ext cx="109728" cy="1280160"/>
-          </a:xfrm>
-          <a:prstGeom prst="rect">
-            <a:avLst/>
-          </a:prstGeom>
-          <a:solidFill>
-            <a:srgbClr val="0B3D2E"/>
-          </a:solidFill>
-          <a:ln>
-            <a:noFill/>
-          </a:ln>
-        </p:spPr>
-        <p:style>
-          <a:lnRef idx="1">
-            <a:schemeClr val="accent1"/>
-          </a:lnRef>
-          <a:fillRef idx="3">
-            <a:schemeClr val="accent1"/>
-          </a:fillRef>
-          <a:effectRef idx="2">
-            <a:schemeClr val="accent1"/>
-          </a:effectRef>
-          <a:fontRef idx="minor">
-            <a:schemeClr val="lt1"/>
-          </a:fontRef>
-        </p:style>
-        <p:txBody>
-          <a:bodyPr rtlCol="0" anchor="ctr"/>
-          <a:lstStyle/>
-          <a:p>
-            <a:pPr algn="ctr"/>
-            <a:endParaRPr/>
-          </a:p>
-        </p:txBody>
-      </p:sp>
-      <p:sp>
-        <p:nvSpPr>
-          <p:cNvPr id="20" name="TextBox 19"/>
-          <p:cNvSpPr txBox="1"/>
-          <p:nvPr/>
-        </p:nvSpPr>
-        <p:spPr>
-          <a:xfrm>
-            <a:off x="9582912" y="1618488"/>
-            <a:ext cx="2103120" cy="411480"/>
-          </a:xfrm>
-          <a:prstGeom prst="rect">
-            <a:avLst/>
-          </a:prstGeom>
-          <a:noFill/>
-        </p:spPr>
-        <p:txBody>
-          <a:bodyPr wrap="square">
-            <a:spAutoFit/>
-          </a:bodyPr>
-          <a:lstStyle/>
-          <a:p>
-            <a:pPr algn="l">
-              <a:spcAft>
-                <a:spcPts val="400"/>
-              </a:spcAft>
-            </a:pPr>
-            <a:r>
-              <a:rPr sz="2600" b="1">
-                <a:solidFill>
-                  <a:srgbClr val="0B3D2E"/>
-                </a:solidFill>
-                <a:latin typeface="Calibri"/>
-              </a:rPr>
-              <a:t>RF wins</a:t>
-            </a:r>
-          </a:p>
-        </p:txBody>
-      </p:sp>
-      <p:sp>
-        <p:nvSpPr>
-          <p:cNvPr id="21" name="TextBox 20"/>
-          <p:cNvSpPr txBox="1"/>
-          <p:nvPr/>
-        </p:nvSpPr>
-        <p:spPr>
-          <a:xfrm>
-            <a:off x="9582912" y="2103120"/>
-            <a:ext cx="2103120" cy="365760"/>
-          </a:xfrm>
-          <a:prstGeom prst="rect">
-            <a:avLst/>
-          </a:prstGeom>
-          <a:noFill/>
-        </p:spPr>
-        <p:txBody>
-          <a:bodyPr wrap="square">
-            <a:spAutoFit/>
-          </a:bodyPr>
-          <a:lstStyle/>
-          <a:p>
-            <a:pPr algn="l">
-              <a:spcAft>
-                <a:spcPts val="400"/>
-              </a:spcAft>
-            </a:pPr>
-            <a:r>
-              <a:rPr sz="1400" b="0">
+              <a:t>Default rate</a:t>
+            </a:r>
+          </a:p>
+        </p:txBody>
+      </p:sp>
+      <p:sp>
+        <p:nvSpPr>
+          <p:cNvPr id="51" name="TextBox 50"/>
+          <p:cNvSpPr txBox="1"/>
+          <p:nvPr/>
+        </p:nvSpPr>
+        <p:spPr>
+          <a:xfrm>
+            <a:off x="4389120" y="5120640"/>
+            <a:ext cx="1783080" cy="274320"/>
+          </a:xfrm>
+          <a:prstGeom prst="rect">
+            <a:avLst/>
+          </a:prstGeom>
+          <a:noFill/>
+        </p:spPr>
+        <p:txBody>
+          <a:bodyPr wrap="square">
+            <a:spAutoFit/>
+          </a:bodyPr>
+          <a:lstStyle/>
+          <a:p>
+            <a:pPr algn="ctr">
+              <a:spcAft>
+                <a:spcPts val="400"/>
+              </a:spcAft>
+            </a:pPr>
+            <a:r>
+              <a:rPr sz="1800" b="1">
+                <a:solidFill>
+                  <a:srgbClr val="1A7A6D"/>
+                </a:solidFill>
+                <a:latin typeface="Calibri"/>
+              </a:rPr>
+              <a:t>8.3%</a:t>
+            </a:r>
+          </a:p>
+        </p:txBody>
+      </p:sp>
+      <p:sp>
+        <p:nvSpPr>
+          <p:cNvPr id="52" name="TextBox 51"/>
+          <p:cNvSpPr txBox="1"/>
+          <p:nvPr/>
+        </p:nvSpPr>
+        <p:spPr>
+          <a:xfrm>
+            <a:off x="4389120" y="5486400"/>
+            <a:ext cx="1783080" cy="411480"/>
+          </a:xfrm>
+          <a:prstGeom prst="rect">
+            <a:avLst/>
+          </a:prstGeom>
+          <a:noFill/>
+        </p:spPr>
+        <p:txBody>
+          <a:bodyPr wrap="square">
+            <a:spAutoFit/>
+          </a:bodyPr>
+          <a:lstStyle/>
+          <a:p>
+            <a:pPr algn="ctr">
+              <a:spcAft>
+                <a:spcPts val="400"/>
+              </a:spcAft>
+            </a:pPr>
+            <a:r>
+              <a:rPr sz="1300" b="0">
                 <a:solidFill>
                   <a:srgbClr val="3D525A"/>
                 </a:solidFill>
                 <a:latin typeface="Calibri"/>
               </a:rPr>
-              <a:t>Primary model</a:t>
-            </a:r>
-          </a:p>
-        </p:txBody>
-      </p:sp>
-      <p:sp>
-        <p:nvSpPr>
-          <p:cNvPr id="22" name="Rounded Rectangle 21"/>
-          <p:cNvSpPr/>
-          <p:nvPr/>
-        </p:nvSpPr>
-        <p:spPr>
-          <a:xfrm>
-            <a:off x="411480" y="2926080"/>
-            <a:ext cx="11338560" cy="3063240"/>
-          </a:xfrm>
-          <a:prstGeom prst="roundRect">
-            <a:avLst>
-              <a:gd name="adj" fmla="val 8000"/>
-            </a:avLst>
-          </a:prstGeom>
-          <a:solidFill>
-            <a:srgbClr val="FFFFFF"/>
-          </a:solidFill>
-          <a:ln>
-            <a:noFill/>
-          </a:ln>
-        </p:spPr>
-        <p:style>
-          <a:lnRef idx="1">
-            <a:schemeClr val="accent1"/>
-          </a:lnRef>
-          <a:fillRef idx="3">
-            <a:schemeClr val="accent1"/>
-          </a:fillRef>
-          <a:effectRef idx="2">
-            <a:schemeClr val="accent1"/>
-          </a:effectRef>
-          <a:fontRef idx="minor">
-            <a:schemeClr val="lt1"/>
-          </a:fontRef>
-        </p:style>
-        <p:txBody>
-          <a:bodyPr rtlCol="0" anchor="ctr"/>
-          <a:lstStyle/>
-          <a:p>
-            <a:pPr algn="ctr"/>
-            <a:endParaRPr/>
-          </a:p>
-        </p:txBody>
-      </p:sp>
-      <p:sp>
-        <p:nvSpPr>
-          <p:cNvPr id="23" name="TextBox 22"/>
-          <p:cNvSpPr txBox="1"/>
-          <p:nvPr/>
-        </p:nvSpPr>
-        <p:spPr>
-          <a:xfrm>
-            <a:off x="731520" y="3108960"/>
-            <a:ext cx="10789920" cy="365760"/>
-          </a:xfrm>
-          <a:prstGeom prst="rect">
-            <a:avLst/>
-          </a:prstGeom>
-          <a:noFill/>
-        </p:spPr>
-        <p:txBody>
-          <a:bodyPr wrap="square">
-            <a:spAutoFit/>
-          </a:bodyPr>
-          <a:lstStyle/>
-          <a:p>
-            <a:pPr algn="l">
+              <a:t>Order-type mix</a:t>
+            </a:r>
+          </a:p>
+        </p:txBody>
+      </p:sp>
+      <p:sp>
+        <p:nvSpPr>
+          <p:cNvPr id="53" name="TextBox 52"/>
+          <p:cNvSpPr txBox="1"/>
+          <p:nvPr/>
+        </p:nvSpPr>
+        <p:spPr>
+          <a:xfrm>
+            <a:off x="6263640" y="5120640"/>
+            <a:ext cx="1783080" cy="274320"/>
+          </a:xfrm>
+          <a:prstGeom prst="rect">
+            <a:avLst/>
+          </a:prstGeom>
+          <a:noFill/>
+        </p:spPr>
+        <p:txBody>
+          <a:bodyPr wrap="square">
+            <a:spAutoFit/>
+          </a:bodyPr>
+          <a:lstStyle/>
+          <a:p>
+            <a:pPr algn="ctr">
               <a:spcAft>
                 <a:spcPts val="400"/>
               </a:spcAft>
@@ -10583,117 +11745,213 @@
             <a:r>
               <a:rPr sz="1800" b="1">
                 <a:solidFill>
-                  <a:srgbClr val="0B3D2E"/>
-                </a:solidFill>
-                <a:latin typeface="Calibri"/>
-              </a:rPr>
-              <a:t>What the numbers mean</a:t>
-            </a:r>
-          </a:p>
-        </p:txBody>
-      </p:sp>
-      <p:sp>
-        <p:nvSpPr>
-          <p:cNvPr id="24" name="TextBox 23"/>
-          <p:cNvSpPr txBox="1"/>
-          <p:nvPr/>
-        </p:nvSpPr>
-        <p:spPr>
-          <a:xfrm>
-            <a:off x="731520" y="3611880"/>
-            <a:ext cx="10789920" cy="2103120"/>
-          </a:xfrm>
-          <a:prstGeom prst="rect">
-            <a:avLst/>
-          </a:prstGeom>
-          <a:noFill/>
-        </p:spPr>
-        <p:txBody>
-          <a:bodyPr wrap="square">
-            <a:spAutoFit/>
-          </a:bodyPr>
-          <a:lstStyle/>
-          <a:p>
-            <a:pPr algn="l">
-              <a:spcBef>
-                <a:spcPts val="600"/>
-              </a:spcBef>
-              <a:spcAft>
-                <a:spcPts val="600"/>
-              </a:spcAft>
-            </a:pPr>
-            <a:r>
-              <a:rPr sz="1700" b="0">
-                <a:solidFill>
-                  <a:srgbClr val="0F2830"/>
-                </a:solidFill>
-                <a:latin typeface="Calibri"/>
-              </a:rPr>
-              <a:t>•  RF: Precision 93.0% · Recall 85.7% · F1 89.2%.</a:t>
-            </a:r>
-          </a:p>
-          <a:p>
-            <a:pPr algn="l">
-              <a:spcBef>
-                <a:spcPts val="600"/>
-              </a:spcBef>
-              <a:spcAft>
-                <a:spcPts val="600"/>
-              </a:spcAft>
-            </a:pPr>
-            <a:r>
-              <a:rPr sz="1700" b="0">
-                <a:solidFill>
-                  <a:srgbClr val="0F2830"/>
-                </a:solidFill>
-                <a:latin typeface="Calibri"/>
-              </a:rPr>
-              <a:t>•  LR: Precision 75.8% · Recall 87.7% · F1 81.3%.</a:t>
-            </a:r>
-          </a:p>
-          <a:p>
-            <a:pPr algn="l">
-              <a:spcBef>
-                <a:spcPts val="600"/>
-              </a:spcBef>
-              <a:spcAft>
-                <a:spcPts val="600"/>
-              </a:spcAft>
-            </a:pPr>
-            <a:r>
-              <a:rPr sz="1700" b="0">
-                <a:solidFill>
-                  <a:srgbClr val="0F2830"/>
-                </a:solidFill>
-                <a:latin typeface="Calibri"/>
-              </a:rPr>
-              <a:t>•  Strong predictors: payment reliability, delay, trading volume, partner mix and sales trend.</a:t>
-            </a:r>
-          </a:p>
-          <a:p>
-            <a:pPr algn="l">
-              <a:spcBef>
-                <a:spcPts val="600"/>
-              </a:spcBef>
-              <a:spcAft>
-                <a:spcPts val="600"/>
-              </a:spcAft>
-            </a:pPr>
-            <a:r>
-              <a:rPr sz="1700" b="0">
-                <a:solidFill>
-                  <a:srgbClr val="0F2830"/>
-                </a:solidFill>
-                <a:latin typeface="Calibri"/>
-              </a:rPr>
-              <a:t>•  That is why Random Forest is the scoring model in the live prototype.</a:t>
-            </a:r>
-          </a:p>
-        </p:txBody>
-      </p:sp>
-      <p:sp>
-        <p:nvSpPr>
-          <p:cNvPr id="25" name="Rectangle 24"/>
+                  <a:srgbClr val="1A7A6D"/>
+                </a:solidFill>
+                <a:latin typeface="Calibri"/>
+              </a:rPr>
+              <a:t>5.5%</a:t>
+            </a:r>
+          </a:p>
+        </p:txBody>
+      </p:sp>
+      <p:sp>
+        <p:nvSpPr>
+          <p:cNvPr id="54" name="TextBox 53"/>
+          <p:cNvSpPr txBox="1"/>
+          <p:nvPr/>
+        </p:nvSpPr>
+        <p:spPr>
+          <a:xfrm>
+            <a:off x="6263640" y="5486400"/>
+            <a:ext cx="1783080" cy="411480"/>
+          </a:xfrm>
+          <a:prstGeom prst="rect">
+            <a:avLst/>
+          </a:prstGeom>
+          <a:noFill/>
+        </p:spPr>
+        <p:txBody>
+          <a:bodyPr wrap="square">
+            <a:spAutoFit/>
+          </a:bodyPr>
+          <a:lstStyle/>
+          <a:p>
+            <a:pPr algn="ctr">
+              <a:spcAft>
+                <a:spcPts val="400"/>
+              </a:spcAft>
+            </a:pPr>
+            <a:r>
+              <a:rPr sz="1300" b="0">
+                <a:solidFill>
+                  <a:srgbClr val="3D525A"/>
+                </a:solidFill>
+                <a:latin typeface="Calibri"/>
+              </a:rPr>
+              <a:t>Account age</a:t>
+            </a:r>
+          </a:p>
+        </p:txBody>
+      </p:sp>
+      <p:sp>
+        <p:nvSpPr>
+          <p:cNvPr id="55" name="TextBox 54"/>
+          <p:cNvSpPr txBox="1"/>
+          <p:nvPr/>
+        </p:nvSpPr>
+        <p:spPr>
+          <a:xfrm>
+            <a:off x="8138159" y="5120640"/>
+            <a:ext cx="1783080" cy="274320"/>
+          </a:xfrm>
+          <a:prstGeom prst="rect">
+            <a:avLst/>
+          </a:prstGeom>
+          <a:noFill/>
+        </p:spPr>
+        <p:txBody>
+          <a:bodyPr wrap="square">
+            <a:spAutoFit/>
+          </a:bodyPr>
+          <a:lstStyle/>
+          <a:p>
+            <a:pPr algn="ctr">
+              <a:spcAft>
+                <a:spcPts val="400"/>
+              </a:spcAft>
+            </a:pPr>
+            <a:r>
+              <a:rPr sz="1800" b="1">
+                <a:solidFill>
+                  <a:srgbClr val="1A7A6D"/>
+                </a:solidFill>
+                <a:latin typeface="Calibri"/>
+              </a:rPr>
+              <a:t>4.6%</a:t>
+            </a:r>
+          </a:p>
+        </p:txBody>
+      </p:sp>
+      <p:sp>
+        <p:nvSpPr>
+          <p:cNvPr id="56" name="TextBox 55"/>
+          <p:cNvSpPr txBox="1"/>
+          <p:nvPr/>
+        </p:nvSpPr>
+        <p:spPr>
+          <a:xfrm>
+            <a:off x="8138159" y="5486400"/>
+            <a:ext cx="1783080" cy="411480"/>
+          </a:xfrm>
+          <a:prstGeom prst="rect">
+            <a:avLst/>
+          </a:prstGeom>
+          <a:noFill/>
+        </p:spPr>
+        <p:txBody>
+          <a:bodyPr wrap="square">
+            <a:spAutoFit/>
+          </a:bodyPr>
+          <a:lstStyle/>
+          <a:p>
+            <a:pPr algn="ctr">
+              <a:spcAft>
+                <a:spcPts val="400"/>
+              </a:spcAft>
+            </a:pPr>
+            <a:r>
+              <a:rPr sz="1300" b="0">
+                <a:solidFill>
+                  <a:srgbClr val="3D525A"/>
+                </a:solidFill>
+                <a:latin typeface="Calibri"/>
+              </a:rPr>
+              <a:t>Buyer share</a:t>
+            </a:r>
+          </a:p>
+        </p:txBody>
+      </p:sp>
+      <p:sp>
+        <p:nvSpPr>
+          <p:cNvPr id="57" name="TextBox 56"/>
+          <p:cNvSpPr txBox="1"/>
+          <p:nvPr/>
+        </p:nvSpPr>
+        <p:spPr>
+          <a:xfrm>
+            <a:off x="10012680" y="5120640"/>
+            <a:ext cx="1783080" cy="274320"/>
+          </a:xfrm>
+          <a:prstGeom prst="rect">
+            <a:avLst/>
+          </a:prstGeom>
+          <a:noFill/>
+        </p:spPr>
+        <p:txBody>
+          <a:bodyPr wrap="square">
+            <a:spAutoFit/>
+          </a:bodyPr>
+          <a:lstStyle/>
+          <a:p>
+            <a:pPr algn="ctr">
+              <a:spcAft>
+                <a:spcPts val="400"/>
+              </a:spcAft>
+            </a:pPr>
+            <a:r>
+              <a:rPr sz="1800" b="1">
+                <a:solidFill>
+                  <a:srgbClr val="1A7A6D"/>
+                </a:solidFill>
+                <a:latin typeface="Calibri"/>
+              </a:rPr>
+              <a:t>4.4%</a:t>
+            </a:r>
+          </a:p>
+        </p:txBody>
+      </p:sp>
+      <p:sp>
+        <p:nvSpPr>
+          <p:cNvPr id="58" name="TextBox 57"/>
+          <p:cNvSpPr txBox="1"/>
+          <p:nvPr/>
+        </p:nvSpPr>
+        <p:spPr>
+          <a:xfrm>
+            <a:off x="10012680" y="5486400"/>
+            <a:ext cx="1783080" cy="411480"/>
+          </a:xfrm>
+          <a:prstGeom prst="rect">
+            <a:avLst/>
+          </a:prstGeom>
+          <a:noFill/>
+        </p:spPr>
+        <p:txBody>
+          <a:bodyPr wrap="square">
+            <a:spAutoFit/>
+          </a:bodyPr>
+          <a:lstStyle/>
+          <a:p>
+            <a:pPr algn="ctr">
+              <a:spcAft>
+                <a:spcPts val="400"/>
+              </a:spcAft>
+            </a:pPr>
+            <a:r>
+              <a:rPr sz="1300" b="0">
+                <a:solidFill>
+                  <a:srgbClr val="3D525A"/>
+                </a:solidFill>
+                <a:latin typeface="Calibri"/>
+              </a:rPr>
+              <a:t>Tx frequency</a:t>
+            </a:r>
+          </a:p>
+        </p:txBody>
+      </p:sp>
+      <p:sp>
+        <p:nvSpPr>
+          <p:cNvPr id="59" name="Rectangle 58"/>
           <p:cNvSpPr/>
           <p:nvPr/>
         </p:nvSpPr>
@@ -10737,7 +11995,7 @@
       </p:sp>
       <p:sp>
         <p:nvSpPr>
-          <p:cNvPr id="26" name="TextBox 25"/>
+          <p:cNvPr id="60" name="TextBox 59"/>
           <p:cNvSpPr txBox="1"/>
           <p:nvPr/>
         </p:nvSpPr>
@@ -10776,7 +12034,7 @@
       </p:sp>
       <p:sp>
         <p:nvSpPr>
-          <p:cNvPr id="27" name="TextBox 26"/>
+          <p:cNvPr id="61" name="TextBox 60"/>
           <p:cNvSpPr txBox="1"/>
           <p:nvPr/>
         </p:nvSpPr>
@@ -10899,7 +12157,7 @@
                                           </p:stCondLst>
                                         </p:cTn>
                                         <p:tgtEl>
-                                          <p:spTgt spid="22"/>
+                                          <p:spTgt spid="7"/>
                                         </p:tgtEl>
                                         <p:attrNameLst>
                                           <p:attrName>style.visibility</p:attrName>
@@ -10913,7 +12171,7 @@
                                       <p:cBhvr>
                                         <p:cTn id="11" dur="350"/>
                                         <p:tgtEl>
-                                          <p:spTgt spid="22"/>
+                                          <p:spTgt spid="7"/>
                                         </p:tgtEl>
                                       </p:cBhvr>
                                     </p:animEffect>
@@ -10934,7 +12192,7 @@
                                           </p:stCondLst>
                                         </p:cTn>
                                         <p:tgtEl>
-                                          <p:spTgt spid="24"/>
+                                          <p:spTgt spid="30"/>
                                         </p:tgtEl>
                                         <p:attrNameLst>
                                           <p:attrName>style.visibility</p:attrName>
@@ -10948,7 +12206,42 @@
                                       <p:cBhvr>
                                         <p:cTn id="14" dur="350"/>
                                         <p:tgtEl>
-                                          <p:spTgt spid="24"/>
+                                          <p:spTgt spid="30"/>
+                                        </p:tgtEl>
+                                      </p:cBhvr>
+                                    </p:animEffect>
+                                  </p:childTnLst>
+                                </p:cTn>
+                              </p:par>
+                              <p:par>
+                                <p:cTn id="15" presetID="10" presetClass="entr" presetSubtype="0" fill="hold" grpId="0" nodeType="withEffect">
+                                  <p:stCondLst>
+                                    <p:cond delay="80"/>
+                                  </p:stCondLst>
+                                  <p:childTnLst>
+                                    <p:set>
+                                      <p:cBhvr>
+                                        <p:cTn id="16" dur="1" fill="hold">
+                                          <p:stCondLst>
+                                            <p:cond delay="0"/>
+                                          </p:stCondLst>
+                                        </p:cTn>
+                                        <p:tgtEl>
+                                          <p:spTgt spid="45"/>
+                                        </p:tgtEl>
+                                        <p:attrNameLst>
+                                          <p:attrName>style.visibility</p:attrName>
+                                        </p:attrNameLst>
+                                      </p:cBhvr>
+                                      <p:to>
+                                        <p:strVal val="visible"/>
+                                      </p:to>
+                                    </p:set>
+                                    <p:animEffect transition="in" filter="fade">
+                                      <p:cBhvr>
+                                        <p:cTn id="17" dur="350"/>
+                                        <p:tgtEl>
+                                          <p:spTgt spid="45"/>
                                         </p:tgtEl>
                                       </p:cBhvr>
                                     </p:animEffect>
@@ -10984,8 +12277,9 @@
     </p:tnLst>
     <p:bldLst>
       <p:bldP spid="2" grpId="0" animBg="1"/>
-      <p:bldP spid="22" grpId="0" animBg="1"/>
-      <p:bldP spid="24" grpId="0"/>
+      <p:bldP spid="7" grpId="0" animBg="1"/>
+      <p:bldP spid="30" grpId="0" animBg="1"/>
+      <p:bldP spid="45" grpId="0" animBg="1"/>
     </p:bldLst>
   </p:timing>
 </p:sld>

</xml_diff>

<commit_message>
Enlarge defence PPT fonts for projector and fix animate overwrite.
Co-authored-by: Cursor <cursoragent@cursor.com>
</commit_message>
<xml_diff>
--- a/Presentation/Ushirika_Group15_Defence_Presentation.pptx
+++ b/Presentation/Ushirika_Group15_Defence_Presentation.pptx
@@ -3238,8 +3238,8 @@
         </p:nvSpPr>
         <p:spPr>
           <a:xfrm>
-            <a:off x="777240" y="320040"/>
-            <a:ext cx="10789920" cy="320040"/>
+            <a:off x="777240" y="256032"/>
+            <a:ext cx="10789920" cy="347472"/>
           </a:xfrm>
           <a:prstGeom prst="rect">
             <a:avLst/>
@@ -3258,7 +3258,7 @@
               </a:spcAft>
             </a:pPr>
             <a:r>
-              <a:rPr sz="1500" b="1">
+              <a:rPr sz="1800" b="1">
                 <a:solidFill>
                   <a:srgbClr val="239688"/>
                 </a:solidFill>
@@ -3277,8 +3277,8 @@
         </p:nvSpPr>
         <p:spPr>
           <a:xfrm>
-            <a:off x="777240" y="640080"/>
-            <a:ext cx="10789920" cy="274320"/>
+            <a:off x="777240" y="621792"/>
+            <a:ext cx="10789920" cy="292608"/>
           </a:xfrm>
           <a:prstGeom prst="rect">
             <a:avLst/>
@@ -3297,7 +3297,7 @@
               </a:spcAft>
             </a:pPr>
             <a:r>
-              <a:rPr sz="1400" b="0">
+              <a:rPr sz="1600" b="0">
                 <a:solidFill>
                   <a:srgbClr val="E6EEF0"/>
                 </a:solidFill>
@@ -3316,7 +3316,7 @@
         </p:nvSpPr>
         <p:spPr>
           <a:xfrm>
-            <a:off x="777240" y="1097280"/>
+            <a:off x="777240" y="1051560"/>
             <a:ext cx="10789920" cy="1234440"/>
           </a:xfrm>
           <a:prstGeom prst="rect">
@@ -3336,7 +3336,7 @@
               </a:spcAft>
             </a:pPr>
             <a:r>
-              <a:rPr sz="3000" b="1">
+              <a:rPr sz="3200" b="1">
                 <a:solidFill>
                   <a:srgbClr val="FFFFFF"/>
                 </a:solidFill>
@@ -3352,7 +3352,7 @@
               </a:spcAft>
             </a:pPr>
             <a:r>
-              <a:rPr sz="3000" b="1">
+              <a:rPr sz="3200" b="1">
                 <a:solidFill>
                   <a:srgbClr val="FFFFFF"/>
                 </a:solidFill>
@@ -3368,7 +3368,7 @@
               </a:spcAft>
             </a:pPr>
             <a:r>
-              <a:rPr sz="3000" b="1">
+              <a:rPr sz="3200" b="1">
                 <a:solidFill>
                   <a:srgbClr val="FFFFFF"/>
                 </a:solidFill>
@@ -3387,8 +3387,8 @@
         </p:nvSpPr>
         <p:spPr>
           <a:xfrm>
-            <a:off x="777240" y="2423160"/>
-            <a:ext cx="10789920" cy="320040"/>
+            <a:off x="777240" y="2377440"/>
+            <a:ext cx="10789920" cy="347472"/>
           </a:xfrm>
           <a:prstGeom prst="rect">
             <a:avLst/>
@@ -3407,7 +3407,7 @@
               </a:spcAft>
             </a:pPr>
             <a:r>
-              <a:rPr sz="1600" b="0">
+              <a:rPr sz="1800" b="0">
                 <a:solidFill>
                   <a:srgbClr val="D8E8E4"/>
                 </a:solidFill>
@@ -3426,8 +3426,8 @@
         </p:nvSpPr>
         <p:spPr>
           <a:xfrm>
-            <a:off x="777240" y="2926080"/>
-            <a:ext cx="6766560" cy="2606040"/>
+            <a:off x="777240" y="2880360"/>
+            <a:ext cx="6766560" cy="2651760"/>
           </a:xfrm>
           <a:prstGeom prst="roundRect">
             <a:avLst>
@@ -3472,7 +3472,7 @@
         </p:nvSpPr>
         <p:spPr>
           <a:xfrm>
-            <a:off x="1005840" y="3063240"/>
+            <a:off x="1005840" y="3017520"/>
             <a:ext cx="6309360" cy="320040"/>
           </a:xfrm>
           <a:prstGeom prst="rect">
@@ -3492,7 +3492,7 @@
               </a:spcAft>
             </a:pPr>
             <a:r>
-              <a:rPr sz="1400" b="1">
+              <a:rPr sz="1600" b="1">
                 <a:solidFill>
                   <a:srgbClr val="239688"/>
                 </a:solidFill>
@@ -3512,7 +3512,7 @@
         <p:spPr>
           <a:xfrm>
             <a:off x="1005840" y="3474720"/>
-            <a:ext cx="3200400" cy="1645920"/>
+            <a:ext cx="3200400" cy="1737360"/>
           </a:xfrm>
           <a:prstGeom prst="rect">
             <a:avLst/>
@@ -3531,7 +3531,7 @@
               </a:spcAft>
             </a:pPr>
             <a:r>
-              <a:rPr sz="1600" b="0">
+              <a:rPr sz="1800" b="0">
                 <a:solidFill>
                   <a:srgbClr val="FFFFFF"/>
                 </a:solidFill>
@@ -3547,7 +3547,7 @@
               </a:spcAft>
             </a:pPr>
             <a:r>
-              <a:rPr sz="1600" b="0">
+              <a:rPr sz="1800" b="0">
                 <a:solidFill>
                   <a:srgbClr val="FFFFFF"/>
                 </a:solidFill>
@@ -3563,7 +3563,7 @@
               </a:spcAft>
             </a:pPr>
             <a:r>
-              <a:rPr sz="1600" b="0">
+              <a:rPr sz="1800" b="0">
                 <a:solidFill>
                   <a:srgbClr val="FFFFFF"/>
                 </a:solidFill>
@@ -3583,7 +3583,7 @@
         <p:spPr>
           <a:xfrm>
             <a:off x="4297680" y="3474720"/>
-            <a:ext cx="3017520" cy="1645920"/>
+            <a:ext cx="3017520" cy="1737360"/>
           </a:xfrm>
           <a:prstGeom prst="rect">
             <a:avLst/>
@@ -3602,7 +3602,7 @@
               </a:spcAft>
             </a:pPr>
             <a:r>
-              <a:rPr sz="1600" b="0">
+              <a:rPr sz="1800" b="0">
                 <a:solidFill>
                   <a:srgbClr val="FFFFFF"/>
                 </a:solidFill>
@@ -3618,7 +3618,7 @@
               </a:spcAft>
             </a:pPr>
             <a:r>
-              <a:rPr sz="1600" b="0">
+              <a:rPr sz="1800" b="0">
                 <a:solidFill>
                   <a:srgbClr val="FFFFFF"/>
                 </a:solidFill>
@@ -3637,8 +3637,8 @@
         </p:nvSpPr>
         <p:spPr>
           <a:xfrm>
-            <a:off x="7772400" y="2926080"/>
-            <a:ext cx="3931920" cy="2606040"/>
+            <a:off x="7772400" y="2880360"/>
+            <a:ext cx="3931920" cy="2651760"/>
           </a:xfrm>
           <a:prstGeom prst="roundRect">
             <a:avLst>
@@ -3683,7 +3683,7 @@
         </p:nvSpPr>
         <p:spPr>
           <a:xfrm>
-            <a:off x="8001000" y="3108960"/>
+            <a:off x="8001000" y="3063240"/>
             <a:ext cx="3566160" cy="274320"/>
           </a:xfrm>
           <a:prstGeom prst="rect">
@@ -3703,7 +3703,7 @@
               </a:spcAft>
             </a:pPr>
             <a:r>
-              <a:rPr sz="1300" b="1">
+              <a:rPr sz="1500" b="1">
                 <a:solidFill>
                   <a:srgbClr val="239688"/>
                 </a:solidFill>
@@ -3722,7 +3722,7 @@
         </p:nvSpPr>
         <p:spPr>
           <a:xfrm>
-            <a:off x="8001000" y="3474720"/>
+            <a:off x="8001000" y="3429000"/>
             <a:ext cx="3566160" cy="502920"/>
           </a:xfrm>
           <a:prstGeom prst="rect">
@@ -3742,38 +3742,93 @@
               </a:spcAft>
             </a:pPr>
             <a:r>
+              <a:rPr sz="2000" b="1">
+                <a:solidFill>
+                  <a:srgbClr val="FFFFFF"/>
+                </a:solidFill>
+                <a:latin typeface="Calibri"/>
+              </a:rPr>
+              <a:t>Mr. Rajabu Msangi</a:t>
+            </a:r>
+          </a:p>
+        </p:txBody>
+      </p:sp>
+      <p:sp>
+        <p:nvSpPr>
+          <p:cNvPr id="16" name="TextBox 15"/>
+          <p:cNvSpPr txBox="1"/>
+          <p:nvPr/>
+        </p:nvSpPr>
+        <p:spPr>
+          <a:xfrm>
+            <a:off x="8001000" y="4114800"/>
+            <a:ext cx="3566160" cy="274320"/>
+          </a:xfrm>
+          <a:prstGeom prst="rect">
+            <a:avLst/>
+          </a:prstGeom>
+          <a:noFill/>
+        </p:spPr>
+        <p:txBody>
+          <a:bodyPr wrap="square">
+            <a:spAutoFit/>
+          </a:bodyPr>
+          <a:lstStyle/>
+          <a:p>
+            <a:pPr algn="l">
+              <a:spcAft>
+                <a:spcPts val="400"/>
+              </a:spcAft>
+            </a:pPr>
+            <a:r>
+              <a:rPr sz="1500" b="1">
+                <a:solidFill>
+                  <a:srgbClr val="239688"/>
+                </a:solidFill>
+                <a:latin typeface="Calibri"/>
+              </a:rPr>
+              <a:t>LIVE PROJECT LINK</a:t>
+            </a:r>
+          </a:p>
+        </p:txBody>
+      </p:sp>
+      <p:sp>
+        <p:nvSpPr>
+          <p:cNvPr id="17" name="TextBox 16"/>
+          <p:cNvSpPr txBox="1"/>
+          <p:nvPr/>
+        </p:nvSpPr>
+        <p:spPr>
+          <a:xfrm>
+            <a:off x="8001000" y="4480560"/>
+            <a:ext cx="3566160" cy="822960"/>
+          </a:xfrm>
+          <a:prstGeom prst="rect">
+            <a:avLst/>
+          </a:prstGeom>
+          <a:noFill/>
+        </p:spPr>
+        <p:txBody>
+          <a:bodyPr wrap="square">
+            <a:spAutoFit/>
+          </a:bodyPr>
+          <a:lstStyle/>
+          <a:p>
+            <a:pPr algn="l">
+              <a:spcAft>
+                <a:spcPts val="400"/>
+              </a:spcAft>
+            </a:pPr>
+            <a:r>
               <a:rPr sz="1800" b="1">
                 <a:solidFill>
-                  <a:srgbClr val="FFFFFF"/>
-                </a:solidFill>
-                <a:latin typeface="Calibri"/>
-              </a:rPr>
-              <a:t>Mr. Rajabu Msangi</a:t>
-            </a:r>
-          </a:p>
-        </p:txBody>
-      </p:sp>
-      <p:sp>
-        <p:nvSpPr>
-          <p:cNvPr id="16" name="TextBox 15"/>
-          <p:cNvSpPr txBox="1"/>
-          <p:nvPr/>
-        </p:nvSpPr>
-        <p:spPr>
-          <a:xfrm>
-            <a:off x="8001000" y="4160520"/>
-            <a:ext cx="3566160" cy="274320"/>
-          </a:xfrm>
-          <a:prstGeom prst="rect">
-            <a:avLst/>
-          </a:prstGeom>
-          <a:noFill/>
-        </p:spPr>
-        <p:txBody>
-          <a:bodyPr wrap="square">
-            <a:spAutoFit/>
-          </a:bodyPr>
-          <a:lstStyle/>
+                  <a:srgbClr val="D8E8E4"/>
+                </a:solidFill>
+                <a:latin typeface="Calibri"/>
+              </a:rPr>
+              <a:t>ushirika-sme-portal</a:t>
+            </a:r>
+          </a:p>
           <a:p>
             <a:pPr algn="l">
               <a:spcAft>
@@ -3781,27 +3836,27 @@
               </a:spcAft>
             </a:pPr>
             <a:r>
-              <a:rPr sz="1300" b="1">
-                <a:solidFill>
-                  <a:srgbClr val="239688"/>
-                </a:solidFill>
-                <a:latin typeface="Calibri"/>
-              </a:rPr>
-              <a:t>LIVE PROJECT LINK</a:t>
-            </a:r>
-          </a:p>
-        </p:txBody>
-      </p:sp>
-      <p:sp>
-        <p:nvSpPr>
-          <p:cNvPr id="17" name="TextBox 16"/>
-          <p:cNvSpPr txBox="1"/>
-          <p:nvPr/>
-        </p:nvSpPr>
-        <p:spPr>
-          <a:xfrm>
-            <a:off x="8001000" y="4526280"/>
-            <a:ext cx="3566160" cy="731520"/>
+              <a:rPr sz="1800" b="1">
+                <a:solidFill>
+                  <a:srgbClr val="D8E8E4"/>
+                </a:solidFill>
+                <a:latin typeface="Calibri"/>
+              </a:rPr>
+              <a:t>.vercel.app</a:t>
+            </a:r>
+          </a:p>
+        </p:txBody>
+      </p:sp>
+      <p:sp>
+        <p:nvSpPr>
+          <p:cNvPr id="18" name="TextBox 17"/>
+          <p:cNvSpPr txBox="1"/>
+          <p:nvPr/>
+        </p:nvSpPr>
+        <p:spPr>
+          <a:xfrm>
+            <a:off x="777240" y="6080760"/>
+            <a:ext cx="9144000" cy="320040"/>
           </a:xfrm>
           <a:prstGeom prst="rect">
             <a:avLst/>
@@ -3820,62 +3875,7 @@
               </a:spcAft>
             </a:pPr>
             <a:r>
-              <a:rPr sz="1600" b="1">
-                <a:solidFill>
-                  <a:srgbClr val="D8E8E4"/>
-                </a:solidFill>
-                <a:latin typeface="Calibri"/>
-              </a:rPr>
-              <a:t>ushirika-sme-portal</a:t>
-            </a:r>
-          </a:p>
-          <a:p>
-            <a:pPr algn="l">
-              <a:spcAft>
-                <a:spcPts val="400"/>
-              </a:spcAft>
-            </a:pPr>
-            <a:r>
-              <a:rPr sz="1600" b="1">
-                <a:solidFill>
-                  <a:srgbClr val="D8E8E4"/>
-                </a:solidFill>
-                <a:latin typeface="Calibri"/>
-              </a:rPr>
-              <a:t>.vercel.app</a:t>
-            </a:r>
-          </a:p>
-        </p:txBody>
-      </p:sp>
-      <p:sp>
-        <p:nvSpPr>
-          <p:cNvPr id="18" name="TextBox 17"/>
-          <p:cNvSpPr txBox="1"/>
-          <p:nvPr/>
-        </p:nvSpPr>
-        <p:spPr>
-          <a:xfrm>
-            <a:off x="777240" y="6126480"/>
-            <a:ext cx="9144000" cy="320040"/>
-          </a:xfrm>
-          <a:prstGeom prst="rect">
-            <a:avLst/>
-          </a:prstGeom>
-          <a:noFill/>
-        </p:spPr>
-        <p:txBody>
-          <a:bodyPr wrap="square">
-            <a:spAutoFit/>
-          </a:bodyPr>
-          <a:lstStyle/>
-          <a:p>
-            <a:pPr algn="l">
-              <a:spcAft>
-                <a:spcPts val="400"/>
-              </a:spcAft>
-            </a:pPr>
-            <a:r>
-              <a:rPr sz="1400" b="0">
+              <a:rPr sz="1600" b="0">
                 <a:solidFill>
                   <a:srgbClr val="9BC4BA"/>
                 </a:solidFill>
@@ -3894,7 +3894,7 @@
         </p:nvSpPr>
         <p:spPr>
           <a:xfrm>
-            <a:off x="10241280" y="6126480"/>
+            <a:off x="10241280" y="6080760"/>
             <a:ext cx="1554480" cy="320040"/>
           </a:xfrm>
           <a:prstGeom prst="rect">
@@ -3914,7 +3914,7 @@
               </a:spcAft>
             </a:pPr>
             <a:r>
-              <a:rPr sz="1400" b="0">
+              <a:rPr sz="1600" b="0">
                 <a:solidFill>
                   <a:srgbClr val="B8D0C8"/>
                 </a:solidFill>
@@ -4226,8 +4226,8 @@
         </p:nvSpPr>
         <p:spPr>
           <a:xfrm>
-            <a:off x="502920" y="201168"/>
-            <a:ext cx="10972800" cy="274320"/>
+            <a:off x="502920" y="164592"/>
+            <a:ext cx="10972800" cy="292608"/>
           </a:xfrm>
           <a:prstGeom prst="rect">
             <a:avLst/>
@@ -4246,7 +4246,7 @@
               </a:spcAft>
             </a:pPr>
             <a:r>
-              <a:rPr sz="1300" b="1">
+              <a:rPr sz="1600" b="1">
                 <a:solidFill>
                   <a:srgbClr val="1A7A6D"/>
                 </a:solidFill>
@@ -4265,8 +4265,8 @@
         </p:nvSpPr>
         <p:spPr>
           <a:xfrm>
-            <a:off x="502920" y="502920"/>
-            <a:ext cx="109728" cy="475488"/>
+            <a:off x="502920" y="475488"/>
+            <a:ext cx="109728" cy="502920"/>
           </a:xfrm>
           <a:prstGeom prst="rect">
             <a:avLst/>
@@ -4309,8 +4309,8 @@
         </p:nvSpPr>
         <p:spPr>
           <a:xfrm>
-            <a:off x="777240" y="438912"/>
-            <a:ext cx="10698480" cy="502920"/>
+            <a:off x="777240" y="411480"/>
+            <a:ext cx="10698480" cy="530352"/>
           </a:xfrm>
           <a:prstGeom prst="rect">
             <a:avLst/>
@@ -4329,7 +4329,7 @@
               </a:spcAft>
             </a:pPr>
             <a:r>
-              <a:rPr sz="2800" b="1">
+              <a:rPr sz="3000" b="1">
                 <a:solidFill>
                   <a:srgbClr val="0B3D2E"/>
                 </a:solidFill>
@@ -4438,7 +4438,7 @@
         </p:nvSpPr>
         <p:spPr>
           <a:xfrm>
-            <a:off x="777240" y="1783080"/>
+            <a:off x="777240" y="1764792"/>
             <a:ext cx="1005840" cy="365760"/>
           </a:xfrm>
           <a:prstGeom prst="rect">
@@ -4458,7 +4458,7 @@
               </a:spcAft>
             </a:pPr>
             <a:r>
-              <a:rPr sz="2200" b="1">
+              <a:rPr sz="2400" b="1">
                 <a:solidFill>
                   <a:srgbClr val="1A7A6D"/>
                 </a:solidFill>
@@ -4477,7 +4477,7 @@
         </p:nvSpPr>
         <p:spPr>
           <a:xfrm>
-            <a:off x="1691640" y="1828800"/>
+            <a:off x="1691640" y="1801368"/>
             <a:ext cx="4023360" cy="365760"/>
           </a:xfrm>
           <a:prstGeom prst="rect">
@@ -4497,7 +4497,7 @@
               </a:spcAft>
             </a:pPr>
             <a:r>
-              <a:rPr sz="1800" b="1">
+              <a:rPr sz="2000" b="1">
                 <a:solidFill>
                   <a:srgbClr val="0B3D2E"/>
                 </a:solidFill>
@@ -4516,8 +4516,8 @@
         </p:nvSpPr>
         <p:spPr>
           <a:xfrm>
-            <a:off x="777240" y="2377440"/>
-            <a:ext cx="4937760" cy="960120"/>
+            <a:off x="777240" y="2331720"/>
+            <a:ext cx="4937760" cy="1051560"/>
           </a:xfrm>
           <a:prstGeom prst="rect">
             <a:avLst/>
@@ -4536,7 +4536,7 @@
               </a:spcAft>
             </a:pPr>
             <a:r>
-              <a:rPr sz="1600" b="0">
+              <a:rPr sz="1800" b="0">
                 <a:solidFill>
                   <a:srgbClr val="3D525A"/>
                 </a:solidFill>
@@ -4645,7 +4645,7 @@
         </p:nvSpPr>
         <p:spPr>
           <a:xfrm>
-            <a:off x="6629400" y="1783080"/>
+            <a:off x="6629400" y="1764792"/>
             <a:ext cx="1005840" cy="365760"/>
           </a:xfrm>
           <a:prstGeom prst="rect">
@@ -4665,7 +4665,7 @@
               </a:spcAft>
             </a:pPr>
             <a:r>
-              <a:rPr sz="2200" b="1">
+              <a:rPr sz="2400" b="1">
                 <a:solidFill>
                   <a:srgbClr val="1A7A6D"/>
                 </a:solidFill>
@@ -4684,7 +4684,7 @@
         </p:nvSpPr>
         <p:spPr>
           <a:xfrm>
-            <a:off x="7543800" y="1828800"/>
+            <a:off x="7543800" y="1801368"/>
             <a:ext cx="4023360" cy="365760"/>
           </a:xfrm>
           <a:prstGeom prst="rect">
@@ -4704,7 +4704,7 @@
               </a:spcAft>
             </a:pPr>
             <a:r>
-              <a:rPr sz="1800" b="1">
+              <a:rPr sz="2000" b="1">
                 <a:solidFill>
                   <a:srgbClr val="0B3D2E"/>
                 </a:solidFill>
@@ -4723,8 +4723,8 @@
         </p:nvSpPr>
         <p:spPr>
           <a:xfrm>
-            <a:off x="6629400" y="2377440"/>
-            <a:ext cx="4937760" cy="960120"/>
+            <a:off x="6629400" y="2331720"/>
+            <a:ext cx="4937760" cy="1051560"/>
           </a:xfrm>
           <a:prstGeom prst="rect">
             <a:avLst/>
@@ -4743,7 +4743,7 @@
               </a:spcAft>
             </a:pPr>
             <a:r>
-              <a:rPr sz="1600" b="0">
+              <a:rPr sz="1800" b="0">
                 <a:solidFill>
                   <a:srgbClr val="3D525A"/>
                 </a:solidFill>
@@ -4852,7 +4852,7 @@
         </p:nvSpPr>
         <p:spPr>
           <a:xfrm>
-            <a:off x="777240" y="4069080"/>
+            <a:off x="777240" y="4050792"/>
             <a:ext cx="1005840" cy="365760"/>
           </a:xfrm>
           <a:prstGeom prst="rect">
@@ -4872,7 +4872,7 @@
               </a:spcAft>
             </a:pPr>
             <a:r>
-              <a:rPr sz="2200" b="1">
+              <a:rPr sz="2400" b="1">
                 <a:solidFill>
                   <a:srgbClr val="1A7A6D"/>
                 </a:solidFill>
@@ -4891,7 +4891,7 @@
         </p:nvSpPr>
         <p:spPr>
           <a:xfrm>
-            <a:off x="1691640" y="4114800"/>
+            <a:off x="1691640" y="4087368"/>
             <a:ext cx="4023360" cy="365760"/>
           </a:xfrm>
           <a:prstGeom prst="rect">
@@ -4911,7 +4911,7 @@
               </a:spcAft>
             </a:pPr>
             <a:r>
-              <a:rPr sz="1800" b="1">
+              <a:rPr sz="2000" b="1">
                 <a:solidFill>
                   <a:srgbClr val="0B3D2E"/>
                 </a:solidFill>
@@ -4930,8 +4930,8 @@
         </p:nvSpPr>
         <p:spPr>
           <a:xfrm>
-            <a:off x="777240" y="4663440"/>
-            <a:ext cx="4937760" cy="960120"/>
+            <a:off x="777240" y="4617720"/>
+            <a:ext cx="4937760" cy="1051560"/>
           </a:xfrm>
           <a:prstGeom prst="rect">
             <a:avLst/>
@@ -4950,7 +4950,7 @@
               </a:spcAft>
             </a:pPr>
             <a:r>
-              <a:rPr sz="1600" b="0">
+              <a:rPr sz="1800" b="0">
                 <a:solidFill>
                   <a:srgbClr val="3D525A"/>
                 </a:solidFill>
@@ -5059,7 +5059,7 @@
         </p:nvSpPr>
         <p:spPr>
           <a:xfrm>
-            <a:off x="6629400" y="4069080"/>
+            <a:off x="6629400" y="4050792"/>
             <a:ext cx="1005840" cy="365760"/>
           </a:xfrm>
           <a:prstGeom prst="rect">
@@ -5079,7 +5079,7 @@
               </a:spcAft>
             </a:pPr>
             <a:r>
-              <a:rPr sz="2200" b="1">
+              <a:rPr sz="2400" b="1">
                 <a:solidFill>
                   <a:srgbClr val="1A7A6D"/>
                 </a:solidFill>
@@ -5098,7 +5098,7 @@
         </p:nvSpPr>
         <p:spPr>
           <a:xfrm>
-            <a:off x="7543800" y="4114800"/>
+            <a:off x="7543800" y="4087368"/>
             <a:ext cx="4023360" cy="365760"/>
           </a:xfrm>
           <a:prstGeom prst="rect">
@@ -5118,7 +5118,7 @@
               </a:spcAft>
             </a:pPr>
             <a:r>
-              <a:rPr sz="1800" b="1">
+              <a:rPr sz="2000" b="1">
                 <a:solidFill>
                   <a:srgbClr val="0B3D2E"/>
                 </a:solidFill>
@@ -5137,8 +5137,8 @@
         </p:nvSpPr>
         <p:spPr>
           <a:xfrm>
-            <a:off x="6629400" y="4663440"/>
-            <a:ext cx="4937760" cy="960120"/>
+            <a:off x="6629400" y="4617720"/>
+            <a:ext cx="4937760" cy="1051560"/>
           </a:xfrm>
           <a:prstGeom prst="rect">
             <a:avLst/>
@@ -5157,7 +5157,7 @@
               </a:spcAft>
             </a:pPr>
             <a:r>
-              <a:rPr sz="1600" b="0">
+              <a:rPr sz="1800" b="0">
                 <a:solidFill>
                   <a:srgbClr val="3D525A"/>
                 </a:solidFill>
@@ -5176,8 +5176,8 @@
         </p:nvSpPr>
         <p:spPr>
           <a:xfrm>
-            <a:off x="0" y="6537960"/>
-            <a:ext cx="12191695" cy="320040"/>
+            <a:off x="0" y="6510528"/>
+            <a:ext cx="12191695" cy="347472"/>
           </a:xfrm>
           <a:prstGeom prst="rect">
             <a:avLst/>
@@ -5220,8 +5220,8 @@
         </p:nvSpPr>
         <p:spPr>
           <a:xfrm>
-            <a:off x="411480" y="6565392"/>
-            <a:ext cx="9144000" cy="256032"/>
+            <a:off x="411480" y="6547104"/>
+            <a:ext cx="9144000" cy="274320"/>
           </a:xfrm>
           <a:prstGeom prst="rect">
             <a:avLst/>
@@ -5240,7 +5240,7 @@
               </a:spcAft>
             </a:pPr>
             <a:r>
-              <a:rPr sz="1200" b="0">
+              <a:rPr sz="1400" b="0">
                 <a:solidFill>
                   <a:srgbClr val="B8D0C8"/>
                 </a:solidFill>
@@ -5259,8 +5259,8 @@
         </p:nvSpPr>
         <p:spPr>
           <a:xfrm>
-            <a:off x="10241280" y="6565392"/>
-            <a:ext cx="1554480" cy="256032"/>
+            <a:off x="10241280" y="6547104"/>
+            <a:ext cx="1554480" cy="274320"/>
           </a:xfrm>
           <a:prstGeom prst="rect">
             <a:avLst/>
@@ -5279,7 +5279,7 @@
               </a:spcAft>
             </a:pPr>
             <a:r>
-              <a:rPr sz="1200" b="0">
+              <a:rPr sz="1400" b="0">
                 <a:solidFill>
                   <a:srgbClr val="B8D0C8"/>
                 </a:solidFill>
@@ -5627,8 +5627,8 @@
         </p:nvSpPr>
         <p:spPr>
           <a:xfrm>
-            <a:off x="502920" y="201168"/>
-            <a:ext cx="10972800" cy="274320"/>
+            <a:off x="502920" y="164592"/>
+            <a:ext cx="10972800" cy="292608"/>
           </a:xfrm>
           <a:prstGeom prst="rect">
             <a:avLst/>
@@ -5647,7 +5647,7 @@
               </a:spcAft>
             </a:pPr>
             <a:r>
-              <a:rPr sz="1300" b="1">
+              <a:rPr sz="1600" b="1">
                 <a:solidFill>
                   <a:srgbClr val="1A7A6D"/>
                 </a:solidFill>
@@ -5666,8 +5666,8 @@
         </p:nvSpPr>
         <p:spPr>
           <a:xfrm>
-            <a:off x="502920" y="502920"/>
-            <a:ext cx="109728" cy="475488"/>
+            <a:off x="502920" y="475488"/>
+            <a:ext cx="109728" cy="502920"/>
           </a:xfrm>
           <a:prstGeom prst="rect">
             <a:avLst/>
@@ -5710,8 +5710,8 @@
         </p:nvSpPr>
         <p:spPr>
           <a:xfrm>
-            <a:off x="777240" y="438912"/>
-            <a:ext cx="10698480" cy="502920"/>
+            <a:off x="777240" y="411480"/>
+            <a:ext cx="10698480" cy="530352"/>
           </a:xfrm>
           <a:prstGeom prst="rect">
             <a:avLst/>
@@ -5730,7 +5730,7 @@
               </a:spcAft>
             </a:pPr>
             <a:r>
-              <a:rPr sz="2800" b="1">
+              <a:rPr sz="3000" b="1">
                 <a:solidFill>
                   <a:srgbClr val="0B3D2E"/>
                 </a:solidFill>
@@ -5859,7 +5859,7 @@
               </a:spcAft>
             </a:pPr>
             <a:r>
-              <a:rPr sz="1300" b="1">
+              <a:rPr sz="1500" b="1">
                 <a:solidFill>
                   <a:srgbClr val="1A7A6D"/>
                 </a:solidFill>
@@ -5898,7 +5898,7 @@
               </a:spcAft>
             </a:pPr>
             <a:r>
-              <a:rPr sz="1700" b="0">
+              <a:rPr sz="1900" b="0">
                 <a:solidFill>
                   <a:srgbClr val="0F2830"/>
                 </a:solidFill>
@@ -6027,7 +6027,7 @@
               </a:spcAft>
             </a:pPr>
             <a:r>
-              <a:rPr sz="1600" b="1">
+              <a:rPr sz="1700" b="1">
                 <a:solidFill>
                   <a:srgbClr val="FFFFFF"/>
                 </a:solidFill>
@@ -6046,8 +6046,8 @@
         </p:nvSpPr>
         <p:spPr>
           <a:xfrm>
-            <a:off x="685800" y="3977639"/>
-            <a:ext cx="3108960" cy="1645920"/>
+            <a:off x="685800" y="3931920"/>
+            <a:ext cx="3108960" cy="1737360"/>
           </a:xfrm>
           <a:prstGeom prst="rect">
             <a:avLst/>
@@ -6066,7 +6066,7 @@
               </a:spcAft>
             </a:pPr>
             <a:r>
-              <a:rPr sz="1600" b="0">
+              <a:rPr sz="1800" b="0">
                 <a:solidFill>
                   <a:srgbClr val="0F2830"/>
                 </a:solidFill>
@@ -6195,7 +6195,7 @@
               </a:spcAft>
             </a:pPr>
             <a:r>
-              <a:rPr sz="1600" b="1">
+              <a:rPr sz="1700" b="1">
                 <a:solidFill>
                   <a:srgbClr val="FFFFFF"/>
                 </a:solidFill>
@@ -6214,8 +6214,8 @@
         </p:nvSpPr>
         <p:spPr>
           <a:xfrm>
-            <a:off x="4526280" y="3977639"/>
-            <a:ext cx="3108960" cy="1645920"/>
+            <a:off x="4526280" y="3931920"/>
+            <a:ext cx="3108960" cy="1737360"/>
           </a:xfrm>
           <a:prstGeom prst="rect">
             <a:avLst/>
@@ -6234,7 +6234,7 @@
               </a:spcAft>
             </a:pPr>
             <a:r>
-              <a:rPr sz="1600" b="0">
+              <a:rPr sz="1800" b="0">
                 <a:solidFill>
                   <a:srgbClr val="0F2830"/>
                 </a:solidFill>
@@ -6363,7 +6363,7 @@
               </a:spcAft>
             </a:pPr>
             <a:r>
-              <a:rPr sz="1600" b="1">
+              <a:rPr sz="1700" b="1">
                 <a:solidFill>
                   <a:srgbClr val="FFFFFF"/>
                 </a:solidFill>
@@ -6382,8 +6382,8 @@
         </p:nvSpPr>
         <p:spPr>
           <a:xfrm>
-            <a:off x="8366760" y="3977639"/>
-            <a:ext cx="3108960" cy="1645920"/>
+            <a:off x="8366760" y="3931920"/>
+            <a:ext cx="3108960" cy="1737360"/>
           </a:xfrm>
           <a:prstGeom prst="rect">
             <a:avLst/>
@@ -6402,7 +6402,7 @@
               </a:spcAft>
             </a:pPr>
             <a:r>
-              <a:rPr sz="1600" b="0">
+              <a:rPr sz="1800" b="0">
                 <a:solidFill>
                   <a:srgbClr val="0F2830"/>
                 </a:solidFill>
@@ -6421,8 +6421,8 @@
         </p:nvSpPr>
         <p:spPr>
           <a:xfrm>
-            <a:off x="0" y="6537960"/>
-            <a:ext cx="12191695" cy="320040"/>
+            <a:off x="0" y="6510528"/>
+            <a:ext cx="12191695" cy="347472"/>
           </a:xfrm>
           <a:prstGeom prst="rect">
             <a:avLst/>
@@ -6465,8 +6465,8 @@
         </p:nvSpPr>
         <p:spPr>
           <a:xfrm>
-            <a:off x="411480" y="6565392"/>
-            <a:ext cx="9144000" cy="256032"/>
+            <a:off x="411480" y="6547104"/>
+            <a:ext cx="9144000" cy="274320"/>
           </a:xfrm>
           <a:prstGeom prst="rect">
             <a:avLst/>
@@ -6485,7 +6485,7 @@
               </a:spcAft>
             </a:pPr>
             <a:r>
-              <a:rPr sz="1200" b="0">
+              <a:rPr sz="1400" b="0">
                 <a:solidFill>
                   <a:srgbClr val="B8D0C8"/>
                 </a:solidFill>
@@ -6504,8 +6504,8 @@
         </p:nvSpPr>
         <p:spPr>
           <a:xfrm>
-            <a:off x="10241280" y="6565392"/>
-            <a:ext cx="1554480" cy="256032"/>
+            <a:off x="10241280" y="6547104"/>
+            <a:ext cx="1554480" cy="274320"/>
           </a:xfrm>
           <a:prstGeom prst="rect">
             <a:avLst/>
@@ -6524,7 +6524,7 @@
               </a:spcAft>
             </a:pPr>
             <a:r>
-              <a:rPr sz="1200" b="0">
+              <a:rPr sz="1400" b="0">
                 <a:solidFill>
                   <a:srgbClr val="B8D0C8"/>
                 </a:solidFill>
@@ -6615,8 +6615,8 @@
         </p:nvSpPr>
         <p:spPr>
           <a:xfrm>
-            <a:off x="502920" y="201168"/>
-            <a:ext cx="10972800" cy="274320"/>
+            <a:off x="502920" y="164592"/>
+            <a:ext cx="10972800" cy="292608"/>
           </a:xfrm>
           <a:prstGeom prst="rect">
             <a:avLst/>
@@ -6635,7 +6635,7 @@
               </a:spcAft>
             </a:pPr>
             <a:r>
-              <a:rPr sz="1300" b="1">
+              <a:rPr sz="1600" b="1">
                 <a:solidFill>
                   <a:srgbClr val="1A7A6D"/>
                 </a:solidFill>
@@ -6654,8 +6654,8 @@
         </p:nvSpPr>
         <p:spPr>
           <a:xfrm>
-            <a:off x="502920" y="502920"/>
-            <a:ext cx="109728" cy="475488"/>
+            <a:off x="502920" y="475488"/>
+            <a:ext cx="109728" cy="502920"/>
           </a:xfrm>
           <a:prstGeom prst="rect">
             <a:avLst/>
@@ -6698,8 +6698,8 @@
         </p:nvSpPr>
         <p:spPr>
           <a:xfrm>
-            <a:off x="777240" y="438912"/>
-            <a:ext cx="10698480" cy="502920"/>
+            <a:off x="777240" y="411480"/>
+            <a:ext cx="10698480" cy="530352"/>
           </a:xfrm>
           <a:prstGeom prst="rect">
             <a:avLst/>
@@ -6718,7 +6718,7 @@
               </a:spcAft>
             </a:pPr>
             <a:r>
-              <a:rPr sz="2800" b="1">
+              <a:rPr sz="3000" b="1">
                 <a:solidFill>
                   <a:srgbClr val="0B3D2E"/>
                 </a:solidFill>
@@ -6847,7 +6847,7 @@
               </a:spcAft>
             </a:pPr>
             <a:r>
-              <a:rPr sz="1700" b="1">
+              <a:rPr sz="1800" b="1">
                 <a:solidFill>
                   <a:srgbClr val="FFFFFF"/>
                 </a:solidFill>
@@ -6886,7 +6886,7 @@
               </a:spcAft>
             </a:pPr>
             <a:r>
-              <a:rPr sz="1600" b="0">
+              <a:rPr sz="1800" b="0">
                 <a:solidFill>
                   <a:srgbClr val="0F2830"/>
                 </a:solidFill>
@@ -6902,7 +6902,7 @@
               </a:spcAft>
             </a:pPr>
             <a:r>
-              <a:rPr sz="1600" b="0">
+              <a:rPr sz="1800" b="0">
                 <a:solidFill>
                   <a:srgbClr val="0F2830"/>
                 </a:solidFill>
@@ -6918,7 +6918,7 @@
               </a:spcAft>
             </a:pPr>
             <a:r>
-              <a:rPr sz="1600" b="0">
+              <a:rPr sz="1800" b="0">
                 <a:solidFill>
                   <a:srgbClr val="0F2830"/>
                 </a:solidFill>
@@ -6957,7 +6957,7 @@
               </a:spcAft>
             </a:pPr>
             <a:r>
-              <a:rPr sz="2200" b="1">
+              <a:rPr sz="2400" b="1">
                 <a:solidFill>
                   <a:srgbClr val="1A7A6D"/>
                 </a:solidFill>
@@ -7086,7 +7086,7 @@
               </a:spcAft>
             </a:pPr>
             <a:r>
-              <a:rPr sz="1700" b="1">
+              <a:rPr sz="1800" b="1">
                 <a:solidFill>
                   <a:srgbClr val="FFFFFF"/>
                 </a:solidFill>
@@ -7125,7 +7125,7 @@
               </a:spcAft>
             </a:pPr>
             <a:r>
-              <a:rPr sz="1600" b="0">
+              <a:rPr sz="1800" b="0">
                 <a:solidFill>
                   <a:srgbClr val="0F2830"/>
                 </a:solidFill>
@@ -7141,7 +7141,7 @@
               </a:spcAft>
             </a:pPr>
             <a:r>
-              <a:rPr sz="1600" b="0">
+              <a:rPr sz="1800" b="0">
                 <a:solidFill>
                   <a:srgbClr val="0F2830"/>
                 </a:solidFill>
@@ -7157,7 +7157,7 @@
               </a:spcAft>
             </a:pPr>
             <a:r>
-              <a:rPr sz="1600" b="0">
+              <a:rPr sz="1800" b="0">
                 <a:solidFill>
                   <a:srgbClr val="0F2830"/>
                 </a:solidFill>
@@ -7196,7 +7196,7 @@
               </a:spcAft>
             </a:pPr>
             <a:r>
-              <a:rPr sz="2200" b="1">
+              <a:rPr sz="2400" b="1">
                 <a:solidFill>
                   <a:srgbClr val="1A7A6D"/>
                 </a:solidFill>
@@ -7325,7 +7325,7 @@
               </a:spcAft>
             </a:pPr>
             <a:r>
-              <a:rPr sz="1700" b="1">
+              <a:rPr sz="1800" b="1">
                 <a:solidFill>
                   <a:srgbClr val="FFFFFF"/>
                 </a:solidFill>
@@ -7364,7 +7364,7 @@
               </a:spcAft>
             </a:pPr>
             <a:r>
-              <a:rPr sz="1600" b="0">
+              <a:rPr sz="1800" b="0">
                 <a:solidFill>
                   <a:srgbClr val="0F2830"/>
                 </a:solidFill>
@@ -7380,7 +7380,7 @@
               </a:spcAft>
             </a:pPr>
             <a:r>
-              <a:rPr sz="1600" b="0">
+              <a:rPr sz="1800" b="0">
                 <a:solidFill>
                   <a:srgbClr val="0F2830"/>
                 </a:solidFill>
@@ -7396,7 +7396,7 @@
               </a:spcAft>
             </a:pPr>
             <a:r>
-              <a:rPr sz="1600" b="0">
+              <a:rPr sz="1800" b="0">
                 <a:solidFill>
                   <a:srgbClr val="0F2830"/>
                 </a:solidFill>
@@ -7435,7 +7435,7 @@
               </a:spcAft>
             </a:pPr>
             <a:r>
-              <a:rPr sz="2200" b="1">
+              <a:rPr sz="2400" b="1">
                 <a:solidFill>
                   <a:srgbClr val="1A7A6D"/>
                 </a:solidFill>
@@ -7564,7 +7564,7 @@
               </a:spcAft>
             </a:pPr>
             <a:r>
-              <a:rPr sz="1700" b="1">
+              <a:rPr sz="1800" b="1">
                 <a:solidFill>
                   <a:srgbClr val="FFFFFF"/>
                 </a:solidFill>
@@ -7603,7 +7603,7 @@
               </a:spcAft>
             </a:pPr>
             <a:r>
-              <a:rPr sz="1600" b="0">
+              <a:rPr sz="1800" b="0">
                 <a:solidFill>
                   <a:srgbClr val="0F2830"/>
                 </a:solidFill>
@@ -7619,7 +7619,7 @@
               </a:spcAft>
             </a:pPr>
             <a:r>
-              <a:rPr sz="1600" b="0">
+              <a:rPr sz="1800" b="0">
                 <a:solidFill>
                   <a:srgbClr val="0F2830"/>
                 </a:solidFill>
@@ -7635,7 +7635,7 @@
               </a:spcAft>
             </a:pPr>
             <a:r>
-              <a:rPr sz="1600" b="0">
+              <a:rPr sz="1800" b="0">
                 <a:solidFill>
                   <a:srgbClr val="0F2830"/>
                 </a:solidFill>
@@ -7720,7 +7720,7 @@
               </a:spcAft>
             </a:pPr>
             <a:r>
-              <a:rPr sz="1600" b="0">
+              <a:rPr sz="1800" b="0">
                 <a:solidFill>
                   <a:srgbClr val="3D525A"/>
                 </a:solidFill>
@@ -7736,7 +7736,7 @@
               </a:spcAft>
             </a:pPr>
             <a:r>
-              <a:rPr sz="1600" b="0">
+              <a:rPr sz="1800" b="0">
                 <a:solidFill>
                   <a:srgbClr val="3D525A"/>
                 </a:solidFill>
@@ -7752,7 +7752,7 @@
               </a:spcAft>
             </a:pPr>
             <a:r>
-              <a:rPr sz="1600" b="0">
+              <a:rPr sz="1800" b="0">
                 <a:solidFill>
                   <a:srgbClr val="3D525A"/>
                 </a:solidFill>
@@ -7771,8 +7771,8 @@
         </p:nvSpPr>
         <p:spPr>
           <a:xfrm>
-            <a:off x="0" y="6537960"/>
-            <a:ext cx="12191695" cy="320040"/>
+            <a:off x="0" y="6510528"/>
+            <a:ext cx="12191695" cy="347472"/>
           </a:xfrm>
           <a:prstGeom prst="rect">
             <a:avLst/>
@@ -7815,8 +7815,8 @@
         </p:nvSpPr>
         <p:spPr>
           <a:xfrm>
-            <a:off x="411480" y="6565392"/>
-            <a:ext cx="9144000" cy="256032"/>
+            <a:off x="411480" y="6547104"/>
+            <a:ext cx="9144000" cy="274320"/>
           </a:xfrm>
           <a:prstGeom prst="rect">
             <a:avLst/>
@@ -7835,7 +7835,7 @@
               </a:spcAft>
             </a:pPr>
             <a:r>
-              <a:rPr sz="1200" b="0">
+              <a:rPr sz="1400" b="0">
                 <a:solidFill>
                   <a:srgbClr val="B8D0C8"/>
                 </a:solidFill>
@@ -7854,8 +7854,8 @@
         </p:nvSpPr>
         <p:spPr>
           <a:xfrm>
-            <a:off x="10241280" y="6565392"/>
-            <a:ext cx="1554480" cy="256032"/>
+            <a:off x="10241280" y="6547104"/>
+            <a:ext cx="1554480" cy="274320"/>
           </a:xfrm>
           <a:prstGeom prst="rect">
             <a:avLst/>
@@ -7874,7 +7874,7 @@
               </a:spcAft>
             </a:pPr>
             <a:r>
-              <a:rPr sz="1200" b="0">
+              <a:rPr sz="1400" b="0">
                 <a:solidFill>
                   <a:srgbClr val="B8D0C8"/>
                 </a:solidFill>
@@ -7965,8 +7965,8 @@
         </p:nvSpPr>
         <p:spPr>
           <a:xfrm>
-            <a:off x="502920" y="201168"/>
-            <a:ext cx="10972800" cy="274320"/>
+            <a:off x="502920" y="164592"/>
+            <a:ext cx="10972800" cy="292608"/>
           </a:xfrm>
           <a:prstGeom prst="rect">
             <a:avLst/>
@@ -7985,7 +7985,7 @@
               </a:spcAft>
             </a:pPr>
             <a:r>
-              <a:rPr sz="1300" b="1">
+              <a:rPr sz="1600" b="1">
                 <a:solidFill>
                   <a:srgbClr val="1A7A6D"/>
                 </a:solidFill>
@@ -8004,8 +8004,8 @@
         </p:nvSpPr>
         <p:spPr>
           <a:xfrm>
-            <a:off x="502920" y="502920"/>
-            <a:ext cx="109728" cy="475488"/>
+            <a:off x="502920" y="475488"/>
+            <a:ext cx="109728" cy="502920"/>
           </a:xfrm>
           <a:prstGeom prst="rect">
             <a:avLst/>
@@ -8048,8 +8048,8 @@
         </p:nvSpPr>
         <p:spPr>
           <a:xfrm>
-            <a:off x="777240" y="438912"/>
-            <a:ext cx="10698480" cy="502920"/>
+            <a:off x="777240" y="411480"/>
+            <a:ext cx="10698480" cy="530352"/>
           </a:xfrm>
           <a:prstGeom prst="rect">
             <a:avLst/>
@@ -8068,7 +8068,7 @@
               </a:spcAft>
             </a:pPr>
             <a:r>
-              <a:rPr sz="2800" b="1">
+              <a:rPr sz="3000" b="1">
                 <a:solidFill>
                   <a:srgbClr val="0B3D2E"/>
                 </a:solidFill>
@@ -8133,8 +8133,8 @@
         </p:nvSpPr>
         <p:spPr>
           <a:xfrm>
-            <a:off x="640080" y="1527048"/>
-            <a:ext cx="6400800" cy="274320"/>
+            <a:off x="640080" y="1508760"/>
+            <a:ext cx="6400800" cy="292608"/>
           </a:xfrm>
           <a:prstGeom prst="rect">
             <a:avLst/>
@@ -8153,7 +8153,7 @@
               </a:spcAft>
             </a:pPr>
             <a:r>
-              <a:rPr sz="1600" b="1">
+              <a:rPr sz="1800" b="1">
                 <a:solidFill>
                   <a:srgbClr val="0B3D2E"/>
                 </a:solidFill>
@@ -8173,7 +8173,7 @@
         <p:spPr>
           <a:xfrm>
             <a:off x="640080" y="1828800"/>
-            <a:ext cx="6400800" cy="320040"/>
+            <a:ext cx="6400800" cy="365760"/>
           </a:xfrm>
           <a:prstGeom prst="rect">
             <a:avLst/>
@@ -8192,7 +8192,7 @@
               </a:spcAft>
             </a:pPr>
             <a:r>
-              <a:rPr sz="1500" b="0">
+              <a:rPr sz="1700" b="0">
                 <a:solidFill>
                   <a:srgbClr val="3D525A"/>
                 </a:solidFill>
@@ -8257,8 +8257,8 @@
         </p:nvSpPr>
         <p:spPr>
           <a:xfrm>
-            <a:off x="640080" y="2487168"/>
-            <a:ext cx="6400800" cy="274320"/>
+            <a:off x="640080" y="2468880"/>
+            <a:ext cx="6400800" cy="292608"/>
           </a:xfrm>
           <a:prstGeom prst="rect">
             <a:avLst/>
@@ -8277,7 +8277,7 @@
               </a:spcAft>
             </a:pPr>
             <a:r>
-              <a:rPr sz="1600" b="1">
+              <a:rPr sz="1800" b="1">
                 <a:solidFill>
                   <a:srgbClr val="0B3D2E"/>
                 </a:solidFill>
@@ -8297,7 +8297,7 @@
         <p:spPr>
           <a:xfrm>
             <a:off x="640080" y="2788920"/>
-            <a:ext cx="6400800" cy="320040"/>
+            <a:ext cx="6400800" cy="365760"/>
           </a:xfrm>
           <a:prstGeom prst="rect">
             <a:avLst/>
@@ -8316,7 +8316,7 @@
               </a:spcAft>
             </a:pPr>
             <a:r>
-              <a:rPr sz="1500" b="0">
+              <a:rPr sz="1700" b="0">
                 <a:solidFill>
                   <a:srgbClr val="3D525A"/>
                 </a:solidFill>
@@ -8381,8 +8381,8 @@
         </p:nvSpPr>
         <p:spPr>
           <a:xfrm>
-            <a:off x="640080" y="3447288"/>
-            <a:ext cx="6400800" cy="274320"/>
+            <a:off x="640080" y="3429000"/>
+            <a:ext cx="6400800" cy="292608"/>
           </a:xfrm>
           <a:prstGeom prst="rect">
             <a:avLst/>
@@ -8401,7 +8401,7 @@
               </a:spcAft>
             </a:pPr>
             <a:r>
-              <a:rPr sz="1600" b="1">
+              <a:rPr sz="1800" b="1">
                 <a:solidFill>
                   <a:srgbClr val="0B3D2E"/>
                 </a:solidFill>
@@ -8421,7 +8421,7 @@
         <p:spPr>
           <a:xfrm>
             <a:off x="640080" y="3749040"/>
-            <a:ext cx="6400800" cy="320040"/>
+            <a:ext cx="6400800" cy="365760"/>
           </a:xfrm>
           <a:prstGeom prst="rect">
             <a:avLst/>
@@ -8440,7 +8440,7 @@
               </a:spcAft>
             </a:pPr>
             <a:r>
-              <a:rPr sz="1500" b="0">
+              <a:rPr sz="1700" b="0">
                 <a:solidFill>
                   <a:srgbClr val="3D525A"/>
                 </a:solidFill>
@@ -8505,8 +8505,8 @@
         </p:nvSpPr>
         <p:spPr>
           <a:xfrm>
-            <a:off x="640080" y="4407408"/>
-            <a:ext cx="6400800" cy="274320"/>
+            <a:off x="640080" y="4389120"/>
+            <a:ext cx="6400800" cy="292608"/>
           </a:xfrm>
           <a:prstGeom prst="rect">
             <a:avLst/>
@@ -8525,7 +8525,7 @@
               </a:spcAft>
             </a:pPr>
             <a:r>
-              <a:rPr sz="1600" b="1">
+              <a:rPr sz="1800" b="1">
                 <a:solidFill>
                   <a:srgbClr val="0B3D2E"/>
                 </a:solidFill>
@@ -8545,7 +8545,7 @@
         <p:spPr>
           <a:xfrm>
             <a:off x="640080" y="4709160"/>
-            <a:ext cx="6400800" cy="320040"/>
+            <a:ext cx="6400800" cy="365760"/>
           </a:xfrm>
           <a:prstGeom prst="rect">
             <a:avLst/>
@@ -8564,7 +8564,7 @@
               </a:spcAft>
             </a:pPr>
             <a:r>
-              <a:rPr sz="1500" b="0">
+              <a:rPr sz="1700" b="0">
                 <a:solidFill>
                   <a:srgbClr val="3D525A"/>
                 </a:solidFill>
@@ -8649,7 +8649,7 @@
               </a:spcAft>
             </a:pPr>
             <a:r>
-              <a:rPr sz="1600" b="1">
+              <a:rPr sz="1800" b="1">
                 <a:solidFill>
                   <a:srgbClr val="239688"/>
                 </a:solidFill>
@@ -8684,14 +8684,14 @@
           <a:p>
             <a:pPr algn="l">
               <a:spcBef>
-                <a:spcPts val="600"/>
+                <a:spcPts val="500"/>
               </a:spcBef>
               <a:spcAft>
-                <a:spcPts val="600"/>
-              </a:spcAft>
-            </a:pPr>
-            <a:r>
-              <a:rPr sz="1500" b="0">
+                <a:spcPts val="500"/>
+              </a:spcAft>
+            </a:pPr>
+            <a:r>
+              <a:rPr sz="1700" b="0">
                 <a:solidFill>
                   <a:srgbClr val="FFFFFF"/>
                 </a:solidFill>
@@ -8703,14 +8703,14 @@
           <a:p>
             <a:pPr algn="l">
               <a:spcBef>
-                <a:spcPts val="600"/>
+                <a:spcPts val="500"/>
               </a:spcBef>
               <a:spcAft>
-                <a:spcPts val="600"/>
-              </a:spcAft>
-            </a:pPr>
-            <a:r>
-              <a:rPr sz="1500" b="0">
+                <a:spcPts val="500"/>
+              </a:spcAft>
+            </a:pPr>
+            <a:r>
+              <a:rPr sz="1700" b="0">
                 <a:solidFill>
                   <a:srgbClr val="FFFFFF"/>
                 </a:solidFill>
@@ -8722,14 +8722,14 @@
           <a:p>
             <a:pPr algn="l">
               <a:spcBef>
-                <a:spcPts val="600"/>
+                <a:spcPts val="500"/>
               </a:spcBef>
               <a:spcAft>
-                <a:spcPts val="600"/>
-              </a:spcAft>
-            </a:pPr>
-            <a:r>
-              <a:rPr sz="1500" b="0">
+                <a:spcPts val="500"/>
+              </a:spcAft>
+            </a:pPr>
+            <a:r>
+              <a:rPr sz="1700" b="0">
                 <a:solidFill>
                   <a:srgbClr val="FFFFFF"/>
                 </a:solidFill>
@@ -8741,14 +8741,14 @@
           <a:p>
             <a:pPr algn="l">
               <a:spcBef>
-                <a:spcPts val="600"/>
+                <a:spcPts val="500"/>
               </a:spcBef>
               <a:spcAft>
-                <a:spcPts val="600"/>
-              </a:spcAft>
-            </a:pPr>
-            <a:r>
-              <a:rPr sz="1500" b="0">
+                <a:spcPts val="500"/>
+              </a:spcAft>
+            </a:pPr>
+            <a:r>
+              <a:rPr sz="1700" b="0">
                 <a:solidFill>
                   <a:srgbClr val="FFFFFF"/>
                 </a:solidFill>
@@ -8767,8 +8767,8 @@
         </p:nvSpPr>
         <p:spPr>
           <a:xfrm>
-            <a:off x="0" y="6537960"/>
-            <a:ext cx="12191695" cy="320040"/>
+            <a:off x="0" y="6510528"/>
+            <a:ext cx="12191695" cy="347472"/>
           </a:xfrm>
           <a:prstGeom prst="rect">
             <a:avLst/>
@@ -8811,8 +8811,8 @@
         </p:nvSpPr>
         <p:spPr>
           <a:xfrm>
-            <a:off x="411480" y="6565392"/>
-            <a:ext cx="9144000" cy="256032"/>
+            <a:off x="411480" y="6547104"/>
+            <a:ext cx="9144000" cy="274320"/>
           </a:xfrm>
           <a:prstGeom prst="rect">
             <a:avLst/>
@@ -8831,7 +8831,7 @@
               </a:spcAft>
             </a:pPr>
             <a:r>
-              <a:rPr sz="1200" b="0">
+              <a:rPr sz="1400" b="0">
                 <a:solidFill>
                   <a:srgbClr val="B8D0C8"/>
                 </a:solidFill>
@@ -8850,8 +8850,8 @@
         </p:nvSpPr>
         <p:spPr>
           <a:xfrm>
-            <a:off x="10241280" y="6565392"/>
-            <a:ext cx="1554480" cy="256032"/>
+            <a:off x="10241280" y="6547104"/>
+            <a:ext cx="1554480" cy="274320"/>
           </a:xfrm>
           <a:prstGeom prst="rect">
             <a:avLst/>
@@ -8870,7 +8870,7 @@
               </a:spcAft>
             </a:pPr>
             <a:r>
-              <a:rPr sz="1200" b="0">
+              <a:rPr sz="1400" b="0">
                 <a:solidFill>
                   <a:srgbClr val="B8D0C8"/>
                 </a:solidFill>
@@ -8961,8 +8961,8 @@
         </p:nvSpPr>
         <p:spPr>
           <a:xfrm>
-            <a:off x="502920" y="201168"/>
-            <a:ext cx="10972800" cy="274320"/>
+            <a:off x="502920" y="164592"/>
+            <a:ext cx="10972800" cy="292608"/>
           </a:xfrm>
           <a:prstGeom prst="rect">
             <a:avLst/>
@@ -8981,7 +8981,7 @@
               </a:spcAft>
             </a:pPr>
             <a:r>
-              <a:rPr sz="1300" b="1">
+              <a:rPr sz="1600" b="1">
                 <a:solidFill>
                   <a:srgbClr val="1A7A6D"/>
                 </a:solidFill>
@@ -9000,8 +9000,8 @@
         </p:nvSpPr>
         <p:spPr>
           <a:xfrm>
-            <a:off x="502920" y="502920"/>
-            <a:ext cx="109728" cy="475488"/>
+            <a:off x="502920" y="475488"/>
+            <a:ext cx="109728" cy="502920"/>
           </a:xfrm>
           <a:prstGeom prst="rect">
             <a:avLst/>
@@ -9044,8 +9044,8 @@
         </p:nvSpPr>
         <p:spPr>
           <a:xfrm>
-            <a:off x="777240" y="438912"/>
-            <a:ext cx="10698480" cy="502920"/>
+            <a:off x="777240" y="411480"/>
+            <a:ext cx="10698480" cy="530352"/>
           </a:xfrm>
           <a:prstGeom prst="rect">
             <a:avLst/>
@@ -9064,7 +9064,7 @@
               </a:spcAft>
             </a:pPr>
             <a:r>
-              <a:rPr sz="2800" b="1">
+              <a:rPr sz="3000" b="1">
                 <a:solidFill>
                   <a:srgbClr val="0B3D2E"/>
                 </a:solidFill>
@@ -9149,7 +9149,7 @@
               </a:spcAft>
             </a:pPr>
             <a:r>
-              <a:rPr sz="1600" b="1">
+              <a:rPr sz="1800" b="1">
                 <a:solidFill>
                   <a:srgbClr val="1A7A6D"/>
                 </a:solidFill>
@@ -9184,14 +9184,14 @@
           <a:p>
             <a:pPr algn="l">
               <a:spcBef>
-                <a:spcPts val="600"/>
+                <a:spcPts val="500"/>
               </a:spcBef>
               <a:spcAft>
-                <a:spcPts val="600"/>
-              </a:spcAft>
-            </a:pPr>
-            <a:r>
-              <a:rPr sz="1500" b="0">
+                <a:spcPts val="500"/>
+              </a:spcAft>
+            </a:pPr>
+            <a:r>
+              <a:rPr sz="1700" b="0">
                 <a:solidFill>
                   <a:srgbClr val="0F2830"/>
                 </a:solidFill>
@@ -9203,14 +9203,14 @@
           <a:p>
             <a:pPr algn="l">
               <a:spcBef>
-                <a:spcPts val="600"/>
+                <a:spcPts val="500"/>
               </a:spcBef>
               <a:spcAft>
-                <a:spcPts val="600"/>
-              </a:spcAft>
-            </a:pPr>
-            <a:r>
-              <a:rPr sz="1500" b="0">
+                <a:spcPts val="500"/>
+              </a:spcAft>
+            </a:pPr>
+            <a:r>
+              <a:rPr sz="1700" b="0">
                 <a:solidFill>
                   <a:srgbClr val="0F2830"/>
                 </a:solidFill>
@@ -9222,14 +9222,14 @@
           <a:p>
             <a:pPr algn="l">
               <a:spcBef>
-                <a:spcPts val="600"/>
+                <a:spcPts val="500"/>
               </a:spcBef>
               <a:spcAft>
-                <a:spcPts val="600"/>
-              </a:spcAft>
-            </a:pPr>
-            <a:r>
-              <a:rPr sz="1500" b="0">
+                <a:spcPts val="500"/>
+              </a:spcAft>
+            </a:pPr>
+            <a:r>
+              <a:rPr sz="1700" b="0">
                 <a:solidFill>
                   <a:srgbClr val="0F2830"/>
                 </a:solidFill>
@@ -9241,14 +9241,14 @@
           <a:p>
             <a:pPr algn="l">
               <a:spcBef>
-                <a:spcPts val="600"/>
+                <a:spcPts val="500"/>
               </a:spcBef>
               <a:spcAft>
-                <a:spcPts val="600"/>
-              </a:spcAft>
-            </a:pPr>
-            <a:r>
-              <a:rPr sz="1500" b="0">
+                <a:spcPts val="500"/>
+              </a:spcAft>
+            </a:pPr>
+            <a:r>
+              <a:rPr sz="1700" b="0">
                 <a:solidFill>
                   <a:srgbClr val="0F2830"/>
                 </a:solidFill>
@@ -9260,14 +9260,14 @@
           <a:p>
             <a:pPr algn="l">
               <a:spcBef>
-                <a:spcPts val="600"/>
+                <a:spcPts val="500"/>
               </a:spcBef>
               <a:spcAft>
-                <a:spcPts val="600"/>
-              </a:spcAft>
-            </a:pPr>
-            <a:r>
-              <a:rPr sz="1500" b="0">
+                <a:spcPts val="500"/>
+              </a:spcAft>
+            </a:pPr>
+            <a:r>
+              <a:rPr sz="1700" b="0">
                 <a:solidFill>
                   <a:srgbClr val="0F2830"/>
                 </a:solidFill>
@@ -9279,14 +9279,14 @@
           <a:p>
             <a:pPr algn="l">
               <a:spcBef>
-                <a:spcPts val="600"/>
+                <a:spcPts val="500"/>
               </a:spcBef>
               <a:spcAft>
-                <a:spcPts val="600"/>
-              </a:spcAft>
-            </a:pPr>
-            <a:r>
-              <a:rPr sz="1500" b="0">
+                <a:spcPts val="500"/>
+              </a:spcAft>
+            </a:pPr>
+            <a:r>
+              <a:rPr sz="1700" b="0">
                 <a:solidFill>
                   <a:srgbClr val="0F2830"/>
                 </a:solidFill>
@@ -9371,7 +9371,7 @@
               </a:spcAft>
             </a:pPr>
             <a:r>
-              <a:rPr sz="1600" b="1">
+              <a:rPr sz="1800" b="1">
                 <a:solidFill>
                   <a:srgbClr val="1A7A6D"/>
                 </a:solidFill>
@@ -9406,14 +9406,14 @@
           <a:p>
             <a:pPr algn="l">
               <a:spcBef>
-                <a:spcPts val="600"/>
+                <a:spcPts val="500"/>
               </a:spcBef>
               <a:spcAft>
-                <a:spcPts val="600"/>
-              </a:spcAft>
-            </a:pPr>
-            <a:r>
-              <a:rPr sz="1500" b="0">
+                <a:spcPts val="500"/>
+              </a:spcAft>
+            </a:pPr>
+            <a:r>
+              <a:rPr sz="1700" b="0">
                 <a:solidFill>
                   <a:srgbClr val="0F2830"/>
                 </a:solidFill>
@@ -9425,14 +9425,14 @@
           <a:p>
             <a:pPr algn="l">
               <a:spcBef>
-                <a:spcPts val="600"/>
+                <a:spcPts val="500"/>
               </a:spcBef>
               <a:spcAft>
-                <a:spcPts val="600"/>
-              </a:spcAft>
-            </a:pPr>
-            <a:r>
-              <a:rPr sz="1500" b="0">
+                <a:spcPts val="500"/>
+              </a:spcAft>
+            </a:pPr>
+            <a:r>
+              <a:rPr sz="1700" b="0">
                 <a:solidFill>
                   <a:srgbClr val="0F2830"/>
                 </a:solidFill>
@@ -9444,14 +9444,14 @@
           <a:p>
             <a:pPr algn="l">
               <a:spcBef>
-                <a:spcPts val="600"/>
+                <a:spcPts val="500"/>
               </a:spcBef>
               <a:spcAft>
-                <a:spcPts val="600"/>
-              </a:spcAft>
-            </a:pPr>
-            <a:r>
-              <a:rPr sz="1500" b="0">
+                <a:spcPts val="500"/>
+              </a:spcAft>
+            </a:pPr>
+            <a:r>
+              <a:rPr sz="1700" b="0">
                 <a:solidFill>
                   <a:srgbClr val="0F2830"/>
                 </a:solidFill>
@@ -9463,14 +9463,14 @@
           <a:p>
             <a:pPr algn="l">
               <a:spcBef>
-                <a:spcPts val="600"/>
+                <a:spcPts val="500"/>
               </a:spcBef>
               <a:spcAft>
-                <a:spcPts val="600"/>
-              </a:spcAft>
-            </a:pPr>
-            <a:r>
-              <a:rPr sz="1500" b="0">
+                <a:spcPts val="500"/>
+              </a:spcAft>
+            </a:pPr>
+            <a:r>
+              <a:rPr sz="1700" b="0">
                 <a:solidFill>
                   <a:srgbClr val="0F2830"/>
                 </a:solidFill>
@@ -9482,14 +9482,14 @@
           <a:p>
             <a:pPr algn="l">
               <a:spcBef>
-                <a:spcPts val="600"/>
+                <a:spcPts val="500"/>
               </a:spcBef>
               <a:spcAft>
-                <a:spcPts val="600"/>
-              </a:spcAft>
-            </a:pPr>
-            <a:r>
-              <a:rPr sz="1500" b="0">
+                <a:spcPts val="500"/>
+              </a:spcAft>
+            </a:pPr>
+            <a:r>
+              <a:rPr sz="1700" b="0">
                 <a:solidFill>
                   <a:srgbClr val="0F2830"/>
                 </a:solidFill>
@@ -9501,14 +9501,14 @@
           <a:p>
             <a:pPr algn="l">
               <a:spcBef>
-                <a:spcPts val="600"/>
+                <a:spcPts val="500"/>
               </a:spcBef>
               <a:spcAft>
-                <a:spcPts val="600"/>
-              </a:spcAft>
-            </a:pPr>
-            <a:r>
-              <a:rPr sz="1500" b="0">
+                <a:spcPts val="500"/>
+              </a:spcAft>
+            </a:pPr>
+            <a:r>
+              <a:rPr sz="1700" b="0">
                 <a:solidFill>
                   <a:srgbClr val="0F2830"/>
                 </a:solidFill>
@@ -9527,8 +9527,8 @@
         </p:nvSpPr>
         <p:spPr>
           <a:xfrm>
-            <a:off x="0" y="6537960"/>
-            <a:ext cx="12191695" cy="320040"/>
+            <a:off x="0" y="6510528"/>
+            <a:ext cx="12191695" cy="347472"/>
           </a:xfrm>
           <a:prstGeom prst="rect">
             <a:avLst/>
@@ -9571,8 +9571,8 @@
         </p:nvSpPr>
         <p:spPr>
           <a:xfrm>
-            <a:off x="411480" y="6565392"/>
-            <a:ext cx="9144000" cy="256032"/>
+            <a:off x="411480" y="6547104"/>
+            <a:ext cx="9144000" cy="274320"/>
           </a:xfrm>
           <a:prstGeom prst="rect">
             <a:avLst/>
@@ -9591,7 +9591,7 @@
               </a:spcAft>
             </a:pPr>
             <a:r>
-              <a:rPr sz="1200" b="0">
+              <a:rPr sz="1400" b="0">
                 <a:solidFill>
                   <a:srgbClr val="B8D0C8"/>
                 </a:solidFill>
@@ -9610,8 +9610,8 @@
         </p:nvSpPr>
         <p:spPr>
           <a:xfrm>
-            <a:off x="10241280" y="6565392"/>
-            <a:ext cx="1554480" cy="256032"/>
+            <a:off x="10241280" y="6547104"/>
+            <a:ext cx="1554480" cy="274320"/>
           </a:xfrm>
           <a:prstGeom prst="rect">
             <a:avLst/>
@@ -9630,7 +9630,7 @@
               </a:spcAft>
             </a:pPr>
             <a:r>
-              <a:rPr sz="1200" b="0">
+              <a:rPr sz="1400" b="0">
                 <a:solidFill>
                   <a:srgbClr val="B8D0C8"/>
                 </a:solidFill>
@@ -9721,8 +9721,8 @@
         </p:nvSpPr>
         <p:spPr>
           <a:xfrm>
-            <a:off x="502920" y="201168"/>
-            <a:ext cx="10972800" cy="274320"/>
+            <a:off x="502920" y="164592"/>
+            <a:ext cx="10972800" cy="292608"/>
           </a:xfrm>
           <a:prstGeom prst="rect">
             <a:avLst/>
@@ -9741,7 +9741,7 @@
               </a:spcAft>
             </a:pPr>
             <a:r>
-              <a:rPr sz="1300" b="1">
+              <a:rPr sz="1600" b="1">
                 <a:solidFill>
                   <a:srgbClr val="1A7A6D"/>
                 </a:solidFill>
@@ -9760,8 +9760,8 @@
         </p:nvSpPr>
         <p:spPr>
           <a:xfrm>
-            <a:off x="502920" y="502920"/>
-            <a:ext cx="109728" cy="475488"/>
+            <a:off x="502920" y="475488"/>
+            <a:ext cx="109728" cy="502920"/>
           </a:xfrm>
           <a:prstGeom prst="rect">
             <a:avLst/>
@@ -9804,8 +9804,8 @@
         </p:nvSpPr>
         <p:spPr>
           <a:xfrm>
-            <a:off x="777240" y="438912"/>
-            <a:ext cx="10698480" cy="502920"/>
+            <a:off x="777240" y="411480"/>
+            <a:ext cx="10698480" cy="530352"/>
           </a:xfrm>
           <a:prstGeom prst="rect">
             <a:avLst/>
@@ -9824,7 +9824,7 @@
               </a:spcAft>
             </a:pPr>
             <a:r>
-              <a:rPr sz="2800" b="1">
+              <a:rPr sz="3000" b="1">
                 <a:solidFill>
                   <a:srgbClr val="0B3D2E"/>
                 </a:solidFill>
@@ -9843,8 +9843,8 @@
         </p:nvSpPr>
         <p:spPr>
           <a:xfrm>
-            <a:off x="502920" y="1005840"/>
-            <a:ext cx="11155680" cy="320040"/>
+            <a:off x="502920" y="987552"/>
+            <a:ext cx="11155680" cy="347472"/>
           </a:xfrm>
           <a:prstGeom prst="rect">
             <a:avLst/>
@@ -9863,13 +9863,13 @@
               </a:spcAft>
             </a:pPr>
             <a:r>
-              <a:rPr sz="1500" b="0">
+              <a:rPr sz="1700" b="0">
                 <a:solidFill>
                   <a:srgbClr val="3D525A"/>
                 </a:solidFill>
                 <a:latin typeface="Calibri"/>
               </a:rPr>
-              <a:t>From the project hold-out evaluation  ·  80/20 stratified split  ·  test n = 280 SMEs</a:t>
+              <a:t>Hold-out evaluation  ·  80/20 stratified split  ·  test n = 280 SMEs</a:t>
             </a:r>
           </a:p>
         </p:txBody>
@@ -9882,8 +9882,8 @@
         </p:nvSpPr>
         <p:spPr>
           <a:xfrm>
-            <a:off x="411480" y="1417320"/>
-            <a:ext cx="7635240" cy="3063240"/>
+            <a:off x="365760" y="1371600"/>
+            <a:ext cx="7680960" cy="3108960"/>
           </a:xfrm>
           <a:prstGeom prst="roundRect">
             <a:avLst>
@@ -9928,8 +9928,8 @@
         </p:nvSpPr>
         <p:spPr>
           <a:xfrm>
-            <a:off x="640080" y="1536192"/>
-            <a:ext cx="7223760" cy="320040"/>
+            <a:off x="548640" y="1463040"/>
+            <a:ext cx="7315200" cy="320040"/>
           </a:xfrm>
           <a:prstGeom prst="rect">
             <a:avLst/>
@@ -9948,13 +9948,13 @@
               </a:spcAft>
             </a:pPr>
             <a:r>
-              <a:rPr sz="1400" b="1">
+              <a:rPr sz="1600" b="1">
                 <a:solidFill>
                   <a:srgbClr val="0B3D2E"/>
                 </a:solidFill>
                 <a:latin typeface="Calibri"/>
               </a:rPr>
-              <a:t>Side-by-side hold-out metrics (creditworthy = positive class)</a:t>
+              <a:t>Hold-out metrics (creditworthy = positive class)</a:t>
             </a:r>
           </a:p>
         </p:txBody>
@@ -9967,8 +9967,8 @@
         </p:nvSpPr>
         <p:spPr>
           <a:xfrm>
-            <a:off x="594360" y="1965960"/>
-            <a:ext cx="7269480" cy="384048"/>
+            <a:off x="502920" y="1874519"/>
+            <a:ext cx="7360920" cy="438912"/>
           </a:xfrm>
           <a:prstGeom prst="rect">
             <a:avLst/>
@@ -10011,8 +10011,8 @@
         </p:nvSpPr>
         <p:spPr>
           <a:xfrm>
-            <a:off x="640080" y="2011680"/>
-            <a:ext cx="1554480" cy="320040"/>
+            <a:off x="594360" y="1938528"/>
+            <a:ext cx="1691640" cy="320040"/>
           </a:xfrm>
           <a:prstGeom prst="rect">
             <a:avLst/>
@@ -10031,7 +10031,7 @@
               </a:spcAft>
             </a:pPr>
             <a:r>
-              <a:rPr sz="1300" b="1">
+              <a:rPr sz="1600" b="1">
                 <a:solidFill>
                   <a:srgbClr val="FFFFFF"/>
                 </a:solidFill>
@@ -10050,7 +10050,46 @@
         </p:nvSpPr>
         <p:spPr>
           <a:xfrm>
-            <a:off x="2194560" y="2011680"/>
+            <a:off x="2286000" y="1938528"/>
+            <a:ext cx="1051560" cy="320040"/>
+          </a:xfrm>
+          <a:prstGeom prst="rect">
+            <a:avLst/>
+          </a:prstGeom>
+          <a:noFill/>
+        </p:spPr>
+        <p:txBody>
+          <a:bodyPr wrap="square">
+            <a:spAutoFit/>
+          </a:bodyPr>
+          <a:lstStyle/>
+          <a:p>
+            <a:pPr algn="ctr">
+              <a:spcAft>
+                <a:spcPts val="400"/>
+              </a:spcAft>
+            </a:pPr>
+            <a:r>
+              <a:rPr sz="1600" b="1">
+                <a:solidFill>
+                  <a:srgbClr val="FFFFFF"/>
+                </a:solidFill>
+                <a:latin typeface="Calibri"/>
+              </a:rPr>
+              <a:t>Acc.</a:t>
+            </a:r>
+          </a:p>
+        </p:txBody>
+      </p:sp>
+      <p:sp>
+        <p:nvSpPr>
+          <p:cNvPr id="12" name="TextBox 11"/>
+          <p:cNvSpPr txBox="1"/>
+          <p:nvPr/>
+        </p:nvSpPr>
+        <p:spPr>
+          <a:xfrm>
+            <a:off x="3337560" y="1938528"/>
             <a:ext cx="1097280" cy="320040"/>
           </a:xfrm>
           <a:prstGeom prst="rect">
@@ -10070,27 +10109,27 @@
               </a:spcAft>
             </a:pPr>
             <a:r>
-              <a:rPr sz="1300" b="1">
+              <a:rPr sz="1600" b="1">
                 <a:solidFill>
                   <a:srgbClr val="FFFFFF"/>
                 </a:solidFill>
                 <a:latin typeface="Calibri"/>
               </a:rPr>
-              <a:t>Accuracy</a:t>
-            </a:r>
-          </a:p>
-        </p:txBody>
-      </p:sp>
-      <p:sp>
-        <p:nvSpPr>
-          <p:cNvPr id="12" name="TextBox 11"/>
-          <p:cNvSpPr txBox="1"/>
-          <p:nvPr/>
-        </p:nvSpPr>
-        <p:spPr>
-          <a:xfrm>
-            <a:off x="3291839" y="2011680"/>
-            <a:ext cx="1143000" cy="320040"/>
+              <a:t>Prec.</a:t>
+            </a:r>
+          </a:p>
+        </p:txBody>
+      </p:sp>
+      <p:sp>
+        <p:nvSpPr>
+          <p:cNvPr id="13" name="TextBox 12"/>
+          <p:cNvSpPr txBox="1"/>
+          <p:nvPr/>
+        </p:nvSpPr>
+        <p:spPr>
+          <a:xfrm>
+            <a:off x="4434840" y="1938528"/>
+            <a:ext cx="1097280" cy="320040"/>
           </a:xfrm>
           <a:prstGeom prst="rect">
             <a:avLst/>
@@ -10109,27 +10148,27 @@
               </a:spcAft>
             </a:pPr>
             <a:r>
-              <a:rPr sz="1300" b="1">
+              <a:rPr sz="1600" b="1">
                 <a:solidFill>
                   <a:srgbClr val="FFFFFF"/>
                 </a:solidFill>
                 <a:latin typeface="Calibri"/>
               </a:rPr>
-              <a:t>Precision</a:t>
-            </a:r>
-          </a:p>
-        </p:txBody>
-      </p:sp>
-      <p:sp>
-        <p:nvSpPr>
-          <p:cNvPr id="13" name="TextBox 12"/>
-          <p:cNvSpPr txBox="1"/>
-          <p:nvPr/>
-        </p:nvSpPr>
-        <p:spPr>
-          <a:xfrm>
-            <a:off x="4434840" y="2011680"/>
-            <a:ext cx="1051560" cy="320040"/>
+              <a:t>Recall</a:t>
+            </a:r>
+          </a:p>
+        </p:txBody>
+      </p:sp>
+      <p:sp>
+        <p:nvSpPr>
+          <p:cNvPr id="14" name="TextBox 13"/>
+          <p:cNvSpPr txBox="1"/>
+          <p:nvPr/>
+        </p:nvSpPr>
+        <p:spPr>
+          <a:xfrm>
+            <a:off x="5532120" y="1938528"/>
+            <a:ext cx="1005840" cy="320040"/>
           </a:xfrm>
           <a:prstGeom prst="rect">
             <a:avLst/>
@@ -10148,27 +10187,27 @@
               </a:spcAft>
             </a:pPr>
             <a:r>
-              <a:rPr sz="1300" b="1">
+              <a:rPr sz="1600" b="1">
                 <a:solidFill>
                   <a:srgbClr val="FFFFFF"/>
                 </a:solidFill>
                 <a:latin typeface="Calibri"/>
               </a:rPr>
-              <a:t>Recall</a:t>
-            </a:r>
-          </a:p>
-        </p:txBody>
-      </p:sp>
-      <p:sp>
-        <p:nvSpPr>
-          <p:cNvPr id="14" name="TextBox 13"/>
-          <p:cNvSpPr txBox="1"/>
-          <p:nvPr/>
-        </p:nvSpPr>
-        <p:spPr>
-          <a:xfrm>
-            <a:off x="5486400" y="2011680"/>
-            <a:ext cx="1005840" cy="320040"/>
+              <a:t>F1</a:t>
+            </a:r>
+          </a:p>
+        </p:txBody>
+      </p:sp>
+      <p:sp>
+        <p:nvSpPr>
+          <p:cNvPr id="15" name="TextBox 14"/>
+          <p:cNvSpPr txBox="1"/>
+          <p:nvPr/>
+        </p:nvSpPr>
+        <p:spPr>
+          <a:xfrm>
+            <a:off x="6537960" y="1938528"/>
+            <a:ext cx="1097280" cy="320040"/>
           </a:xfrm>
           <a:prstGeom prst="rect">
             <a:avLst/>
@@ -10187,52 +10226,13 @@
               </a:spcAft>
             </a:pPr>
             <a:r>
-              <a:rPr sz="1300" b="1">
+              <a:rPr sz="1600" b="1">
                 <a:solidFill>
                   <a:srgbClr val="FFFFFF"/>
                 </a:solidFill>
                 <a:latin typeface="Calibri"/>
               </a:rPr>
-              <a:t>F1</a:t>
-            </a:r>
-          </a:p>
-        </p:txBody>
-      </p:sp>
-      <p:sp>
-        <p:nvSpPr>
-          <p:cNvPr id="15" name="TextBox 14"/>
-          <p:cNvSpPr txBox="1"/>
-          <p:nvPr/>
-        </p:nvSpPr>
-        <p:spPr>
-          <a:xfrm>
-            <a:off x="6492240" y="2011680"/>
-            <a:ext cx="1143000" cy="320040"/>
-          </a:xfrm>
-          <a:prstGeom prst="rect">
-            <a:avLst/>
-          </a:prstGeom>
-          <a:noFill/>
-        </p:spPr>
-        <p:txBody>
-          <a:bodyPr wrap="square">
-            <a:spAutoFit/>
-          </a:bodyPr>
-          <a:lstStyle/>
-          <a:p>
-            <a:pPr algn="ctr">
-              <a:spcAft>
-                <a:spcPts val="400"/>
-              </a:spcAft>
-            </a:pPr>
-            <a:r>
-              <a:rPr sz="1300" b="1">
-                <a:solidFill>
-                  <a:srgbClr val="FFFFFF"/>
-                </a:solidFill>
-                <a:latin typeface="Calibri"/>
-              </a:rPr>
-              <a:t>ROC-AUC</a:t>
+              <a:t>AUC</a:t>
             </a:r>
           </a:p>
         </p:txBody>
@@ -10245,8 +10245,8 @@
         </p:nvSpPr>
         <p:spPr>
           <a:xfrm>
-            <a:off x="594360" y="2350008"/>
-            <a:ext cx="7269480" cy="502920"/>
+            <a:off x="502920" y="2313432"/>
+            <a:ext cx="7360920" cy="502920"/>
           </a:xfrm>
           <a:prstGeom prst="rect">
             <a:avLst/>
@@ -10289,8 +10289,8 @@
         </p:nvSpPr>
         <p:spPr>
           <a:xfrm>
-            <a:off x="640080" y="2450592"/>
-            <a:ext cx="1554480" cy="320040"/>
+            <a:off x="594360" y="2395728"/>
+            <a:ext cx="1691640" cy="365760"/>
           </a:xfrm>
           <a:prstGeom prst="rect">
             <a:avLst/>
@@ -10309,7 +10309,7 @@
               </a:spcAft>
             </a:pPr>
             <a:r>
-              <a:rPr sz="1400" b="1">
+              <a:rPr sz="1600" b="1">
                 <a:solidFill>
                   <a:srgbClr val="0B3D2E"/>
                 </a:solidFill>
@@ -10328,8 +10328,8 @@
         </p:nvSpPr>
         <p:spPr>
           <a:xfrm>
-            <a:off x="2194560" y="2450592"/>
-            <a:ext cx="1097280" cy="320040"/>
+            <a:off x="2286000" y="2395728"/>
+            <a:ext cx="1051560" cy="365760"/>
           </a:xfrm>
           <a:prstGeom prst="rect">
             <a:avLst/>
@@ -10348,7 +10348,7 @@
               </a:spcAft>
             </a:pPr>
             <a:r>
-              <a:rPr sz="1400" b="1">
+              <a:rPr sz="1600" b="1">
                 <a:solidFill>
                   <a:srgbClr val="0B3D2E"/>
                 </a:solidFill>
@@ -10367,8 +10367,8 @@
         </p:nvSpPr>
         <p:spPr>
           <a:xfrm>
-            <a:off x="3291839" y="2450592"/>
-            <a:ext cx="1143000" cy="320040"/>
+            <a:off x="3337560" y="2395728"/>
+            <a:ext cx="1097280" cy="365760"/>
           </a:xfrm>
           <a:prstGeom prst="rect">
             <a:avLst/>
@@ -10387,7 +10387,7 @@
               </a:spcAft>
             </a:pPr>
             <a:r>
-              <a:rPr sz="1400" b="1">
+              <a:rPr sz="1600" b="1">
                 <a:solidFill>
                   <a:srgbClr val="0B3D2E"/>
                 </a:solidFill>
@@ -10406,8 +10406,8 @@
         </p:nvSpPr>
         <p:spPr>
           <a:xfrm>
-            <a:off x="4434840" y="2450592"/>
-            <a:ext cx="1051560" cy="320040"/>
+            <a:off x="4434840" y="2395728"/>
+            <a:ext cx="1097280" cy="365760"/>
           </a:xfrm>
           <a:prstGeom prst="rect">
             <a:avLst/>
@@ -10426,7 +10426,7 @@
               </a:spcAft>
             </a:pPr>
             <a:r>
-              <a:rPr sz="1400" b="1">
+              <a:rPr sz="1600" b="1">
                 <a:solidFill>
                   <a:srgbClr val="0B3D2E"/>
                 </a:solidFill>
@@ -10445,8 +10445,8 @@
         </p:nvSpPr>
         <p:spPr>
           <a:xfrm>
-            <a:off x="5486400" y="2450592"/>
-            <a:ext cx="1005840" cy="320040"/>
+            <a:off x="5532120" y="2395728"/>
+            <a:ext cx="1005840" cy="365760"/>
           </a:xfrm>
           <a:prstGeom prst="rect">
             <a:avLst/>
@@ -10465,7 +10465,7 @@
               </a:spcAft>
             </a:pPr>
             <a:r>
-              <a:rPr sz="1400" b="1">
+              <a:rPr sz="1600" b="1">
                 <a:solidFill>
                   <a:srgbClr val="0B3D2E"/>
                 </a:solidFill>
@@ -10484,8 +10484,8 @@
         </p:nvSpPr>
         <p:spPr>
           <a:xfrm>
-            <a:off x="6492240" y="2450592"/>
-            <a:ext cx="1143000" cy="320040"/>
+            <a:off x="6537960" y="2395728"/>
+            <a:ext cx="1097280" cy="365760"/>
           </a:xfrm>
           <a:prstGeom prst="rect">
             <a:avLst/>
@@ -10504,7 +10504,7 @@
               </a:spcAft>
             </a:pPr>
             <a:r>
-              <a:rPr sz="1400" b="1">
+              <a:rPr sz="1600" b="1">
                 <a:solidFill>
                   <a:srgbClr val="0B3D2E"/>
                 </a:solidFill>
@@ -10523,8 +10523,8 @@
         </p:nvSpPr>
         <p:spPr>
           <a:xfrm>
-            <a:off x="640080" y="2971800"/>
-            <a:ext cx="1554480" cy="320040"/>
+            <a:off x="594360" y="2926080"/>
+            <a:ext cx="1691640" cy="365760"/>
           </a:xfrm>
           <a:prstGeom prst="rect">
             <a:avLst/>
@@ -10543,7 +10543,7 @@
               </a:spcAft>
             </a:pPr>
             <a:r>
-              <a:rPr sz="1400" b="0">
+              <a:rPr sz="1600" b="0">
                 <a:solidFill>
                   <a:srgbClr val="3D525A"/>
                 </a:solidFill>
@@ -10562,8 +10562,8 @@
         </p:nvSpPr>
         <p:spPr>
           <a:xfrm>
-            <a:off x="2194560" y="2971800"/>
-            <a:ext cx="1097280" cy="320040"/>
+            <a:off x="2286000" y="2926080"/>
+            <a:ext cx="1051560" cy="365760"/>
           </a:xfrm>
           <a:prstGeom prst="rect">
             <a:avLst/>
@@ -10582,7 +10582,7 @@
               </a:spcAft>
             </a:pPr>
             <a:r>
-              <a:rPr sz="1400" b="0">
+              <a:rPr sz="1600" b="0">
                 <a:solidFill>
                   <a:srgbClr val="3D525A"/>
                 </a:solidFill>
@@ -10601,8 +10601,8 @@
         </p:nvSpPr>
         <p:spPr>
           <a:xfrm>
-            <a:off x="3291839" y="2971800"/>
-            <a:ext cx="1143000" cy="320040"/>
+            <a:off x="3337560" y="2926080"/>
+            <a:ext cx="1097280" cy="365760"/>
           </a:xfrm>
           <a:prstGeom prst="rect">
             <a:avLst/>
@@ -10621,7 +10621,7 @@
               </a:spcAft>
             </a:pPr>
             <a:r>
-              <a:rPr sz="1400" b="0">
+              <a:rPr sz="1600" b="0">
                 <a:solidFill>
                   <a:srgbClr val="3D525A"/>
                 </a:solidFill>
@@ -10640,8 +10640,8 @@
         </p:nvSpPr>
         <p:spPr>
           <a:xfrm>
-            <a:off x="4434840" y="2971800"/>
-            <a:ext cx="1051560" cy="320040"/>
+            <a:off x="4434840" y="2926080"/>
+            <a:ext cx="1097280" cy="365760"/>
           </a:xfrm>
           <a:prstGeom prst="rect">
             <a:avLst/>
@@ -10660,7 +10660,7 @@
               </a:spcAft>
             </a:pPr>
             <a:r>
-              <a:rPr sz="1400" b="0">
+              <a:rPr sz="1600" b="0">
                 <a:solidFill>
                   <a:srgbClr val="3D525A"/>
                 </a:solidFill>
@@ -10679,8 +10679,8 @@
         </p:nvSpPr>
         <p:spPr>
           <a:xfrm>
-            <a:off x="5486400" y="2971800"/>
-            <a:ext cx="1005840" cy="320040"/>
+            <a:off x="5532120" y="2926080"/>
+            <a:ext cx="1005840" cy="365760"/>
           </a:xfrm>
           <a:prstGeom prst="rect">
             <a:avLst/>
@@ -10699,7 +10699,7 @@
               </a:spcAft>
             </a:pPr>
             <a:r>
-              <a:rPr sz="1400" b="0">
+              <a:rPr sz="1600" b="0">
                 <a:solidFill>
                   <a:srgbClr val="3D525A"/>
                 </a:solidFill>
@@ -10718,8 +10718,8 @@
         </p:nvSpPr>
         <p:spPr>
           <a:xfrm>
-            <a:off x="6492240" y="2971800"/>
-            <a:ext cx="1143000" cy="320040"/>
+            <a:off x="6537960" y="2926080"/>
+            <a:ext cx="1097280" cy="365760"/>
           </a:xfrm>
           <a:prstGeom prst="rect">
             <a:avLst/>
@@ -10738,7 +10738,7 @@
               </a:spcAft>
             </a:pPr>
             <a:r>
-              <a:rPr sz="1400" b="0">
+              <a:rPr sz="1600" b="0">
                 <a:solidFill>
                   <a:srgbClr val="3D525A"/>
                 </a:solidFill>
@@ -10757,8 +10757,8 @@
         </p:nvSpPr>
         <p:spPr>
           <a:xfrm>
-            <a:off x="640080" y="3520440"/>
-            <a:ext cx="7223760" cy="777240"/>
+            <a:off x="594360" y="3429000"/>
+            <a:ext cx="7223760" cy="868680"/>
           </a:xfrm>
           <a:prstGeom prst="rect">
             <a:avLst/>
@@ -10777,13 +10777,13 @@
               </a:spcAft>
             </a:pPr>
             <a:r>
-              <a:rPr sz="1400" b="0">
+              <a:rPr sz="1600" b="0">
                 <a:solidFill>
                   <a:srgbClr val="0F2830"/>
                 </a:solidFill>
                 <a:latin typeface="Calibri"/>
               </a:rPr>
-              <a:t>Proof of choice: RF ROC-AUC is 8.3 points higher than LR (95.8% vs 87.5%).</a:t>
+              <a:t>Proof of choice: RF ROC-AUC is +8.3 pts vs LR (95.8% vs 87.5%).</a:t>
             </a:r>
           </a:p>
           <a:p>
@@ -10793,13 +10793,13 @@
               </a:spcAft>
             </a:pPr>
             <a:r>
-              <a:rPr sz="1400" b="0">
+              <a:rPr sz="1600" b="0">
                 <a:solidFill>
                   <a:srgbClr val="0F2830"/>
                 </a:solidFill>
                 <a:latin typeface="Calibri"/>
               </a:rPr>
-              <a:t>RF also has higher accuracy (+10.7 pts) and precision (+17.2 pts) — fewer false “creditworthy” labels.</a:t>
+              <a:t>RF accuracy +10.7 pts and precision +17.2 pts — fewer false “creditworthy” labels.</a:t>
             </a:r>
           </a:p>
         </p:txBody>
@@ -10812,8 +10812,8 @@
         </p:nvSpPr>
         <p:spPr>
           <a:xfrm>
-            <a:off x="8229600" y="1417320"/>
-            <a:ext cx="3520440" cy="3063240"/>
+            <a:off x="8229600" y="1371600"/>
+            <a:ext cx="3520440" cy="3108960"/>
           </a:xfrm>
           <a:prstGeom prst="roundRect">
             <a:avLst>
@@ -10858,7 +10858,7 @@
         </p:nvSpPr>
         <p:spPr>
           <a:xfrm>
-            <a:off x="8412480" y="1554480"/>
+            <a:off x="8412480" y="1481328"/>
             <a:ext cx="3200400" cy="320040"/>
           </a:xfrm>
           <a:prstGeom prst="rect">
@@ -10878,7 +10878,7 @@
               </a:spcAft>
             </a:pPr>
             <a:r>
-              <a:rPr sz="1400" b="1">
+              <a:rPr sz="1600" b="1">
                 <a:solidFill>
                   <a:srgbClr val="239688"/>
                 </a:solidFill>
@@ -10897,8 +10897,8 @@
         </p:nvSpPr>
         <p:spPr>
           <a:xfrm>
-            <a:off x="8412480" y="1920240"/>
-            <a:ext cx="3200400" cy="320040"/>
+            <a:off x="8412480" y="1828800"/>
+            <a:ext cx="3200400" cy="274320"/>
           </a:xfrm>
           <a:prstGeom prst="rect">
             <a:avLst/>
@@ -10917,7 +10917,7 @@
               </a:spcAft>
             </a:pPr>
             <a:r>
-              <a:rPr sz="1300" b="0">
+              <a:rPr sz="1500" b="0">
                 <a:solidFill>
                   <a:srgbClr val="D8E8E4"/>
                 </a:solidFill>
@@ -10936,8 +10936,8 @@
         </p:nvSpPr>
         <p:spPr>
           <a:xfrm>
-            <a:off x="8412480" y="2331720"/>
-            <a:ext cx="2011680" cy="228600"/>
+            <a:off x="8412480" y="2240280"/>
+            <a:ext cx="3200400" cy="256032"/>
           </a:xfrm>
           <a:prstGeom prst="rect">
             <a:avLst/>
@@ -10956,13 +10956,13 @@
               </a:spcAft>
             </a:pPr>
             <a:r>
-              <a:rPr sz="1200" b="0">
-                <a:solidFill>
-                  <a:srgbClr val="D8E8E4"/>
-                </a:solidFill>
-                <a:latin typeface="Calibri"/>
-              </a:rPr>
-              <a:t>True Negative</a:t>
+              <a:rPr sz="1700" b="1">
+                <a:solidFill>
+                  <a:srgbClr val="FFFFFF"/>
+                </a:solidFill>
+                <a:latin typeface="Calibri"/>
+              </a:rPr>
+              <a:t>TN 116</a:t>
             </a:r>
           </a:p>
         </p:txBody>
@@ -10975,47 +10975,86 @@
         </p:nvSpPr>
         <p:spPr>
           <a:xfrm>
-            <a:off x="10424160" y="2331720"/>
-            <a:ext cx="1097280" cy="228600"/>
-          </a:xfrm>
-          <a:prstGeom prst="rect">
-            <a:avLst/>
-          </a:prstGeom>
-          <a:noFill/>
-        </p:spPr>
-        <p:txBody>
-          <a:bodyPr wrap="square">
-            <a:spAutoFit/>
-          </a:bodyPr>
-          <a:lstStyle/>
-          <a:p>
-            <a:pPr algn="r">
-              <a:spcAft>
-                <a:spcPts val="400"/>
-              </a:spcAft>
-            </a:pPr>
-            <a:r>
-              <a:rPr sz="1400" b="1">
+            <a:off x="8412480" y="2478024"/>
+            <a:ext cx="3200400" cy="256032"/>
+          </a:xfrm>
+          <a:prstGeom prst="rect">
+            <a:avLst/>
+          </a:prstGeom>
+          <a:noFill/>
+        </p:spPr>
+        <p:txBody>
+          <a:bodyPr wrap="square">
+            <a:spAutoFit/>
+          </a:bodyPr>
+          <a:lstStyle/>
+          <a:p>
+            <a:pPr algn="l">
+              <a:spcAft>
+                <a:spcPts val="400"/>
+              </a:spcAft>
+            </a:pPr>
+            <a:r>
+              <a:rPr sz="1400" b="0">
+                <a:solidFill>
+                  <a:srgbClr val="9BC4BA"/>
+                </a:solidFill>
+                <a:latin typeface="Calibri"/>
+              </a:rPr>
+              <a:t>Correct higher-risk</a:t>
+            </a:r>
+          </a:p>
+        </p:txBody>
+      </p:sp>
+      <p:sp>
+        <p:nvSpPr>
+          <p:cNvPr id="35" name="TextBox 34"/>
+          <p:cNvSpPr txBox="1"/>
+          <p:nvPr/>
+        </p:nvSpPr>
+        <p:spPr>
+          <a:xfrm>
+            <a:off x="8412480" y="2743200"/>
+            <a:ext cx="3200400" cy="256032"/>
+          </a:xfrm>
+          <a:prstGeom prst="rect">
+            <a:avLst/>
+          </a:prstGeom>
+          <a:noFill/>
+        </p:spPr>
+        <p:txBody>
+          <a:bodyPr wrap="square">
+            <a:spAutoFit/>
+          </a:bodyPr>
+          <a:lstStyle/>
+          <a:p>
+            <a:pPr algn="l">
+              <a:spcAft>
+                <a:spcPts val="400"/>
+              </a:spcAft>
+            </a:pPr>
+            <a:r>
+              <a:rPr sz="1700" b="1">
                 <a:solidFill>
                   <a:srgbClr val="FFFFFF"/>
                 </a:solidFill>
                 <a:latin typeface="Calibri"/>
               </a:rPr>
-              <a:t>116</a:t>
-            </a:r>
-          </a:p>
-        </p:txBody>
-      </p:sp>
-      <p:sp>
-        <p:nvSpPr>
-          <p:cNvPr id="35" name="TextBox 34"/>
-          <p:cNvSpPr txBox="1"/>
-          <p:nvPr/>
-        </p:nvSpPr>
-        <p:spPr>
-          <a:xfrm>
-            <a:off x="8412480" y="2532888"/>
-            <a:ext cx="3108960" cy="228600"/>
+              <a:t>FP 10</a:t>
+            </a:r>
+          </a:p>
+        </p:txBody>
+      </p:sp>
+      <p:sp>
+        <p:nvSpPr>
+          <p:cNvPr id="36" name="TextBox 35"/>
+          <p:cNvSpPr txBox="1"/>
+          <p:nvPr/>
+        </p:nvSpPr>
+        <p:spPr>
+          <a:xfrm>
+            <a:off x="8412480" y="2980944"/>
+            <a:ext cx="3200400" cy="256032"/>
           </a:xfrm>
           <a:prstGeom prst="rect">
             <a:avLst/>
@@ -11034,27 +11073,27 @@
               </a:spcAft>
             </a:pPr>
             <a:r>
-              <a:rPr sz="1100" b="0">
+              <a:rPr sz="1400" b="0">
                 <a:solidFill>
                   <a:srgbClr val="9BC4BA"/>
                 </a:solidFill>
                 <a:latin typeface="Calibri"/>
               </a:rPr>
-              <a:t>Correct higher-risk</a:t>
-            </a:r>
-          </a:p>
-        </p:txBody>
-      </p:sp>
-      <p:sp>
-        <p:nvSpPr>
-          <p:cNvPr id="36" name="TextBox 35"/>
-          <p:cNvSpPr txBox="1"/>
-          <p:nvPr/>
-        </p:nvSpPr>
-        <p:spPr>
-          <a:xfrm>
-            <a:off x="8412480" y="2807208"/>
-            <a:ext cx="2011680" cy="228600"/>
+              <a:t>Wrongly called safe</a:t>
+            </a:r>
+          </a:p>
+        </p:txBody>
+      </p:sp>
+      <p:sp>
+        <p:nvSpPr>
+          <p:cNvPr id="37" name="TextBox 36"/>
+          <p:cNvSpPr txBox="1"/>
+          <p:nvPr/>
+        </p:nvSpPr>
+        <p:spPr>
+          <a:xfrm>
+            <a:off x="8412480" y="3246120"/>
+            <a:ext cx="3200400" cy="256032"/>
           </a:xfrm>
           <a:prstGeom prst="rect">
             <a:avLst/>
@@ -11073,52 +11112,13 @@
               </a:spcAft>
             </a:pPr>
             <a:r>
-              <a:rPr sz="1200" b="0">
-                <a:solidFill>
-                  <a:srgbClr val="D8E8E4"/>
-                </a:solidFill>
-                <a:latin typeface="Calibri"/>
-              </a:rPr>
-              <a:t>False Positive</a:t>
-            </a:r>
-          </a:p>
-        </p:txBody>
-      </p:sp>
-      <p:sp>
-        <p:nvSpPr>
-          <p:cNvPr id="37" name="TextBox 36"/>
-          <p:cNvSpPr txBox="1"/>
-          <p:nvPr/>
-        </p:nvSpPr>
-        <p:spPr>
-          <a:xfrm>
-            <a:off x="10424160" y="2807208"/>
-            <a:ext cx="1097280" cy="228600"/>
-          </a:xfrm>
-          <a:prstGeom prst="rect">
-            <a:avLst/>
-          </a:prstGeom>
-          <a:noFill/>
-        </p:spPr>
-        <p:txBody>
-          <a:bodyPr wrap="square">
-            <a:spAutoFit/>
-          </a:bodyPr>
-          <a:lstStyle/>
-          <a:p>
-            <a:pPr algn="r">
-              <a:spcAft>
-                <a:spcPts val="400"/>
-              </a:spcAft>
-            </a:pPr>
-            <a:r>
-              <a:rPr sz="1400" b="1">
+              <a:rPr sz="1700" b="1">
                 <a:solidFill>
                   <a:srgbClr val="FFFFFF"/>
                 </a:solidFill>
                 <a:latin typeface="Calibri"/>
               </a:rPr>
-              <a:t>10</a:t>
+              <a:t>FN 22</a:t>
             </a:r>
           </a:p>
         </p:txBody>
@@ -11131,8 +11131,8 @@
         </p:nvSpPr>
         <p:spPr>
           <a:xfrm>
-            <a:off x="8412480" y="3008376"/>
-            <a:ext cx="3108960" cy="228600"/>
+            <a:off x="8412480" y="3483864"/>
+            <a:ext cx="3200400" cy="256032"/>
           </a:xfrm>
           <a:prstGeom prst="rect">
             <a:avLst/>
@@ -11151,13 +11151,13 @@
               </a:spcAft>
             </a:pPr>
             <a:r>
-              <a:rPr sz="1100" b="0">
+              <a:rPr sz="1400" b="0">
                 <a:solidFill>
                   <a:srgbClr val="9BC4BA"/>
                 </a:solidFill>
                 <a:latin typeface="Calibri"/>
               </a:rPr>
-              <a:t>Wrongly called safe</a:t>
+              <a:t>Missed creditworthy</a:t>
             </a:r>
           </a:p>
         </p:txBody>
@@ -11170,8 +11170,8 @@
         </p:nvSpPr>
         <p:spPr>
           <a:xfrm>
-            <a:off x="8412480" y="3282696"/>
-            <a:ext cx="2011680" cy="228600"/>
+            <a:off x="8412480" y="3749040"/>
+            <a:ext cx="3200400" cy="256032"/>
           </a:xfrm>
           <a:prstGeom prst="rect">
             <a:avLst/>
@@ -11190,13 +11190,13 @@
               </a:spcAft>
             </a:pPr>
             <a:r>
-              <a:rPr sz="1200" b="0">
-                <a:solidFill>
-                  <a:srgbClr val="D8E8E4"/>
-                </a:solidFill>
-                <a:latin typeface="Calibri"/>
-              </a:rPr>
-              <a:t>False Negative</a:t>
+              <a:rPr sz="1700" b="1">
+                <a:solidFill>
+                  <a:srgbClr val="FFFFFF"/>
+                </a:solidFill>
+                <a:latin typeface="Calibri"/>
+              </a:rPr>
+              <a:t>TP 132</a:t>
             </a:r>
           </a:p>
         </p:txBody>
@@ -11209,47 +11209,8 @@
         </p:nvSpPr>
         <p:spPr>
           <a:xfrm>
-            <a:off x="10424160" y="3282696"/>
-            <a:ext cx="1097280" cy="228600"/>
-          </a:xfrm>
-          <a:prstGeom prst="rect">
-            <a:avLst/>
-          </a:prstGeom>
-          <a:noFill/>
-        </p:spPr>
-        <p:txBody>
-          <a:bodyPr wrap="square">
-            <a:spAutoFit/>
-          </a:bodyPr>
-          <a:lstStyle/>
-          <a:p>
-            <a:pPr algn="r">
-              <a:spcAft>
-                <a:spcPts val="400"/>
-              </a:spcAft>
-            </a:pPr>
-            <a:r>
-              <a:rPr sz="1400" b="1">
-                <a:solidFill>
-                  <a:srgbClr val="FFFFFF"/>
-                </a:solidFill>
-                <a:latin typeface="Calibri"/>
-              </a:rPr>
-              <a:t>22</a:t>
-            </a:r>
-          </a:p>
-        </p:txBody>
-      </p:sp>
-      <p:sp>
-        <p:nvSpPr>
-          <p:cNvPr id="41" name="TextBox 40"/>
-          <p:cNvSpPr txBox="1"/>
-          <p:nvPr/>
-        </p:nvSpPr>
-        <p:spPr>
-          <a:xfrm>
-            <a:off x="8412480" y="3483864"/>
-            <a:ext cx="3108960" cy="228600"/>
+            <a:off x="8412480" y="3986784"/>
+            <a:ext cx="3200400" cy="256032"/>
           </a:xfrm>
           <a:prstGeom prst="rect">
             <a:avLst/>
@@ -11268,129 +11229,12 @@
               </a:spcAft>
             </a:pPr>
             <a:r>
-              <a:rPr sz="1100" b="0">
+              <a:rPr sz="1400" b="0">
                 <a:solidFill>
                   <a:srgbClr val="9BC4BA"/>
                 </a:solidFill>
                 <a:latin typeface="Calibri"/>
               </a:rPr>
-              <a:t>Missed creditworthy</a:t>
-            </a:r>
-          </a:p>
-        </p:txBody>
-      </p:sp>
-      <p:sp>
-        <p:nvSpPr>
-          <p:cNvPr id="42" name="TextBox 41"/>
-          <p:cNvSpPr txBox="1"/>
-          <p:nvPr/>
-        </p:nvSpPr>
-        <p:spPr>
-          <a:xfrm>
-            <a:off x="8412480" y="3758183"/>
-            <a:ext cx="2011680" cy="228600"/>
-          </a:xfrm>
-          <a:prstGeom prst="rect">
-            <a:avLst/>
-          </a:prstGeom>
-          <a:noFill/>
-        </p:spPr>
-        <p:txBody>
-          <a:bodyPr wrap="square">
-            <a:spAutoFit/>
-          </a:bodyPr>
-          <a:lstStyle/>
-          <a:p>
-            <a:pPr algn="l">
-              <a:spcAft>
-                <a:spcPts val="400"/>
-              </a:spcAft>
-            </a:pPr>
-            <a:r>
-              <a:rPr sz="1200" b="0">
-                <a:solidFill>
-                  <a:srgbClr val="D8E8E4"/>
-                </a:solidFill>
-                <a:latin typeface="Calibri"/>
-              </a:rPr>
-              <a:t>True Positive</a:t>
-            </a:r>
-          </a:p>
-        </p:txBody>
-      </p:sp>
-      <p:sp>
-        <p:nvSpPr>
-          <p:cNvPr id="43" name="TextBox 42"/>
-          <p:cNvSpPr txBox="1"/>
-          <p:nvPr/>
-        </p:nvSpPr>
-        <p:spPr>
-          <a:xfrm>
-            <a:off x="10424160" y="3758183"/>
-            <a:ext cx="1097280" cy="228600"/>
-          </a:xfrm>
-          <a:prstGeom prst="rect">
-            <a:avLst/>
-          </a:prstGeom>
-          <a:noFill/>
-        </p:spPr>
-        <p:txBody>
-          <a:bodyPr wrap="square">
-            <a:spAutoFit/>
-          </a:bodyPr>
-          <a:lstStyle/>
-          <a:p>
-            <a:pPr algn="r">
-              <a:spcAft>
-                <a:spcPts val="400"/>
-              </a:spcAft>
-            </a:pPr>
-            <a:r>
-              <a:rPr sz="1400" b="1">
-                <a:solidFill>
-                  <a:srgbClr val="FFFFFF"/>
-                </a:solidFill>
-                <a:latin typeface="Calibri"/>
-              </a:rPr>
-              <a:t>132</a:t>
-            </a:r>
-          </a:p>
-        </p:txBody>
-      </p:sp>
-      <p:sp>
-        <p:nvSpPr>
-          <p:cNvPr id="44" name="TextBox 43"/>
-          <p:cNvSpPr txBox="1"/>
-          <p:nvPr/>
-        </p:nvSpPr>
-        <p:spPr>
-          <a:xfrm>
-            <a:off x="8412480" y="3959351"/>
-            <a:ext cx="3108960" cy="228600"/>
-          </a:xfrm>
-          <a:prstGeom prst="rect">
-            <a:avLst/>
-          </a:prstGeom>
-          <a:noFill/>
-        </p:spPr>
-        <p:txBody>
-          <a:bodyPr wrap="square">
-            <a:spAutoFit/>
-          </a:bodyPr>
-          <a:lstStyle/>
-          <a:p>
-            <a:pPr algn="l">
-              <a:spcAft>
-                <a:spcPts val="400"/>
-              </a:spcAft>
-            </a:pPr>
-            <a:r>
-              <a:rPr sz="1100" b="0">
-                <a:solidFill>
-                  <a:srgbClr val="9BC4BA"/>
-                </a:solidFill>
-                <a:latin typeface="Calibri"/>
-              </a:rPr>
               <a:t>Correct creditworthy</a:t>
             </a:r>
           </a:p>
@@ -11398,14 +11242,14 @@
       </p:sp>
       <p:sp>
         <p:nvSpPr>
-          <p:cNvPr id="45" name="Rounded Rectangle 44"/>
+          <p:cNvPr id="41" name="Rounded Rectangle 40"/>
           <p:cNvSpPr/>
           <p:nvPr/>
         </p:nvSpPr>
         <p:spPr>
           <a:xfrm>
-            <a:off x="411480" y="4663440"/>
-            <a:ext cx="11338560" cy="1508760"/>
+            <a:off x="365760" y="4617720"/>
+            <a:ext cx="11430000" cy="1554480"/>
           </a:xfrm>
           <a:prstGeom prst="roundRect">
             <a:avLst>
@@ -11444,39 +11288,195 @@
       </p:sp>
       <p:sp>
         <p:nvSpPr>
+          <p:cNvPr id="42" name="TextBox 41"/>
+          <p:cNvSpPr txBox="1"/>
+          <p:nvPr/>
+        </p:nvSpPr>
+        <p:spPr>
+          <a:xfrm>
+            <a:off x="594360" y="4709160"/>
+            <a:ext cx="10972800" cy="292608"/>
+          </a:xfrm>
+          <a:prstGeom prst="rect">
+            <a:avLst/>
+          </a:prstGeom>
+          <a:noFill/>
+        </p:spPr>
+        <p:txBody>
+          <a:bodyPr wrap="square">
+            <a:spAutoFit/>
+          </a:bodyPr>
+          <a:lstStyle/>
+          <a:p>
+            <a:pPr algn="l">
+              <a:spcAft>
+                <a:spcPts val="400"/>
+              </a:spcAft>
+            </a:pPr>
+            <a:r>
+              <a:rPr sz="1600" b="1">
+                <a:solidFill>
+                  <a:srgbClr val="0B3D2E"/>
+                </a:solidFill>
+                <a:latin typeface="Calibri"/>
+              </a:rPr>
+              <a:t>What drove RF decisions (feature importance)</a:t>
+            </a:r>
+          </a:p>
+        </p:txBody>
+      </p:sp>
+      <p:sp>
+        <p:nvSpPr>
+          <p:cNvPr id="43" name="TextBox 42"/>
+          <p:cNvSpPr txBox="1"/>
+          <p:nvPr/>
+        </p:nvSpPr>
+        <p:spPr>
+          <a:xfrm>
+            <a:off x="548640" y="5074920"/>
+            <a:ext cx="1828800" cy="320040"/>
+          </a:xfrm>
+          <a:prstGeom prst="rect">
+            <a:avLst/>
+          </a:prstGeom>
+          <a:noFill/>
+        </p:spPr>
+        <p:txBody>
+          <a:bodyPr wrap="square">
+            <a:spAutoFit/>
+          </a:bodyPr>
+          <a:lstStyle/>
+          <a:p>
+            <a:pPr algn="ctr">
+              <a:spcAft>
+                <a:spcPts val="400"/>
+              </a:spcAft>
+            </a:pPr>
+            <a:r>
+              <a:rPr sz="2000" b="1">
+                <a:solidFill>
+                  <a:srgbClr val="1A7A6D"/>
+                </a:solidFill>
+                <a:latin typeface="Calibri"/>
+              </a:rPr>
+              <a:t>19.8%</a:t>
+            </a:r>
+          </a:p>
+        </p:txBody>
+      </p:sp>
+      <p:sp>
+        <p:nvSpPr>
+          <p:cNvPr id="44" name="TextBox 43"/>
+          <p:cNvSpPr txBox="1"/>
+          <p:nvPr/>
+        </p:nvSpPr>
+        <p:spPr>
+          <a:xfrm>
+            <a:off x="548640" y="5486400"/>
+            <a:ext cx="1828800" cy="411480"/>
+          </a:xfrm>
+          <a:prstGeom prst="rect">
+            <a:avLst/>
+          </a:prstGeom>
+          <a:noFill/>
+        </p:spPr>
+        <p:txBody>
+          <a:bodyPr wrap="square">
+            <a:spAutoFit/>
+          </a:bodyPr>
+          <a:lstStyle/>
+          <a:p>
+            <a:pPr algn="ctr">
+              <a:spcAft>
+                <a:spcPts val="400"/>
+              </a:spcAft>
+            </a:pPr>
+            <a:r>
+              <a:rPr sz="1500" b="0">
+                <a:solidFill>
+                  <a:srgbClr val="3D525A"/>
+                </a:solidFill>
+                <a:latin typeface="Calibri"/>
+              </a:rPr>
+              <a:t>On-time rate</a:t>
+            </a:r>
+          </a:p>
+        </p:txBody>
+      </p:sp>
+      <p:sp>
+        <p:nvSpPr>
+          <p:cNvPr id="45" name="TextBox 44"/>
+          <p:cNvSpPr txBox="1"/>
+          <p:nvPr/>
+        </p:nvSpPr>
+        <p:spPr>
+          <a:xfrm>
+            <a:off x="2468880" y="5074920"/>
+            <a:ext cx="1828800" cy="320040"/>
+          </a:xfrm>
+          <a:prstGeom prst="rect">
+            <a:avLst/>
+          </a:prstGeom>
+          <a:noFill/>
+        </p:spPr>
+        <p:txBody>
+          <a:bodyPr wrap="square">
+            <a:spAutoFit/>
+          </a:bodyPr>
+          <a:lstStyle/>
+          <a:p>
+            <a:pPr algn="ctr">
+              <a:spcAft>
+                <a:spcPts val="400"/>
+              </a:spcAft>
+            </a:pPr>
+            <a:r>
+              <a:rPr sz="2000" b="1">
+                <a:solidFill>
+                  <a:srgbClr val="1A7A6D"/>
+                </a:solidFill>
+                <a:latin typeface="Calibri"/>
+              </a:rPr>
+              <a:t>18.7%</a:t>
+            </a:r>
+          </a:p>
+        </p:txBody>
+      </p:sp>
+      <p:sp>
+        <p:nvSpPr>
           <p:cNvPr id="46" name="TextBox 45"/>
           <p:cNvSpPr txBox="1"/>
           <p:nvPr/>
         </p:nvSpPr>
         <p:spPr>
           <a:xfrm>
-            <a:off x="640080" y="4754880"/>
-            <a:ext cx="10972800" cy="274320"/>
-          </a:xfrm>
-          <a:prstGeom prst="rect">
-            <a:avLst/>
-          </a:prstGeom>
-          <a:noFill/>
-        </p:spPr>
-        <p:txBody>
-          <a:bodyPr wrap="square">
-            <a:spAutoFit/>
-          </a:bodyPr>
-          <a:lstStyle/>
-          <a:p>
-            <a:pPr algn="l">
-              <a:spcAft>
-                <a:spcPts val="400"/>
-              </a:spcAft>
-            </a:pPr>
-            <a:r>
-              <a:rPr sz="1400" b="1">
-                <a:solidFill>
-                  <a:srgbClr val="0B3D2E"/>
-                </a:solidFill>
-                <a:latin typeface="Calibri"/>
-              </a:rPr>
-              <a:t>What drove the RF decisions (feature importance from the same training run)</a:t>
+            <a:off x="2468880" y="5486400"/>
+            <a:ext cx="1828800" cy="411480"/>
+          </a:xfrm>
+          <a:prstGeom prst="rect">
+            <a:avLst/>
+          </a:prstGeom>
+          <a:noFill/>
+        </p:spPr>
+        <p:txBody>
+          <a:bodyPr wrap="square">
+            <a:spAutoFit/>
+          </a:bodyPr>
+          <a:lstStyle/>
+          <a:p>
+            <a:pPr algn="ctr">
+              <a:spcAft>
+                <a:spcPts val="400"/>
+              </a:spcAft>
+            </a:pPr>
+            <a:r>
+              <a:rPr sz="1500" b="0">
+                <a:solidFill>
+                  <a:srgbClr val="3D525A"/>
+                </a:solidFill>
+                <a:latin typeface="Calibri"/>
+              </a:rPr>
+              <a:t>Default rate</a:t>
             </a:r>
           </a:p>
         </p:txBody>
@@ -11489,8 +11489,8 @@
         </p:nvSpPr>
         <p:spPr>
           <a:xfrm>
-            <a:off x="640080" y="5120640"/>
-            <a:ext cx="1783080" cy="274320"/>
+            <a:off x="4389120" y="5074920"/>
+            <a:ext cx="1828800" cy="320040"/>
           </a:xfrm>
           <a:prstGeom prst="rect">
             <a:avLst/>
@@ -11509,13 +11509,13 @@
               </a:spcAft>
             </a:pPr>
             <a:r>
-              <a:rPr sz="1800" b="1">
+              <a:rPr sz="2000" b="1">
                 <a:solidFill>
                   <a:srgbClr val="1A7A6D"/>
                 </a:solidFill>
                 <a:latin typeface="Calibri"/>
               </a:rPr>
-              <a:t>19.8%</a:t>
+              <a:t>8.3%</a:t>
             </a:r>
           </a:p>
         </p:txBody>
@@ -11528,8 +11528,8 @@
         </p:nvSpPr>
         <p:spPr>
           <a:xfrm>
-            <a:off x="640080" y="5486400"/>
-            <a:ext cx="1783080" cy="411480"/>
+            <a:off x="4389120" y="5486400"/>
+            <a:ext cx="1828800" cy="411480"/>
           </a:xfrm>
           <a:prstGeom prst="rect">
             <a:avLst/>
@@ -11548,13 +11548,13 @@
               </a:spcAft>
             </a:pPr>
             <a:r>
-              <a:rPr sz="1300" b="0">
+              <a:rPr sz="1500" b="0">
                 <a:solidFill>
                   <a:srgbClr val="3D525A"/>
                 </a:solidFill>
                 <a:latin typeface="Calibri"/>
               </a:rPr>
-              <a:t>On-time rate</a:t>
+              <a:t>Order-type mix</a:t>
             </a:r>
           </a:p>
         </p:txBody>
@@ -11567,8 +11567,8 @@
         </p:nvSpPr>
         <p:spPr>
           <a:xfrm>
-            <a:off x="2514600" y="5120640"/>
-            <a:ext cx="1783080" cy="274320"/>
+            <a:off x="6309360" y="5074920"/>
+            <a:ext cx="1828800" cy="320040"/>
           </a:xfrm>
           <a:prstGeom prst="rect">
             <a:avLst/>
@@ -11587,13 +11587,13 @@
               </a:spcAft>
             </a:pPr>
             <a:r>
-              <a:rPr sz="1800" b="1">
+              <a:rPr sz="2000" b="1">
                 <a:solidFill>
                   <a:srgbClr val="1A7A6D"/>
                 </a:solidFill>
                 <a:latin typeface="Calibri"/>
               </a:rPr>
-              <a:t>18.7%</a:t>
+              <a:t>5.5%</a:t>
             </a:r>
           </a:p>
         </p:txBody>
@@ -11606,8 +11606,8 @@
         </p:nvSpPr>
         <p:spPr>
           <a:xfrm>
-            <a:off x="2514600" y="5486400"/>
-            <a:ext cx="1783080" cy="411480"/>
+            <a:off x="6309360" y="5486400"/>
+            <a:ext cx="1828800" cy="411480"/>
           </a:xfrm>
           <a:prstGeom prst="rect">
             <a:avLst/>
@@ -11626,13 +11626,13 @@
               </a:spcAft>
             </a:pPr>
             <a:r>
-              <a:rPr sz="1300" b="0">
+              <a:rPr sz="1500" b="0">
                 <a:solidFill>
                   <a:srgbClr val="3D525A"/>
                 </a:solidFill>
                 <a:latin typeface="Calibri"/>
               </a:rPr>
-              <a:t>Default rate</a:t>
+              <a:t>Account age</a:t>
             </a:r>
           </a:p>
         </p:txBody>
@@ -11645,8 +11645,8 @@
         </p:nvSpPr>
         <p:spPr>
           <a:xfrm>
-            <a:off x="4389120" y="5120640"/>
-            <a:ext cx="1783080" cy="274320"/>
+            <a:off x="8229600" y="5074920"/>
+            <a:ext cx="1828800" cy="320040"/>
           </a:xfrm>
           <a:prstGeom prst="rect">
             <a:avLst/>
@@ -11665,13 +11665,13 @@
               </a:spcAft>
             </a:pPr>
             <a:r>
-              <a:rPr sz="1800" b="1">
+              <a:rPr sz="2000" b="1">
                 <a:solidFill>
                   <a:srgbClr val="1A7A6D"/>
                 </a:solidFill>
                 <a:latin typeface="Calibri"/>
               </a:rPr>
-              <a:t>8.3%</a:t>
+              <a:t>4.6%</a:t>
             </a:r>
           </a:p>
         </p:txBody>
@@ -11684,8 +11684,8 @@
         </p:nvSpPr>
         <p:spPr>
           <a:xfrm>
-            <a:off x="4389120" y="5486400"/>
-            <a:ext cx="1783080" cy="411480"/>
+            <a:off x="8229600" y="5486400"/>
+            <a:ext cx="1828800" cy="411480"/>
           </a:xfrm>
           <a:prstGeom prst="rect">
             <a:avLst/>
@@ -11704,13 +11704,13 @@
               </a:spcAft>
             </a:pPr>
             <a:r>
-              <a:rPr sz="1300" b="0">
+              <a:rPr sz="1500" b="0">
                 <a:solidFill>
                   <a:srgbClr val="3D525A"/>
                 </a:solidFill>
                 <a:latin typeface="Calibri"/>
               </a:rPr>
-              <a:t>Order-type mix</a:t>
+              <a:t>Buyer share</a:t>
             </a:r>
           </a:p>
         </p:txBody>
@@ -11723,8 +11723,8 @@
         </p:nvSpPr>
         <p:spPr>
           <a:xfrm>
-            <a:off x="6263640" y="5120640"/>
-            <a:ext cx="1783080" cy="274320"/>
+            <a:off x="10149840" y="5074920"/>
+            <a:ext cx="1828800" cy="320040"/>
           </a:xfrm>
           <a:prstGeom prst="rect">
             <a:avLst/>
@@ -11743,13 +11743,13 @@
               </a:spcAft>
             </a:pPr>
             <a:r>
-              <a:rPr sz="1800" b="1">
+              <a:rPr sz="2000" b="1">
                 <a:solidFill>
                   <a:srgbClr val="1A7A6D"/>
                 </a:solidFill>
                 <a:latin typeface="Calibri"/>
               </a:rPr>
-              <a:t>5.5%</a:t>
+              <a:t>4.4%</a:t>
             </a:r>
           </a:p>
         </p:txBody>
@@ -11762,8 +11762,8 @@
         </p:nvSpPr>
         <p:spPr>
           <a:xfrm>
-            <a:off x="6263640" y="5486400"/>
-            <a:ext cx="1783080" cy="411480"/>
+            <a:off x="10149840" y="5486400"/>
+            <a:ext cx="1828800" cy="411480"/>
           </a:xfrm>
           <a:prstGeom prst="rect">
             <a:avLst/>
@@ -11782,168 +11782,12 @@
               </a:spcAft>
             </a:pPr>
             <a:r>
-              <a:rPr sz="1300" b="0">
+              <a:rPr sz="1500" b="0">
                 <a:solidFill>
                   <a:srgbClr val="3D525A"/>
                 </a:solidFill>
                 <a:latin typeface="Calibri"/>
               </a:rPr>
-              <a:t>Account age</a:t>
-            </a:r>
-          </a:p>
-        </p:txBody>
-      </p:sp>
-      <p:sp>
-        <p:nvSpPr>
-          <p:cNvPr id="55" name="TextBox 54"/>
-          <p:cNvSpPr txBox="1"/>
-          <p:nvPr/>
-        </p:nvSpPr>
-        <p:spPr>
-          <a:xfrm>
-            <a:off x="8138159" y="5120640"/>
-            <a:ext cx="1783080" cy="274320"/>
-          </a:xfrm>
-          <a:prstGeom prst="rect">
-            <a:avLst/>
-          </a:prstGeom>
-          <a:noFill/>
-        </p:spPr>
-        <p:txBody>
-          <a:bodyPr wrap="square">
-            <a:spAutoFit/>
-          </a:bodyPr>
-          <a:lstStyle/>
-          <a:p>
-            <a:pPr algn="ctr">
-              <a:spcAft>
-                <a:spcPts val="400"/>
-              </a:spcAft>
-            </a:pPr>
-            <a:r>
-              <a:rPr sz="1800" b="1">
-                <a:solidFill>
-                  <a:srgbClr val="1A7A6D"/>
-                </a:solidFill>
-                <a:latin typeface="Calibri"/>
-              </a:rPr>
-              <a:t>4.6%</a:t>
-            </a:r>
-          </a:p>
-        </p:txBody>
-      </p:sp>
-      <p:sp>
-        <p:nvSpPr>
-          <p:cNvPr id="56" name="TextBox 55"/>
-          <p:cNvSpPr txBox="1"/>
-          <p:nvPr/>
-        </p:nvSpPr>
-        <p:spPr>
-          <a:xfrm>
-            <a:off x="8138159" y="5486400"/>
-            <a:ext cx="1783080" cy="411480"/>
-          </a:xfrm>
-          <a:prstGeom prst="rect">
-            <a:avLst/>
-          </a:prstGeom>
-          <a:noFill/>
-        </p:spPr>
-        <p:txBody>
-          <a:bodyPr wrap="square">
-            <a:spAutoFit/>
-          </a:bodyPr>
-          <a:lstStyle/>
-          <a:p>
-            <a:pPr algn="ctr">
-              <a:spcAft>
-                <a:spcPts val="400"/>
-              </a:spcAft>
-            </a:pPr>
-            <a:r>
-              <a:rPr sz="1300" b="0">
-                <a:solidFill>
-                  <a:srgbClr val="3D525A"/>
-                </a:solidFill>
-                <a:latin typeface="Calibri"/>
-              </a:rPr>
-              <a:t>Buyer share</a:t>
-            </a:r>
-          </a:p>
-        </p:txBody>
-      </p:sp>
-      <p:sp>
-        <p:nvSpPr>
-          <p:cNvPr id="57" name="TextBox 56"/>
-          <p:cNvSpPr txBox="1"/>
-          <p:nvPr/>
-        </p:nvSpPr>
-        <p:spPr>
-          <a:xfrm>
-            <a:off x="10012680" y="5120640"/>
-            <a:ext cx="1783080" cy="274320"/>
-          </a:xfrm>
-          <a:prstGeom prst="rect">
-            <a:avLst/>
-          </a:prstGeom>
-          <a:noFill/>
-        </p:spPr>
-        <p:txBody>
-          <a:bodyPr wrap="square">
-            <a:spAutoFit/>
-          </a:bodyPr>
-          <a:lstStyle/>
-          <a:p>
-            <a:pPr algn="ctr">
-              <a:spcAft>
-                <a:spcPts val="400"/>
-              </a:spcAft>
-            </a:pPr>
-            <a:r>
-              <a:rPr sz="1800" b="1">
-                <a:solidFill>
-                  <a:srgbClr val="1A7A6D"/>
-                </a:solidFill>
-                <a:latin typeface="Calibri"/>
-              </a:rPr>
-              <a:t>4.4%</a:t>
-            </a:r>
-          </a:p>
-        </p:txBody>
-      </p:sp>
-      <p:sp>
-        <p:nvSpPr>
-          <p:cNvPr id="58" name="TextBox 57"/>
-          <p:cNvSpPr txBox="1"/>
-          <p:nvPr/>
-        </p:nvSpPr>
-        <p:spPr>
-          <a:xfrm>
-            <a:off x="10012680" y="5486400"/>
-            <a:ext cx="1783080" cy="411480"/>
-          </a:xfrm>
-          <a:prstGeom prst="rect">
-            <a:avLst/>
-          </a:prstGeom>
-          <a:noFill/>
-        </p:spPr>
-        <p:txBody>
-          <a:bodyPr wrap="square">
-            <a:spAutoFit/>
-          </a:bodyPr>
-          <a:lstStyle/>
-          <a:p>
-            <a:pPr algn="ctr">
-              <a:spcAft>
-                <a:spcPts val="400"/>
-              </a:spcAft>
-            </a:pPr>
-            <a:r>
-              <a:rPr sz="1300" b="0">
-                <a:solidFill>
-                  <a:srgbClr val="3D525A"/>
-                </a:solidFill>
-                <a:latin typeface="Calibri"/>
-              </a:rPr>
               <a:t>Tx frequency</a:t>
             </a:r>
           </a:p>
@@ -11951,14 +11795,14 @@
       </p:sp>
       <p:sp>
         <p:nvSpPr>
-          <p:cNvPr id="59" name="Rectangle 58"/>
+          <p:cNvPr id="55" name="Rectangle 54"/>
           <p:cNvSpPr/>
           <p:nvPr/>
         </p:nvSpPr>
         <p:spPr>
           <a:xfrm>
-            <a:off x="0" y="6537960"/>
-            <a:ext cx="12191695" cy="320040"/>
+            <a:off x="0" y="6510528"/>
+            <a:ext cx="12191695" cy="347472"/>
           </a:xfrm>
           <a:prstGeom prst="rect">
             <a:avLst/>
@@ -11995,14 +11839,14 @@
       </p:sp>
       <p:sp>
         <p:nvSpPr>
-          <p:cNvPr id="60" name="TextBox 59"/>
-          <p:cNvSpPr txBox="1"/>
-          <p:nvPr/>
-        </p:nvSpPr>
-        <p:spPr>
-          <a:xfrm>
-            <a:off x="411480" y="6565392"/>
-            <a:ext cx="9144000" cy="256032"/>
+          <p:cNvPr id="56" name="TextBox 55"/>
+          <p:cNvSpPr txBox="1"/>
+          <p:nvPr/>
+        </p:nvSpPr>
+        <p:spPr>
+          <a:xfrm>
+            <a:off x="411480" y="6547104"/>
+            <a:ext cx="9144000" cy="274320"/>
           </a:xfrm>
           <a:prstGeom prst="rect">
             <a:avLst/>
@@ -12021,7 +11865,7 @@
               </a:spcAft>
             </a:pPr>
             <a:r>
-              <a:rPr sz="1200" b="0">
+              <a:rPr sz="1400" b="0">
                 <a:solidFill>
                   <a:srgbClr val="B8D0C8"/>
                 </a:solidFill>
@@ -12034,14 +11878,14 @@
       </p:sp>
       <p:sp>
         <p:nvSpPr>
-          <p:cNvPr id="61" name="TextBox 60"/>
-          <p:cNvSpPr txBox="1"/>
-          <p:nvPr/>
-        </p:nvSpPr>
-        <p:spPr>
-          <a:xfrm>
-            <a:off x="10241280" y="6565392"/>
-            <a:ext cx="1554480" cy="256032"/>
+          <p:cNvPr id="57" name="TextBox 56"/>
+          <p:cNvSpPr txBox="1"/>
+          <p:nvPr/>
+        </p:nvSpPr>
+        <p:spPr>
+          <a:xfrm>
+            <a:off x="10241280" y="6547104"/>
+            <a:ext cx="1554480" cy="274320"/>
           </a:xfrm>
           <a:prstGeom prst="rect">
             <a:avLst/>
@@ -12060,7 +11904,7 @@
               </a:spcAft>
             </a:pPr>
             <a:r>
-              <a:rPr sz="1200" b="0">
+              <a:rPr sz="1400" b="0">
                 <a:solidFill>
                   <a:srgbClr val="B8D0C8"/>
                 </a:solidFill>
@@ -12227,7 +12071,7 @@
                                           </p:stCondLst>
                                         </p:cTn>
                                         <p:tgtEl>
-                                          <p:spTgt spid="45"/>
+                                          <p:spTgt spid="41"/>
                                         </p:tgtEl>
                                         <p:attrNameLst>
                                           <p:attrName>style.visibility</p:attrName>
@@ -12241,7 +12085,7 @@
                                       <p:cBhvr>
                                         <p:cTn id="17" dur="350"/>
                                         <p:tgtEl>
-                                          <p:spTgt spid="45"/>
+                                          <p:spTgt spid="41"/>
                                         </p:tgtEl>
                                       </p:cBhvr>
                                     </p:animEffect>
@@ -12279,7 +12123,7 @@
       <p:bldP spid="2" grpId="0" animBg="1"/>
       <p:bldP spid="7" grpId="0" animBg="1"/>
       <p:bldP spid="30" grpId="0" animBg="1"/>
-      <p:bldP spid="45" grpId="0" animBg="1"/>
+      <p:bldP spid="41" grpId="0" animBg="1"/>
     </p:bldLst>
   </p:timing>
 </p:sld>
@@ -12354,8 +12198,8 @@
         </p:nvSpPr>
         <p:spPr>
           <a:xfrm>
-            <a:off x="502920" y="201168"/>
-            <a:ext cx="10972800" cy="274320"/>
+            <a:off x="502920" y="164592"/>
+            <a:ext cx="10972800" cy="292608"/>
           </a:xfrm>
           <a:prstGeom prst="rect">
             <a:avLst/>
@@ -12374,7 +12218,7 @@
               </a:spcAft>
             </a:pPr>
             <a:r>
-              <a:rPr sz="1300" b="1">
+              <a:rPr sz="1600" b="1">
                 <a:solidFill>
                   <a:srgbClr val="1A7A6D"/>
                 </a:solidFill>
@@ -12393,8 +12237,8 @@
         </p:nvSpPr>
         <p:spPr>
           <a:xfrm>
-            <a:off x="502920" y="502920"/>
-            <a:ext cx="109728" cy="475488"/>
+            <a:off x="502920" y="475488"/>
+            <a:ext cx="109728" cy="502920"/>
           </a:xfrm>
           <a:prstGeom prst="rect">
             <a:avLst/>
@@ -12437,8 +12281,8 @@
         </p:nvSpPr>
         <p:spPr>
           <a:xfrm>
-            <a:off x="777240" y="438912"/>
-            <a:ext cx="10698480" cy="502920"/>
+            <a:off x="777240" y="411480"/>
+            <a:ext cx="10698480" cy="530352"/>
           </a:xfrm>
           <a:prstGeom prst="rect">
             <a:avLst/>
@@ -12457,7 +12301,7 @@
               </a:spcAft>
             </a:pPr>
             <a:r>
-              <a:rPr sz="2800" b="1">
+              <a:rPr sz="3000" b="1">
                 <a:solidFill>
                   <a:srgbClr val="0B3D2E"/>
                 </a:solidFill>
@@ -12477,7 +12321,7 @@
         <p:spPr>
           <a:xfrm>
             <a:off x="411480" y="1417320"/>
-            <a:ext cx="3657600" cy="1691640"/>
+            <a:ext cx="3657600" cy="1737360"/>
           </a:xfrm>
           <a:prstGeom prst="roundRect">
             <a:avLst>
@@ -12523,7 +12367,7 @@
         <p:spPr>
           <a:xfrm>
             <a:off x="411480" y="1417320"/>
-            <a:ext cx="3657600" cy="411480"/>
+            <a:ext cx="3657600" cy="438912"/>
           </a:xfrm>
           <a:prstGeom prst="rect">
             <a:avLst/>
@@ -12586,7 +12430,7 @@
               </a:spcAft>
             </a:pPr>
             <a:r>
-              <a:rPr sz="1400" b="1">
+              <a:rPr sz="1500" b="1">
                 <a:solidFill>
                   <a:srgbClr val="FFFFFF"/>
                 </a:solidFill>
@@ -12605,8 +12449,8 @@
         </p:nvSpPr>
         <p:spPr>
           <a:xfrm>
-            <a:off x="3108960" y="1481328"/>
-            <a:ext cx="822960" cy="310896"/>
+            <a:off x="3063240" y="1481328"/>
+            <a:ext cx="868680" cy="329184"/>
           </a:xfrm>
           <a:prstGeom prst="roundRect">
             <a:avLst>
@@ -12651,8 +12495,8 @@
         </p:nvSpPr>
         <p:spPr>
           <a:xfrm>
-            <a:off x="3108960" y="1499616"/>
-            <a:ext cx="822960" cy="274320"/>
+            <a:off x="3063240" y="1499616"/>
+            <a:ext cx="868680" cy="292608"/>
           </a:xfrm>
           <a:prstGeom prst="rect">
             <a:avLst/>
@@ -12671,7 +12515,7 @@
               </a:spcAft>
             </a:pPr>
             <a:r>
-              <a:rPr sz="1200" b="1">
+              <a:rPr sz="1400" b="1">
                 <a:solidFill>
                   <a:srgbClr val="FFFFFF"/>
                 </a:solidFill>
@@ -12691,7 +12535,7 @@
         <p:spPr>
           <a:xfrm>
             <a:off x="594360" y="2011680"/>
-            <a:ext cx="3291840" cy="914400"/>
+            <a:ext cx="3291840" cy="960120"/>
           </a:xfrm>
           <a:prstGeom prst="rect">
             <a:avLst/>
@@ -12710,7 +12554,7 @@
               </a:spcAft>
             </a:pPr>
             <a:r>
-              <a:rPr sz="1400" b="0">
+              <a:rPr sz="1600" b="0">
                 <a:solidFill>
                   <a:srgbClr val="3D525A"/>
                 </a:solidFill>
@@ -12730,7 +12574,7 @@
         <p:spPr>
           <a:xfrm>
             <a:off x="4251960" y="1417320"/>
-            <a:ext cx="3657600" cy="1691640"/>
+            <a:ext cx="3657600" cy="1737360"/>
           </a:xfrm>
           <a:prstGeom prst="roundRect">
             <a:avLst>
@@ -12776,7 +12620,7 @@
         <p:spPr>
           <a:xfrm>
             <a:off x="4251960" y="1417320"/>
-            <a:ext cx="3657600" cy="411480"/>
+            <a:ext cx="3657600" cy="438912"/>
           </a:xfrm>
           <a:prstGeom prst="rect">
             <a:avLst/>
@@ -12839,7 +12683,7 @@
               </a:spcAft>
             </a:pPr>
             <a:r>
-              <a:rPr sz="1400" b="1">
+              <a:rPr sz="1500" b="1">
                 <a:solidFill>
                   <a:srgbClr val="FFFFFF"/>
                 </a:solidFill>
@@ -12858,8 +12702,8 @@
         </p:nvSpPr>
         <p:spPr>
           <a:xfrm>
-            <a:off x="6949440" y="1481328"/>
-            <a:ext cx="822960" cy="310896"/>
+            <a:off x="6903720" y="1481328"/>
+            <a:ext cx="868680" cy="329184"/>
           </a:xfrm>
           <a:prstGeom prst="roundRect">
             <a:avLst>
@@ -12904,8 +12748,8 @@
         </p:nvSpPr>
         <p:spPr>
           <a:xfrm>
-            <a:off x="6949440" y="1499616"/>
-            <a:ext cx="822960" cy="274320"/>
+            <a:off x="6903720" y="1499616"/>
+            <a:ext cx="868680" cy="292608"/>
           </a:xfrm>
           <a:prstGeom prst="rect">
             <a:avLst/>
@@ -12924,7 +12768,7 @@
               </a:spcAft>
             </a:pPr>
             <a:r>
-              <a:rPr sz="1200" b="1">
+              <a:rPr sz="1400" b="1">
                 <a:solidFill>
                   <a:srgbClr val="FFFFFF"/>
                 </a:solidFill>
@@ -12944,7 +12788,7 @@
         <p:spPr>
           <a:xfrm>
             <a:off x="4434840" y="2011680"/>
-            <a:ext cx="3291840" cy="914400"/>
+            <a:ext cx="3291840" cy="960120"/>
           </a:xfrm>
           <a:prstGeom prst="rect">
             <a:avLst/>
@@ -12963,7 +12807,7 @@
               </a:spcAft>
             </a:pPr>
             <a:r>
-              <a:rPr sz="1400" b="0">
+              <a:rPr sz="1600" b="0">
                 <a:solidFill>
                   <a:srgbClr val="3D525A"/>
                 </a:solidFill>
@@ -12983,7 +12827,7 @@
         <p:spPr>
           <a:xfrm>
             <a:off x="8092440" y="1417320"/>
-            <a:ext cx="3657600" cy="1691640"/>
+            <a:ext cx="3657600" cy="1737360"/>
           </a:xfrm>
           <a:prstGeom prst="roundRect">
             <a:avLst>
@@ -13029,7 +12873,7 @@
         <p:spPr>
           <a:xfrm>
             <a:off x="8092440" y="1417320"/>
-            <a:ext cx="3657600" cy="411480"/>
+            <a:ext cx="3657600" cy="438912"/>
           </a:xfrm>
           <a:prstGeom prst="rect">
             <a:avLst/>
@@ -13092,7 +12936,7 @@
               </a:spcAft>
             </a:pPr>
             <a:r>
-              <a:rPr sz="1400" b="1">
+              <a:rPr sz="1500" b="1">
                 <a:solidFill>
                   <a:srgbClr val="FFFFFF"/>
                 </a:solidFill>
@@ -13111,8 +12955,8 @@
         </p:nvSpPr>
         <p:spPr>
           <a:xfrm>
-            <a:off x="10789920" y="1481328"/>
-            <a:ext cx="822960" cy="310896"/>
+            <a:off x="10744200" y="1481328"/>
+            <a:ext cx="868680" cy="329184"/>
           </a:xfrm>
           <a:prstGeom prst="roundRect">
             <a:avLst>
@@ -13157,8 +13001,8 @@
         </p:nvSpPr>
         <p:spPr>
           <a:xfrm>
-            <a:off x="10789920" y="1499616"/>
-            <a:ext cx="822960" cy="274320"/>
+            <a:off x="10744200" y="1499616"/>
+            <a:ext cx="868680" cy="292608"/>
           </a:xfrm>
           <a:prstGeom prst="rect">
             <a:avLst/>
@@ -13177,7 +13021,7 @@
               </a:spcAft>
             </a:pPr>
             <a:r>
-              <a:rPr sz="1200" b="1">
+              <a:rPr sz="1400" b="1">
                 <a:solidFill>
                   <a:srgbClr val="FFFFFF"/>
                 </a:solidFill>
@@ -13197,7 +13041,7 @@
         <p:spPr>
           <a:xfrm>
             <a:off x="8275320" y="2011680"/>
-            <a:ext cx="3291840" cy="914400"/>
+            <a:ext cx="3291840" cy="960120"/>
           </a:xfrm>
           <a:prstGeom prst="rect">
             <a:avLst/>
@@ -13216,7 +13060,7 @@
               </a:spcAft>
             </a:pPr>
             <a:r>
-              <a:rPr sz="1400" b="0">
+              <a:rPr sz="1600" b="0">
                 <a:solidFill>
                   <a:srgbClr val="3D525A"/>
                 </a:solidFill>
@@ -13235,8 +13079,8 @@
         </p:nvSpPr>
         <p:spPr>
           <a:xfrm>
-            <a:off x="411480" y="3291840"/>
-            <a:ext cx="11338560" cy="2743200"/>
+            <a:off x="411480" y="3337560"/>
+            <a:ext cx="11338560" cy="2697480"/>
           </a:xfrm>
           <a:prstGeom prst="roundRect">
             <a:avLst>
@@ -13281,7 +13125,7 @@
         </p:nvSpPr>
         <p:spPr>
           <a:xfrm>
-            <a:off x="685800" y="3429000"/>
+            <a:off x="685800" y="3456432"/>
             <a:ext cx="10881360" cy="320040"/>
           </a:xfrm>
           <a:prstGeom prst="rect">
@@ -13301,7 +13145,7 @@
               </a:spcAft>
             </a:pPr>
             <a:r>
-              <a:rPr sz="1500" b="1">
+              <a:rPr sz="1700" b="1">
                 <a:solidFill>
                   <a:srgbClr val="239688"/>
                 </a:solidFill>
@@ -13320,7 +13164,7 @@
         </p:nvSpPr>
         <p:spPr>
           <a:xfrm>
-            <a:off x="685800" y="3794760"/>
+            <a:off x="685800" y="3840480"/>
             <a:ext cx="10881360" cy="502920"/>
           </a:xfrm>
           <a:prstGeom prst="rect">
@@ -13340,13 +13184,13 @@
               </a:spcAft>
             </a:pPr>
             <a:r>
-              <a:rPr sz="1500" b="0">
+              <a:rPr sz="1600" b="0">
                 <a:solidFill>
                   <a:srgbClr val="FFFFFF"/>
                 </a:solidFill>
                 <a:latin typeface="Calibri"/>
               </a:rPr>
-              <a:t>The portal is live, but it is still a prototype — not a bank production system. The next step is a lender pilot on real SME ledgers, plus official verification links.</a:t>
+              <a:t>The portal is live, but it is still a prototype — not a bank production system. Next: lender pilot on real SME ledgers, plus official verification links.</a:t>
             </a:r>
           </a:p>
         </p:txBody>
@@ -13359,8 +13203,8 @@
         </p:nvSpPr>
         <p:spPr>
           <a:xfrm>
-            <a:off x="685800" y="4434840"/>
-            <a:ext cx="3474720" cy="1371600"/>
+            <a:off x="685800" y="4480560"/>
+            <a:ext cx="3474720" cy="1325880"/>
           </a:xfrm>
           <a:prstGeom prst="roundRect">
             <a:avLst>
@@ -13405,7 +13249,7 @@
         </p:nvSpPr>
         <p:spPr>
           <a:xfrm>
-            <a:off x="868680" y="4526280"/>
+            <a:off x="868680" y="4572000"/>
             <a:ext cx="3108960" cy="274320"/>
           </a:xfrm>
           <a:prstGeom prst="rect">
@@ -13425,7 +13269,7 @@
               </a:spcAft>
             </a:pPr>
             <a:r>
-              <a:rPr sz="1500" b="1">
+              <a:rPr sz="1600" b="1">
                 <a:solidFill>
                   <a:srgbClr val="239688"/>
                 </a:solidFill>
@@ -13444,8 +13288,8 @@
         </p:nvSpPr>
         <p:spPr>
           <a:xfrm>
-            <a:off x="868680" y="4892040"/>
-            <a:ext cx="3108960" cy="777240"/>
+            <a:off x="868680" y="4937760"/>
+            <a:ext cx="3108960" cy="731520"/>
           </a:xfrm>
           <a:prstGeom prst="rect">
             <a:avLst/>
@@ -13464,13 +13308,13 @@
               </a:spcAft>
             </a:pPr>
             <a:r>
-              <a:rPr sz="1300" b="0">
+              <a:rPr sz="1500" b="0">
                 <a:solidFill>
                   <a:srgbClr val="E6EEF0"/>
                 </a:solidFill>
                 <a:latin typeface="Calibri"/>
               </a:rPr>
-              <a:t>Integrate with TRA to verify TIN numbers so registered businesses can be confirmed.</a:t>
+              <a:t>Verify TIN numbers with TRA so registered businesses can be confirmed.</a:t>
             </a:r>
           </a:p>
         </p:txBody>
@@ -13483,8 +13327,8 @@
         </p:nvSpPr>
         <p:spPr>
           <a:xfrm>
-            <a:off x="4343400" y="4434840"/>
-            <a:ext cx="3474720" cy="1371600"/>
+            <a:off x="4343400" y="4480560"/>
+            <a:ext cx="3474720" cy="1325880"/>
           </a:xfrm>
           <a:prstGeom prst="roundRect">
             <a:avLst>
@@ -13529,7 +13373,7 @@
         </p:nvSpPr>
         <p:spPr>
           <a:xfrm>
-            <a:off x="4526280" y="4526280"/>
+            <a:off x="4526280" y="4572000"/>
             <a:ext cx="3108960" cy="274320"/>
           </a:xfrm>
           <a:prstGeom prst="rect">
@@ -13549,7 +13393,7 @@
               </a:spcAft>
             </a:pPr>
             <a:r>
-              <a:rPr sz="1500" b="1">
+              <a:rPr sz="1600" b="1">
                 <a:solidFill>
                   <a:srgbClr val="239688"/>
                 </a:solidFill>
@@ -13568,8 +13412,8 @@
         </p:nvSpPr>
         <p:spPr>
           <a:xfrm>
-            <a:off x="4526280" y="4892040"/>
-            <a:ext cx="3108960" cy="777240"/>
+            <a:off x="4526280" y="4937760"/>
+            <a:ext cx="3108960" cy="731520"/>
           </a:xfrm>
           <a:prstGeom prst="rect">
             <a:avLst/>
@@ -13588,13 +13432,13 @@
               </a:spcAft>
             </a:pPr>
             <a:r>
-              <a:rPr sz="1300" b="0">
+              <a:rPr sz="1500" b="0">
                 <a:solidFill>
                   <a:srgbClr val="E6EEF0"/>
                 </a:solidFill>
                 <a:latin typeface="Calibri"/>
               </a:rPr>
-              <a:t>Link EFD receipt verification so sales reported in the portal can be checked against fiscal records.</a:t>
+              <a:t>Check EFD receipts so reported sales match fiscal records.</a:t>
             </a:r>
           </a:p>
         </p:txBody>
@@ -13607,8 +13451,8 @@
         </p:nvSpPr>
         <p:spPr>
           <a:xfrm>
-            <a:off x="8001000" y="4434840"/>
-            <a:ext cx="3474720" cy="1371600"/>
+            <a:off x="8001000" y="4480560"/>
+            <a:ext cx="3474720" cy="1325880"/>
           </a:xfrm>
           <a:prstGeom prst="roundRect">
             <a:avLst>
@@ -13653,7 +13497,7 @@
         </p:nvSpPr>
         <p:spPr>
           <a:xfrm>
-            <a:off x="8183880" y="4526280"/>
+            <a:off x="8183880" y="4572000"/>
             <a:ext cx="3108960" cy="274320"/>
           </a:xfrm>
           <a:prstGeom prst="rect">
@@ -13673,7 +13517,7 @@
               </a:spcAft>
             </a:pPr>
             <a:r>
-              <a:rPr sz="1500" b="1">
+              <a:rPr sz="1600" b="1">
                 <a:solidFill>
                   <a:srgbClr val="239688"/>
                 </a:solidFill>
@@ -13692,8 +13536,8 @@
         </p:nvSpPr>
         <p:spPr>
           <a:xfrm>
-            <a:off x="8183880" y="4892040"/>
-            <a:ext cx="3108960" cy="777240"/>
+            <a:off x="8183880" y="4937760"/>
+            <a:ext cx="3108960" cy="731520"/>
           </a:xfrm>
           <a:prstGeom prst="rect">
             <a:avLst/>
@@ -13712,13 +13556,13 @@
               </a:spcAft>
             </a:pPr>
             <a:r>
-              <a:rPr sz="1300" b="0">
+              <a:rPr sz="1500" b="0">
                 <a:solidFill>
                   <a:srgbClr val="E6EEF0"/>
                 </a:solidFill>
                 <a:latin typeface="Calibri"/>
               </a:rPr>
-              <a:t>Integrate with NIDA authority to verify national ID numbers beyond the current format and DOB checks.</a:t>
+              <a:t>Verify national IDs with NIDA beyond format and date-of-birth checks.</a:t>
             </a:r>
           </a:p>
         </p:txBody>
@@ -13731,8 +13575,8 @@
         </p:nvSpPr>
         <p:spPr>
           <a:xfrm>
-            <a:off x="0" y="6537960"/>
-            <a:ext cx="12191695" cy="320040"/>
+            <a:off x="0" y="6510528"/>
+            <a:ext cx="12191695" cy="347472"/>
           </a:xfrm>
           <a:prstGeom prst="rect">
             <a:avLst/>
@@ -13775,8 +13619,8 @@
         </p:nvSpPr>
         <p:spPr>
           <a:xfrm>
-            <a:off x="411480" y="6565392"/>
-            <a:ext cx="9144000" cy="256032"/>
+            <a:off x="411480" y="6547104"/>
+            <a:ext cx="9144000" cy="274320"/>
           </a:xfrm>
           <a:prstGeom prst="rect">
             <a:avLst/>
@@ -13795,7 +13639,7 @@
               </a:spcAft>
             </a:pPr>
             <a:r>
-              <a:rPr sz="1200" b="0">
+              <a:rPr sz="1400" b="0">
                 <a:solidFill>
                   <a:srgbClr val="B8D0C8"/>
                 </a:solidFill>
@@ -13814,8 +13658,8 @@
         </p:nvSpPr>
         <p:spPr>
           <a:xfrm>
-            <a:off x="10241280" y="6565392"/>
-            <a:ext cx="1554480" cy="256032"/>
+            <a:off x="10241280" y="6547104"/>
+            <a:ext cx="1554480" cy="274320"/>
           </a:xfrm>
           <a:prstGeom prst="rect">
             <a:avLst/>
@@ -13834,7 +13678,7 @@
               </a:spcAft>
             </a:pPr>
             <a:r>
-              <a:rPr sz="1200" b="0">
+              <a:rPr sz="1400" b="0">
                 <a:solidFill>
                   <a:srgbClr val="B8D0C8"/>
                 </a:solidFill>
@@ -14109,7 +13953,7 @@
         </p:nvSpPr>
         <p:spPr>
           <a:xfrm>
-            <a:off x="777240" y="502920"/>
+            <a:off x="777240" y="457200"/>
             <a:ext cx="10515600" cy="320040"/>
           </a:xfrm>
           <a:prstGeom prst="rect">
@@ -14129,7 +13973,7 @@
               </a:spcAft>
             </a:pPr>
             <a:r>
-              <a:rPr sz="1400" b="1">
+              <a:rPr sz="1600" b="1">
                 <a:solidFill>
                   <a:srgbClr val="239688"/>
                 </a:solidFill>
@@ -14148,7 +13992,7 @@
         </p:nvSpPr>
         <p:spPr>
           <a:xfrm>
-            <a:off x="777240" y="960120"/>
+            <a:off x="777240" y="914400"/>
             <a:ext cx="10515600" cy="640080"/>
           </a:xfrm>
           <a:prstGeom prst="rect">
@@ -14168,7 +14012,7 @@
               </a:spcAft>
             </a:pPr>
             <a:r>
-              <a:rPr sz="3200" b="1">
+              <a:rPr sz="3400" b="1">
                 <a:solidFill>
                   <a:srgbClr val="FFFFFF"/>
                 </a:solidFill>
@@ -14187,7 +14031,7 @@
         </p:nvSpPr>
         <p:spPr>
           <a:xfrm>
-            <a:off x="777240" y="1737360"/>
+            <a:off x="777240" y="1691640"/>
             <a:ext cx="10515600" cy="1005840"/>
           </a:xfrm>
           <a:prstGeom prst="rect">
@@ -14207,7 +14051,7 @@
               </a:spcAft>
             </a:pPr>
             <a:r>
-              <a:rPr sz="1700" b="0">
+              <a:rPr sz="1900" b="0">
                 <a:solidFill>
                   <a:srgbClr val="E6EEF0"/>
                 </a:solidFill>
@@ -14226,7 +14070,7 @@
         </p:nvSpPr>
         <p:spPr>
           <a:xfrm>
-            <a:off x="777240" y="3017520"/>
+            <a:off x="777240" y="2971800"/>
             <a:ext cx="10607040" cy="640080"/>
           </a:xfrm>
           <a:prstGeom prst="roundRect">
@@ -14272,7 +14116,7 @@
         </p:nvSpPr>
         <p:spPr>
           <a:xfrm>
-            <a:off x="1005840" y="3182112"/>
+            <a:off x="1005840" y="3118104"/>
             <a:ext cx="2926080" cy="365760"/>
           </a:xfrm>
           <a:prstGeom prst="rect">
@@ -14292,7 +14136,7 @@
               </a:spcAft>
             </a:pPr>
             <a:r>
-              <a:rPr sz="1600" b="1">
+              <a:rPr sz="1800" b="1">
                 <a:solidFill>
                   <a:srgbClr val="239688"/>
                 </a:solidFill>
@@ -14311,7 +14155,7 @@
         </p:nvSpPr>
         <p:spPr>
           <a:xfrm>
-            <a:off x="4114800" y="3182112"/>
+            <a:off x="4114800" y="3118104"/>
             <a:ext cx="7040880" cy="365760"/>
           </a:xfrm>
           <a:prstGeom prst="rect">
@@ -14331,7 +14175,7 @@
               </a:spcAft>
             </a:pPr>
             <a:r>
-              <a:rPr sz="1600" b="0">
+              <a:rPr sz="1800" b="0">
                 <a:solidFill>
                   <a:srgbClr val="FFFFFF"/>
                 </a:solidFill>
@@ -14350,7 +14194,7 @@
         </p:nvSpPr>
         <p:spPr>
           <a:xfrm>
-            <a:off x="777240" y="3794759"/>
+            <a:off x="777240" y="3749039"/>
             <a:ext cx="10607040" cy="640080"/>
           </a:xfrm>
           <a:prstGeom prst="roundRect">
@@ -14396,7 +14240,7 @@
         </p:nvSpPr>
         <p:spPr>
           <a:xfrm>
-            <a:off x="1005840" y="3959351"/>
+            <a:off x="1005840" y="3895343"/>
             <a:ext cx="2926080" cy="365760"/>
           </a:xfrm>
           <a:prstGeom prst="rect">
@@ -14416,7 +14260,7 @@
               </a:spcAft>
             </a:pPr>
             <a:r>
-              <a:rPr sz="1600" b="1">
+              <a:rPr sz="1800" b="1">
                 <a:solidFill>
                   <a:srgbClr val="239688"/>
                 </a:solidFill>
@@ -14435,7 +14279,7 @@
         </p:nvSpPr>
         <p:spPr>
           <a:xfrm>
-            <a:off x="4114800" y="3959351"/>
+            <a:off x="4114800" y="3895343"/>
             <a:ext cx="7040880" cy="365760"/>
           </a:xfrm>
           <a:prstGeom prst="rect">
@@ -14455,7 +14299,7 @@
               </a:spcAft>
             </a:pPr>
             <a:r>
-              <a:rPr sz="1600" b="0">
+              <a:rPr sz="1800" b="0">
                 <a:solidFill>
                   <a:srgbClr val="FFFFFF"/>
                 </a:solidFill>
@@ -14474,7 +14318,7 @@
         </p:nvSpPr>
         <p:spPr>
           <a:xfrm>
-            <a:off x="777240" y="4572000"/>
+            <a:off x="777240" y="4526280"/>
             <a:ext cx="10607040" cy="640080"/>
           </a:xfrm>
           <a:prstGeom prst="roundRect">
@@ -14520,7 +14364,7 @@
         </p:nvSpPr>
         <p:spPr>
           <a:xfrm>
-            <a:off x="1005840" y="4736592"/>
+            <a:off x="1005840" y="4672584"/>
             <a:ext cx="2926080" cy="365760"/>
           </a:xfrm>
           <a:prstGeom prst="rect">
@@ -14540,7 +14384,7 @@
               </a:spcAft>
             </a:pPr>
             <a:r>
-              <a:rPr sz="1600" b="1">
+              <a:rPr sz="1800" b="1">
                 <a:solidFill>
                   <a:srgbClr val="239688"/>
                 </a:solidFill>
@@ -14559,7 +14403,7 @@
         </p:nvSpPr>
         <p:spPr>
           <a:xfrm>
-            <a:off x="4114800" y="4736592"/>
+            <a:off x="4114800" y="4672584"/>
             <a:ext cx="7040880" cy="365760"/>
           </a:xfrm>
           <a:prstGeom prst="rect">
@@ -14579,85 +14423,85 @@
               </a:spcAft>
             </a:pPr>
             <a:r>
+              <a:rPr sz="1800" b="0">
+                <a:solidFill>
+                  <a:srgbClr val="FFFFFF"/>
+                </a:solidFill>
+                <a:latin typeface="Calibri"/>
+              </a:rPr>
+              <a:t>Managed database, hosting hardening, and ongoing model review.</a:t>
+            </a:r>
+          </a:p>
+        </p:txBody>
+      </p:sp>
+      <p:sp>
+        <p:nvSpPr>
+          <p:cNvPr id="16" name="TextBox 15"/>
+          <p:cNvSpPr txBox="1"/>
+          <p:nvPr/>
+        </p:nvSpPr>
+        <p:spPr>
+          <a:xfrm>
+            <a:off x="777240" y="5897880"/>
+            <a:ext cx="9144000" cy="365760"/>
+          </a:xfrm>
+          <a:prstGeom prst="rect">
+            <a:avLst/>
+          </a:prstGeom>
+          <a:noFill/>
+        </p:spPr>
+        <p:txBody>
+          <a:bodyPr wrap="square">
+            <a:spAutoFit/>
+          </a:bodyPr>
+          <a:lstStyle/>
+          <a:p>
+            <a:pPr algn="l">
+              <a:spcAft>
+                <a:spcPts val="400"/>
+              </a:spcAft>
+            </a:pPr>
+            <a:r>
+              <a:rPr sz="2000" b="1">
+                <a:solidFill>
+                  <a:srgbClr val="239688"/>
+                </a:solidFill>
+                <a:latin typeface="Calibri"/>
+              </a:rPr>
+              <a:t>Asanteni  ·  Questions and discussion</a:t>
+            </a:r>
+          </a:p>
+        </p:txBody>
+      </p:sp>
+      <p:sp>
+        <p:nvSpPr>
+          <p:cNvPr id="17" name="TextBox 16"/>
+          <p:cNvSpPr txBox="1"/>
+          <p:nvPr/>
+        </p:nvSpPr>
+        <p:spPr>
+          <a:xfrm>
+            <a:off x="10241280" y="5897880"/>
+            <a:ext cx="1554480" cy="365760"/>
+          </a:xfrm>
+          <a:prstGeom prst="rect">
+            <a:avLst/>
+          </a:prstGeom>
+          <a:noFill/>
+        </p:spPr>
+        <p:txBody>
+          <a:bodyPr wrap="square">
+            <a:spAutoFit/>
+          </a:bodyPr>
+          <a:lstStyle/>
+          <a:p>
+            <a:pPr algn="r">
+              <a:spcAft>
+                <a:spcPts val="400"/>
+              </a:spcAft>
+            </a:pPr>
+            <a:r>
               <a:rPr sz="1600" b="0">
-                <a:solidFill>
-                  <a:srgbClr val="FFFFFF"/>
-                </a:solidFill>
-                <a:latin typeface="Calibri"/>
-              </a:rPr>
-              <a:t>Managed database, hosting hardening, and ongoing model review.</a:t>
-            </a:r>
-          </a:p>
-        </p:txBody>
-      </p:sp>
-      <p:sp>
-        <p:nvSpPr>
-          <p:cNvPr id="16" name="TextBox 15"/>
-          <p:cNvSpPr txBox="1"/>
-          <p:nvPr/>
-        </p:nvSpPr>
-        <p:spPr>
-          <a:xfrm>
-            <a:off x="777240" y="5943600"/>
-            <a:ext cx="9144000" cy="365760"/>
-          </a:xfrm>
-          <a:prstGeom prst="rect">
-            <a:avLst/>
-          </a:prstGeom>
-          <a:noFill/>
-        </p:spPr>
-        <p:txBody>
-          <a:bodyPr wrap="square">
-            <a:spAutoFit/>
-          </a:bodyPr>
-          <a:lstStyle/>
-          <a:p>
-            <a:pPr algn="l">
-              <a:spcAft>
-                <a:spcPts val="400"/>
-              </a:spcAft>
-            </a:pPr>
-            <a:r>
-              <a:rPr sz="1800" b="1">
-                <a:solidFill>
-                  <a:srgbClr val="239688"/>
-                </a:solidFill>
-                <a:latin typeface="Calibri"/>
-              </a:rPr>
-              <a:t>Asanteni  ·  Questions and discussion</a:t>
-            </a:r>
-          </a:p>
-        </p:txBody>
-      </p:sp>
-      <p:sp>
-        <p:nvSpPr>
-          <p:cNvPr id="17" name="TextBox 16"/>
-          <p:cNvSpPr txBox="1"/>
-          <p:nvPr/>
-        </p:nvSpPr>
-        <p:spPr>
-          <a:xfrm>
-            <a:off x="10241280" y="5943600"/>
-            <a:ext cx="1554480" cy="365760"/>
-          </a:xfrm>
-          <a:prstGeom prst="rect">
-            <a:avLst/>
-          </a:prstGeom>
-          <a:noFill/>
-        </p:spPr>
-        <p:txBody>
-          <a:bodyPr wrap="square">
-            <a:spAutoFit/>
-          </a:bodyPr>
-          <a:lstStyle/>
-          <a:p>
-            <a:pPr algn="r">
-              <a:spcAft>
-                <a:spcPts val="400"/>
-              </a:spcAft>
-            </a:pPr>
-            <a:r>
-              <a:rPr sz="1400" b="0">
                 <a:solidFill>
                   <a:srgbClr val="B8D0C8"/>
                 </a:solidFill>

</xml_diff>